<commit_message>
Restyle avalúos deck in institutional blue and white, flatter cards
Co-Authored-By: Claude Opus 5.5 <noreply@anthropic.com>
Claude-Session: https://claude.ai/code/session_01Czk2XnZSpBwy6TjibqLL9A
</commit_message>
<xml_diff>
--- a/administracion-avaluos/Proyecto_Administracion_de_Avaluos.pptx
+++ b/administracion-avaluos/Proyecto_Administracion_de_Avaluos.pptx
@@ -122,17 +122,17 @@
   <p:extLst>
     <p:ext uri="{521415D9-36F7-43E2-AB2F-B90AF26B5E84}">
       <p14:sectionLst xmlns:p14="http://schemas.microsoft.com/office/powerpoint/2010/main">
-        <p14:section name="Portada" id="{b45addff-f7f0-4268-0673-6d76c4322210}">
+        <p14:section name="Portada" id="{2aac6b3a-cddc-8a6b-5b6a-b2f1befeb885}">
           <p14:sldIdLst>
             <p14:sldId id="256"/>
           </p14:sldIdLst>
         </p14:section>
-        <p14:section name="Agenda" id="{8b377bce-b953-bf90-8a1b-f442adffdb54}">
+        <p14:section name="Agenda" id="{feb7e73d-9cd6-6d19-e2ec-b6b03484bb8d}">
           <p14:sldIdLst>
             <p14:sldId id="257"/>
           </p14:sldIdLst>
         </p14:section>
-        <p14:section name="A. Situación actual" id="{1cdb75c5-f4cf-bfaf-c15a-44e0c21af6c6}">
+        <p14:section name="A. Situación actual" id="{3f88c0aa-c65a-dea2-551a-2eda415fd1b3}">
           <p14:sldIdLst>
             <p14:sldId id="258"/>
             <p14:sldId id="259"/>
@@ -141,19 +141,19 @@
             <p14:sldId id="262"/>
           </p14:sldIdLst>
         </p14:section>
-        <p14:section name="Datos operativos" id="{56327ebf-9f38-00b5-fa87-b6d83b311c0e}">
+        <p14:section name="Datos operativos" id="{9acde0da-f896-90f2-0322-52a880e29a79}">
           <p14:sldIdLst>
             <p14:sldId id="263"/>
             <p14:sldId id="264"/>
             <p14:sldId id="265"/>
           </p14:sldIdLst>
         </p14:section>
-        <p14:section name="Riesgo identificado" id="{398c377a-5c7a-c3a6-1e4d-6acb8e4c4f64}">
+        <p14:section name="Riesgo identificado" id="{6f9940ff-de3a-b251-a283-f7e43ae0cb0a}">
           <p14:sldIdLst>
             <p14:sldId id="266"/>
           </p14:sldIdLst>
         </p14:section>
-        <p14:section name="B. Propuesta" id="{e9d86697-2137-ac9c-807f-a7204aabbebd}">
+        <p14:section name="B. Propuesta" id="{09fe9182-0851-8f89-ceba-348580857f5e}">
           <p14:sldIdLst>
             <p14:sldId id="267"/>
             <p14:sldId id="268"/>
@@ -161,7 +161,7 @@
             <p14:sldId id="270"/>
           </p14:sldIdLst>
         </p14:section>
-        <p14:section name="Solicitud" id="{350f2317-1564-ccb5-ce33-9b0281c99bf5}">
+        <p14:section name="Solicitud" id="{0f25d45d-b092-8fd5-946c-dc1831f04e69}">
           <p14:sldIdLst>
             <p14:sldId id="271"/>
           </p14:sldIdLst>
@@ -189,7 +189,7 @@
             <a:pPr>
               <a:defRPr sz="1300" b="0" i="0" u="none" strike="noStrike">
                 <a:solidFill>
-                  <a:srgbClr val="123642"/>
+                  <a:srgbClr val="0A2A5C"/>
                 </a:solidFill>
                 <a:latin typeface="+mn-lt"/>
               </a:defRPr>
@@ -197,7 +197,7 @@
             <a:r>
               <a:rPr sz="1300" b="0" i="0" u="none" strike="noStrike">
                 <a:solidFill>
-                  <a:srgbClr val="123642"/>
+                  <a:srgbClr val="0A2A5C"/>
                 </a:solidFill>
                 <a:latin typeface="+mn-lt"/>
               </a:rPr>
@@ -232,7 +232,7 @@
           </c:tx>
           <c:spPr>
             <a:solidFill>
-              <a:srgbClr val="1D6F7A"/>
+              <a:srgbClr val="1F5FAE"/>
             </a:solidFill>
             <a:effectLst/>
           </c:spPr>
@@ -246,7 +246,7 @@
                 <a:pPr>
                   <a:defRPr b="0" i="0" strike="noStrike" sz="1200" u="none">
                     <a:solidFill>
-                      <a:srgbClr val="1F2A30"/>
+                      <a:srgbClr val="1E2A3A"/>
                     </a:solidFill>
                     <a:latin typeface="+mn-lt"/>
                   </a:defRPr>
@@ -344,7 +344,7 @@
               <a:pPr>
                 <a:defRPr b="0" i="0" strike="noStrike" sz="1200" u="none">
                   <a:solidFill>
-                    <a:srgbClr val="1F2A30"/>
+                    <a:srgbClr val="1E2A3A"/>
                   </a:solidFill>
                   <a:latin typeface="+mn-lt"/>
                 </a:defRPr>
@@ -392,7 +392,7 @@
             <a:pPr>
               <a:defRPr sz="1200" b="0" i="0" u="none" strike="noStrike">
                 <a:solidFill>
-                  <a:srgbClr val="5B7C86"/>
+                  <a:srgbClr val="5F7590"/>
                 </a:solidFill>
                 <a:latin typeface="+mn-lt"/>
               </a:defRPr>
@@ -434,7 +434,7 @@
             <a:pPr>
               <a:defRPr sz="1100" b="0" i="0" u="none" strike="noStrike">
                 <a:solidFill>
-                  <a:srgbClr val="5B7C86"/>
+                  <a:srgbClr val="5F7590"/>
                 </a:solidFill>
                 <a:latin typeface="+mn-lt"/>
               </a:defRPr>
@@ -484,7 +484,7 @@
             <a:pPr>
               <a:defRPr sz="1300" b="0" i="0" u="none" strike="noStrike">
                 <a:solidFill>
-                  <a:srgbClr val="123642"/>
+                  <a:srgbClr val="0A2A5C"/>
                 </a:solidFill>
                 <a:latin typeface="+mn-lt"/>
               </a:defRPr>
@@ -492,7 +492,7 @@
             <a:r>
               <a:rPr sz="1300" b="0" i="0" u="none" strike="noStrike">
                 <a:solidFill>
-                  <a:srgbClr val="123642"/>
+                  <a:srgbClr val="0A2A5C"/>
                 </a:solidFill>
                 <a:latin typeface="+mn-lt"/>
               </a:rPr>
@@ -527,7 +527,7 @@
           </c:tx>
           <c:spPr>
             <a:solidFill>
-              <a:srgbClr val="C0392B"/>
+              <a:srgbClr val="1F5FAE"/>
             </a:solidFill>
             <a:effectLst/>
           </c:spPr>
@@ -541,7 +541,7 @@
                 <a:pPr>
                   <a:defRPr b="0" i="0" strike="noStrike" sz="1200" u="none">
                     <a:solidFill>
-                      <a:srgbClr val="1F2A30"/>
+                      <a:srgbClr val="1E2A3A"/>
                     </a:solidFill>
                     <a:latin typeface="+mn-lt"/>
                   </a:defRPr>
@@ -640,7 +640,7 @@
               <a:pPr>
                 <a:defRPr b="0" i="0" strike="noStrike" sz="1200" u="none">
                   <a:solidFill>
-                    <a:srgbClr val="1F2A30"/>
+                    <a:srgbClr val="1E2A3A"/>
                   </a:solidFill>
                   <a:latin typeface="+mn-lt"/>
                 </a:defRPr>
@@ -680,11 +680,11 @@
           </c:tx>
           <c:spPr>
             <a:solidFill>
-              <a:srgbClr val="E3A72F"/>
+              <a:srgbClr val="0A2A5C"/>
             </a:solidFill>
             <a:ln w="25400" cap="flat">
               <a:solidFill>
-                <a:srgbClr val="E3A72F"/>
+                <a:srgbClr val="0A2A5C"/>
               </a:solidFill>
               <a:prstDash val="dash"/>
               <a:round/>
@@ -701,7 +701,7 @@
                 <a:pPr>
                   <a:defRPr b="0" i="0" strike="noStrike" sz="1200" u="none">
                     <a:solidFill>
-                      <a:srgbClr val="1F2A30"/>
+                      <a:srgbClr val="1E2A3A"/>
                     </a:solidFill>
                     <a:latin typeface="+mn-lt"/>
                   </a:defRPr>
@@ -721,11 +721,11 @@
             <c:size val="6"/>
             <c:spPr>
               <a:solidFill>
-                <a:srgbClr val="E3A72F"/>
+                <a:srgbClr val="0A2A5C"/>
               </a:solidFill>
               <a:ln w="9525" cap="flat">
                 <a:solidFill>
-                  <a:srgbClr val="E3A72F"/>
+                  <a:srgbClr val="0A2A5C"/>
                 </a:solidFill>
                 <a:prstDash val="solid"/>
                 <a:round/>
@@ -817,7 +817,7 @@
               <a:pPr>
                 <a:defRPr b="0" i="0" strike="noStrike" sz="1200" u="none">
                   <a:solidFill>
-                    <a:srgbClr val="1F2A30"/>
+                    <a:srgbClr val="1E2A3A"/>
                   </a:solidFill>
                   <a:latin typeface="+mn-lt"/>
                 </a:defRPr>
@@ -864,7 +864,7 @@
             <a:pPr>
               <a:defRPr sz="1200" b="0" i="0" u="none" strike="noStrike">
                 <a:solidFill>
-                  <a:srgbClr val="5B7C86"/>
+                  <a:srgbClr val="5F7590"/>
                 </a:solidFill>
                 <a:latin typeface="+mn-lt"/>
               </a:defRPr>
@@ -907,7 +907,7 @@
             <a:pPr>
               <a:defRPr sz="1100" b="0" i="0" u="none" strike="noStrike">
                 <a:solidFill>
-                  <a:srgbClr val="5B7C86"/>
+                  <a:srgbClr val="5F7590"/>
                 </a:solidFill>
                 <a:latin typeface="+mn-lt"/>
               </a:defRPr>
@@ -937,7 +937,7 @@
           <a:pPr>
             <a:defRPr sz="1100">
               <a:solidFill>
-                <a:srgbClr val="5B7C86"/>
+                <a:srgbClr val="5F7590"/>
               </a:solidFill>
               <a:latin typeface="+mn-lt"/>
               <a:cs typeface="+mn-lt"/>
@@ -2756,7 +2756,7 @@
     <p:bg>
       <p:bgPr>
         <a:solidFill>
-          <a:srgbClr val="123642"/>
+          <a:srgbClr val="0A2A5C"/>
         </a:solidFill>
       </p:bgPr>
     </p:bg>
@@ -2866,7 +2866,7 @@
     <p:bg>
       <p:bgPr>
         <a:solidFill>
-          <a:srgbClr val="123642"/>
+          <a:srgbClr val="0A2A5C"/>
         </a:solidFill>
       </p:bgPr>
     </p:bg>
@@ -3636,11 +3636,11 @@
             <a:avLst/>
           </a:prstGeom>
           <a:solidFill>
-            <a:srgbClr val="1D6F7A"/>
+            <a:srgbClr val="1F5FAE"/>
           </a:solidFill>
           <a:ln w="12700">
             <a:solidFill>
-              <a:srgbClr val="1D6F7A"/>
+              <a:srgbClr val="1F5FAE"/>
             </a:solidFill>
             <a:prstDash val="solid"/>
           </a:ln>
@@ -3685,11 +3685,11 @@
             <a:avLst/>
           </a:prstGeom>
           <a:solidFill>
-            <a:srgbClr val="E3A72F"/>
+            <a:srgbClr val="9CC3F0"/>
           </a:solidFill>
           <a:ln w="12700">
             <a:solidFill>
-              <a:srgbClr val="E3A72F"/>
+              <a:srgbClr val="9CC3F0"/>
             </a:solidFill>
             <a:prstDash val="solid"/>
           </a:ln>
@@ -3799,43 +3799,36 @@
             </a:avLst>
           </a:prstGeom>
           <a:solidFill>
-            <a:srgbClr val="123642"/>
+            <a:srgbClr val="0A2A5C"/>
+          </a:solidFill>
+          <a:ln w="9525">
+            <a:solidFill>
+              <a:srgbClr val="0A2A5C"/>
+            </a:solidFill>
+            <a:prstDash val="solid"/>
+          </a:ln>
+        </p:spPr>
+      </p:sp>
+      <p:sp>
+        <p:nvSpPr>
+          <p:cNvPr id="4" name="stat 1 circle"/>
+          <p:cNvSpPr/>
+          <p:nvPr/>
+        </p:nvSpPr>
+        <p:spPr>
+          <a:xfrm>
+            <a:off x="914400" y="1783080"/>
+            <a:ext cx="731520" cy="731520"/>
+          </a:xfrm>
+          <a:prstGeom prst="ellipse">
+            <a:avLst/>
+          </a:prstGeom>
+          <a:solidFill>
+            <a:srgbClr val="9CC3F0"/>
           </a:solidFill>
           <a:ln w="12700">
             <a:solidFill>
-              <a:srgbClr val="123642"/>
-            </a:solidFill>
-            <a:prstDash val="solid"/>
-          </a:ln>
-          <a:effectLst>
-            <a:outerShdw sx="100000" sy="100000" kx="0" ky="0" algn="bl" rotWithShape="0" blurRad="76200" dist="25400" dir="5400000">
-              <a:srgbClr val="000000">
-                <a:alpha val="12000"/>
-              </a:srgbClr>
-            </a:outerShdw>
-          </a:effectLst>
-        </p:spPr>
-      </p:sp>
-      <p:sp>
-        <p:nvSpPr>
-          <p:cNvPr id="4" name="stat 1 circle"/>
-          <p:cNvSpPr/>
-          <p:nvPr/>
-        </p:nvSpPr>
-        <p:spPr>
-          <a:xfrm>
-            <a:off x="914400" y="1783080"/>
-            <a:ext cx="731520" cy="731520"/>
-          </a:xfrm>
-          <a:prstGeom prst="ellipse">
-            <a:avLst/>
-          </a:prstGeom>
-          <a:solidFill>
-            <a:srgbClr val="E3A72F"/>
-          </a:solidFill>
-          <a:ln w="12700">
-            <a:solidFill>
-              <a:srgbClr val="E3A72F"/>
+              <a:srgbClr val="9CC3F0"/>
             </a:solidFill>
             <a:prstDash val="solid"/>
           </a:ln>
@@ -3993,43 +3986,36 @@
             </a:avLst>
           </a:prstGeom>
           <a:solidFill>
-            <a:srgbClr val="EEF3F4"/>
+            <a:srgbClr val="F4F7FB"/>
+          </a:solidFill>
+          <a:ln w="9525">
+            <a:solidFill>
+              <a:srgbClr val="DCE5F0"/>
+            </a:solidFill>
+            <a:prstDash val="solid"/>
+          </a:ln>
+        </p:spPr>
+      </p:sp>
+      <p:sp>
+        <p:nvSpPr>
+          <p:cNvPr id="10" name="stat 2 circle"/>
+          <p:cNvSpPr/>
+          <p:nvPr/>
+        </p:nvSpPr>
+        <p:spPr>
+          <a:xfrm>
+            <a:off x="4709160" y="1783080"/>
+            <a:ext cx="731520" cy="731520"/>
+          </a:xfrm>
+          <a:prstGeom prst="ellipse">
+            <a:avLst/>
+          </a:prstGeom>
+          <a:solidFill>
+            <a:srgbClr val="1F5FAE"/>
           </a:solidFill>
           <a:ln w="12700">
             <a:solidFill>
-              <a:srgbClr val="EEF3F4"/>
-            </a:solidFill>
-            <a:prstDash val="solid"/>
-          </a:ln>
-          <a:effectLst>
-            <a:outerShdw sx="100000" sy="100000" kx="0" ky="0" algn="bl" rotWithShape="0" blurRad="76200" dist="25400" dir="5400000">
-              <a:srgbClr val="000000">
-                <a:alpha val="12000"/>
-              </a:srgbClr>
-            </a:outerShdw>
-          </a:effectLst>
-        </p:spPr>
-      </p:sp>
-      <p:sp>
-        <p:nvSpPr>
-          <p:cNvPr id="10" name="stat 2 circle"/>
-          <p:cNvSpPr/>
-          <p:nvPr/>
-        </p:nvSpPr>
-        <p:spPr>
-          <a:xfrm>
-            <a:off x="4709160" y="1783080"/>
-            <a:ext cx="731520" cy="731520"/>
-          </a:xfrm>
-          <a:prstGeom prst="ellipse">
-            <a:avLst/>
-          </a:prstGeom>
-          <a:solidFill>
-            <a:srgbClr val="1D6F7A"/>
-          </a:solidFill>
-          <a:ln w="12700">
-            <a:solidFill>
-              <a:srgbClr val="1D6F7A"/>
+              <a:srgbClr val="1F5FAE"/>
             </a:solidFill>
             <a:prstDash val="solid"/>
           </a:ln>
@@ -4187,43 +4173,36 @@
             </a:avLst>
           </a:prstGeom>
           <a:solidFill>
-            <a:srgbClr val="EEF3F4"/>
+            <a:srgbClr val="F4F7FB"/>
+          </a:solidFill>
+          <a:ln w="9525">
+            <a:solidFill>
+              <a:srgbClr val="DCE5F0"/>
+            </a:solidFill>
+            <a:prstDash val="solid"/>
+          </a:ln>
+        </p:spPr>
+      </p:sp>
+      <p:sp>
+        <p:nvSpPr>
+          <p:cNvPr id="16" name="stat 3 circle"/>
+          <p:cNvSpPr/>
+          <p:nvPr/>
+        </p:nvSpPr>
+        <p:spPr>
+          <a:xfrm>
+            <a:off x="8503920" y="1783080"/>
+            <a:ext cx="731520" cy="731520"/>
+          </a:xfrm>
+          <a:prstGeom prst="ellipse">
+            <a:avLst/>
+          </a:prstGeom>
+          <a:solidFill>
+            <a:srgbClr val="1F5FAE"/>
           </a:solidFill>
           <a:ln w="12700">
             <a:solidFill>
-              <a:srgbClr val="EEF3F4"/>
-            </a:solidFill>
-            <a:prstDash val="solid"/>
-          </a:ln>
-          <a:effectLst>
-            <a:outerShdw sx="100000" sy="100000" kx="0" ky="0" algn="bl" rotWithShape="0" blurRad="76200" dist="25400" dir="5400000">
-              <a:srgbClr val="000000">
-                <a:alpha val="12000"/>
-              </a:srgbClr>
-            </a:outerShdw>
-          </a:effectLst>
-        </p:spPr>
-      </p:sp>
-      <p:sp>
-        <p:nvSpPr>
-          <p:cNvPr id="16" name="stat 3 circle"/>
-          <p:cNvSpPr/>
-          <p:nvPr/>
-        </p:nvSpPr>
-        <p:spPr>
-          <a:xfrm>
-            <a:off x="8503920" y="1783080"/>
-            <a:ext cx="731520" cy="731520"/>
-          </a:xfrm>
-          <a:prstGeom prst="ellipse">
-            <a:avLst/>
-          </a:prstGeom>
-          <a:solidFill>
-            <a:srgbClr val="1D6F7A"/>
-          </a:solidFill>
-          <a:ln w="12700">
-            <a:solidFill>
-              <a:srgbClr val="1D6F7A"/>
+              <a:srgbClr val="1F5FAE"/>
             </a:solidFill>
             <a:prstDash val="solid"/>
           </a:ln>
@@ -4525,21 +4504,14 @@
             </a:avLst>
           </a:prstGeom>
           <a:solidFill>
-            <a:srgbClr val="C0392B"/>
+            <a:srgbClr val="164A8F"/>
           </a:solidFill>
-          <a:ln w="12700">
+          <a:ln w="9525">
             <a:solidFill>
-              <a:srgbClr val="C0392B"/>
+              <a:srgbClr val="164A8F"/>
             </a:solidFill>
             <a:prstDash val="solid"/>
           </a:ln>
-          <a:effectLst>
-            <a:outerShdw sx="100000" sy="100000" kx="0" ky="0" algn="bl" rotWithShape="0" blurRad="76200" dist="25400" dir="5400000">
-              <a:srgbClr val="000000">
-                <a:alpha val="12000"/>
-              </a:srgbClr>
-            </a:outerShdw>
-          </a:effectLst>
         </p:spPr>
       </p:sp>
       <p:pic>
@@ -4658,21 +4630,14 @@
             </a:avLst>
           </a:prstGeom>
           <a:solidFill>
-            <a:srgbClr val="EEF3F4"/>
+            <a:srgbClr val="F4F7FB"/>
           </a:solidFill>
-          <a:ln w="12700">
+          <a:ln w="9525">
             <a:solidFill>
-              <a:srgbClr val="EEF3F4"/>
+              <a:srgbClr val="DCE5F0"/>
             </a:solidFill>
             <a:prstDash val="solid"/>
           </a:ln>
-          <a:effectLst>
-            <a:outerShdw sx="100000" sy="100000" kx="0" ky="0" algn="bl" rotWithShape="0" blurRad="76200" dist="25400" dir="5400000">
-              <a:srgbClr val="000000">
-                <a:alpha val="12000"/>
-              </a:srgbClr>
-            </a:outerShdw>
-          </a:effectLst>
         </p:spPr>
       </p:sp>
       <p:sp>
@@ -4777,21 +4742,14 @@
             </a:avLst>
           </a:prstGeom>
           <a:solidFill>
-            <a:srgbClr val="EEF3F4"/>
+            <a:srgbClr val="F4F7FB"/>
           </a:solidFill>
-          <a:ln w="12700">
+          <a:ln w="9525">
             <a:solidFill>
-              <a:srgbClr val="EEF3F4"/>
+              <a:srgbClr val="DCE5F0"/>
             </a:solidFill>
             <a:prstDash val="solid"/>
           </a:ln>
-          <a:effectLst>
-            <a:outerShdw sx="100000" sy="100000" kx="0" ky="0" algn="bl" rotWithShape="0" blurRad="76200" dist="25400" dir="5400000">
-              <a:srgbClr val="000000">
-                <a:alpha val="12000"/>
-              </a:srgbClr>
-            </a:outerShdw>
-          </a:effectLst>
         </p:spPr>
       </p:sp>
       <p:sp>
@@ -5042,11 +5000,11 @@
             </a:avLst>
           </a:prstGeom>
           <a:solidFill>
-            <a:srgbClr val="1D6F7A"/>
+            <a:srgbClr val="1F5FAE"/>
           </a:solidFill>
           <a:ln w="12700">
             <a:solidFill>
-              <a:srgbClr val="1D6F7A"/>
+              <a:srgbClr val="1F5FAE"/>
             </a:solidFill>
             <a:prstDash val="solid"/>
           </a:ln>
@@ -5079,7 +5037,7 @@
             <a:r>
               <a:rPr lang="en-US" sz="4000" b="1" dirty="0">
                 <a:solidFill>
-                  <a:schemeClr val="accent2"/>
+                  <a:schemeClr val="bg1"/>
                 </a:solidFill>
                 <a:latin typeface="Cambria" pitchFamily="34" charset="0"/>
                 <a:ea typeface="Cambria" pitchFamily="34" charset="-122"/>
@@ -5144,11 +5102,11 @@
             </a:avLst>
           </a:prstGeom>
           <a:solidFill>
-            <a:srgbClr val="1D6F7A"/>
+            <a:srgbClr val="1F5FAE"/>
           </a:solidFill>
           <a:ln w="12700">
             <a:solidFill>
-              <a:srgbClr val="1D6F7A"/>
+              <a:srgbClr val="1F5FAE"/>
             </a:solidFill>
             <a:prstDash val="solid"/>
           </a:ln>
@@ -5181,7 +5139,7 @@
             <a:r>
               <a:rPr lang="en-US" sz="4000" b="1" dirty="0">
                 <a:solidFill>
-                  <a:schemeClr val="accent2"/>
+                  <a:schemeClr val="bg1"/>
                 </a:solidFill>
                 <a:latin typeface="Cambria" pitchFamily="34" charset="0"/>
                 <a:ea typeface="Cambria" pitchFamily="34" charset="-122"/>
@@ -5246,11 +5204,11 @@
             </a:avLst>
           </a:prstGeom>
           <a:solidFill>
-            <a:srgbClr val="1D6F7A"/>
+            <a:srgbClr val="1F5FAE"/>
           </a:solidFill>
           <a:ln w="12700">
             <a:solidFill>
-              <a:srgbClr val="1D6F7A"/>
+              <a:srgbClr val="1F5FAE"/>
             </a:solidFill>
             <a:prstDash val="solid"/>
           </a:ln>
@@ -5283,7 +5241,7 @@
             <a:r>
               <a:rPr lang="en-US" sz="4000" b="1" dirty="0">
                 <a:solidFill>
-                  <a:schemeClr val="accent2"/>
+                  <a:schemeClr val="bg1"/>
                 </a:solidFill>
                 <a:latin typeface="Cambria" pitchFamily="34" charset="0"/>
                 <a:ea typeface="Cambria" pitchFamily="34" charset="-122"/>
@@ -5492,43 +5450,36 @@
             </a:avLst>
           </a:prstGeom>
           <a:solidFill>
-            <a:srgbClr val="EEF3F4"/>
+            <a:srgbClr val="F4F7FB"/>
+          </a:solidFill>
+          <a:ln w="9525">
+            <a:solidFill>
+              <a:srgbClr val="DCE5F0"/>
+            </a:solidFill>
+            <a:prstDash val="solid"/>
+          </a:ln>
+        </p:spPr>
+      </p:sp>
+      <p:sp>
+        <p:nvSpPr>
+          <p:cNvPr id="5" name="norma 1 circle"/>
+          <p:cNvSpPr/>
+          <p:nvPr/>
+        </p:nvSpPr>
+        <p:spPr>
+          <a:xfrm>
+            <a:off x="868680" y="3017520"/>
+            <a:ext cx="777240" cy="777240"/>
+          </a:xfrm>
+          <a:prstGeom prst="ellipse">
+            <a:avLst/>
+          </a:prstGeom>
+          <a:solidFill>
+            <a:srgbClr val="1F5FAE"/>
           </a:solidFill>
           <a:ln w="12700">
             <a:solidFill>
-              <a:srgbClr val="EEF3F4"/>
-            </a:solidFill>
-            <a:prstDash val="solid"/>
-          </a:ln>
-          <a:effectLst>
-            <a:outerShdw sx="100000" sy="100000" kx="0" ky="0" algn="bl" rotWithShape="0" blurRad="76200" dist="25400" dir="5400000">
-              <a:srgbClr val="000000">
-                <a:alpha val="12000"/>
-              </a:srgbClr>
-            </a:outerShdw>
-          </a:effectLst>
-        </p:spPr>
-      </p:sp>
-      <p:sp>
-        <p:nvSpPr>
-          <p:cNvPr id="5" name="norma 1 circle"/>
-          <p:cNvSpPr/>
-          <p:nvPr/>
-        </p:nvSpPr>
-        <p:spPr>
-          <a:xfrm>
-            <a:off x="868680" y="3017520"/>
-            <a:ext cx="777240" cy="777240"/>
-          </a:xfrm>
-          <a:prstGeom prst="ellipse">
-            <a:avLst/>
-          </a:prstGeom>
-          <a:solidFill>
-            <a:srgbClr val="1D6F7A"/>
-          </a:solidFill>
-          <a:ln w="12700">
-            <a:solidFill>
-              <a:srgbClr val="1D6F7A"/>
+              <a:srgbClr val="1F5FAE"/>
             </a:solidFill>
             <a:prstDash val="solid"/>
           </a:ln>
@@ -5650,43 +5601,36 @@
             </a:avLst>
           </a:prstGeom>
           <a:solidFill>
-            <a:srgbClr val="EEF3F4"/>
+            <a:srgbClr val="F4F7FB"/>
+          </a:solidFill>
+          <a:ln w="9525">
+            <a:solidFill>
+              <a:srgbClr val="DCE5F0"/>
+            </a:solidFill>
+            <a:prstDash val="solid"/>
+          </a:ln>
+        </p:spPr>
+      </p:sp>
+      <p:sp>
+        <p:nvSpPr>
+          <p:cNvPr id="10" name="norma 2 circle"/>
+          <p:cNvSpPr/>
+          <p:nvPr/>
+        </p:nvSpPr>
+        <p:spPr>
+          <a:xfrm>
+            <a:off x="3931920" y="3017520"/>
+            <a:ext cx="777240" cy="777240"/>
+          </a:xfrm>
+          <a:prstGeom prst="ellipse">
+            <a:avLst/>
+          </a:prstGeom>
+          <a:solidFill>
+            <a:srgbClr val="1F5FAE"/>
           </a:solidFill>
           <a:ln w="12700">
             <a:solidFill>
-              <a:srgbClr val="EEF3F4"/>
-            </a:solidFill>
-            <a:prstDash val="solid"/>
-          </a:ln>
-          <a:effectLst>
-            <a:outerShdw sx="100000" sy="100000" kx="0" ky="0" algn="bl" rotWithShape="0" blurRad="76200" dist="25400" dir="5400000">
-              <a:srgbClr val="000000">
-                <a:alpha val="12000"/>
-              </a:srgbClr>
-            </a:outerShdw>
-          </a:effectLst>
-        </p:spPr>
-      </p:sp>
-      <p:sp>
-        <p:nvSpPr>
-          <p:cNvPr id="10" name="norma 2 circle"/>
-          <p:cNvSpPr/>
-          <p:nvPr/>
-        </p:nvSpPr>
-        <p:spPr>
-          <a:xfrm>
-            <a:off x="3931920" y="3017520"/>
-            <a:ext cx="777240" cy="777240"/>
-          </a:xfrm>
-          <a:prstGeom prst="ellipse">
-            <a:avLst/>
-          </a:prstGeom>
-          <a:solidFill>
-            <a:srgbClr val="1D6F7A"/>
-          </a:solidFill>
-          <a:ln w="12700">
-            <a:solidFill>
-              <a:srgbClr val="1D6F7A"/>
+              <a:srgbClr val="1F5FAE"/>
             </a:solidFill>
             <a:prstDash val="solid"/>
           </a:ln>
@@ -5844,11 +5788,11 @@
             </a:avLst>
           </a:prstGeom>
           <a:solidFill>
-            <a:srgbClr val="1D6F7A"/>
+            <a:srgbClr val="1F5FAE"/>
           </a:solidFill>
           <a:ln w="12700">
             <a:solidFill>
-              <a:srgbClr val="1D6F7A"/>
+              <a:srgbClr val="1F5FAE"/>
             </a:solidFill>
             <a:prstDash val="solid"/>
           </a:ln>
@@ -5895,7 +5839,7 @@
             <a:r>
               <a:rPr lang="en-US" sz="1400" dirty="0">
                 <a:solidFill>
-                  <a:srgbClr val="9FC3C9"/>
+                  <a:srgbClr val="C9DBF2"/>
                 </a:solidFill>
               </a:rPr>
               <a:t>Autoriza la Política</a:t>
@@ -5921,11 +5865,11 @@
             </a:avLst>
           </a:prstGeom>
           <a:solidFill>
-            <a:srgbClr val="123642"/>
+            <a:srgbClr val="0A2A5C"/>
           </a:solidFill>
           <a:ln w="12700">
             <a:solidFill>
-              <a:srgbClr val="123642"/>
+              <a:srgbClr val="0A2A5C"/>
             </a:solidFill>
             <a:prstDash val="solid"/>
           </a:ln>
@@ -5972,7 +5916,7 @@
             <a:r>
               <a:rPr lang="en-US" sz="1400" dirty="0">
                 <a:solidFill>
-                  <a:srgbClr val="9FC3C9"/>
+                  <a:srgbClr val="C9DBF2"/>
                 </a:solidFill>
               </a:rPr>
               <a:t>Aprobación</a:t>
@@ -6130,21 +6074,14 @@
             </a:avLst>
           </a:prstGeom>
           <a:solidFill>
-            <a:srgbClr val="EEF3F4"/>
+            <a:srgbClr val="F4F7FB"/>
           </a:solidFill>
-          <a:ln w="12700">
+          <a:ln w="9525">
             <a:solidFill>
-              <a:srgbClr val="EEF3F4"/>
+              <a:srgbClr val="DCE5F0"/>
             </a:solidFill>
             <a:prstDash val="solid"/>
           </a:ln>
-          <a:effectLst>
-            <a:outerShdw sx="100000" sy="100000" kx="0" ky="0" algn="bl" rotWithShape="0" blurRad="76200" dist="25400" dir="5400000">
-              <a:srgbClr val="000000">
-                <a:alpha val="12000"/>
-              </a:srgbClr>
-            </a:outerShdw>
-          </a:effectLst>
         </p:spPr>
       </p:sp>
       <p:sp>
@@ -6174,7 +6111,7 @@
             <a:r>
               <a:rPr lang="en-US" sz="7200" b="1" dirty="0">
                 <a:solidFill>
-                  <a:schemeClr val="accent2"/>
+                  <a:schemeClr val="accent1"/>
                 </a:solidFill>
                 <a:latin typeface="Cambria" pitchFamily="34" charset="0"/>
                 <a:ea typeface="Cambria" pitchFamily="34" charset="-122"/>
@@ -6216,7 +6153,7 @@
             <a:r>
               <a:rPr lang="en-US" sz="1800" b="1" dirty="0">
                 <a:solidFill>
-                  <a:srgbClr val="123642"/>
+                  <a:srgbClr val="0A2A5C"/>
                 </a:solidFill>
               </a:rPr>
               <a:t>Contratar en cumplimiento a la NRP – 27 artículo 40 que establece lo siguiente: </a:t>
@@ -6420,21 +6357,14 @@
             </a:avLst>
           </a:prstGeom>
           <a:solidFill>
-            <a:srgbClr val="EEF3F4"/>
+            <a:srgbClr val="F4F7FB"/>
           </a:solidFill>
-          <a:ln w="12700">
+          <a:ln w="9525">
             <a:solidFill>
-              <a:srgbClr val="EEF3F4"/>
+              <a:srgbClr val="DCE5F0"/>
             </a:solidFill>
             <a:prstDash val="solid"/>
           </a:ln>
-          <a:effectLst>
-            <a:outerShdw sx="100000" sy="100000" kx="0" ky="0" algn="bl" rotWithShape="0" blurRad="76200" dist="25400" dir="5400000">
-              <a:srgbClr val="000000">
-                <a:alpha val="12000"/>
-              </a:srgbClr>
-            </a:outerShdw>
-          </a:effectLst>
         </p:spPr>
       </p:sp>
       <p:sp>
@@ -6650,11 +6580,11 @@
             </a:avLst>
           </a:prstGeom>
           <a:solidFill>
-            <a:srgbClr val="5B7C86"/>
+            <a:srgbClr val="5F7590"/>
           </a:solidFill>
           <a:ln w="12700">
             <a:solidFill>
-              <a:srgbClr val="5B7C86"/>
+              <a:srgbClr val="5F7590"/>
             </a:solidFill>
             <a:prstDash val="solid"/>
           </a:ln>
@@ -6713,7 +6643,7 @@
           <a:noFill/>
           <a:ln w="25400">
             <a:solidFill>
-              <a:srgbClr val="5B7C86"/>
+              <a:srgbClr val="5F7590"/>
             </a:solidFill>
             <a:prstDash val="solid"/>
           </a:ln>
@@ -6736,11 +6666,11 @@
             </a:avLst>
           </a:prstGeom>
           <a:solidFill>
-            <a:srgbClr val="1D6F7A"/>
+            <a:srgbClr val="1F5FAE"/>
           </a:solidFill>
           <a:ln w="12700">
             <a:solidFill>
-              <a:srgbClr val="1D6F7A"/>
+              <a:srgbClr val="1F5FAE"/>
             </a:solidFill>
             <a:prstDash val="solid"/>
           </a:ln>
@@ -6799,7 +6729,7 @@
           <a:noFill/>
           <a:ln w="25400">
             <a:solidFill>
-              <a:srgbClr val="5B7C86"/>
+              <a:srgbClr val="5F7590"/>
             </a:solidFill>
             <a:prstDash val="solid"/>
           </a:ln>
@@ -6822,11 +6752,11 @@
             </a:avLst>
           </a:prstGeom>
           <a:solidFill>
-            <a:srgbClr val="123642"/>
+            <a:srgbClr val="0A2A5C"/>
           </a:solidFill>
           <a:ln w="12700">
             <a:solidFill>
-              <a:srgbClr val="123642"/>
+              <a:srgbClr val="0A2A5C"/>
             </a:solidFill>
             <a:prstDash val="solid"/>
           </a:ln>
@@ -7027,11 +6957,11 @@
             <a:avLst/>
           </a:prstGeom>
           <a:solidFill>
-            <a:srgbClr val="E3A72F"/>
+            <a:srgbClr val="9CC3F0"/>
           </a:solidFill>
           <a:ln w="12700">
             <a:solidFill>
-              <a:srgbClr val="E3A72F"/>
+              <a:srgbClr val="9CC3F0"/>
             </a:solidFill>
             <a:prstDash val="solid"/>
           </a:ln>
@@ -7112,11 +7042,11 @@
             <a:avLst/>
           </a:prstGeom>
           <a:solidFill>
-            <a:srgbClr val="E3A72F"/>
+            <a:srgbClr val="9CC3F0"/>
           </a:solidFill>
           <a:ln w="12700">
             <a:solidFill>
-              <a:srgbClr val="E3A72F"/>
+              <a:srgbClr val="9CC3F0"/>
             </a:solidFill>
             <a:prstDash val="solid"/>
           </a:ln>
@@ -7197,11 +7127,11 @@
             <a:avLst/>
           </a:prstGeom>
           <a:solidFill>
-            <a:srgbClr val="E3A72F"/>
+            <a:srgbClr val="9CC3F0"/>
           </a:solidFill>
           <a:ln w="12700">
             <a:solidFill>
-              <a:srgbClr val="E3A72F"/>
+              <a:srgbClr val="9CC3F0"/>
             </a:solidFill>
             <a:prstDash val="solid"/>
           </a:ln>
@@ -7422,43 +7352,36 @@
             </a:avLst>
           </a:prstGeom>
           <a:solidFill>
-            <a:srgbClr val="EEF3F4"/>
+            <a:srgbClr val="F4F7FB"/>
+          </a:solidFill>
+          <a:ln w="9525">
+            <a:solidFill>
+              <a:srgbClr val="DCE5F0"/>
+            </a:solidFill>
+            <a:prstDash val="solid"/>
+          </a:ln>
+        </p:spPr>
+      </p:sp>
+      <p:sp>
+        <p:nvSpPr>
+          <p:cNvPr id="4" name="agenda 1 circle"/>
+          <p:cNvSpPr/>
+          <p:nvPr/>
+        </p:nvSpPr>
+        <p:spPr>
+          <a:xfrm>
+            <a:off x="868680" y="2103120"/>
+            <a:ext cx="868680" cy="868680"/>
+          </a:xfrm>
+          <a:prstGeom prst="ellipse">
+            <a:avLst/>
+          </a:prstGeom>
+          <a:solidFill>
+            <a:srgbClr val="1F5FAE"/>
           </a:solidFill>
           <a:ln w="12700">
             <a:solidFill>
-              <a:srgbClr val="EEF3F4"/>
-            </a:solidFill>
-            <a:prstDash val="solid"/>
-          </a:ln>
-          <a:effectLst>
-            <a:outerShdw sx="100000" sy="100000" kx="0" ky="0" algn="bl" rotWithShape="0" blurRad="76200" dist="25400" dir="5400000">
-              <a:srgbClr val="000000">
-                <a:alpha val="12000"/>
-              </a:srgbClr>
-            </a:outerShdw>
-          </a:effectLst>
-        </p:spPr>
-      </p:sp>
-      <p:sp>
-        <p:nvSpPr>
-          <p:cNvPr id="4" name="agenda 1 circle"/>
-          <p:cNvSpPr/>
-          <p:nvPr/>
-        </p:nvSpPr>
-        <p:spPr>
-          <a:xfrm>
-            <a:off x="868680" y="2103120"/>
-            <a:ext cx="868680" cy="868680"/>
-          </a:xfrm>
-          <a:prstGeom prst="ellipse">
-            <a:avLst/>
-          </a:prstGeom>
-          <a:solidFill>
-            <a:srgbClr val="1D6F7A"/>
-          </a:solidFill>
-          <a:ln w="12700">
-            <a:solidFill>
-              <a:srgbClr val="1D6F7A"/>
+              <a:srgbClr val="1F5FAE"/>
             </a:solidFill>
             <a:prstDash val="solid"/>
           </a:ln>
@@ -7619,43 +7542,36 @@
             </a:avLst>
           </a:prstGeom>
           <a:solidFill>
-            <a:srgbClr val="EEF3F4"/>
+            <a:srgbClr val="F4F7FB"/>
+          </a:solidFill>
+          <a:ln w="9525">
+            <a:solidFill>
+              <a:srgbClr val="DCE5F0"/>
+            </a:solidFill>
+            <a:prstDash val="solid"/>
+          </a:ln>
+        </p:spPr>
+      </p:sp>
+      <p:sp>
+        <p:nvSpPr>
+          <p:cNvPr id="10" name="agenda 2 circle"/>
+          <p:cNvSpPr/>
+          <p:nvPr/>
+        </p:nvSpPr>
+        <p:spPr>
+          <a:xfrm>
+            <a:off x="3703320" y="2103120"/>
+            <a:ext cx="868680" cy="868680"/>
+          </a:xfrm>
+          <a:prstGeom prst="ellipse">
+            <a:avLst/>
+          </a:prstGeom>
+          <a:solidFill>
+            <a:srgbClr val="1F5FAE"/>
           </a:solidFill>
           <a:ln w="12700">
             <a:solidFill>
-              <a:srgbClr val="EEF3F4"/>
-            </a:solidFill>
-            <a:prstDash val="solid"/>
-          </a:ln>
-          <a:effectLst>
-            <a:outerShdw sx="100000" sy="100000" kx="0" ky="0" algn="bl" rotWithShape="0" blurRad="76200" dist="25400" dir="5400000">
-              <a:srgbClr val="000000">
-                <a:alpha val="12000"/>
-              </a:srgbClr>
-            </a:outerShdw>
-          </a:effectLst>
-        </p:spPr>
-      </p:sp>
-      <p:sp>
-        <p:nvSpPr>
-          <p:cNvPr id="10" name="agenda 2 circle"/>
-          <p:cNvSpPr/>
-          <p:nvPr/>
-        </p:nvSpPr>
-        <p:spPr>
-          <a:xfrm>
-            <a:off x="3703320" y="2103120"/>
-            <a:ext cx="868680" cy="868680"/>
-          </a:xfrm>
-          <a:prstGeom prst="ellipse">
-            <a:avLst/>
-          </a:prstGeom>
-          <a:solidFill>
-            <a:srgbClr val="1D6F7A"/>
-          </a:solidFill>
-          <a:ln w="12700">
-            <a:solidFill>
-              <a:srgbClr val="1D6F7A"/>
+              <a:srgbClr val="1F5FAE"/>
             </a:solidFill>
             <a:prstDash val="solid"/>
           </a:ln>
@@ -7816,43 +7732,36 @@
             </a:avLst>
           </a:prstGeom>
           <a:solidFill>
-            <a:srgbClr val="EEF3F4"/>
+            <a:srgbClr val="F4F7FB"/>
+          </a:solidFill>
+          <a:ln w="9525">
+            <a:solidFill>
+              <a:srgbClr val="DCE5F0"/>
+            </a:solidFill>
+            <a:prstDash val="solid"/>
+          </a:ln>
+        </p:spPr>
+      </p:sp>
+      <p:sp>
+        <p:nvSpPr>
+          <p:cNvPr id="16" name="agenda 3 circle"/>
+          <p:cNvSpPr/>
+          <p:nvPr/>
+        </p:nvSpPr>
+        <p:spPr>
+          <a:xfrm>
+            <a:off x="6537960" y="2103120"/>
+            <a:ext cx="868680" cy="868680"/>
+          </a:xfrm>
+          <a:prstGeom prst="ellipse">
+            <a:avLst/>
+          </a:prstGeom>
+          <a:solidFill>
+            <a:srgbClr val="164A8F"/>
           </a:solidFill>
           <a:ln w="12700">
             <a:solidFill>
-              <a:srgbClr val="EEF3F4"/>
-            </a:solidFill>
-            <a:prstDash val="solid"/>
-          </a:ln>
-          <a:effectLst>
-            <a:outerShdw sx="100000" sy="100000" kx="0" ky="0" algn="bl" rotWithShape="0" blurRad="76200" dist="25400" dir="5400000">
-              <a:srgbClr val="000000">
-                <a:alpha val="12000"/>
-              </a:srgbClr>
-            </a:outerShdw>
-          </a:effectLst>
-        </p:spPr>
-      </p:sp>
-      <p:sp>
-        <p:nvSpPr>
-          <p:cNvPr id="16" name="agenda 3 circle"/>
-          <p:cNvSpPr/>
-          <p:nvPr/>
-        </p:nvSpPr>
-        <p:spPr>
-          <a:xfrm>
-            <a:off x="6537960" y="2103120"/>
-            <a:ext cx="868680" cy="868680"/>
-          </a:xfrm>
-          <a:prstGeom prst="ellipse">
-            <a:avLst/>
-          </a:prstGeom>
-          <a:solidFill>
-            <a:srgbClr val="C0392B"/>
-          </a:solidFill>
-          <a:ln w="12700">
-            <a:solidFill>
-              <a:srgbClr val="C0392B"/>
+              <a:srgbClr val="164A8F"/>
             </a:solidFill>
             <a:prstDash val="solid"/>
           </a:ln>
@@ -8013,43 +7922,36 @@
             </a:avLst>
           </a:prstGeom>
           <a:solidFill>
-            <a:srgbClr val="EEF3F4"/>
+            <a:srgbClr val="F4F7FB"/>
+          </a:solidFill>
+          <a:ln w="9525">
+            <a:solidFill>
+              <a:srgbClr val="DCE5F0"/>
+            </a:solidFill>
+            <a:prstDash val="solid"/>
+          </a:ln>
+        </p:spPr>
+      </p:sp>
+      <p:sp>
+        <p:nvSpPr>
+          <p:cNvPr id="22" name="agenda 4 circle"/>
+          <p:cNvSpPr/>
+          <p:nvPr/>
+        </p:nvSpPr>
+        <p:spPr>
+          <a:xfrm>
+            <a:off x="9372600" y="2103120"/>
+            <a:ext cx="868680" cy="868680"/>
+          </a:xfrm>
+          <a:prstGeom prst="ellipse">
+            <a:avLst/>
+          </a:prstGeom>
+          <a:solidFill>
+            <a:srgbClr val="1F5FAE"/>
           </a:solidFill>
           <a:ln w="12700">
             <a:solidFill>
-              <a:srgbClr val="EEF3F4"/>
-            </a:solidFill>
-            <a:prstDash val="solid"/>
-          </a:ln>
-          <a:effectLst>
-            <a:outerShdw sx="100000" sy="100000" kx="0" ky="0" algn="bl" rotWithShape="0" blurRad="76200" dist="25400" dir="5400000">
-              <a:srgbClr val="000000">
-                <a:alpha val="12000"/>
-              </a:srgbClr>
-            </a:outerShdw>
-          </a:effectLst>
-        </p:spPr>
-      </p:sp>
-      <p:sp>
-        <p:nvSpPr>
-          <p:cNvPr id="22" name="agenda 4 circle"/>
-          <p:cNvSpPr/>
-          <p:nvPr/>
-        </p:nvSpPr>
-        <p:spPr>
-          <a:xfrm>
-            <a:off x="9372600" y="2103120"/>
-            <a:ext cx="868680" cy="868680"/>
-          </a:xfrm>
-          <a:prstGeom prst="ellipse">
-            <a:avLst/>
-          </a:prstGeom>
-          <a:solidFill>
-            <a:srgbClr val="1D6F7A"/>
-          </a:solidFill>
-          <a:ln w="12700">
-            <a:solidFill>
-              <a:srgbClr val="1D6F7A"/>
+              <a:srgbClr val="1F5FAE"/>
             </a:solidFill>
             <a:prstDash val="solid"/>
           </a:ln>
@@ -8464,43 +8366,36 @@
             </a:avLst>
           </a:prstGeom>
           <a:solidFill>
-            <a:srgbClr val="EEF3F4"/>
+            <a:srgbClr val="F4F7FB"/>
+          </a:solidFill>
+          <a:ln w="9525">
+            <a:solidFill>
+              <a:srgbClr val="DCE5F0"/>
+            </a:solidFill>
+            <a:prstDash val="solid"/>
+          </a:ln>
+        </p:spPr>
+      </p:sp>
+      <p:sp>
+        <p:nvSpPr>
+          <p:cNvPr id="4" name="gerencia 1 circle"/>
+          <p:cNvSpPr/>
+          <p:nvPr/>
+        </p:nvSpPr>
+        <p:spPr>
+          <a:xfrm>
+            <a:off x="868680" y="1737360"/>
+            <a:ext cx="777240" cy="777240"/>
+          </a:xfrm>
+          <a:prstGeom prst="ellipse">
+            <a:avLst/>
+          </a:prstGeom>
+          <a:solidFill>
+            <a:srgbClr val="1F5FAE"/>
           </a:solidFill>
           <a:ln w="12700">
             <a:solidFill>
-              <a:srgbClr val="EEF3F4"/>
-            </a:solidFill>
-            <a:prstDash val="solid"/>
-          </a:ln>
-          <a:effectLst>
-            <a:outerShdw sx="100000" sy="100000" kx="0" ky="0" algn="bl" rotWithShape="0" blurRad="76200" dist="25400" dir="5400000">
-              <a:srgbClr val="000000">
-                <a:alpha val="12000"/>
-              </a:srgbClr>
-            </a:outerShdw>
-          </a:effectLst>
-        </p:spPr>
-      </p:sp>
-      <p:sp>
-        <p:nvSpPr>
-          <p:cNvPr id="4" name="gerencia 1 circle"/>
-          <p:cNvSpPr/>
-          <p:nvPr/>
-        </p:nvSpPr>
-        <p:spPr>
-          <a:xfrm>
-            <a:off x="868680" y="1737360"/>
-            <a:ext cx="777240" cy="777240"/>
-          </a:xfrm>
-          <a:prstGeom prst="ellipse">
-            <a:avLst/>
-          </a:prstGeom>
-          <a:solidFill>
-            <a:srgbClr val="1D6F7A"/>
-          </a:solidFill>
-          <a:ln w="12700">
-            <a:solidFill>
-              <a:srgbClr val="1D6F7A"/>
+              <a:srgbClr val="1F5FAE"/>
             </a:solidFill>
             <a:prstDash val="solid"/>
           </a:ln>
@@ -8697,43 +8592,36 @@
             </a:avLst>
           </a:prstGeom>
           <a:solidFill>
-            <a:srgbClr val="EEF3F4"/>
+            <a:srgbClr val="F4F7FB"/>
+          </a:solidFill>
+          <a:ln w="9525">
+            <a:solidFill>
+              <a:srgbClr val="DCE5F0"/>
+            </a:solidFill>
+            <a:prstDash val="solid"/>
+          </a:ln>
+        </p:spPr>
+      </p:sp>
+      <p:sp>
+        <p:nvSpPr>
+          <p:cNvPr id="11" name="gerencia 2 circle"/>
+          <p:cNvSpPr/>
+          <p:nvPr/>
+        </p:nvSpPr>
+        <p:spPr>
+          <a:xfrm>
+            <a:off x="3703320" y="1737360"/>
+            <a:ext cx="777240" cy="777240"/>
+          </a:xfrm>
+          <a:prstGeom prst="ellipse">
+            <a:avLst/>
+          </a:prstGeom>
+          <a:solidFill>
+            <a:srgbClr val="1F5FAE"/>
           </a:solidFill>
           <a:ln w="12700">
             <a:solidFill>
-              <a:srgbClr val="EEF3F4"/>
-            </a:solidFill>
-            <a:prstDash val="solid"/>
-          </a:ln>
-          <a:effectLst>
-            <a:outerShdw sx="100000" sy="100000" kx="0" ky="0" algn="bl" rotWithShape="0" blurRad="76200" dist="25400" dir="5400000">
-              <a:srgbClr val="000000">
-                <a:alpha val="12000"/>
-              </a:srgbClr>
-            </a:outerShdw>
-          </a:effectLst>
-        </p:spPr>
-      </p:sp>
-      <p:sp>
-        <p:nvSpPr>
-          <p:cNvPr id="11" name="gerencia 2 circle"/>
-          <p:cNvSpPr/>
-          <p:nvPr/>
-        </p:nvSpPr>
-        <p:spPr>
-          <a:xfrm>
-            <a:off x="3703320" y="1737360"/>
-            <a:ext cx="777240" cy="777240"/>
-          </a:xfrm>
-          <a:prstGeom prst="ellipse">
-            <a:avLst/>
-          </a:prstGeom>
-          <a:solidFill>
-            <a:srgbClr val="1D6F7A"/>
-          </a:solidFill>
-          <a:ln w="12700">
-            <a:solidFill>
-              <a:srgbClr val="1D6F7A"/>
+              <a:srgbClr val="1F5FAE"/>
             </a:solidFill>
             <a:prstDash val="solid"/>
           </a:ln>
@@ -8930,43 +8818,36 @@
             </a:avLst>
           </a:prstGeom>
           <a:solidFill>
-            <a:srgbClr val="EEF3F4"/>
+            <a:srgbClr val="F4F7FB"/>
+          </a:solidFill>
+          <a:ln w="9525">
+            <a:solidFill>
+              <a:srgbClr val="DCE5F0"/>
+            </a:solidFill>
+            <a:prstDash val="solid"/>
+          </a:ln>
+        </p:spPr>
+      </p:sp>
+      <p:sp>
+        <p:nvSpPr>
+          <p:cNvPr id="18" name="gerencia 3 circle"/>
+          <p:cNvSpPr/>
+          <p:nvPr/>
+        </p:nvSpPr>
+        <p:spPr>
+          <a:xfrm>
+            <a:off x="6537960" y="1737360"/>
+            <a:ext cx="777240" cy="777240"/>
+          </a:xfrm>
+          <a:prstGeom prst="ellipse">
+            <a:avLst/>
+          </a:prstGeom>
+          <a:solidFill>
+            <a:srgbClr val="1F5FAE"/>
           </a:solidFill>
           <a:ln w="12700">
             <a:solidFill>
-              <a:srgbClr val="EEF3F4"/>
-            </a:solidFill>
-            <a:prstDash val="solid"/>
-          </a:ln>
-          <a:effectLst>
-            <a:outerShdw sx="100000" sy="100000" kx="0" ky="0" algn="bl" rotWithShape="0" blurRad="76200" dist="25400" dir="5400000">
-              <a:srgbClr val="000000">
-                <a:alpha val="12000"/>
-              </a:srgbClr>
-            </a:outerShdw>
-          </a:effectLst>
-        </p:spPr>
-      </p:sp>
-      <p:sp>
-        <p:nvSpPr>
-          <p:cNvPr id="18" name="gerencia 3 circle"/>
-          <p:cNvSpPr/>
-          <p:nvPr/>
-        </p:nvSpPr>
-        <p:spPr>
-          <a:xfrm>
-            <a:off x="6537960" y="1737360"/>
-            <a:ext cx="777240" cy="777240"/>
-          </a:xfrm>
-          <a:prstGeom prst="ellipse">
-            <a:avLst/>
-          </a:prstGeom>
-          <a:solidFill>
-            <a:srgbClr val="1D6F7A"/>
-          </a:solidFill>
-          <a:ln w="12700">
-            <a:solidFill>
-              <a:srgbClr val="1D6F7A"/>
+              <a:srgbClr val="1F5FAE"/>
             </a:solidFill>
             <a:prstDash val="solid"/>
           </a:ln>
@@ -9163,43 +9044,36 @@
             </a:avLst>
           </a:prstGeom>
           <a:solidFill>
-            <a:srgbClr val="EEF3F4"/>
+            <a:srgbClr val="F4F7FB"/>
+          </a:solidFill>
+          <a:ln w="9525">
+            <a:solidFill>
+              <a:srgbClr val="DCE5F0"/>
+            </a:solidFill>
+            <a:prstDash val="solid"/>
+          </a:ln>
+        </p:spPr>
+      </p:sp>
+      <p:sp>
+        <p:nvSpPr>
+          <p:cNvPr id="25" name="gerencia 4 circle"/>
+          <p:cNvSpPr/>
+          <p:nvPr/>
+        </p:nvSpPr>
+        <p:spPr>
+          <a:xfrm>
+            <a:off x="9372600" y="1737360"/>
+            <a:ext cx="777240" cy="777240"/>
+          </a:xfrm>
+          <a:prstGeom prst="ellipse">
+            <a:avLst/>
+          </a:prstGeom>
+          <a:solidFill>
+            <a:srgbClr val="1F5FAE"/>
           </a:solidFill>
           <a:ln w="12700">
             <a:solidFill>
-              <a:srgbClr val="EEF3F4"/>
-            </a:solidFill>
-            <a:prstDash val="solid"/>
-          </a:ln>
-          <a:effectLst>
-            <a:outerShdw sx="100000" sy="100000" kx="0" ky="0" algn="bl" rotWithShape="0" blurRad="76200" dist="25400" dir="5400000">
-              <a:srgbClr val="000000">
-                <a:alpha val="12000"/>
-              </a:srgbClr>
-            </a:outerShdw>
-          </a:effectLst>
-        </p:spPr>
-      </p:sp>
-      <p:sp>
-        <p:nvSpPr>
-          <p:cNvPr id="25" name="gerencia 4 circle"/>
-          <p:cNvSpPr/>
-          <p:nvPr/>
-        </p:nvSpPr>
-        <p:spPr>
-          <a:xfrm>
-            <a:off x="9372600" y="1737360"/>
-            <a:ext cx="777240" cy="777240"/>
-          </a:xfrm>
-          <a:prstGeom prst="ellipse">
-            <a:avLst/>
-          </a:prstGeom>
-          <a:solidFill>
-            <a:srgbClr val="1D6F7A"/>
-          </a:solidFill>
-          <a:ln w="12700">
-            <a:solidFill>
-              <a:srgbClr val="1D6F7A"/>
+              <a:srgbClr val="1F5FAE"/>
             </a:solidFill>
             <a:prstDash val="solid"/>
           </a:ln>
@@ -9549,11 +9423,11 @@
             <a:avLst/>
           </a:prstGeom>
           <a:solidFill>
-            <a:srgbClr val="EEF3F4"/>
+            <a:srgbClr val="F4F7FB"/>
           </a:solidFill>
           <a:ln w="12700">
             <a:solidFill>
-              <a:srgbClr val="EEF3F4"/>
+              <a:srgbClr val="F4F7FB"/>
             </a:solidFill>
             <a:prstDash val="solid"/>
           </a:ln>
@@ -9645,11 +9519,11 @@
             <a:avLst/>
           </a:prstGeom>
           <a:solidFill>
-            <a:srgbClr val="EEF3F4"/>
+            <a:srgbClr val="F4F7FB"/>
           </a:solidFill>
           <a:ln w="12700">
             <a:solidFill>
-              <a:srgbClr val="EEF3F4"/>
+              <a:srgbClr val="F4F7FB"/>
             </a:solidFill>
             <a:prstDash val="solid"/>
           </a:ln>
@@ -9741,11 +9615,11 @@
             <a:avLst/>
           </a:prstGeom>
           <a:solidFill>
-            <a:srgbClr val="EEF3F4"/>
+            <a:srgbClr val="F4F7FB"/>
           </a:solidFill>
           <a:ln w="12700">
             <a:solidFill>
-              <a:srgbClr val="EEF3F4"/>
+              <a:srgbClr val="F4F7FB"/>
             </a:solidFill>
             <a:prstDash val="solid"/>
           </a:ln>
@@ -9837,11 +9711,11 @@
             <a:avLst/>
           </a:prstGeom>
           <a:solidFill>
-            <a:srgbClr val="EEF3F4"/>
+            <a:srgbClr val="F4F7FB"/>
           </a:solidFill>
           <a:ln w="12700">
             <a:solidFill>
-              <a:srgbClr val="EEF3F4"/>
+              <a:srgbClr val="F4F7FB"/>
             </a:solidFill>
             <a:prstDash val="solid"/>
           </a:ln>
@@ -9935,21 +9809,14 @@
             </a:avLst>
           </a:prstGeom>
           <a:solidFill>
-            <a:srgbClr val="123642"/>
+            <a:srgbClr val="0A2A5C"/>
           </a:solidFill>
-          <a:ln w="12700">
+          <a:ln w="9525">
             <a:solidFill>
-              <a:srgbClr val="123642"/>
+              <a:srgbClr val="0A2A5C"/>
             </a:solidFill>
             <a:prstDash val="solid"/>
           </a:ln>
-          <a:effectLst>
-            <a:outerShdw sx="100000" sy="100000" kx="0" ky="0" algn="bl" rotWithShape="0" blurRad="76200" dist="25400" dir="5400000">
-              <a:srgbClr val="000000">
-                <a:alpha val="12000"/>
-              </a:srgbClr>
-            </a:outerShdw>
-          </a:effectLst>
         </p:spPr>
       </p:sp>
       <p:sp>
@@ -10188,43 +10055,36 @@
             </a:avLst>
           </a:prstGeom>
           <a:solidFill>
-            <a:srgbClr val="EEF3F4"/>
+            <a:srgbClr val="F4F7FB"/>
+          </a:solidFill>
+          <a:ln w="9525">
+            <a:solidFill>
+              <a:srgbClr val="DCE5F0"/>
+            </a:solidFill>
+            <a:prstDash val="solid"/>
+          </a:ln>
+        </p:spPr>
+      </p:sp>
+      <p:sp>
+        <p:nvSpPr>
+          <p:cNvPr id="4" name="columna 1 circle"/>
+          <p:cNvSpPr/>
+          <p:nvPr/>
+        </p:nvSpPr>
+        <p:spPr>
+          <a:xfrm>
+            <a:off x="914400" y="1691640"/>
+            <a:ext cx="731520" cy="731520"/>
+          </a:xfrm>
+          <a:prstGeom prst="ellipse">
+            <a:avLst/>
+          </a:prstGeom>
+          <a:solidFill>
+            <a:srgbClr val="1F5FAE"/>
           </a:solidFill>
           <a:ln w="12700">
             <a:solidFill>
-              <a:srgbClr val="EEF3F4"/>
-            </a:solidFill>
-            <a:prstDash val="solid"/>
-          </a:ln>
-          <a:effectLst>
-            <a:outerShdw sx="100000" sy="100000" kx="0" ky="0" algn="bl" rotWithShape="0" blurRad="76200" dist="25400" dir="5400000">
-              <a:srgbClr val="000000">
-                <a:alpha val="12000"/>
-              </a:srgbClr>
-            </a:outerShdw>
-          </a:effectLst>
-        </p:spPr>
-      </p:sp>
-      <p:sp>
-        <p:nvSpPr>
-          <p:cNvPr id="4" name="columna 1 circle"/>
-          <p:cNvSpPr/>
-          <p:nvPr/>
-        </p:nvSpPr>
-        <p:spPr>
-          <a:xfrm>
-            <a:off x="914400" y="1691640"/>
-            <a:ext cx="731520" cy="731520"/>
-          </a:xfrm>
-          <a:prstGeom prst="ellipse">
-            <a:avLst/>
-          </a:prstGeom>
-          <a:solidFill>
-            <a:srgbClr val="1D6F7A"/>
-          </a:solidFill>
-          <a:ln w="12700">
-            <a:solidFill>
-              <a:srgbClr val="1D6F7A"/>
+              <a:srgbClr val="1F5FAE"/>
             </a:solidFill>
             <a:prstDash val="solid"/>
           </a:ln>
@@ -10349,11 +10209,11 @@
             </a:avLst>
           </a:prstGeom>
           <a:solidFill>
-            <a:srgbClr val="123642"/>
+            <a:srgbClr val="0A2A5C"/>
           </a:solidFill>
           <a:ln w="12700">
             <a:solidFill>
-              <a:srgbClr val="123642"/>
+              <a:srgbClr val="0A2A5C"/>
             </a:solidFill>
             <a:prstDash val="solid"/>
           </a:ln>
@@ -10412,43 +10272,36 @@
             </a:avLst>
           </a:prstGeom>
           <a:solidFill>
-            <a:srgbClr val="EEF3F4"/>
+            <a:srgbClr val="F4F7FB"/>
+          </a:solidFill>
+          <a:ln w="9525">
+            <a:solidFill>
+              <a:srgbClr val="DCE5F0"/>
+            </a:solidFill>
+            <a:prstDash val="solid"/>
+          </a:ln>
+        </p:spPr>
+      </p:sp>
+      <p:sp>
+        <p:nvSpPr>
+          <p:cNvPr id="11" name="columna 2 circle"/>
+          <p:cNvSpPr/>
+          <p:nvPr/>
+        </p:nvSpPr>
+        <p:spPr>
+          <a:xfrm>
+            <a:off x="6629400" y="1691640"/>
+            <a:ext cx="731520" cy="731520"/>
+          </a:xfrm>
+          <a:prstGeom prst="ellipse">
+            <a:avLst/>
+          </a:prstGeom>
+          <a:solidFill>
+            <a:srgbClr val="1F5FAE"/>
           </a:solidFill>
           <a:ln w="12700">
             <a:solidFill>
-              <a:srgbClr val="EEF3F4"/>
-            </a:solidFill>
-            <a:prstDash val="solid"/>
-          </a:ln>
-          <a:effectLst>
-            <a:outerShdw sx="100000" sy="100000" kx="0" ky="0" algn="bl" rotWithShape="0" blurRad="76200" dist="25400" dir="5400000">
-              <a:srgbClr val="000000">
-                <a:alpha val="12000"/>
-              </a:srgbClr>
-            </a:outerShdw>
-          </a:effectLst>
-        </p:spPr>
-      </p:sp>
-      <p:sp>
-        <p:nvSpPr>
-          <p:cNvPr id="11" name="columna 2 circle"/>
-          <p:cNvSpPr/>
-          <p:nvPr/>
-        </p:nvSpPr>
-        <p:spPr>
-          <a:xfrm>
-            <a:off x="6629400" y="1691640"/>
-            <a:ext cx="731520" cy="731520"/>
-          </a:xfrm>
-          <a:prstGeom prst="ellipse">
-            <a:avLst/>
-          </a:prstGeom>
-          <a:solidFill>
-            <a:srgbClr val="1D6F7A"/>
-          </a:solidFill>
-          <a:ln w="12700">
-            <a:solidFill>
-              <a:srgbClr val="1D6F7A"/>
+              <a:srgbClr val="1F5FAE"/>
             </a:solidFill>
             <a:prstDash val="solid"/>
           </a:ln>
@@ -10590,11 +10443,11 @@
             </a:avLst>
           </a:prstGeom>
           <a:solidFill>
-            <a:srgbClr val="123642"/>
+            <a:srgbClr val="0A2A5C"/>
           </a:solidFill>
           <a:ln w="12700">
             <a:solidFill>
-              <a:srgbClr val="123642"/>
+              <a:srgbClr val="0A2A5C"/>
             </a:solidFill>
             <a:prstDash val="solid"/>
           </a:ln>
@@ -10797,43 +10650,36 @@
             </a:avLst>
           </a:prstGeom>
           <a:solidFill>
-            <a:srgbClr val="EEF3F4"/>
+            <a:srgbClr val="F4F7FB"/>
+          </a:solidFill>
+          <a:ln w="9525">
+            <a:solidFill>
+              <a:srgbClr val="DCE5F0"/>
+            </a:solidFill>
+            <a:prstDash val="solid"/>
+          </a:ln>
+        </p:spPr>
+      </p:sp>
+      <p:sp>
+        <p:nvSpPr>
+          <p:cNvPr id="5" name="actividad 1 circle"/>
+          <p:cNvSpPr/>
+          <p:nvPr/>
+        </p:nvSpPr>
+        <p:spPr>
+          <a:xfrm>
+            <a:off x="731520" y="1874520"/>
+            <a:ext cx="548640" cy="548640"/>
+          </a:xfrm>
+          <a:prstGeom prst="ellipse">
+            <a:avLst/>
+          </a:prstGeom>
+          <a:solidFill>
+            <a:srgbClr val="1F5FAE"/>
           </a:solidFill>
           <a:ln w="12700">
             <a:solidFill>
-              <a:srgbClr val="EEF3F4"/>
-            </a:solidFill>
-            <a:prstDash val="solid"/>
-          </a:ln>
-          <a:effectLst>
-            <a:outerShdw sx="100000" sy="100000" kx="0" ky="0" algn="bl" rotWithShape="0" blurRad="76200" dist="25400" dir="5400000">
-              <a:srgbClr val="000000">
-                <a:alpha val="12000"/>
-              </a:srgbClr>
-            </a:outerShdw>
-          </a:effectLst>
-        </p:spPr>
-      </p:sp>
-      <p:sp>
-        <p:nvSpPr>
-          <p:cNvPr id="5" name="actividad 1 circle"/>
-          <p:cNvSpPr/>
-          <p:nvPr/>
-        </p:nvSpPr>
-        <p:spPr>
-          <a:xfrm>
-            <a:off x="731520" y="1874520"/>
-            <a:ext cx="548640" cy="548640"/>
-          </a:xfrm>
-          <a:prstGeom prst="ellipse">
-            <a:avLst/>
-          </a:prstGeom>
-          <a:solidFill>
-            <a:srgbClr val="1D6F7A"/>
-          </a:solidFill>
-          <a:ln w="12700">
-            <a:solidFill>
-              <a:srgbClr val="1D6F7A"/>
+              <a:srgbClr val="1F5FAE"/>
             </a:solidFill>
             <a:prstDash val="solid"/>
           </a:ln>
@@ -10916,43 +10762,36 @@
             </a:avLst>
           </a:prstGeom>
           <a:solidFill>
-            <a:srgbClr val="EEF3F4"/>
+            <a:srgbClr val="F4F7FB"/>
+          </a:solidFill>
+          <a:ln w="9525">
+            <a:solidFill>
+              <a:srgbClr val="DCE5F0"/>
+            </a:solidFill>
+            <a:prstDash val="solid"/>
+          </a:ln>
+        </p:spPr>
+      </p:sp>
+      <p:sp>
+        <p:nvSpPr>
+          <p:cNvPr id="9" name="actividad 2 circle"/>
+          <p:cNvSpPr/>
+          <p:nvPr/>
+        </p:nvSpPr>
+        <p:spPr>
+          <a:xfrm>
+            <a:off x="4709160" y="1874520"/>
+            <a:ext cx="548640" cy="548640"/>
+          </a:xfrm>
+          <a:prstGeom prst="ellipse">
+            <a:avLst/>
+          </a:prstGeom>
+          <a:solidFill>
+            <a:srgbClr val="1F5FAE"/>
           </a:solidFill>
           <a:ln w="12700">
             <a:solidFill>
-              <a:srgbClr val="EEF3F4"/>
-            </a:solidFill>
-            <a:prstDash val="solid"/>
-          </a:ln>
-          <a:effectLst>
-            <a:outerShdw sx="100000" sy="100000" kx="0" ky="0" algn="bl" rotWithShape="0" blurRad="76200" dist="25400" dir="5400000">
-              <a:srgbClr val="000000">
-                <a:alpha val="12000"/>
-              </a:srgbClr>
-            </a:outerShdw>
-          </a:effectLst>
-        </p:spPr>
-      </p:sp>
-      <p:sp>
-        <p:nvSpPr>
-          <p:cNvPr id="9" name="actividad 2 circle"/>
-          <p:cNvSpPr/>
-          <p:nvPr/>
-        </p:nvSpPr>
-        <p:spPr>
-          <a:xfrm>
-            <a:off x="4709160" y="1874520"/>
-            <a:ext cx="548640" cy="548640"/>
-          </a:xfrm>
-          <a:prstGeom prst="ellipse">
-            <a:avLst/>
-          </a:prstGeom>
-          <a:solidFill>
-            <a:srgbClr val="1D6F7A"/>
-          </a:solidFill>
-          <a:ln w="12700">
-            <a:solidFill>
-              <a:srgbClr val="1D6F7A"/>
+              <a:srgbClr val="1F5FAE"/>
             </a:solidFill>
             <a:prstDash val="solid"/>
           </a:ln>
@@ -11035,43 +10874,36 @@
             </a:avLst>
           </a:prstGeom>
           <a:solidFill>
-            <a:srgbClr val="EEF3F4"/>
+            <a:srgbClr val="F4F7FB"/>
+          </a:solidFill>
+          <a:ln w="9525">
+            <a:solidFill>
+              <a:srgbClr val="DCE5F0"/>
+            </a:solidFill>
+            <a:prstDash val="solid"/>
+          </a:ln>
+        </p:spPr>
+      </p:sp>
+      <p:sp>
+        <p:nvSpPr>
+          <p:cNvPr id="13" name="actividad 3 circle"/>
+          <p:cNvSpPr/>
+          <p:nvPr/>
+        </p:nvSpPr>
+        <p:spPr>
+          <a:xfrm>
+            <a:off x="731520" y="2971800"/>
+            <a:ext cx="548640" cy="548640"/>
+          </a:xfrm>
+          <a:prstGeom prst="ellipse">
+            <a:avLst/>
+          </a:prstGeom>
+          <a:solidFill>
+            <a:srgbClr val="1F5FAE"/>
           </a:solidFill>
           <a:ln w="12700">
             <a:solidFill>
-              <a:srgbClr val="EEF3F4"/>
-            </a:solidFill>
-            <a:prstDash val="solid"/>
-          </a:ln>
-          <a:effectLst>
-            <a:outerShdw sx="100000" sy="100000" kx="0" ky="0" algn="bl" rotWithShape="0" blurRad="76200" dist="25400" dir="5400000">
-              <a:srgbClr val="000000">
-                <a:alpha val="12000"/>
-              </a:srgbClr>
-            </a:outerShdw>
-          </a:effectLst>
-        </p:spPr>
-      </p:sp>
-      <p:sp>
-        <p:nvSpPr>
-          <p:cNvPr id="13" name="actividad 3 circle"/>
-          <p:cNvSpPr/>
-          <p:nvPr/>
-        </p:nvSpPr>
-        <p:spPr>
-          <a:xfrm>
-            <a:off x="731520" y="2971800"/>
-            <a:ext cx="548640" cy="548640"/>
-          </a:xfrm>
-          <a:prstGeom prst="ellipse">
-            <a:avLst/>
-          </a:prstGeom>
-          <a:solidFill>
-            <a:srgbClr val="1D6F7A"/>
-          </a:solidFill>
-          <a:ln w="12700">
-            <a:solidFill>
-              <a:srgbClr val="1D6F7A"/>
+              <a:srgbClr val="1F5FAE"/>
             </a:solidFill>
             <a:prstDash val="solid"/>
           </a:ln>
@@ -11154,43 +10986,36 @@
             </a:avLst>
           </a:prstGeom>
           <a:solidFill>
-            <a:srgbClr val="EEF3F4"/>
+            <a:srgbClr val="F4F7FB"/>
+          </a:solidFill>
+          <a:ln w="9525">
+            <a:solidFill>
+              <a:srgbClr val="DCE5F0"/>
+            </a:solidFill>
+            <a:prstDash val="solid"/>
+          </a:ln>
+        </p:spPr>
+      </p:sp>
+      <p:sp>
+        <p:nvSpPr>
+          <p:cNvPr id="17" name="actividad 4 circle"/>
+          <p:cNvSpPr/>
+          <p:nvPr/>
+        </p:nvSpPr>
+        <p:spPr>
+          <a:xfrm>
+            <a:off x="4709160" y="2971800"/>
+            <a:ext cx="548640" cy="548640"/>
+          </a:xfrm>
+          <a:prstGeom prst="ellipse">
+            <a:avLst/>
+          </a:prstGeom>
+          <a:solidFill>
+            <a:srgbClr val="1F5FAE"/>
           </a:solidFill>
           <a:ln w="12700">
             <a:solidFill>
-              <a:srgbClr val="EEF3F4"/>
-            </a:solidFill>
-            <a:prstDash val="solid"/>
-          </a:ln>
-          <a:effectLst>
-            <a:outerShdw sx="100000" sy="100000" kx="0" ky="0" algn="bl" rotWithShape="0" blurRad="76200" dist="25400" dir="5400000">
-              <a:srgbClr val="000000">
-                <a:alpha val="12000"/>
-              </a:srgbClr>
-            </a:outerShdw>
-          </a:effectLst>
-        </p:spPr>
-      </p:sp>
-      <p:sp>
-        <p:nvSpPr>
-          <p:cNvPr id="17" name="actividad 4 circle"/>
-          <p:cNvSpPr/>
-          <p:nvPr/>
-        </p:nvSpPr>
-        <p:spPr>
-          <a:xfrm>
-            <a:off x="4709160" y="2971800"/>
-            <a:ext cx="548640" cy="548640"/>
-          </a:xfrm>
-          <a:prstGeom prst="ellipse">
-            <a:avLst/>
-          </a:prstGeom>
-          <a:solidFill>
-            <a:srgbClr val="1D6F7A"/>
-          </a:solidFill>
-          <a:ln w="12700">
-            <a:solidFill>
-              <a:srgbClr val="1D6F7A"/>
+              <a:srgbClr val="1F5FAE"/>
             </a:solidFill>
             <a:prstDash val="solid"/>
           </a:ln>
@@ -11273,43 +11098,36 @@
             </a:avLst>
           </a:prstGeom>
           <a:solidFill>
-            <a:srgbClr val="EEF3F4"/>
+            <a:srgbClr val="F4F7FB"/>
+          </a:solidFill>
+          <a:ln w="9525">
+            <a:solidFill>
+              <a:srgbClr val="DCE5F0"/>
+            </a:solidFill>
+            <a:prstDash val="solid"/>
+          </a:ln>
+        </p:spPr>
+      </p:sp>
+      <p:sp>
+        <p:nvSpPr>
+          <p:cNvPr id="21" name="actividad 5 circle"/>
+          <p:cNvSpPr/>
+          <p:nvPr/>
+        </p:nvSpPr>
+        <p:spPr>
+          <a:xfrm>
+            <a:off x="731520" y="4069080"/>
+            <a:ext cx="548640" cy="548640"/>
+          </a:xfrm>
+          <a:prstGeom prst="ellipse">
+            <a:avLst/>
+          </a:prstGeom>
+          <a:solidFill>
+            <a:srgbClr val="1F5FAE"/>
           </a:solidFill>
           <a:ln w="12700">
             <a:solidFill>
-              <a:srgbClr val="EEF3F4"/>
-            </a:solidFill>
-            <a:prstDash val="solid"/>
-          </a:ln>
-          <a:effectLst>
-            <a:outerShdw sx="100000" sy="100000" kx="0" ky="0" algn="bl" rotWithShape="0" blurRad="76200" dist="25400" dir="5400000">
-              <a:srgbClr val="000000">
-                <a:alpha val="12000"/>
-              </a:srgbClr>
-            </a:outerShdw>
-          </a:effectLst>
-        </p:spPr>
-      </p:sp>
-      <p:sp>
-        <p:nvSpPr>
-          <p:cNvPr id="21" name="actividad 5 circle"/>
-          <p:cNvSpPr/>
-          <p:nvPr/>
-        </p:nvSpPr>
-        <p:spPr>
-          <a:xfrm>
-            <a:off x="731520" y="4069080"/>
-            <a:ext cx="548640" cy="548640"/>
-          </a:xfrm>
-          <a:prstGeom prst="ellipse">
-            <a:avLst/>
-          </a:prstGeom>
-          <a:solidFill>
-            <a:srgbClr val="1D6F7A"/>
-          </a:solidFill>
-          <a:ln w="12700">
-            <a:solidFill>
-              <a:srgbClr val="1D6F7A"/>
+              <a:srgbClr val="1F5FAE"/>
             </a:solidFill>
             <a:prstDash val="solid"/>
           </a:ln>
@@ -11392,43 +11210,36 @@
             </a:avLst>
           </a:prstGeom>
           <a:solidFill>
-            <a:srgbClr val="EEF3F4"/>
+            <a:srgbClr val="F4F7FB"/>
+          </a:solidFill>
+          <a:ln w="9525">
+            <a:solidFill>
+              <a:srgbClr val="DCE5F0"/>
+            </a:solidFill>
+            <a:prstDash val="solid"/>
+          </a:ln>
+        </p:spPr>
+      </p:sp>
+      <p:sp>
+        <p:nvSpPr>
+          <p:cNvPr id="25" name="actividad 6 circle"/>
+          <p:cNvSpPr/>
+          <p:nvPr/>
+        </p:nvSpPr>
+        <p:spPr>
+          <a:xfrm>
+            <a:off x="4709160" y="4069080"/>
+            <a:ext cx="548640" cy="548640"/>
+          </a:xfrm>
+          <a:prstGeom prst="ellipse">
+            <a:avLst/>
+          </a:prstGeom>
+          <a:solidFill>
+            <a:srgbClr val="1F5FAE"/>
           </a:solidFill>
           <a:ln w="12700">
             <a:solidFill>
-              <a:srgbClr val="EEF3F4"/>
-            </a:solidFill>
-            <a:prstDash val="solid"/>
-          </a:ln>
-          <a:effectLst>
-            <a:outerShdw sx="100000" sy="100000" kx="0" ky="0" algn="bl" rotWithShape="0" blurRad="76200" dist="25400" dir="5400000">
-              <a:srgbClr val="000000">
-                <a:alpha val="12000"/>
-              </a:srgbClr>
-            </a:outerShdw>
-          </a:effectLst>
-        </p:spPr>
-      </p:sp>
-      <p:sp>
-        <p:nvSpPr>
-          <p:cNvPr id="25" name="actividad 6 circle"/>
-          <p:cNvSpPr/>
-          <p:nvPr/>
-        </p:nvSpPr>
-        <p:spPr>
-          <a:xfrm>
-            <a:off x="4709160" y="4069080"/>
-            <a:ext cx="548640" cy="548640"/>
-          </a:xfrm>
-          <a:prstGeom prst="ellipse">
-            <a:avLst/>
-          </a:prstGeom>
-          <a:solidFill>
-            <a:srgbClr val="1D6F7A"/>
-          </a:solidFill>
-          <a:ln w="12700">
-            <a:solidFill>
-              <a:srgbClr val="1D6F7A"/>
+              <a:srgbClr val="1F5FAE"/>
             </a:solidFill>
             <a:prstDash val="solid"/>
           </a:ln>
@@ -11511,43 +11322,36 @@
             </a:avLst>
           </a:prstGeom>
           <a:solidFill>
-            <a:srgbClr val="EEF3F4"/>
+            <a:srgbClr val="F4F7FB"/>
+          </a:solidFill>
+          <a:ln w="9525">
+            <a:solidFill>
+              <a:srgbClr val="DCE5F0"/>
+            </a:solidFill>
+            <a:prstDash val="solid"/>
+          </a:ln>
+        </p:spPr>
+      </p:sp>
+      <p:sp>
+        <p:nvSpPr>
+          <p:cNvPr id="29" name="actividad 7 circle"/>
+          <p:cNvSpPr/>
+          <p:nvPr/>
+        </p:nvSpPr>
+        <p:spPr>
+          <a:xfrm>
+            <a:off x="731520" y="5166360"/>
+            <a:ext cx="548640" cy="548640"/>
+          </a:xfrm>
+          <a:prstGeom prst="ellipse">
+            <a:avLst/>
+          </a:prstGeom>
+          <a:solidFill>
+            <a:srgbClr val="1F5FAE"/>
           </a:solidFill>
           <a:ln w="12700">
             <a:solidFill>
-              <a:srgbClr val="EEF3F4"/>
-            </a:solidFill>
-            <a:prstDash val="solid"/>
-          </a:ln>
-          <a:effectLst>
-            <a:outerShdw sx="100000" sy="100000" kx="0" ky="0" algn="bl" rotWithShape="0" blurRad="76200" dist="25400" dir="5400000">
-              <a:srgbClr val="000000">
-                <a:alpha val="12000"/>
-              </a:srgbClr>
-            </a:outerShdw>
-          </a:effectLst>
-        </p:spPr>
-      </p:sp>
-      <p:sp>
-        <p:nvSpPr>
-          <p:cNvPr id="29" name="actividad 7 circle"/>
-          <p:cNvSpPr/>
-          <p:nvPr/>
-        </p:nvSpPr>
-        <p:spPr>
-          <a:xfrm>
-            <a:off x="731520" y="5166360"/>
-            <a:ext cx="548640" cy="548640"/>
-          </a:xfrm>
-          <a:prstGeom prst="ellipse">
-            <a:avLst/>
-          </a:prstGeom>
-          <a:solidFill>
-            <a:srgbClr val="1D6F7A"/>
-          </a:solidFill>
-          <a:ln w="12700">
-            <a:solidFill>
-              <a:srgbClr val="1D6F7A"/>
+              <a:srgbClr val="1F5FAE"/>
             </a:solidFill>
             <a:prstDash val="solid"/>
           </a:ln>
@@ -11630,43 +11434,36 @@
             </a:avLst>
           </a:prstGeom>
           <a:solidFill>
-            <a:srgbClr val="EEF3F4"/>
+            <a:srgbClr val="F4F7FB"/>
+          </a:solidFill>
+          <a:ln w="9525">
+            <a:solidFill>
+              <a:srgbClr val="DCE5F0"/>
+            </a:solidFill>
+            <a:prstDash val="solid"/>
+          </a:ln>
+        </p:spPr>
+      </p:sp>
+      <p:sp>
+        <p:nvSpPr>
+          <p:cNvPr id="33" name="actividad 8 circle"/>
+          <p:cNvSpPr/>
+          <p:nvPr/>
+        </p:nvSpPr>
+        <p:spPr>
+          <a:xfrm>
+            <a:off x="4709160" y="5166360"/>
+            <a:ext cx="548640" cy="548640"/>
+          </a:xfrm>
+          <a:prstGeom prst="ellipse">
+            <a:avLst/>
+          </a:prstGeom>
+          <a:solidFill>
+            <a:srgbClr val="1F5FAE"/>
           </a:solidFill>
           <a:ln w="12700">
             <a:solidFill>
-              <a:srgbClr val="EEF3F4"/>
-            </a:solidFill>
-            <a:prstDash val="solid"/>
-          </a:ln>
-          <a:effectLst>
-            <a:outerShdw sx="100000" sy="100000" kx="0" ky="0" algn="bl" rotWithShape="0" blurRad="76200" dist="25400" dir="5400000">
-              <a:srgbClr val="000000">
-                <a:alpha val="12000"/>
-              </a:srgbClr>
-            </a:outerShdw>
-          </a:effectLst>
-        </p:spPr>
-      </p:sp>
-      <p:sp>
-        <p:nvSpPr>
-          <p:cNvPr id="33" name="actividad 8 circle"/>
-          <p:cNvSpPr/>
-          <p:nvPr/>
-        </p:nvSpPr>
-        <p:spPr>
-          <a:xfrm>
-            <a:off x="4709160" y="5166360"/>
-            <a:ext cx="548640" cy="548640"/>
-          </a:xfrm>
-          <a:prstGeom prst="ellipse">
-            <a:avLst/>
-          </a:prstGeom>
-          <a:solidFill>
-            <a:srgbClr val="1D6F7A"/>
-          </a:solidFill>
-          <a:ln w="12700">
-            <a:solidFill>
-              <a:srgbClr val="1D6F7A"/>
+              <a:srgbClr val="1F5FAE"/>
             </a:solidFill>
             <a:prstDash val="solid"/>
           </a:ln>
@@ -11749,21 +11546,14 @@
             </a:avLst>
           </a:prstGeom>
           <a:solidFill>
-            <a:srgbClr val="123642"/>
+            <a:srgbClr val="0A2A5C"/>
           </a:solidFill>
-          <a:ln w="12700">
+          <a:ln w="9525">
             <a:solidFill>
-              <a:srgbClr val="123642"/>
+              <a:srgbClr val="0A2A5C"/>
             </a:solidFill>
             <a:prstDash val="solid"/>
           </a:ln>
-          <a:effectLst>
-            <a:outerShdw sx="100000" sy="100000" kx="0" ky="0" algn="bl" rotWithShape="0" blurRad="76200" dist="25400" dir="5400000">
-              <a:srgbClr val="000000">
-                <a:alpha val="12000"/>
-              </a:srgbClr>
-            </a:outerShdw>
-          </a:effectLst>
         </p:spPr>
       </p:sp>
       <p:sp>
@@ -12065,21 +11855,14 @@
             </a:avLst>
           </a:prstGeom>
           <a:solidFill>
-            <a:srgbClr val="123642"/>
+            <a:srgbClr val="0A2A5C"/>
           </a:solidFill>
-          <a:ln w="12700">
+          <a:ln w="9525">
             <a:solidFill>
-              <a:srgbClr val="123642"/>
+              <a:srgbClr val="0A2A5C"/>
             </a:solidFill>
             <a:prstDash val="solid"/>
           </a:ln>
-          <a:effectLst>
-            <a:outerShdw sx="100000" sy="100000" kx="0" ky="0" algn="bl" rotWithShape="0" blurRad="76200" dist="25400" dir="5400000">
-              <a:srgbClr val="000000">
-                <a:alpha val="12000"/>
-              </a:srgbClr>
-            </a:outerShdw>
-          </a:effectLst>
         </p:spPr>
       </p:sp>
       <p:sp>
@@ -12258,7 +12041,7 @@
                   <a:tcPr marL="91440" marR="91440" marT="45720" marB="45720" anchor="ctr">
                     <a:lnL w="9525" cap="flat" cmpd="sng" algn="ctr">
                       <a:solidFill>
-                        <a:srgbClr val="D9E6E8"/>
+                        <a:srgbClr val="DCE5F0"/>
                       </a:solidFill>
                       <a:prstDash val="solid"/>
                       <a:round/>
@@ -12267,7 +12050,7 @@
                     </a:lnL>
                     <a:lnR w="9525" cap="flat" cmpd="sng" algn="ctr">
                       <a:solidFill>
-                        <a:srgbClr val="D9E6E8"/>
+                        <a:srgbClr val="DCE5F0"/>
                       </a:solidFill>
                       <a:prstDash val="solid"/>
                       <a:round/>
@@ -12276,7 +12059,7 @@
                     </a:lnR>
                     <a:lnT w="9525" cap="flat" cmpd="sng" algn="ctr">
                       <a:solidFill>
-                        <a:srgbClr val="D9E6E8"/>
+                        <a:srgbClr val="DCE5F0"/>
                       </a:solidFill>
                       <a:prstDash val="solid"/>
                       <a:round/>
@@ -12285,7 +12068,7 @@
                     </a:lnT>
                     <a:lnB w="9525" cap="flat" cmpd="sng" algn="ctr">
                       <a:solidFill>
-                        <a:srgbClr val="D9E6E8"/>
+                        <a:srgbClr val="DCE5F0"/>
                       </a:solidFill>
                       <a:prstDash val="solid"/>
                       <a:round/>
@@ -12293,7 +12076,7 @@
                       <a:tailEnd type="none" w="med" len="med"/>
                     </a:lnB>
                     <a:solidFill>
-                      <a:srgbClr val="1D6F7A"/>
+                      <a:srgbClr val="1F5FAE"/>
                     </a:solidFill>
                   </a:tcPr>
                 </a:tc>
@@ -12326,7 +12109,7 @@
                   <a:tcPr marL="91440" marR="91440" marT="45720" marB="45720" anchor="ctr">
                     <a:lnL w="9525" cap="flat" cmpd="sng" algn="ctr">
                       <a:solidFill>
-                        <a:srgbClr val="D9E6E8"/>
+                        <a:srgbClr val="DCE5F0"/>
                       </a:solidFill>
                       <a:prstDash val="solid"/>
                       <a:round/>
@@ -12335,7 +12118,7 @@
                     </a:lnL>
                     <a:lnR w="9525" cap="flat" cmpd="sng" algn="ctr">
                       <a:solidFill>
-                        <a:srgbClr val="D9E6E8"/>
+                        <a:srgbClr val="DCE5F0"/>
                       </a:solidFill>
                       <a:prstDash val="solid"/>
                       <a:round/>
@@ -12344,7 +12127,7 @@
                     </a:lnR>
                     <a:lnT w="9525" cap="flat" cmpd="sng" algn="ctr">
                       <a:solidFill>
-                        <a:srgbClr val="D9E6E8"/>
+                        <a:srgbClr val="DCE5F0"/>
                       </a:solidFill>
                       <a:prstDash val="solid"/>
                       <a:round/>
@@ -12353,7 +12136,7 @@
                     </a:lnT>
                     <a:lnB w="9525" cap="flat" cmpd="sng" algn="ctr">
                       <a:solidFill>
-                        <a:srgbClr val="D9E6E8"/>
+                        <a:srgbClr val="DCE5F0"/>
                       </a:solidFill>
                       <a:prstDash val="solid"/>
                       <a:round/>
@@ -12361,7 +12144,7 @@
                       <a:tailEnd type="none" w="med" len="med"/>
                     </a:lnB>
                     <a:solidFill>
-                      <a:srgbClr val="1D6F7A"/>
+                      <a:srgbClr val="1F5FAE"/>
                     </a:solidFill>
                   </a:tcPr>
                 </a:tc>
@@ -12394,7 +12177,7 @@
                   <a:tcPr marL="91440" marR="91440" marT="45720" marB="45720" anchor="ctr">
                     <a:lnL w="9525" cap="flat" cmpd="sng" algn="ctr">
                       <a:solidFill>
-                        <a:srgbClr val="D9E6E8"/>
+                        <a:srgbClr val="DCE5F0"/>
                       </a:solidFill>
                       <a:prstDash val="solid"/>
                       <a:round/>
@@ -12403,7 +12186,7 @@
                     </a:lnL>
                     <a:lnR w="9525" cap="flat" cmpd="sng" algn="ctr">
                       <a:solidFill>
-                        <a:srgbClr val="D9E6E8"/>
+                        <a:srgbClr val="DCE5F0"/>
                       </a:solidFill>
                       <a:prstDash val="solid"/>
                       <a:round/>
@@ -12412,7 +12195,7 @@
                     </a:lnR>
                     <a:lnT w="9525" cap="flat" cmpd="sng" algn="ctr">
                       <a:solidFill>
-                        <a:srgbClr val="D9E6E8"/>
+                        <a:srgbClr val="DCE5F0"/>
                       </a:solidFill>
                       <a:prstDash val="solid"/>
                       <a:round/>
@@ -12421,7 +12204,7 @@
                     </a:lnT>
                     <a:lnB w="9525" cap="flat" cmpd="sng" algn="ctr">
                       <a:solidFill>
-                        <a:srgbClr val="D9E6E8"/>
+                        <a:srgbClr val="DCE5F0"/>
                       </a:solidFill>
                       <a:prstDash val="solid"/>
                       <a:round/>
@@ -12429,7 +12212,7 @@
                       <a:tailEnd type="none" w="med" len="med"/>
                     </a:lnB>
                     <a:solidFill>
-                      <a:srgbClr val="1D6F7A"/>
+                      <a:srgbClr val="1F5FAE"/>
                     </a:solidFill>
                   </a:tcPr>
                 </a:tc>
@@ -12462,7 +12245,7 @@
                   <a:tcPr marL="91440" marR="91440" marT="45720" marB="45720" anchor="ctr">
                     <a:lnL w="9525" cap="flat" cmpd="sng" algn="ctr">
                       <a:solidFill>
-                        <a:srgbClr val="D9E6E8"/>
+                        <a:srgbClr val="DCE5F0"/>
                       </a:solidFill>
                       <a:prstDash val="solid"/>
                       <a:round/>
@@ -12471,7 +12254,7 @@
                     </a:lnL>
                     <a:lnR w="9525" cap="flat" cmpd="sng" algn="ctr">
                       <a:solidFill>
-                        <a:srgbClr val="D9E6E8"/>
+                        <a:srgbClr val="DCE5F0"/>
                       </a:solidFill>
                       <a:prstDash val="solid"/>
                       <a:round/>
@@ -12480,7 +12263,7 @@
                     </a:lnR>
                     <a:lnT w="9525" cap="flat" cmpd="sng" algn="ctr">
                       <a:solidFill>
-                        <a:srgbClr val="D9E6E8"/>
+                        <a:srgbClr val="DCE5F0"/>
                       </a:solidFill>
                       <a:prstDash val="solid"/>
                       <a:round/>
@@ -12489,7 +12272,7 @@
                     </a:lnT>
                     <a:lnB w="9525" cap="flat" cmpd="sng" algn="ctr">
                       <a:solidFill>
-                        <a:srgbClr val="D9E6E8"/>
+                        <a:srgbClr val="DCE5F0"/>
                       </a:solidFill>
                       <a:prstDash val="solid"/>
                       <a:round/>
@@ -12497,7 +12280,7 @@
                       <a:tailEnd type="none" w="med" len="med"/>
                     </a:lnB>
                     <a:solidFill>
-                      <a:srgbClr val="1D6F7A"/>
+                      <a:srgbClr val="1F5FAE"/>
                     </a:solidFill>
                   </a:tcPr>
                 </a:tc>
@@ -12530,7 +12313,7 @@
                   <a:tcPr marL="91440" marR="91440" marT="45720" marB="45720" anchor="ctr">
                     <a:lnL w="9525" cap="flat" cmpd="sng" algn="ctr">
                       <a:solidFill>
-                        <a:srgbClr val="D9E6E8"/>
+                        <a:srgbClr val="DCE5F0"/>
                       </a:solidFill>
                       <a:prstDash val="solid"/>
                       <a:round/>
@@ -12539,7 +12322,7 @@
                     </a:lnL>
                     <a:lnR w="9525" cap="flat" cmpd="sng" algn="ctr">
                       <a:solidFill>
-                        <a:srgbClr val="D9E6E8"/>
+                        <a:srgbClr val="DCE5F0"/>
                       </a:solidFill>
                       <a:prstDash val="solid"/>
                       <a:round/>
@@ -12548,7 +12331,7 @@
                     </a:lnR>
                     <a:lnT w="9525" cap="flat" cmpd="sng" algn="ctr">
                       <a:solidFill>
-                        <a:srgbClr val="D9E6E8"/>
+                        <a:srgbClr val="DCE5F0"/>
                       </a:solidFill>
                       <a:prstDash val="solid"/>
                       <a:round/>
@@ -12557,7 +12340,7 @@
                     </a:lnT>
                     <a:lnB w="9525" cap="flat" cmpd="sng" algn="ctr">
                       <a:solidFill>
-                        <a:srgbClr val="D9E6E8"/>
+                        <a:srgbClr val="DCE5F0"/>
                       </a:solidFill>
                       <a:prstDash val="solid"/>
                       <a:round/>
@@ -12565,7 +12348,7 @@
                       <a:tailEnd type="none" w="med" len="med"/>
                     </a:lnB>
                     <a:solidFill>
-                      <a:srgbClr val="1D6F7A"/>
+                      <a:srgbClr val="1F5FAE"/>
                     </a:solidFill>
                   </a:tcPr>
                 </a:tc>
@@ -12598,7 +12381,7 @@
                   <a:tcPr marL="91440" marR="91440" marT="45720" marB="45720" anchor="ctr">
                     <a:lnL w="9525" cap="flat" cmpd="sng" algn="ctr">
                       <a:solidFill>
-                        <a:srgbClr val="D9E6E8"/>
+                        <a:srgbClr val="DCE5F0"/>
                       </a:solidFill>
                       <a:prstDash val="solid"/>
                       <a:round/>
@@ -12607,7 +12390,7 @@
                     </a:lnL>
                     <a:lnR w="9525" cap="flat" cmpd="sng" algn="ctr">
                       <a:solidFill>
-                        <a:srgbClr val="D9E6E8"/>
+                        <a:srgbClr val="DCE5F0"/>
                       </a:solidFill>
                       <a:prstDash val="solid"/>
                       <a:round/>
@@ -12616,7 +12399,7 @@
                     </a:lnR>
                     <a:lnT w="9525" cap="flat" cmpd="sng" algn="ctr">
                       <a:solidFill>
-                        <a:srgbClr val="D9E6E8"/>
+                        <a:srgbClr val="DCE5F0"/>
                       </a:solidFill>
                       <a:prstDash val="solid"/>
                       <a:round/>
@@ -12625,7 +12408,7 @@
                     </a:lnT>
                     <a:lnB w="9525" cap="flat" cmpd="sng" algn="ctr">
                       <a:solidFill>
-                        <a:srgbClr val="D9E6E8"/>
+                        <a:srgbClr val="DCE5F0"/>
                       </a:solidFill>
                       <a:prstDash val="solid"/>
                       <a:round/>
@@ -12633,7 +12416,7 @@
                       <a:tailEnd type="none" w="med" len="med"/>
                     </a:lnB>
                     <a:solidFill>
-                      <a:srgbClr val="1D6F7A"/>
+                      <a:srgbClr val="1F5FAE"/>
                     </a:solidFill>
                   </a:tcPr>
                 </a:tc>
@@ -12666,7 +12449,7 @@
                   <a:tcPr marL="91440" marR="91440" marT="45720" marB="45720" anchor="ctr">
                     <a:lnL w="9525" cap="flat" cmpd="sng" algn="ctr">
                       <a:solidFill>
-                        <a:srgbClr val="D9E6E8"/>
+                        <a:srgbClr val="DCE5F0"/>
                       </a:solidFill>
                       <a:prstDash val="solid"/>
                       <a:round/>
@@ -12675,7 +12458,7 @@
                     </a:lnL>
                     <a:lnR w="9525" cap="flat" cmpd="sng" algn="ctr">
                       <a:solidFill>
-                        <a:srgbClr val="D9E6E8"/>
+                        <a:srgbClr val="DCE5F0"/>
                       </a:solidFill>
                       <a:prstDash val="solid"/>
                       <a:round/>
@@ -12684,7 +12467,7 @@
                     </a:lnR>
                     <a:lnT w="9525" cap="flat" cmpd="sng" algn="ctr">
                       <a:solidFill>
-                        <a:srgbClr val="D9E6E8"/>
+                        <a:srgbClr val="DCE5F0"/>
                       </a:solidFill>
                       <a:prstDash val="solid"/>
                       <a:round/>
@@ -12693,7 +12476,7 @@
                     </a:lnT>
                     <a:lnB w="9525" cap="flat" cmpd="sng" algn="ctr">
                       <a:solidFill>
-                        <a:srgbClr val="D9E6E8"/>
+                        <a:srgbClr val="DCE5F0"/>
                       </a:solidFill>
                       <a:prstDash val="solid"/>
                       <a:round/>
@@ -12701,7 +12484,7 @@
                       <a:tailEnd type="none" w="med" len="med"/>
                     </a:lnB>
                     <a:solidFill>
-                      <a:srgbClr val="1D6F7A"/>
+                      <a:srgbClr val="1F5FAE"/>
                     </a:solidFill>
                   </a:tcPr>
                 </a:tc>
@@ -12734,7 +12517,7 @@
                   <a:tcPr marL="91440" marR="91440" marT="45720" marB="45720" anchor="ctr">
                     <a:lnL w="9525" cap="flat" cmpd="sng" algn="ctr">
                       <a:solidFill>
-                        <a:srgbClr val="D9E6E8"/>
+                        <a:srgbClr val="DCE5F0"/>
                       </a:solidFill>
                       <a:prstDash val="solid"/>
                       <a:round/>
@@ -12743,7 +12526,7 @@
                     </a:lnL>
                     <a:lnR w="9525" cap="flat" cmpd="sng" algn="ctr">
                       <a:solidFill>
-                        <a:srgbClr val="D9E6E8"/>
+                        <a:srgbClr val="DCE5F0"/>
                       </a:solidFill>
                       <a:prstDash val="solid"/>
                       <a:round/>
@@ -12752,7 +12535,7 @@
                     </a:lnR>
                     <a:lnT w="9525" cap="flat" cmpd="sng" algn="ctr">
                       <a:solidFill>
-                        <a:srgbClr val="D9E6E8"/>
+                        <a:srgbClr val="DCE5F0"/>
                       </a:solidFill>
                       <a:prstDash val="solid"/>
                       <a:round/>
@@ -12761,7 +12544,7 @@
                     </a:lnT>
                     <a:lnB w="9525" cap="flat" cmpd="sng" algn="ctr">
                       <a:solidFill>
-                        <a:srgbClr val="D9E6E8"/>
+                        <a:srgbClr val="DCE5F0"/>
                       </a:solidFill>
                       <a:prstDash val="solid"/>
                       <a:round/>
@@ -12769,7 +12552,7 @@
                       <a:tailEnd type="none" w="med" len="med"/>
                     </a:lnB>
                     <a:solidFill>
-                      <a:srgbClr val="1D6F7A"/>
+                      <a:srgbClr val="1F5FAE"/>
                     </a:solidFill>
                   </a:tcPr>
                 </a:tc>
@@ -12802,7 +12585,7 @@
                   <a:tcPr marL="91440" marR="91440" marT="45720" marB="45720" anchor="ctr">
                     <a:lnL w="9525" cap="flat" cmpd="sng" algn="ctr">
                       <a:solidFill>
-                        <a:srgbClr val="D9E6E8"/>
+                        <a:srgbClr val="DCE5F0"/>
                       </a:solidFill>
                       <a:prstDash val="solid"/>
                       <a:round/>
@@ -12811,7 +12594,7 @@
                     </a:lnL>
                     <a:lnR w="9525" cap="flat" cmpd="sng" algn="ctr">
                       <a:solidFill>
-                        <a:srgbClr val="D9E6E8"/>
+                        <a:srgbClr val="DCE5F0"/>
                       </a:solidFill>
                       <a:prstDash val="solid"/>
                       <a:round/>
@@ -12820,7 +12603,7 @@
                     </a:lnR>
                     <a:lnT w="9525" cap="flat" cmpd="sng" algn="ctr">
                       <a:solidFill>
-                        <a:srgbClr val="D9E6E8"/>
+                        <a:srgbClr val="DCE5F0"/>
                       </a:solidFill>
                       <a:prstDash val="solid"/>
                       <a:round/>
@@ -12829,7 +12612,7 @@
                     </a:lnT>
                     <a:lnB w="9525" cap="flat" cmpd="sng" algn="ctr">
                       <a:solidFill>
-                        <a:srgbClr val="D9E6E8"/>
+                        <a:srgbClr val="DCE5F0"/>
                       </a:solidFill>
                       <a:prstDash val="solid"/>
                       <a:round/>
@@ -12837,7 +12620,7 @@
                       <a:tailEnd type="none" w="med" len="med"/>
                     </a:lnB>
                     <a:solidFill>
-                      <a:srgbClr val="1D6F7A"/>
+                      <a:srgbClr val="1F5FAE"/>
                     </a:solidFill>
                   </a:tcPr>
                 </a:tc>
@@ -12870,7 +12653,7 @@
                   <a:tcPr marL="91440" marR="91440" marT="45720" marB="45720" anchor="ctr">
                     <a:lnL w="9525" cap="flat" cmpd="sng" algn="ctr">
                       <a:solidFill>
-                        <a:srgbClr val="D9E6E8"/>
+                        <a:srgbClr val="DCE5F0"/>
                       </a:solidFill>
                       <a:prstDash val="solid"/>
                       <a:round/>
@@ -12879,7 +12662,7 @@
                     </a:lnL>
                     <a:lnR w="9525" cap="flat" cmpd="sng" algn="ctr">
                       <a:solidFill>
-                        <a:srgbClr val="D9E6E8"/>
+                        <a:srgbClr val="DCE5F0"/>
                       </a:solidFill>
                       <a:prstDash val="solid"/>
                       <a:round/>
@@ -12888,7 +12671,7 @@
                     </a:lnR>
                     <a:lnT w="9525" cap="flat" cmpd="sng" algn="ctr">
                       <a:solidFill>
-                        <a:srgbClr val="D9E6E8"/>
+                        <a:srgbClr val="DCE5F0"/>
                       </a:solidFill>
                       <a:prstDash val="solid"/>
                       <a:round/>
@@ -12897,7 +12680,7 @@
                     </a:lnT>
                     <a:lnB w="9525" cap="flat" cmpd="sng" algn="ctr">
                       <a:solidFill>
-                        <a:srgbClr val="D9E6E8"/>
+                        <a:srgbClr val="DCE5F0"/>
                       </a:solidFill>
                       <a:prstDash val="solid"/>
                       <a:round/>
@@ -12905,7 +12688,7 @@
                       <a:tailEnd type="none" w="med" len="med"/>
                     </a:lnB>
                     <a:solidFill>
-                      <a:srgbClr val="1D6F7A"/>
+                      <a:srgbClr val="1F5FAE"/>
                     </a:solidFill>
                   </a:tcPr>
                 </a:tc>
@@ -12938,7 +12721,7 @@
                   <a:tcPr marL="91440" marR="91440" marT="45720" marB="45720" anchor="ctr">
                     <a:lnL w="9525" cap="flat" cmpd="sng" algn="ctr">
                       <a:solidFill>
-                        <a:srgbClr val="D9E6E8"/>
+                        <a:srgbClr val="DCE5F0"/>
                       </a:solidFill>
                       <a:prstDash val="solid"/>
                       <a:round/>
@@ -12947,7 +12730,7 @@
                     </a:lnL>
                     <a:lnR w="9525" cap="flat" cmpd="sng" algn="ctr">
                       <a:solidFill>
-                        <a:srgbClr val="D9E6E8"/>
+                        <a:srgbClr val="DCE5F0"/>
                       </a:solidFill>
                       <a:prstDash val="solid"/>
                       <a:round/>
@@ -12956,7 +12739,7 @@
                     </a:lnR>
                     <a:lnT w="9525" cap="flat" cmpd="sng" algn="ctr">
                       <a:solidFill>
-                        <a:srgbClr val="D9E6E8"/>
+                        <a:srgbClr val="DCE5F0"/>
                       </a:solidFill>
                       <a:prstDash val="solid"/>
                       <a:round/>
@@ -12965,7 +12748,7 @@
                     </a:lnT>
                     <a:lnB w="9525" cap="flat" cmpd="sng" algn="ctr">
                       <a:solidFill>
-                        <a:srgbClr val="D9E6E8"/>
+                        <a:srgbClr val="DCE5F0"/>
                       </a:solidFill>
                       <a:prstDash val="solid"/>
                       <a:round/>
@@ -12973,7 +12756,7 @@
                       <a:tailEnd type="none" w="med" len="med"/>
                     </a:lnB>
                     <a:solidFill>
-                      <a:srgbClr val="1D6F7A"/>
+                      <a:srgbClr val="1F5FAE"/>
                     </a:solidFill>
                   </a:tcPr>
                 </a:tc>
@@ -12990,7 +12773,7 @@
                       <a:r>
                         <a:rPr lang="en-US" sz="1300" b="1" dirty="0">
                           <a:solidFill>
-                            <a:srgbClr val="1F2A30"/>
+                            <a:srgbClr val="1E2A3A"/>
                           </a:solidFill>
                           <a:latin typeface="Calibri" pitchFamily="34" charset="0"/>
                           <a:ea typeface="Calibri" pitchFamily="34" charset="-122"/>
@@ -13008,7 +12791,7 @@
                   <a:tcPr marL="91440" marR="91440" marT="45720" marB="45720" anchor="ctr">
                     <a:lnL w="9525" cap="flat" cmpd="sng" algn="ctr">
                       <a:solidFill>
-                        <a:srgbClr val="D9E6E8"/>
+                        <a:srgbClr val="DCE5F0"/>
                       </a:solidFill>
                       <a:prstDash val="solid"/>
                       <a:round/>
@@ -13017,7 +12800,7 @@
                     </a:lnL>
                     <a:lnR w="9525" cap="flat" cmpd="sng" algn="ctr">
                       <a:solidFill>
-                        <a:srgbClr val="D9E6E8"/>
+                        <a:srgbClr val="DCE5F0"/>
                       </a:solidFill>
                       <a:prstDash val="solid"/>
                       <a:round/>
@@ -13026,7 +12809,7 @@
                     </a:lnR>
                     <a:lnT w="9525" cap="flat" cmpd="sng" algn="ctr">
                       <a:solidFill>
-                        <a:srgbClr val="D9E6E8"/>
+                        <a:srgbClr val="DCE5F0"/>
                       </a:solidFill>
                       <a:prstDash val="solid"/>
                       <a:round/>
@@ -13035,7 +12818,7 @@
                     </a:lnT>
                     <a:lnB w="9525" cap="flat" cmpd="sng" algn="ctr">
                       <a:solidFill>
-                        <a:srgbClr val="D9E6E8"/>
+                        <a:srgbClr val="DCE5F0"/>
                       </a:solidFill>
                       <a:prstDash val="solid"/>
                       <a:round/>
@@ -13058,7 +12841,7 @@
                       <a:r>
                         <a:rPr lang="en-US" sz="1300" dirty="0">
                           <a:solidFill>
-                            <a:srgbClr val="1F2A30"/>
+                            <a:srgbClr val="1E2A3A"/>
                           </a:solidFill>
                           <a:latin typeface="Calibri" pitchFamily="34" charset="0"/>
                           <a:ea typeface="Calibri" pitchFamily="34" charset="-122"/>
@@ -13076,7 +12859,7 @@
                   <a:tcPr marL="91440" marR="91440" marT="45720" marB="45720" anchor="ctr">
                     <a:lnL w="9525" cap="flat" cmpd="sng" algn="ctr">
                       <a:solidFill>
-                        <a:srgbClr val="D9E6E8"/>
+                        <a:srgbClr val="DCE5F0"/>
                       </a:solidFill>
                       <a:prstDash val="solid"/>
                       <a:round/>
@@ -13085,7 +12868,7 @@
                     </a:lnL>
                     <a:lnR w="9525" cap="flat" cmpd="sng" algn="ctr">
                       <a:solidFill>
-                        <a:srgbClr val="D9E6E8"/>
+                        <a:srgbClr val="DCE5F0"/>
                       </a:solidFill>
                       <a:prstDash val="solid"/>
                       <a:round/>
@@ -13094,7 +12877,7 @@
                     </a:lnR>
                     <a:lnT w="9525" cap="flat" cmpd="sng" algn="ctr">
                       <a:solidFill>
-                        <a:srgbClr val="D9E6E8"/>
+                        <a:srgbClr val="DCE5F0"/>
                       </a:solidFill>
                       <a:prstDash val="solid"/>
                       <a:round/>
@@ -13103,7 +12886,7 @@
                     </a:lnT>
                     <a:lnB w="9525" cap="flat" cmpd="sng" algn="ctr">
                       <a:solidFill>
-                        <a:srgbClr val="D9E6E8"/>
+                        <a:srgbClr val="DCE5F0"/>
                       </a:solidFill>
                       <a:prstDash val="solid"/>
                       <a:round/>
@@ -13126,7 +12909,7 @@
                       <a:r>
                         <a:rPr lang="en-US" sz="1300" dirty="0">
                           <a:solidFill>
-                            <a:srgbClr val="1F2A30"/>
+                            <a:srgbClr val="1E2A3A"/>
                           </a:solidFill>
                           <a:latin typeface="Calibri" pitchFamily="34" charset="0"/>
                           <a:ea typeface="Calibri" pitchFamily="34" charset="-122"/>
@@ -13144,7 +12927,7 @@
                   <a:tcPr marL="91440" marR="91440" marT="45720" marB="45720" anchor="ctr">
                     <a:lnL w="9525" cap="flat" cmpd="sng" algn="ctr">
                       <a:solidFill>
-                        <a:srgbClr val="D9E6E8"/>
+                        <a:srgbClr val="DCE5F0"/>
                       </a:solidFill>
                       <a:prstDash val="solid"/>
                       <a:round/>
@@ -13153,7 +12936,7 @@
                     </a:lnL>
                     <a:lnR w="9525" cap="flat" cmpd="sng" algn="ctr">
                       <a:solidFill>
-                        <a:srgbClr val="D9E6E8"/>
+                        <a:srgbClr val="DCE5F0"/>
                       </a:solidFill>
                       <a:prstDash val="solid"/>
                       <a:round/>
@@ -13162,7 +12945,7 @@
                     </a:lnR>
                     <a:lnT w="9525" cap="flat" cmpd="sng" algn="ctr">
                       <a:solidFill>
-                        <a:srgbClr val="D9E6E8"/>
+                        <a:srgbClr val="DCE5F0"/>
                       </a:solidFill>
                       <a:prstDash val="solid"/>
                       <a:round/>
@@ -13171,7 +12954,7 @@
                     </a:lnT>
                     <a:lnB w="9525" cap="flat" cmpd="sng" algn="ctr">
                       <a:solidFill>
-                        <a:srgbClr val="D9E6E8"/>
+                        <a:srgbClr val="DCE5F0"/>
                       </a:solidFill>
                       <a:prstDash val="solid"/>
                       <a:round/>
@@ -13194,7 +12977,7 @@
                       <a:r>
                         <a:rPr lang="en-US" sz="1300" dirty="0">
                           <a:solidFill>
-                            <a:srgbClr val="1F2A30"/>
+                            <a:srgbClr val="1E2A3A"/>
                           </a:solidFill>
                           <a:latin typeface="Calibri" pitchFamily="34" charset="0"/>
                           <a:ea typeface="Calibri" pitchFamily="34" charset="-122"/>
@@ -13212,7 +12995,7 @@
                   <a:tcPr marL="91440" marR="91440" marT="45720" marB="45720" anchor="ctr">
                     <a:lnL w="9525" cap="flat" cmpd="sng" algn="ctr">
                       <a:solidFill>
-                        <a:srgbClr val="D9E6E8"/>
+                        <a:srgbClr val="DCE5F0"/>
                       </a:solidFill>
                       <a:prstDash val="solid"/>
                       <a:round/>
@@ -13221,7 +13004,7 @@
                     </a:lnL>
                     <a:lnR w="9525" cap="flat" cmpd="sng" algn="ctr">
                       <a:solidFill>
-                        <a:srgbClr val="D9E6E8"/>
+                        <a:srgbClr val="DCE5F0"/>
                       </a:solidFill>
                       <a:prstDash val="solid"/>
                       <a:round/>
@@ -13230,7 +13013,7 @@
                     </a:lnR>
                     <a:lnT w="9525" cap="flat" cmpd="sng" algn="ctr">
                       <a:solidFill>
-                        <a:srgbClr val="D9E6E8"/>
+                        <a:srgbClr val="DCE5F0"/>
                       </a:solidFill>
                       <a:prstDash val="solid"/>
                       <a:round/>
@@ -13239,7 +13022,7 @@
                     </a:lnT>
                     <a:lnB w="9525" cap="flat" cmpd="sng" algn="ctr">
                       <a:solidFill>
-                        <a:srgbClr val="D9E6E8"/>
+                        <a:srgbClr val="DCE5F0"/>
                       </a:solidFill>
                       <a:prstDash val="solid"/>
                       <a:round/>
@@ -13262,7 +13045,7 @@
                       <a:r>
                         <a:rPr lang="en-US" sz="1300" dirty="0">
                           <a:solidFill>
-                            <a:srgbClr val="1F2A30"/>
+                            <a:srgbClr val="1E2A3A"/>
                           </a:solidFill>
                           <a:latin typeface="Calibri" pitchFamily="34" charset="0"/>
                           <a:ea typeface="Calibri" pitchFamily="34" charset="-122"/>
@@ -13280,7 +13063,7 @@
                   <a:tcPr marL="91440" marR="91440" marT="45720" marB="45720" anchor="ctr">
                     <a:lnL w="9525" cap="flat" cmpd="sng" algn="ctr">
                       <a:solidFill>
-                        <a:srgbClr val="D9E6E8"/>
+                        <a:srgbClr val="DCE5F0"/>
                       </a:solidFill>
                       <a:prstDash val="solid"/>
                       <a:round/>
@@ -13289,7 +13072,7 @@
                     </a:lnL>
                     <a:lnR w="9525" cap="flat" cmpd="sng" algn="ctr">
                       <a:solidFill>
-                        <a:srgbClr val="D9E6E8"/>
+                        <a:srgbClr val="DCE5F0"/>
                       </a:solidFill>
                       <a:prstDash val="solid"/>
                       <a:round/>
@@ -13298,7 +13081,7 @@
                     </a:lnR>
                     <a:lnT w="9525" cap="flat" cmpd="sng" algn="ctr">
                       <a:solidFill>
-                        <a:srgbClr val="D9E6E8"/>
+                        <a:srgbClr val="DCE5F0"/>
                       </a:solidFill>
                       <a:prstDash val="solid"/>
                       <a:round/>
@@ -13307,7 +13090,7 @@
                     </a:lnT>
                     <a:lnB w="9525" cap="flat" cmpd="sng" algn="ctr">
                       <a:solidFill>
-                        <a:srgbClr val="D9E6E8"/>
+                        <a:srgbClr val="DCE5F0"/>
                       </a:solidFill>
                       <a:prstDash val="solid"/>
                       <a:round/>
@@ -13330,7 +13113,7 @@
                       <a:r>
                         <a:rPr lang="en-US" sz="1300" dirty="0">
                           <a:solidFill>
-                            <a:srgbClr val="1F2A30"/>
+                            <a:srgbClr val="1E2A3A"/>
                           </a:solidFill>
                           <a:latin typeface="Calibri" pitchFamily="34" charset="0"/>
                           <a:ea typeface="Calibri" pitchFamily="34" charset="-122"/>
@@ -13348,7 +13131,7 @@
                   <a:tcPr marL="91440" marR="91440" marT="45720" marB="45720" anchor="ctr">
                     <a:lnL w="9525" cap="flat" cmpd="sng" algn="ctr">
                       <a:solidFill>
-                        <a:srgbClr val="D9E6E8"/>
+                        <a:srgbClr val="DCE5F0"/>
                       </a:solidFill>
                       <a:prstDash val="solid"/>
                       <a:round/>
@@ -13357,7 +13140,7 @@
                     </a:lnL>
                     <a:lnR w="9525" cap="flat" cmpd="sng" algn="ctr">
                       <a:solidFill>
-                        <a:srgbClr val="D9E6E8"/>
+                        <a:srgbClr val="DCE5F0"/>
                       </a:solidFill>
                       <a:prstDash val="solid"/>
                       <a:round/>
@@ -13366,7 +13149,7 @@
                     </a:lnR>
                     <a:lnT w="9525" cap="flat" cmpd="sng" algn="ctr">
                       <a:solidFill>
-                        <a:srgbClr val="D9E6E8"/>
+                        <a:srgbClr val="DCE5F0"/>
                       </a:solidFill>
                       <a:prstDash val="solid"/>
                       <a:round/>
@@ -13375,7 +13158,7 @@
                     </a:lnT>
                     <a:lnB w="9525" cap="flat" cmpd="sng" algn="ctr">
                       <a:solidFill>
-                        <a:srgbClr val="D9E6E8"/>
+                        <a:srgbClr val="DCE5F0"/>
                       </a:solidFill>
                       <a:prstDash val="solid"/>
                       <a:round/>
@@ -13398,7 +13181,7 @@
                       <a:r>
                         <a:rPr lang="en-US" sz="1300" dirty="0">
                           <a:solidFill>
-                            <a:srgbClr val="1F2A30"/>
+                            <a:srgbClr val="1E2A3A"/>
                           </a:solidFill>
                           <a:latin typeface="Calibri" pitchFamily="34" charset="0"/>
                           <a:ea typeface="Calibri" pitchFamily="34" charset="-122"/>
@@ -13416,7 +13199,7 @@
                   <a:tcPr marL="91440" marR="91440" marT="45720" marB="45720" anchor="ctr">
                     <a:lnL w="9525" cap="flat" cmpd="sng" algn="ctr">
                       <a:solidFill>
-                        <a:srgbClr val="D9E6E8"/>
+                        <a:srgbClr val="DCE5F0"/>
                       </a:solidFill>
                       <a:prstDash val="solid"/>
                       <a:round/>
@@ -13425,7 +13208,7 @@
                     </a:lnL>
                     <a:lnR w="9525" cap="flat" cmpd="sng" algn="ctr">
                       <a:solidFill>
-                        <a:srgbClr val="D9E6E8"/>
+                        <a:srgbClr val="DCE5F0"/>
                       </a:solidFill>
                       <a:prstDash val="solid"/>
                       <a:round/>
@@ -13434,7 +13217,7 @@
                     </a:lnR>
                     <a:lnT w="9525" cap="flat" cmpd="sng" algn="ctr">
                       <a:solidFill>
-                        <a:srgbClr val="D9E6E8"/>
+                        <a:srgbClr val="DCE5F0"/>
                       </a:solidFill>
                       <a:prstDash val="solid"/>
                       <a:round/>
@@ -13443,7 +13226,7 @@
                     </a:lnT>
                     <a:lnB w="9525" cap="flat" cmpd="sng" algn="ctr">
                       <a:solidFill>
-                        <a:srgbClr val="D9E6E8"/>
+                        <a:srgbClr val="DCE5F0"/>
                       </a:solidFill>
                       <a:prstDash val="solid"/>
                       <a:round/>
@@ -13466,7 +13249,7 @@
                       <a:r>
                         <a:rPr lang="en-US" sz="1300" dirty="0">
                           <a:solidFill>
-                            <a:srgbClr val="1F2A30"/>
+                            <a:srgbClr val="1E2A3A"/>
                           </a:solidFill>
                           <a:latin typeface="Calibri" pitchFamily="34" charset="0"/>
                           <a:ea typeface="Calibri" pitchFamily="34" charset="-122"/>
@@ -13484,7 +13267,7 @@
                   <a:tcPr marL="91440" marR="91440" marT="45720" marB="45720" anchor="ctr">
                     <a:lnL w="9525" cap="flat" cmpd="sng" algn="ctr">
                       <a:solidFill>
-                        <a:srgbClr val="D9E6E8"/>
+                        <a:srgbClr val="DCE5F0"/>
                       </a:solidFill>
                       <a:prstDash val="solid"/>
                       <a:round/>
@@ -13493,7 +13276,7 @@
                     </a:lnL>
                     <a:lnR w="9525" cap="flat" cmpd="sng" algn="ctr">
                       <a:solidFill>
-                        <a:srgbClr val="D9E6E8"/>
+                        <a:srgbClr val="DCE5F0"/>
                       </a:solidFill>
                       <a:prstDash val="solid"/>
                       <a:round/>
@@ -13502,7 +13285,7 @@
                     </a:lnR>
                     <a:lnT w="9525" cap="flat" cmpd="sng" algn="ctr">
                       <a:solidFill>
-                        <a:srgbClr val="D9E6E8"/>
+                        <a:srgbClr val="DCE5F0"/>
                       </a:solidFill>
                       <a:prstDash val="solid"/>
                       <a:round/>
@@ -13511,7 +13294,7 @@
                     </a:lnT>
                     <a:lnB w="9525" cap="flat" cmpd="sng" algn="ctr">
                       <a:solidFill>
-                        <a:srgbClr val="D9E6E8"/>
+                        <a:srgbClr val="DCE5F0"/>
                       </a:solidFill>
                       <a:prstDash val="solid"/>
                       <a:round/>
@@ -13534,7 +13317,7 @@
                       <a:r>
                         <a:rPr lang="en-US" sz="1300" dirty="0">
                           <a:solidFill>
-                            <a:srgbClr val="1F2A30"/>
+                            <a:srgbClr val="1E2A3A"/>
                           </a:solidFill>
                           <a:latin typeface="Calibri" pitchFamily="34" charset="0"/>
                           <a:ea typeface="Calibri" pitchFamily="34" charset="-122"/>
@@ -13552,7 +13335,7 @@
                   <a:tcPr marL="91440" marR="91440" marT="45720" marB="45720" anchor="ctr">
                     <a:lnL w="9525" cap="flat" cmpd="sng" algn="ctr">
                       <a:solidFill>
-                        <a:srgbClr val="D9E6E8"/>
+                        <a:srgbClr val="DCE5F0"/>
                       </a:solidFill>
                       <a:prstDash val="solid"/>
                       <a:round/>
@@ -13561,7 +13344,7 @@
                     </a:lnL>
                     <a:lnR w="9525" cap="flat" cmpd="sng" algn="ctr">
                       <a:solidFill>
-                        <a:srgbClr val="D9E6E8"/>
+                        <a:srgbClr val="DCE5F0"/>
                       </a:solidFill>
                       <a:prstDash val="solid"/>
                       <a:round/>
@@ -13570,7 +13353,7 @@
                     </a:lnR>
                     <a:lnT w="9525" cap="flat" cmpd="sng" algn="ctr">
                       <a:solidFill>
-                        <a:srgbClr val="D9E6E8"/>
+                        <a:srgbClr val="DCE5F0"/>
                       </a:solidFill>
                       <a:prstDash val="solid"/>
                       <a:round/>
@@ -13579,7 +13362,7 @@
                     </a:lnT>
                     <a:lnB w="9525" cap="flat" cmpd="sng" algn="ctr">
                       <a:solidFill>
-                        <a:srgbClr val="D9E6E8"/>
+                        <a:srgbClr val="DCE5F0"/>
                       </a:solidFill>
                       <a:prstDash val="solid"/>
                       <a:round/>
@@ -13602,7 +13385,7 @@
                       <a:r>
                         <a:rPr lang="en-US" sz="1300" dirty="0">
                           <a:solidFill>
-                            <a:srgbClr val="1F2A30"/>
+                            <a:srgbClr val="1E2A3A"/>
                           </a:solidFill>
                           <a:latin typeface="Calibri" pitchFamily="34" charset="0"/>
                           <a:ea typeface="Calibri" pitchFamily="34" charset="-122"/>
@@ -13620,7 +13403,7 @@
                   <a:tcPr marL="91440" marR="91440" marT="45720" marB="45720" anchor="ctr">
                     <a:lnL w="9525" cap="flat" cmpd="sng" algn="ctr">
                       <a:solidFill>
-                        <a:srgbClr val="D9E6E8"/>
+                        <a:srgbClr val="DCE5F0"/>
                       </a:solidFill>
                       <a:prstDash val="solid"/>
                       <a:round/>
@@ -13629,7 +13412,7 @@
                     </a:lnL>
                     <a:lnR w="9525" cap="flat" cmpd="sng" algn="ctr">
                       <a:solidFill>
-                        <a:srgbClr val="D9E6E8"/>
+                        <a:srgbClr val="DCE5F0"/>
                       </a:solidFill>
                       <a:prstDash val="solid"/>
                       <a:round/>
@@ -13638,7 +13421,7 @@
                     </a:lnR>
                     <a:lnT w="9525" cap="flat" cmpd="sng" algn="ctr">
                       <a:solidFill>
-                        <a:srgbClr val="D9E6E8"/>
+                        <a:srgbClr val="DCE5F0"/>
                       </a:solidFill>
                       <a:prstDash val="solid"/>
                       <a:round/>
@@ -13647,7 +13430,7 @@
                     </a:lnT>
                     <a:lnB w="9525" cap="flat" cmpd="sng" algn="ctr">
                       <a:solidFill>
-                        <a:srgbClr val="D9E6E8"/>
+                        <a:srgbClr val="DCE5F0"/>
                       </a:solidFill>
                       <a:prstDash val="solid"/>
                       <a:round/>
@@ -13670,7 +13453,7 @@
                       <a:r>
                         <a:rPr lang="en-US" sz="1300" b="1" dirty="0">
                           <a:solidFill>
-                            <a:srgbClr val="1F2A30"/>
+                            <a:srgbClr val="1E2A3A"/>
                           </a:solidFill>
                           <a:latin typeface="Calibri" pitchFamily="34" charset="0"/>
                           <a:ea typeface="Calibri" pitchFamily="34" charset="-122"/>
@@ -13688,7 +13471,7 @@
                   <a:tcPr marL="91440" marR="91440" marT="45720" marB="45720" anchor="ctr">
                     <a:lnL w="9525" cap="flat" cmpd="sng" algn="ctr">
                       <a:solidFill>
-                        <a:srgbClr val="D9E6E8"/>
+                        <a:srgbClr val="DCE5F0"/>
                       </a:solidFill>
                       <a:prstDash val="solid"/>
                       <a:round/>
@@ -13697,7 +13480,7 @@
                     </a:lnL>
                     <a:lnR w="9525" cap="flat" cmpd="sng" algn="ctr">
                       <a:solidFill>
-                        <a:srgbClr val="D9E6E8"/>
+                        <a:srgbClr val="DCE5F0"/>
                       </a:solidFill>
                       <a:prstDash val="solid"/>
                       <a:round/>
@@ -13706,7 +13489,7 @@
                     </a:lnR>
                     <a:lnT w="9525" cap="flat" cmpd="sng" algn="ctr">
                       <a:solidFill>
-                        <a:srgbClr val="D9E6E8"/>
+                        <a:srgbClr val="DCE5F0"/>
                       </a:solidFill>
                       <a:prstDash val="solid"/>
                       <a:round/>
@@ -13715,7 +13498,7 @@
                     </a:lnT>
                     <a:lnB w="9525" cap="flat" cmpd="sng" algn="ctr">
                       <a:solidFill>
-                        <a:srgbClr val="D9E6E8"/>
+                        <a:srgbClr val="DCE5F0"/>
                       </a:solidFill>
                       <a:prstDash val="solid"/>
                       <a:round/>
@@ -13956,21 +13739,14 @@
             </a:avLst>
           </a:prstGeom>
           <a:solidFill>
-            <a:srgbClr val="123642"/>
+            <a:srgbClr val="0A2A5C"/>
           </a:solidFill>
-          <a:ln w="12700">
+          <a:ln w="9525">
             <a:solidFill>
-              <a:srgbClr val="123642"/>
+              <a:srgbClr val="0A2A5C"/>
             </a:solidFill>
             <a:prstDash val="solid"/>
           </a:ln>
-          <a:effectLst>
-            <a:outerShdw sx="100000" sy="100000" kx="0" ky="0" algn="bl" rotWithShape="0" blurRad="76200" dist="25400" dir="5400000">
-              <a:srgbClr val="000000">
-                <a:alpha val="12000"/>
-              </a:srgbClr>
-            </a:outerShdw>
-          </a:effectLst>
         </p:spPr>
       </p:sp>
       <p:sp>
@@ -14149,7 +13925,7 @@
                   <a:tcPr marL="91440" marR="91440" marT="45720" marB="45720" anchor="ctr">
                     <a:lnL w="9525" cap="flat" cmpd="sng" algn="ctr">
                       <a:solidFill>
-                        <a:srgbClr val="D9E6E8"/>
+                        <a:srgbClr val="DCE5F0"/>
                       </a:solidFill>
                       <a:prstDash val="solid"/>
                       <a:round/>
@@ -14158,7 +13934,7 @@
                     </a:lnL>
                     <a:lnR w="9525" cap="flat" cmpd="sng" algn="ctr">
                       <a:solidFill>
-                        <a:srgbClr val="D9E6E8"/>
+                        <a:srgbClr val="DCE5F0"/>
                       </a:solidFill>
                       <a:prstDash val="solid"/>
                       <a:round/>
@@ -14167,7 +13943,7 @@
                     </a:lnR>
                     <a:lnT w="9525" cap="flat" cmpd="sng" algn="ctr">
                       <a:solidFill>
-                        <a:srgbClr val="D9E6E8"/>
+                        <a:srgbClr val="DCE5F0"/>
                       </a:solidFill>
                       <a:prstDash val="solid"/>
                       <a:round/>
@@ -14176,7 +13952,7 @@
                     </a:lnT>
                     <a:lnB w="9525" cap="flat" cmpd="sng" algn="ctr">
                       <a:solidFill>
-                        <a:srgbClr val="D9E6E8"/>
+                        <a:srgbClr val="DCE5F0"/>
                       </a:solidFill>
                       <a:prstDash val="solid"/>
                       <a:round/>
@@ -14184,7 +13960,7 @@
                       <a:tailEnd type="none" w="med" len="med"/>
                     </a:lnB>
                     <a:solidFill>
-                      <a:srgbClr val="1D6F7A"/>
+                      <a:srgbClr val="1F5FAE"/>
                     </a:solidFill>
                   </a:tcPr>
                 </a:tc>
@@ -14217,7 +13993,7 @@
                   <a:tcPr marL="91440" marR="91440" marT="45720" marB="45720" anchor="ctr">
                     <a:lnL w="9525" cap="flat" cmpd="sng" algn="ctr">
                       <a:solidFill>
-                        <a:srgbClr val="D9E6E8"/>
+                        <a:srgbClr val="DCE5F0"/>
                       </a:solidFill>
                       <a:prstDash val="solid"/>
                       <a:round/>
@@ -14226,7 +14002,7 @@
                     </a:lnL>
                     <a:lnR w="9525" cap="flat" cmpd="sng" algn="ctr">
                       <a:solidFill>
-                        <a:srgbClr val="D9E6E8"/>
+                        <a:srgbClr val="DCE5F0"/>
                       </a:solidFill>
                       <a:prstDash val="solid"/>
                       <a:round/>
@@ -14235,7 +14011,7 @@
                     </a:lnR>
                     <a:lnT w="9525" cap="flat" cmpd="sng" algn="ctr">
                       <a:solidFill>
-                        <a:srgbClr val="D9E6E8"/>
+                        <a:srgbClr val="DCE5F0"/>
                       </a:solidFill>
                       <a:prstDash val="solid"/>
                       <a:round/>
@@ -14244,7 +14020,7 @@
                     </a:lnT>
                     <a:lnB w="9525" cap="flat" cmpd="sng" algn="ctr">
                       <a:solidFill>
-                        <a:srgbClr val="D9E6E8"/>
+                        <a:srgbClr val="DCE5F0"/>
                       </a:solidFill>
                       <a:prstDash val="solid"/>
                       <a:round/>
@@ -14252,7 +14028,7 @@
                       <a:tailEnd type="none" w="med" len="med"/>
                     </a:lnB>
                     <a:solidFill>
-                      <a:srgbClr val="1D6F7A"/>
+                      <a:srgbClr val="1F5FAE"/>
                     </a:solidFill>
                   </a:tcPr>
                 </a:tc>
@@ -14285,7 +14061,7 @@
                   <a:tcPr marL="91440" marR="91440" marT="45720" marB="45720" anchor="ctr">
                     <a:lnL w="9525" cap="flat" cmpd="sng" algn="ctr">
                       <a:solidFill>
-                        <a:srgbClr val="D9E6E8"/>
+                        <a:srgbClr val="DCE5F0"/>
                       </a:solidFill>
                       <a:prstDash val="solid"/>
                       <a:round/>
@@ -14294,7 +14070,7 @@
                     </a:lnL>
                     <a:lnR w="9525" cap="flat" cmpd="sng" algn="ctr">
                       <a:solidFill>
-                        <a:srgbClr val="D9E6E8"/>
+                        <a:srgbClr val="DCE5F0"/>
                       </a:solidFill>
                       <a:prstDash val="solid"/>
                       <a:round/>
@@ -14303,7 +14079,7 @@
                     </a:lnR>
                     <a:lnT w="9525" cap="flat" cmpd="sng" algn="ctr">
                       <a:solidFill>
-                        <a:srgbClr val="D9E6E8"/>
+                        <a:srgbClr val="DCE5F0"/>
                       </a:solidFill>
                       <a:prstDash val="solid"/>
                       <a:round/>
@@ -14312,7 +14088,7 @@
                     </a:lnT>
                     <a:lnB w="9525" cap="flat" cmpd="sng" algn="ctr">
                       <a:solidFill>
-                        <a:srgbClr val="D9E6E8"/>
+                        <a:srgbClr val="DCE5F0"/>
                       </a:solidFill>
                       <a:prstDash val="solid"/>
                       <a:round/>
@@ -14320,7 +14096,7 @@
                       <a:tailEnd type="none" w="med" len="med"/>
                     </a:lnB>
                     <a:solidFill>
-                      <a:srgbClr val="1D6F7A"/>
+                      <a:srgbClr val="1F5FAE"/>
                     </a:solidFill>
                   </a:tcPr>
                 </a:tc>
@@ -14353,7 +14129,7 @@
                   <a:tcPr marL="91440" marR="91440" marT="45720" marB="45720" anchor="ctr">
                     <a:lnL w="9525" cap="flat" cmpd="sng" algn="ctr">
                       <a:solidFill>
-                        <a:srgbClr val="D9E6E8"/>
+                        <a:srgbClr val="DCE5F0"/>
                       </a:solidFill>
                       <a:prstDash val="solid"/>
                       <a:round/>
@@ -14362,7 +14138,7 @@
                     </a:lnL>
                     <a:lnR w="9525" cap="flat" cmpd="sng" algn="ctr">
                       <a:solidFill>
-                        <a:srgbClr val="D9E6E8"/>
+                        <a:srgbClr val="DCE5F0"/>
                       </a:solidFill>
                       <a:prstDash val="solid"/>
                       <a:round/>
@@ -14371,7 +14147,7 @@
                     </a:lnR>
                     <a:lnT w="9525" cap="flat" cmpd="sng" algn="ctr">
                       <a:solidFill>
-                        <a:srgbClr val="D9E6E8"/>
+                        <a:srgbClr val="DCE5F0"/>
                       </a:solidFill>
                       <a:prstDash val="solid"/>
                       <a:round/>
@@ -14380,7 +14156,7 @@
                     </a:lnT>
                     <a:lnB w="9525" cap="flat" cmpd="sng" algn="ctr">
                       <a:solidFill>
-                        <a:srgbClr val="D9E6E8"/>
+                        <a:srgbClr val="DCE5F0"/>
                       </a:solidFill>
                       <a:prstDash val="solid"/>
                       <a:round/>
@@ -14388,7 +14164,7 @@
                       <a:tailEnd type="none" w="med" len="med"/>
                     </a:lnB>
                     <a:solidFill>
-                      <a:srgbClr val="1D6F7A"/>
+                      <a:srgbClr val="1F5FAE"/>
                     </a:solidFill>
                   </a:tcPr>
                 </a:tc>
@@ -14421,7 +14197,7 @@
                   <a:tcPr marL="91440" marR="91440" marT="45720" marB="45720" anchor="ctr">
                     <a:lnL w="9525" cap="flat" cmpd="sng" algn="ctr">
                       <a:solidFill>
-                        <a:srgbClr val="D9E6E8"/>
+                        <a:srgbClr val="DCE5F0"/>
                       </a:solidFill>
                       <a:prstDash val="solid"/>
                       <a:round/>
@@ -14430,7 +14206,7 @@
                     </a:lnL>
                     <a:lnR w="9525" cap="flat" cmpd="sng" algn="ctr">
                       <a:solidFill>
-                        <a:srgbClr val="D9E6E8"/>
+                        <a:srgbClr val="DCE5F0"/>
                       </a:solidFill>
                       <a:prstDash val="solid"/>
                       <a:round/>
@@ -14439,7 +14215,7 @@
                     </a:lnR>
                     <a:lnT w="9525" cap="flat" cmpd="sng" algn="ctr">
                       <a:solidFill>
-                        <a:srgbClr val="D9E6E8"/>
+                        <a:srgbClr val="DCE5F0"/>
                       </a:solidFill>
                       <a:prstDash val="solid"/>
                       <a:round/>
@@ -14448,7 +14224,7 @@
                     </a:lnT>
                     <a:lnB w="9525" cap="flat" cmpd="sng" algn="ctr">
                       <a:solidFill>
-                        <a:srgbClr val="D9E6E8"/>
+                        <a:srgbClr val="DCE5F0"/>
                       </a:solidFill>
                       <a:prstDash val="solid"/>
                       <a:round/>
@@ -14456,7 +14232,7 @@
                       <a:tailEnd type="none" w="med" len="med"/>
                     </a:lnB>
                     <a:solidFill>
-                      <a:srgbClr val="1D6F7A"/>
+                      <a:srgbClr val="1F5FAE"/>
                     </a:solidFill>
                   </a:tcPr>
                 </a:tc>
@@ -14489,7 +14265,7 @@
                   <a:tcPr marL="91440" marR="91440" marT="45720" marB="45720" anchor="ctr">
                     <a:lnL w="9525" cap="flat" cmpd="sng" algn="ctr">
                       <a:solidFill>
-                        <a:srgbClr val="D9E6E8"/>
+                        <a:srgbClr val="DCE5F0"/>
                       </a:solidFill>
                       <a:prstDash val="solid"/>
                       <a:round/>
@@ -14498,7 +14274,7 @@
                     </a:lnL>
                     <a:lnR w="9525" cap="flat" cmpd="sng" algn="ctr">
                       <a:solidFill>
-                        <a:srgbClr val="D9E6E8"/>
+                        <a:srgbClr val="DCE5F0"/>
                       </a:solidFill>
                       <a:prstDash val="solid"/>
                       <a:round/>
@@ -14507,7 +14283,7 @@
                     </a:lnR>
                     <a:lnT w="9525" cap="flat" cmpd="sng" algn="ctr">
                       <a:solidFill>
-                        <a:srgbClr val="D9E6E8"/>
+                        <a:srgbClr val="DCE5F0"/>
                       </a:solidFill>
                       <a:prstDash val="solid"/>
                       <a:round/>
@@ -14516,7 +14292,7 @@
                     </a:lnT>
                     <a:lnB w="9525" cap="flat" cmpd="sng" algn="ctr">
                       <a:solidFill>
-                        <a:srgbClr val="D9E6E8"/>
+                        <a:srgbClr val="DCE5F0"/>
                       </a:solidFill>
                       <a:prstDash val="solid"/>
                       <a:round/>
@@ -14524,7 +14300,7 @@
                       <a:tailEnd type="none" w="med" len="med"/>
                     </a:lnB>
                     <a:solidFill>
-                      <a:srgbClr val="1D6F7A"/>
+                      <a:srgbClr val="1F5FAE"/>
                     </a:solidFill>
                   </a:tcPr>
                 </a:tc>
@@ -14557,7 +14333,7 @@
                   <a:tcPr marL="91440" marR="91440" marT="45720" marB="45720" anchor="ctr">
                     <a:lnL w="9525" cap="flat" cmpd="sng" algn="ctr">
                       <a:solidFill>
-                        <a:srgbClr val="D9E6E8"/>
+                        <a:srgbClr val="DCE5F0"/>
                       </a:solidFill>
                       <a:prstDash val="solid"/>
                       <a:round/>
@@ -14566,7 +14342,7 @@
                     </a:lnL>
                     <a:lnR w="9525" cap="flat" cmpd="sng" algn="ctr">
                       <a:solidFill>
-                        <a:srgbClr val="D9E6E8"/>
+                        <a:srgbClr val="DCE5F0"/>
                       </a:solidFill>
                       <a:prstDash val="solid"/>
                       <a:round/>
@@ -14575,7 +14351,7 @@
                     </a:lnR>
                     <a:lnT w="9525" cap="flat" cmpd="sng" algn="ctr">
                       <a:solidFill>
-                        <a:srgbClr val="D9E6E8"/>
+                        <a:srgbClr val="DCE5F0"/>
                       </a:solidFill>
                       <a:prstDash val="solid"/>
                       <a:round/>
@@ -14584,7 +14360,7 @@
                     </a:lnT>
                     <a:lnB w="9525" cap="flat" cmpd="sng" algn="ctr">
                       <a:solidFill>
-                        <a:srgbClr val="D9E6E8"/>
+                        <a:srgbClr val="DCE5F0"/>
                       </a:solidFill>
                       <a:prstDash val="solid"/>
                       <a:round/>
@@ -14592,7 +14368,7 @@
                       <a:tailEnd type="none" w="med" len="med"/>
                     </a:lnB>
                     <a:solidFill>
-                      <a:srgbClr val="1D6F7A"/>
+                      <a:srgbClr val="1F5FAE"/>
                     </a:solidFill>
                   </a:tcPr>
                 </a:tc>
@@ -14625,7 +14401,7 @@
                   <a:tcPr marL="91440" marR="91440" marT="45720" marB="45720" anchor="ctr">
                     <a:lnL w="9525" cap="flat" cmpd="sng" algn="ctr">
                       <a:solidFill>
-                        <a:srgbClr val="D9E6E8"/>
+                        <a:srgbClr val="DCE5F0"/>
                       </a:solidFill>
                       <a:prstDash val="solid"/>
                       <a:round/>
@@ -14634,7 +14410,7 @@
                     </a:lnL>
                     <a:lnR w="9525" cap="flat" cmpd="sng" algn="ctr">
                       <a:solidFill>
-                        <a:srgbClr val="D9E6E8"/>
+                        <a:srgbClr val="DCE5F0"/>
                       </a:solidFill>
                       <a:prstDash val="solid"/>
                       <a:round/>
@@ -14643,7 +14419,7 @@
                     </a:lnR>
                     <a:lnT w="9525" cap="flat" cmpd="sng" algn="ctr">
                       <a:solidFill>
-                        <a:srgbClr val="D9E6E8"/>
+                        <a:srgbClr val="DCE5F0"/>
                       </a:solidFill>
                       <a:prstDash val="solid"/>
                       <a:round/>
@@ -14652,7 +14428,7 @@
                     </a:lnT>
                     <a:lnB w="9525" cap="flat" cmpd="sng" algn="ctr">
                       <a:solidFill>
-                        <a:srgbClr val="D9E6E8"/>
+                        <a:srgbClr val="DCE5F0"/>
                       </a:solidFill>
                       <a:prstDash val="solid"/>
                       <a:round/>
@@ -14660,7 +14436,7 @@
                       <a:tailEnd type="none" w="med" len="med"/>
                     </a:lnB>
                     <a:solidFill>
-                      <a:srgbClr val="1D6F7A"/>
+                      <a:srgbClr val="1F5FAE"/>
                     </a:solidFill>
                   </a:tcPr>
                 </a:tc>
@@ -14693,7 +14469,7 @@
                   <a:tcPr marL="91440" marR="91440" marT="45720" marB="45720" anchor="ctr">
                     <a:lnL w="9525" cap="flat" cmpd="sng" algn="ctr">
                       <a:solidFill>
-                        <a:srgbClr val="D9E6E8"/>
+                        <a:srgbClr val="DCE5F0"/>
                       </a:solidFill>
                       <a:prstDash val="solid"/>
                       <a:round/>
@@ -14702,7 +14478,7 @@
                     </a:lnL>
                     <a:lnR w="9525" cap="flat" cmpd="sng" algn="ctr">
                       <a:solidFill>
-                        <a:srgbClr val="D9E6E8"/>
+                        <a:srgbClr val="DCE5F0"/>
                       </a:solidFill>
                       <a:prstDash val="solid"/>
                       <a:round/>
@@ -14711,7 +14487,7 @@
                     </a:lnR>
                     <a:lnT w="9525" cap="flat" cmpd="sng" algn="ctr">
                       <a:solidFill>
-                        <a:srgbClr val="D9E6E8"/>
+                        <a:srgbClr val="DCE5F0"/>
                       </a:solidFill>
                       <a:prstDash val="solid"/>
                       <a:round/>
@@ -14720,7 +14496,7 @@
                     </a:lnT>
                     <a:lnB w="9525" cap="flat" cmpd="sng" algn="ctr">
                       <a:solidFill>
-                        <a:srgbClr val="D9E6E8"/>
+                        <a:srgbClr val="DCE5F0"/>
                       </a:solidFill>
                       <a:prstDash val="solid"/>
                       <a:round/>
@@ -14728,7 +14504,7 @@
                       <a:tailEnd type="none" w="med" len="med"/>
                     </a:lnB>
                     <a:solidFill>
-                      <a:srgbClr val="1D6F7A"/>
+                      <a:srgbClr val="1F5FAE"/>
                     </a:solidFill>
                   </a:tcPr>
                 </a:tc>
@@ -14761,7 +14537,7 @@
                   <a:tcPr marL="91440" marR="91440" marT="45720" marB="45720" anchor="ctr">
                     <a:lnL w="9525" cap="flat" cmpd="sng" algn="ctr">
                       <a:solidFill>
-                        <a:srgbClr val="D9E6E8"/>
+                        <a:srgbClr val="DCE5F0"/>
                       </a:solidFill>
                       <a:prstDash val="solid"/>
                       <a:round/>
@@ -14770,7 +14546,7 @@
                     </a:lnL>
                     <a:lnR w="9525" cap="flat" cmpd="sng" algn="ctr">
                       <a:solidFill>
-                        <a:srgbClr val="D9E6E8"/>
+                        <a:srgbClr val="DCE5F0"/>
                       </a:solidFill>
                       <a:prstDash val="solid"/>
                       <a:round/>
@@ -14779,7 +14555,7 @@
                     </a:lnR>
                     <a:lnT w="9525" cap="flat" cmpd="sng" algn="ctr">
                       <a:solidFill>
-                        <a:srgbClr val="D9E6E8"/>
+                        <a:srgbClr val="DCE5F0"/>
                       </a:solidFill>
                       <a:prstDash val="solid"/>
                       <a:round/>
@@ -14788,7 +14564,7 @@
                     </a:lnT>
                     <a:lnB w="9525" cap="flat" cmpd="sng" algn="ctr">
                       <a:solidFill>
-                        <a:srgbClr val="D9E6E8"/>
+                        <a:srgbClr val="DCE5F0"/>
                       </a:solidFill>
                       <a:prstDash val="solid"/>
                       <a:round/>
@@ -14796,7 +14572,7 @@
                       <a:tailEnd type="none" w="med" len="med"/>
                     </a:lnB>
                     <a:solidFill>
-                      <a:srgbClr val="1D6F7A"/>
+                      <a:srgbClr val="1F5FAE"/>
                     </a:solidFill>
                   </a:tcPr>
                 </a:tc>
@@ -14829,7 +14605,7 @@
                   <a:tcPr marL="91440" marR="91440" marT="45720" marB="45720" anchor="ctr">
                     <a:lnL w="9525" cap="flat" cmpd="sng" algn="ctr">
                       <a:solidFill>
-                        <a:srgbClr val="D9E6E8"/>
+                        <a:srgbClr val="DCE5F0"/>
                       </a:solidFill>
                       <a:prstDash val="solid"/>
                       <a:round/>
@@ -14838,7 +14614,7 @@
                     </a:lnL>
                     <a:lnR w="9525" cap="flat" cmpd="sng" algn="ctr">
                       <a:solidFill>
-                        <a:srgbClr val="D9E6E8"/>
+                        <a:srgbClr val="DCE5F0"/>
                       </a:solidFill>
                       <a:prstDash val="solid"/>
                       <a:round/>
@@ -14847,7 +14623,7 @@
                     </a:lnR>
                     <a:lnT w="9525" cap="flat" cmpd="sng" algn="ctr">
                       <a:solidFill>
-                        <a:srgbClr val="D9E6E8"/>
+                        <a:srgbClr val="DCE5F0"/>
                       </a:solidFill>
                       <a:prstDash val="solid"/>
                       <a:round/>
@@ -14856,7 +14632,7 @@
                     </a:lnT>
                     <a:lnB w="9525" cap="flat" cmpd="sng" algn="ctr">
                       <a:solidFill>
-                        <a:srgbClr val="D9E6E8"/>
+                        <a:srgbClr val="DCE5F0"/>
                       </a:solidFill>
                       <a:prstDash val="solid"/>
                       <a:round/>
@@ -14864,7 +14640,7 @@
                       <a:tailEnd type="none" w="med" len="med"/>
                     </a:lnB>
                     <a:solidFill>
-                      <a:srgbClr val="1D6F7A"/>
+                      <a:srgbClr val="1F5FAE"/>
                     </a:solidFill>
                   </a:tcPr>
                 </a:tc>
@@ -14881,7 +14657,7 @@
                       <a:r>
                         <a:rPr lang="en-US" sz="1200" b="1" dirty="0">
                           <a:solidFill>
-                            <a:srgbClr val="1F2A30"/>
+                            <a:srgbClr val="1E2A3A"/>
                           </a:solidFill>
                           <a:latin typeface="Calibri" pitchFamily="34" charset="0"/>
                           <a:ea typeface="Calibri" pitchFamily="34" charset="-122"/>
@@ -14899,7 +14675,7 @@
                   <a:tcPr marL="91440" marR="91440" marT="45720" marB="45720" anchor="ctr">
                     <a:lnL w="9525" cap="flat" cmpd="sng" algn="ctr">
                       <a:solidFill>
-                        <a:srgbClr val="D9E6E8"/>
+                        <a:srgbClr val="DCE5F0"/>
                       </a:solidFill>
                       <a:prstDash val="solid"/>
                       <a:round/>
@@ -14908,7 +14684,7 @@
                     </a:lnL>
                     <a:lnR w="9525" cap="flat" cmpd="sng" algn="ctr">
                       <a:solidFill>
-                        <a:srgbClr val="D9E6E8"/>
+                        <a:srgbClr val="DCE5F0"/>
                       </a:solidFill>
                       <a:prstDash val="solid"/>
                       <a:round/>
@@ -14917,7 +14693,7 @@
                     </a:lnR>
                     <a:lnT w="9525" cap="flat" cmpd="sng" algn="ctr">
                       <a:solidFill>
-                        <a:srgbClr val="D9E6E8"/>
+                        <a:srgbClr val="DCE5F0"/>
                       </a:solidFill>
                       <a:prstDash val="solid"/>
                       <a:round/>
@@ -14926,7 +14702,7 @@
                     </a:lnT>
                     <a:lnB w="9525" cap="flat" cmpd="sng" algn="ctr">
                       <a:solidFill>
-                        <a:srgbClr val="D9E6E8"/>
+                        <a:srgbClr val="DCE5F0"/>
                       </a:solidFill>
                       <a:prstDash val="solid"/>
                       <a:round/>
@@ -14949,7 +14725,7 @@
                       <a:r>
                         <a:rPr lang="en-US" sz="1200" dirty="0">
                           <a:solidFill>
-                            <a:srgbClr val="1F2A30"/>
+                            <a:srgbClr val="1E2A3A"/>
                           </a:solidFill>
                           <a:latin typeface="Calibri" pitchFamily="34" charset="0"/>
                           <a:ea typeface="Calibri" pitchFamily="34" charset="-122"/>
@@ -14967,7 +14743,7 @@
                   <a:tcPr marL="91440" marR="91440" marT="45720" marB="45720" anchor="ctr">
                     <a:lnL w="9525" cap="flat" cmpd="sng" algn="ctr">
                       <a:solidFill>
-                        <a:srgbClr val="D9E6E8"/>
+                        <a:srgbClr val="DCE5F0"/>
                       </a:solidFill>
                       <a:prstDash val="solid"/>
                       <a:round/>
@@ -14976,7 +14752,7 @@
                     </a:lnL>
                     <a:lnR w="9525" cap="flat" cmpd="sng" algn="ctr">
                       <a:solidFill>
-                        <a:srgbClr val="D9E6E8"/>
+                        <a:srgbClr val="DCE5F0"/>
                       </a:solidFill>
                       <a:prstDash val="solid"/>
                       <a:round/>
@@ -14985,7 +14761,7 @@
                     </a:lnR>
                     <a:lnT w="9525" cap="flat" cmpd="sng" algn="ctr">
                       <a:solidFill>
-                        <a:srgbClr val="D9E6E8"/>
+                        <a:srgbClr val="DCE5F0"/>
                       </a:solidFill>
                       <a:prstDash val="solid"/>
                       <a:round/>
@@ -14994,7 +14770,7 @@
                     </a:lnT>
                     <a:lnB w="9525" cap="flat" cmpd="sng" algn="ctr">
                       <a:solidFill>
-                        <a:srgbClr val="D9E6E8"/>
+                        <a:srgbClr val="DCE5F0"/>
                       </a:solidFill>
                       <a:prstDash val="solid"/>
                       <a:round/>
@@ -15017,7 +14793,7 @@
                       <a:r>
                         <a:rPr lang="en-US" sz="1200" dirty="0">
                           <a:solidFill>
-                            <a:srgbClr val="1F2A30"/>
+                            <a:srgbClr val="1E2A3A"/>
                           </a:solidFill>
                           <a:latin typeface="Calibri" pitchFamily="34" charset="0"/>
                           <a:ea typeface="Calibri" pitchFamily="34" charset="-122"/>
@@ -15035,7 +14811,7 @@
                   <a:tcPr marL="91440" marR="91440" marT="45720" marB="45720" anchor="ctr">
                     <a:lnL w="9525" cap="flat" cmpd="sng" algn="ctr">
                       <a:solidFill>
-                        <a:srgbClr val="D9E6E8"/>
+                        <a:srgbClr val="DCE5F0"/>
                       </a:solidFill>
                       <a:prstDash val="solid"/>
                       <a:round/>
@@ -15044,7 +14820,7 @@
                     </a:lnL>
                     <a:lnR w="9525" cap="flat" cmpd="sng" algn="ctr">
                       <a:solidFill>
-                        <a:srgbClr val="D9E6E8"/>
+                        <a:srgbClr val="DCE5F0"/>
                       </a:solidFill>
                       <a:prstDash val="solid"/>
                       <a:round/>
@@ -15053,7 +14829,7 @@
                     </a:lnR>
                     <a:lnT w="9525" cap="flat" cmpd="sng" algn="ctr">
                       <a:solidFill>
-                        <a:srgbClr val="D9E6E8"/>
+                        <a:srgbClr val="DCE5F0"/>
                       </a:solidFill>
                       <a:prstDash val="solid"/>
                       <a:round/>
@@ -15062,7 +14838,7 @@
                     </a:lnT>
                     <a:lnB w="9525" cap="flat" cmpd="sng" algn="ctr">
                       <a:solidFill>
-                        <a:srgbClr val="D9E6E8"/>
+                        <a:srgbClr val="DCE5F0"/>
                       </a:solidFill>
                       <a:prstDash val="solid"/>
                       <a:round/>
@@ -15085,7 +14861,7 @@
                       <a:r>
                         <a:rPr lang="en-US" sz="1200" dirty="0">
                           <a:solidFill>
-                            <a:srgbClr val="1F2A30"/>
+                            <a:srgbClr val="1E2A3A"/>
                           </a:solidFill>
                           <a:latin typeface="Calibri" pitchFamily="34" charset="0"/>
                           <a:ea typeface="Calibri" pitchFamily="34" charset="-122"/>
@@ -15103,7 +14879,7 @@
                   <a:tcPr marL="91440" marR="91440" marT="45720" marB="45720" anchor="ctr">
                     <a:lnL w="9525" cap="flat" cmpd="sng" algn="ctr">
                       <a:solidFill>
-                        <a:srgbClr val="D9E6E8"/>
+                        <a:srgbClr val="DCE5F0"/>
                       </a:solidFill>
                       <a:prstDash val="solid"/>
                       <a:round/>
@@ -15112,7 +14888,7 @@
                     </a:lnL>
                     <a:lnR w="9525" cap="flat" cmpd="sng" algn="ctr">
                       <a:solidFill>
-                        <a:srgbClr val="D9E6E8"/>
+                        <a:srgbClr val="DCE5F0"/>
                       </a:solidFill>
                       <a:prstDash val="solid"/>
                       <a:round/>
@@ -15121,7 +14897,7 @@
                     </a:lnR>
                     <a:lnT w="9525" cap="flat" cmpd="sng" algn="ctr">
                       <a:solidFill>
-                        <a:srgbClr val="D9E6E8"/>
+                        <a:srgbClr val="DCE5F0"/>
                       </a:solidFill>
                       <a:prstDash val="solid"/>
                       <a:round/>
@@ -15130,7 +14906,7 @@
                     </a:lnT>
                     <a:lnB w="9525" cap="flat" cmpd="sng" algn="ctr">
                       <a:solidFill>
-                        <a:srgbClr val="D9E6E8"/>
+                        <a:srgbClr val="DCE5F0"/>
                       </a:solidFill>
                       <a:prstDash val="solid"/>
                       <a:round/>
@@ -15153,7 +14929,7 @@
                       <a:r>
                         <a:rPr lang="en-US" sz="1200" dirty="0">
                           <a:solidFill>
-                            <a:srgbClr val="1F2A30"/>
+                            <a:srgbClr val="1E2A3A"/>
                           </a:solidFill>
                           <a:latin typeface="Calibri" pitchFamily="34" charset="0"/>
                           <a:ea typeface="Calibri" pitchFamily="34" charset="-122"/>
@@ -15171,7 +14947,7 @@
                   <a:tcPr marL="91440" marR="91440" marT="45720" marB="45720" anchor="ctr">
                     <a:lnL w="9525" cap="flat" cmpd="sng" algn="ctr">
                       <a:solidFill>
-                        <a:srgbClr val="D9E6E8"/>
+                        <a:srgbClr val="DCE5F0"/>
                       </a:solidFill>
                       <a:prstDash val="solid"/>
                       <a:round/>
@@ -15180,7 +14956,7 @@
                     </a:lnL>
                     <a:lnR w="9525" cap="flat" cmpd="sng" algn="ctr">
                       <a:solidFill>
-                        <a:srgbClr val="D9E6E8"/>
+                        <a:srgbClr val="DCE5F0"/>
                       </a:solidFill>
                       <a:prstDash val="solid"/>
                       <a:round/>
@@ -15189,7 +14965,7 @@
                     </a:lnR>
                     <a:lnT w="9525" cap="flat" cmpd="sng" algn="ctr">
                       <a:solidFill>
-                        <a:srgbClr val="D9E6E8"/>
+                        <a:srgbClr val="DCE5F0"/>
                       </a:solidFill>
                       <a:prstDash val="solid"/>
                       <a:round/>
@@ -15198,7 +14974,7 @@
                     </a:lnT>
                     <a:lnB w="9525" cap="flat" cmpd="sng" algn="ctr">
                       <a:solidFill>
-                        <a:srgbClr val="D9E6E8"/>
+                        <a:srgbClr val="DCE5F0"/>
                       </a:solidFill>
                       <a:prstDash val="solid"/>
                       <a:round/>
@@ -15221,7 +14997,7 @@
                       <a:r>
                         <a:rPr lang="en-US" sz="1200" dirty="0">
                           <a:solidFill>
-                            <a:srgbClr val="1F2A30"/>
+                            <a:srgbClr val="1E2A3A"/>
                           </a:solidFill>
                           <a:latin typeface="Calibri" pitchFamily="34" charset="0"/>
                           <a:ea typeface="Calibri" pitchFamily="34" charset="-122"/>
@@ -15239,7 +15015,7 @@
                   <a:tcPr marL="91440" marR="91440" marT="45720" marB="45720" anchor="ctr">
                     <a:lnL w="9525" cap="flat" cmpd="sng" algn="ctr">
                       <a:solidFill>
-                        <a:srgbClr val="D9E6E8"/>
+                        <a:srgbClr val="DCE5F0"/>
                       </a:solidFill>
                       <a:prstDash val="solid"/>
                       <a:round/>
@@ -15248,7 +15024,7 @@
                     </a:lnL>
                     <a:lnR w="9525" cap="flat" cmpd="sng" algn="ctr">
                       <a:solidFill>
-                        <a:srgbClr val="D9E6E8"/>
+                        <a:srgbClr val="DCE5F0"/>
                       </a:solidFill>
                       <a:prstDash val="solid"/>
                       <a:round/>
@@ -15257,7 +15033,7 @@
                     </a:lnR>
                     <a:lnT w="9525" cap="flat" cmpd="sng" algn="ctr">
                       <a:solidFill>
-                        <a:srgbClr val="D9E6E8"/>
+                        <a:srgbClr val="DCE5F0"/>
                       </a:solidFill>
                       <a:prstDash val="solid"/>
                       <a:round/>
@@ -15266,7 +15042,7 @@
                     </a:lnT>
                     <a:lnB w="9525" cap="flat" cmpd="sng" algn="ctr">
                       <a:solidFill>
-                        <a:srgbClr val="D9E6E8"/>
+                        <a:srgbClr val="DCE5F0"/>
                       </a:solidFill>
                       <a:prstDash val="solid"/>
                       <a:round/>
@@ -15289,7 +15065,7 @@
                       <a:r>
                         <a:rPr lang="en-US" sz="1200" dirty="0">
                           <a:solidFill>
-                            <a:srgbClr val="1F2A30"/>
+                            <a:srgbClr val="1E2A3A"/>
                           </a:solidFill>
                           <a:latin typeface="Calibri" pitchFamily="34" charset="0"/>
                           <a:ea typeface="Calibri" pitchFamily="34" charset="-122"/>
@@ -15307,7 +15083,7 @@
                   <a:tcPr marL="91440" marR="91440" marT="45720" marB="45720" anchor="ctr">
                     <a:lnL w="9525" cap="flat" cmpd="sng" algn="ctr">
                       <a:solidFill>
-                        <a:srgbClr val="D9E6E8"/>
+                        <a:srgbClr val="DCE5F0"/>
                       </a:solidFill>
                       <a:prstDash val="solid"/>
                       <a:round/>
@@ -15316,7 +15092,7 @@
                     </a:lnL>
                     <a:lnR w="9525" cap="flat" cmpd="sng" algn="ctr">
                       <a:solidFill>
-                        <a:srgbClr val="D9E6E8"/>
+                        <a:srgbClr val="DCE5F0"/>
                       </a:solidFill>
                       <a:prstDash val="solid"/>
                       <a:round/>
@@ -15325,7 +15101,7 @@
                     </a:lnR>
                     <a:lnT w="9525" cap="flat" cmpd="sng" algn="ctr">
                       <a:solidFill>
-                        <a:srgbClr val="D9E6E8"/>
+                        <a:srgbClr val="DCE5F0"/>
                       </a:solidFill>
                       <a:prstDash val="solid"/>
                       <a:round/>
@@ -15334,7 +15110,7 @@
                     </a:lnT>
                     <a:lnB w="9525" cap="flat" cmpd="sng" algn="ctr">
                       <a:solidFill>
-                        <a:srgbClr val="D9E6E8"/>
+                        <a:srgbClr val="DCE5F0"/>
                       </a:solidFill>
                       <a:prstDash val="solid"/>
                       <a:round/>
@@ -15357,7 +15133,7 @@
                       <a:r>
                         <a:rPr lang="en-US" sz="1200" dirty="0">
                           <a:solidFill>
-                            <a:srgbClr val="1F2A30"/>
+                            <a:srgbClr val="1E2A3A"/>
                           </a:solidFill>
                           <a:latin typeface="Calibri" pitchFamily="34" charset="0"/>
                           <a:ea typeface="Calibri" pitchFamily="34" charset="-122"/>
@@ -15375,7 +15151,7 @@
                   <a:tcPr marL="91440" marR="91440" marT="45720" marB="45720" anchor="ctr">
                     <a:lnL w="9525" cap="flat" cmpd="sng" algn="ctr">
                       <a:solidFill>
-                        <a:srgbClr val="D9E6E8"/>
+                        <a:srgbClr val="DCE5F0"/>
                       </a:solidFill>
                       <a:prstDash val="solid"/>
                       <a:round/>
@@ -15384,7 +15160,7 @@
                     </a:lnL>
                     <a:lnR w="9525" cap="flat" cmpd="sng" algn="ctr">
                       <a:solidFill>
-                        <a:srgbClr val="D9E6E8"/>
+                        <a:srgbClr val="DCE5F0"/>
                       </a:solidFill>
                       <a:prstDash val="solid"/>
                       <a:round/>
@@ -15393,7 +15169,7 @@
                     </a:lnR>
                     <a:lnT w="9525" cap="flat" cmpd="sng" algn="ctr">
                       <a:solidFill>
-                        <a:srgbClr val="D9E6E8"/>
+                        <a:srgbClr val="DCE5F0"/>
                       </a:solidFill>
                       <a:prstDash val="solid"/>
                       <a:round/>
@@ -15402,7 +15178,7 @@
                     </a:lnT>
                     <a:lnB w="9525" cap="flat" cmpd="sng" algn="ctr">
                       <a:solidFill>
-                        <a:srgbClr val="D9E6E8"/>
+                        <a:srgbClr val="DCE5F0"/>
                       </a:solidFill>
                       <a:prstDash val="solid"/>
                       <a:round/>
@@ -15425,7 +15201,7 @@
                       <a:r>
                         <a:rPr lang="en-US" sz="1200" dirty="0">
                           <a:solidFill>
-                            <a:srgbClr val="1F2A30"/>
+                            <a:srgbClr val="1E2A3A"/>
                           </a:solidFill>
                           <a:latin typeface="Calibri" pitchFamily="34" charset="0"/>
                           <a:ea typeface="Calibri" pitchFamily="34" charset="-122"/>
@@ -15443,7 +15219,7 @@
                   <a:tcPr marL="91440" marR="91440" marT="45720" marB="45720" anchor="ctr">
                     <a:lnL w="9525" cap="flat" cmpd="sng" algn="ctr">
                       <a:solidFill>
-                        <a:srgbClr val="D9E6E8"/>
+                        <a:srgbClr val="DCE5F0"/>
                       </a:solidFill>
                       <a:prstDash val="solid"/>
                       <a:round/>
@@ -15452,7 +15228,7 @@
                     </a:lnL>
                     <a:lnR w="9525" cap="flat" cmpd="sng" algn="ctr">
                       <a:solidFill>
-                        <a:srgbClr val="D9E6E8"/>
+                        <a:srgbClr val="DCE5F0"/>
                       </a:solidFill>
                       <a:prstDash val="solid"/>
                       <a:round/>
@@ -15461,7 +15237,7 @@
                     </a:lnR>
                     <a:lnT w="9525" cap="flat" cmpd="sng" algn="ctr">
                       <a:solidFill>
-                        <a:srgbClr val="D9E6E8"/>
+                        <a:srgbClr val="DCE5F0"/>
                       </a:solidFill>
                       <a:prstDash val="solid"/>
                       <a:round/>
@@ -15470,7 +15246,7 @@
                     </a:lnT>
                     <a:lnB w="9525" cap="flat" cmpd="sng" algn="ctr">
                       <a:solidFill>
-                        <a:srgbClr val="D9E6E8"/>
+                        <a:srgbClr val="DCE5F0"/>
                       </a:solidFill>
                       <a:prstDash val="solid"/>
                       <a:round/>
@@ -15493,7 +15269,7 @@
                       <a:r>
                         <a:rPr lang="en-US" sz="1200" dirty="0">
                           <a:solidFill>
-                            <a:srgbClr val="1F2A30"/>
+                            <a:srgbClr val="1E2A3A"/>
                           </a:solidFill>
                           <a:latin typeface="Calibri" pitchFamily="34" charset="0"/>
                           <a:ea typeface="Calibri" pitchFamily="34" charset="-122"/>
@@ -15511,7 +15287,7 @@
                   <a:tcPr marL="91440" marR="91440" marT="45720" marB="45720" anchor="ctr">
                     <a:lnL w="9525" cap="flat" cmpd="sng" algn="ctr">
                       <a:solidFill>
-                        <a:srgbClr val="D9E6E8"/>
+                        <a:srgbClr val="DCE5F0"/>
                       </a:solidFill>
                       <a:prstDash val="solid"/>
                       <a:round/>
@@ -15520,7 +15296,7 @@
                     </a:lnL>
                     <a:lnR w="9525" cap="flat" cmpd="sng" algn="ctr">
                       <a:solidFill>
-                        <a:srgbClr val="D9E6E8"/>
+                        <a:srgbClr val="DCE5F0"/>
                       </a:solidFill>
                       <a:prstDash val="solid"/>
                       <a:round/>
@@ -15529,7 +15305,7 @@
                     </a:lnR>
                     <a:lnT w="9525" cap="flat" cmpd="sng" algn="ctr">
                       <a:solidFill>
-                        <a:srgbClr val="D9E6E8"/>
+                        <a:srgbClr val="DCE5F0"/>
                       </a:solidFill>
                       <a:prstDash val="solid"/>
                       <a:round/>
@@ -15538,7 +15314,7 @@
                     </a:lnT>
                     <a:lnB w="9525" cap="flat" cmpd="sng" algn="ctr">
                       <a:solidFill>
-                        <a:srgbClr val="D9E6E8"/>
+                        <a:srgbClr val="DCE5F0"/>
                       </a:solidFill>
                       <a:prstDash val="solid"/>
                       <a:round/>
@@ -15561,7 +15337,7 @@
                       <a:r>
                         <a:rPr lang="en-US" sz="1200" b="1" dirty="0">
                           <a:solidFill>
-                            <a:srgbClr val="1F2A30"/>
+                            <a:srgbClr val="1E2A3A"/>
                           </a:solidFill>
                           <a:latin typeface="Calibri" pitchFamily="34" charset="0"/>
                           <a:ea typeface="Calibri" pitchFamily="34" charset="-122"/>
@@ -15579,7 +15355,7 @@
                   <a:tcPr marL="91440" marR="91440" marT="45720" marB="45720" anchor="ctr">
                     <a:lnL w="9525" cap="flat" cmpd="sng" algn="ctr">
                       <a:solidFill>
-                        <a:srgbClr val="D9E6E8"/>
+                        <a:srgbClr val="DCE5F0"/>
                       </a:solidFill>
                       <a:prstDash val="solid"/>
                       <a:round/>
@@ -15588,7 +15364,7 @@
                     </a:lnL>
                     <a:lnR w="9525" cap="flat" cmpd="sng" algn="ctr">
                       <a:solidFill>
-                        <a:srgbClr val="D9E6E8"/>
+                        <a:srgbClr val="DCE5F0"/>
                       </a:solidFill>
                       <a:prstDash val="solid"/>
                       <a:round/>
@@ -15597,7 +15373,7 @@
                     </a:lnR>
                     <a:lnT w="9525" cap="flat" cmpd="sng" algn="ctr">
                       <a:solidFill>
-                        <a:srgbClr val="D9E6E8"/>
+                        <a:srgbClr val="DCE5F0"/>
                       </a:solidFill>
                       <a:prstDash val="solid"/>
                       <a:round/>
@@ -15606,7 +15382,7 @@
                     </a:lnT>
                     <a:lnB w="9525" cap="flat" cmpd="sng" algn="ctr">
                       <a:solidFill>
-                        <a:srgbClr val="D9E6E8"/>
+                        <a:srgbClr val="DCE5F0"/>
                       </a:solidFill>
                       <a:prstDash val="solid"/>
                       <a:round/>
@@ -15713,47 +15489,47 @@
 </file>
 
 <file path=ppt/theme/theme1.xml><?xml version="1.0" encoding="utf-8"?>
-<a:theme xmlns:a="http://schemas.openxmlformats.org/drawingml/2006/main" name="Avaluos Riesgo">
+<a:theme xmlns:a="http://schemas.openxmlformats.org/drawingml/2006/main" name="Avaluos Institucional">
   <a:themeElements>
-    <a:clrScheme name="Avaluos Riesgo">
+    <a:clrScheme name="Avaluos Institucional">
       <a:dk1>
-        <a:srgbClr val="1F2A30"/>
+        <a:srgbClr val="1E2A3A"/>
       </a:dk1>
       <a:lt1>
         <a:srgbClr val="FFFFFF"/>
       </a:lt1>
       <a:dk2>
-        <a:srgbClr val="123642"/>
+        <a:srgbClr val="0A2A5C"/>
       </a:dk2>
       <a:lt2>
-        <a:srgbClr val="EEF3F4"/>
+        <a:srgbClr val="F4F7FB"/>
       </a:lt2>
       <a:accent1>
-        <a:srgbClr val="1D6F7A"/>
+        <a:srgbClr val="1F5FAE"/>
       </a:accent1>
       <a:accent2>
-        <a:srgbClr val="E3A72F"/>
+        <a:srgbClr val="9CC3F0"/>
       </a:accent2>
       <a:accent3>
-        <a:srgbClr val="C0392B"/>
+        <a:srgbClr val="164A8F"/>
       </a:accent3>
       <a:accent4>
-        <a:srgbClr val="5B7C86"/>
+        <a:srgbClr val="5F7590"/>
       </a:accent4>
       <a:accent5>
-        <a:srgbClr val="9FC3C9"/>
+        <a:srgbClr val="C9DBF2"/>
       </a:accent5>
       <a:accent6>
-        <a:srgbClr val="D9E6E8"/>
+        <a:srgbClr val="DCE5F0"/>
       </a:accent6>
       <a:hlink>
-        <a:srgbClr val="1D6F7A"/>
+        <a:srgbClr val="1F5FAE"/>
       </a:hlink>
       <a:folHlink>
-        <a:srgbClr val="5B7C86"/>
+        <a:srgbClr val="5F7590"/>
       </a:folHlink>
     </a:clrScheme>
-    <a:fontScheme name="Avaluos Riesgo">
+    <a:fontScheme name="Avaluos Institucional">
       <a:majorFont>
         <a:latin typeface="Cambria"/>
         <a:ea typeface=""/>

</xml_diff>

<commit_message>
Use red only for risk elements and rebalance agenda and content layouts
Co-Authored-By: Claude Opus 5.5 <noreply@anthropic.com>
Claude-Session: https://claude.ai/code/session_01Czk2XnZSpBwy6TjibqLL9A
</commit_message>
<xml_diff>
--- a/administracion-avaluos/Proyecto_Administracion_de_Avaluos.pptx
+++ b/administracion-avaluos/Proyecto_Administracion_de_Avaluos.pptx
@@ -122,17 +122,17 @@
   <p:extLst>
     <p:ext uri="{521415D9-36F7-43E2-AB2F-B90AF26B5E84}">
       <p14:sectionLst xmlns:p14="http://schemas.microsoft.com/office/powerpoint/2010/main">
-        <p14:section name="Portada" id="{2aac6b3a-cddc-8a6b-5b6a-b2f1befeb885}">
+        <p14:section name="Portada" id="{c661e664-b82c-c211-0e4a-3a4a54c2c9b7}">
           <p14:sldIdLst>
             <p14:sldId id="256"/>
           </p14:sldIdLst>
         </p14:section>
-        <p14:section name="Agenda" id="{feb7e73d-9cd6-6d19-e2ec-b6b03484bb8d}">
+        <p14:section name="Agenda" id="{3cd19daa-abda-3c52-b4d2-8d60eca5f79a}">
           <p14:sldIdLst>
             <p14:sldId id="257"/>
           </p14:sldIdLst>
         </p14:section>
-        <p14:section name="A. Situación actual" id="{3f88c0aa-c65a-dea2-551a-2eda415fd1b3}">
+        <p14:section name="A. Situación actual" id="{080dd570-131c-2337-e7a8-5b5f58a3f19e}">
           <p14:sldIdLst>
             <p14:sldId id="258"/>
             <p14:sldId id="259"/>
@@ -141,19 +141,19 @@
             <p14:sldId id="262"/>
           </p14:sldIdLst>
         </p14:section>
-        <p14:section name="Datos operativos" id="{9acde0da-f896-90f2-0322-52a880e29a79}">
+        <p14:section name="Datos operativos" id="{46e2077f-4e92-a6bd-d797-b93eac4ca648}">
           <p14:sldIdLst>
             <p14:sldId id="263"/>
             <p14:sldId id="264"/>
             <p14:sldId id="265"/>
           </p14:sldIdLst>
         </p14:section>
-        <p14:section name="Riesgo identificado" id="{6f9940ff-de3a-b251-a283-f7e43ae0cb0a}">
+        <p14:section name="Riesgo identificado" id="{66fd3ea6-eb99-2181-0d52-b42d91fbfe14}">
           <p14:sldIdLst>
             <p14:sldId id="266"/>
           </p14:sldIdLst>
         </p14:section>
-        <p14:section name="B. Propuesta" id="{09fe9182-0851-8f89-ceba-348580857f5e}">
+        <p14:section name="B. Propuesta" id="{491ed73d-afbc-2802-7cd9-63c9fdf84546}">
           <p14:sldIdLst>
             <p14:sldId id="267"/>
             <p14:sldId id="268"/>
@@ -161,7 +161,7 @@
             <p14:sldId id="270"/>
           </p14:sldIdLst>
         </p14:section>
-        <p14:section name="Solicitud" id="{0f25d45d-b092-8fd5-946c-dc1831f04e69}">
+        <p14:section name="Solicitud" id="{a37644ab-1a46-45e6-d21a-e7ddbdd7f40a}">
           <p14:sldIdLst>
             <p14:sldId id="271"/>
           </p14:sldIdLst>
@@ -527,7 +527,7 @@
           </c:tx>
           <c:spPr>
             <a:solidFill>
-              <a:srgbClr val="1F5FAE"/>
+              <a:srgbClr val="C62828"/>
             </a:solidFill>
             <a:effectLst/>
           </c:spPr>
@@ -3791,7 +3791,7 @@
         <p:spPr>
           <a:xfrm>
             <a:off x="548640" y="1463040"/>
-            <a:ext cx="3474720" cy="3931920"/>
+            <a:ext cx="3474720" cy="4206240"/>
           </a:xfrm>
           <a:prstGeom prst="roundRect">
             <a:avLst>
@@ -3978,7 +3978,7 @@
         <p:spPr>
           <a:xfrm>
             <a:off x="4343400" y="1463040"/>
-            <a:ext cx="3474720" cy="3931920"/>
+            <a:ext cx="3474720" cy="4206240"/>
           </a:xfrm>
           <a:prstGeom prst="roundRect">
             <a:avLst>
@@ -4165,7 +4165,7 @@
         <p:spPr>
           <a:xfrm>
             <a:off x="8138160" y="1463040"/>
-            <a:ext cx="3474720" cy="3931920"/>
+            <a:ext cx="3474720" cy="4206240"/>
           </a:xfrm>
           <a:prstGeom prst="roundRect">
             <a:avLst>
@@ -4351,7 +4351,7 @@
         </p:nvSpPr>
         <p:spPr>
           <a:xfrm>
-            <a:off x="548640" y="5669280"/>
+            <a:off x="548640" y="5897880"/>
             <a:ext cx="9144000" cy="274320"/>
           </a:xfrm>
           <a:prstGeom prst="rect">
@@ -4504,11 +4504,11 @@
             </a:avLst>
           </a:prstGeom>
           <a:solidFill>
-            <a:srgbClr val="164A8F"/>
+            <a:srgbClr val="C62828"/>
           </a:solidFill>
           <a:ln w="9525">
             <a:solidFill>
-              <a:srgbClr val="164A8F"/>
+              <a:srgbClr val="C62828"/>
             </a:solidFill>
             <a:prstDash val="solid"/>
           </a:ln>
@@ -6132,7 +6132,7 @@
         <p:spPr>
           <a:xfrm>
             <a:off x="1463040" y="1645920"/>
-            <a:ext cx="9784080" cy="4160520"/>
+            <a:ext cx="9784080" cy="4206240"/>
           </a:xfrm>
           <a:prstGeom prst="rect">
             <a:avLst/>
@@ -6151,14 +6151,14 @@
               <a:buNone/>
             </a:pPr>
             <a:r>
-              <a:rPr lang="en-US" sz="1800" b="1" dirty="0">
+              <a:rPr lang="en-US" sz="1900" b="1" dirty="0">
                 <a:solidFill>
                   <a:srgbClr val="0A2A5C"/>
                 </a:solidFill>
               </a:rPr>
               <a:t>Contratar en cumplimiento a la NRP – 27 artículo 40 que establece lo siguiente: </a:t>
             </a:r>
-            <a:endParaRPr lang="en-US" sz="1800" dirty="0"/>
+            <a:endParaRPr lang="en-US" sz="1900" dirty="0"/>
           </a:p>
           <a:p>
             <a:pPr indent="0" marL="0">
@@ -6168,14 +6168,14 @@
               <a:buNone/>
             </a:pPr>
             <a:r>
-              <a:rPr lang="en-US" sz="1800" dirty="0">
+              <a:rPr lang="en-US" sz="1900" dirty="0">
                 <a:solidFill>
                   <a:schemeClr val="tx1"/>
                 </a:solidFill>
               </a:rPr>
               <a:t>Las entidades deberán contar con un Revisor que verifique el cumplimiento del contenido mínimo del informe de valuación establecido en el artículo 33 de las presentes Normas, sin poder modificar en ningún momento el valor de mercado reportado y los valores obtenidos. En caso de haber observaciones, el revisor deberá dejarlas debidamente documentadas, a efectos de que el Perito encargado de su realización subsane las deficiencias o justifique lo observado, de acuerdo con lo establecido en las presentes Normas.</a:t>
             </a:r>
-            <a:endParaRPr lang="en-US" sz="1800" dirty="0"/>
+            <a:endParaRPr lang="en-US" sz="1900" dirty="0"/>
           </a:p>
           <a:p>
             <a:pPr indent="0" marL="0">
@@ -6185,14 +6185,14 @@
               <a:buNone/>
             </a:pPr>
             <a:r>
-              <a:rPr lang="en-US" sz="1800" dirty="0">
+              <a:rPr lang="en-US" sz="1900" dirty="0">
                 <a:solidFill>
                   <a:schemeClr val="tx1"/>
                 </a:solidFill>
               </a:rPr>
               <a:t>Al existir diferencia de criterios, el Revisor podrá emitir sus observaciones y opiniones debidamente justificadas y documentadas pero será el Perito quién deberá, si aplica, cambiar algún aspecto previamente definido en el informe de valuación dejándolo debidamente justificado y documentado.</a:t>
             </a:r>
-            <a:endParaRPr lang="en-US" sz="1800" dirty="0"/>
+            <a:endParaRPr lang="en-US" sz="1900" dirty="0"/>
           </a:p>
         </p:txBody>
       </p:sp>
@@ -6349,11 +6349,11 @@
         <p:spPr>
           <a:xfrm>
             <a:off x="548640" y="2286000"/>
-            <a:ext cx="5120640" cy="3703320"/>
+            <a:ext cx="5120640" cy="3154680"/>
           </a:xfrm>
           <a:prstGeom prst="roundRect">
             <a:avLst>
-              <a:gd name="adj" fmla="val 2963"/>
+              <a:gd name="adj" fmla="val 3478"/>
             </a:avLst>
           </a:prstGeom>
           <a:solidFill>
@@ -6414,8 +6414,8 @@
         </p:nvSpPr>
         <p:spPr>
           <a:xfrm>
-            <a:off x="868680" y="3063240"/>
-            <a:ext cx="4480560" cy="2651760"/>
+            <a:off x="868680" y="3108960"/>
+            <a:ext cx="4480560" cy="2194560"/>
           </a:xfrm>
           <a:prstGeom prst="rect">
             <a:avLst/>
@@ -6429,74 +6429,74 @@
           <a:p>
             <a:pPr marL="342900" indent="-342900">
               <a:spcAft>
-                <a:spcPts val="1000"/>
+                <a:spcPts val="1600"/>
               </a:spcAft>
               <a:buSzPct val="100000"/>
               <a:buChar char="•"/>
             </a:pPr>
             <a:r>
-              <a:rPr lang="en-US" sz="1600" dirty="0">
+              <a:rPr lang="en-US" sz="1700" dirty="0">
                 <a:solidFill>
                   <a:schemeClr val="tx1"/>
                 </a:solidFill>
               </a:rPr>
               <a:t>4 gerencias y 20 personas intervienen</a:t>
             </a:r>
-            <a:endParaRPr lang="en-US" sz="1600" dirty="0"/>
+            <a:endParaRPr lang="en-US" sz="1700" dirty="0"/>
           </a:p>
           <a:p>
             <a:pPr marL="342900" indent="-342900">
               <a:spcAft>
-                <a:spcPts val="1000"/>
+                <a:spcPts val="1600"/>
               </a:spcAft>
               <a:buSzPct val="100000"/>
               <a:buChar char="•"/>
             </a:pPr>
             <a:r>
-              <a:rPr lang="en-US" sz="1600" dirty="0">
+              <a:rPr lang="en-US" sz="1700" dirty="0">
                 <a:solidFill>
                   <a:schemeClr val="tx1"/>
                 </a:solidFill>
               </a:rPr>
               <a:t>No existe un área de control centralizada</a:t>
             </a:r>
-            <a:endParaRPr lang="en-US" sz="1600" dirty="0"/>
+            <a:endParaRPr lang="en-US" sz="1700" dirty="0"/>
           </a:p>
           <a:p>
             <a:pPr marL="342900" indent="-342900">
               <a:spcAft>
-                <a:spcPts val="1000"/>
+                <a:spcPts val="1600"/>
               </a:spcAft>
               <a:buSzPct val="100000"/>
               <a:buChar char="•"/>
             </a:pPr>
             <a:r>
-              <a:rPr lang="en-US" sz="1600" dirty="0">
+              <a:rPr lang="en-US" sz="1700" dirty="0">
                 <a:solidFill>
                   <a:schemeClr val="tx1"/>
                 </a:solidFill>
               </a:rPr>
               <a:t>Observaciones reiterativas de la SSF</a:t>
             </a:r>
-            <a:endParaRPr lang="en-US" sz="1600" dirty="0"/>
+            <a:endParaRPr lang="en-US" sz="1700" dirty="0"/>
           </a:p>
           <a:p>
             <a:pPr marL="342900" indent="-342900">
               <a:spcAft>
-                <a:spcPts val="1000"/>
+                <a:spcPts val="1600"/>
               </a:spcAft>
               <a:buSzPct val="100000"/>
               <a:buChar char="•"/>
             </a:pPr>
             <a:r>
-              <a:rPr lang="en-US" sz="1600" dirty="0">
+              <a:rPr lang="en-US" sz="1700" dirty="0">
                 <a:solidFill>
                   <a:schemeClr val="tx1"/>
                 </a:solidFill>
               </a:rPr>
               <a:t>Falta de Políticas y Procedimientos internos</a:t>
             </a:r>
-            <a:endParaRPr lang="en-US" sz="1600" dirty="0"/>
+            <a:endParaRPr lang="en-US" sz="1700" dirty="0"/>
           </a:p>
         </p:txBody>
       </p:sp>
@@ -6516,7 +6516,7 @@
         </p:blipFill>
         <p:spPr>
           <a:xfrm>
-            <a:off x="5806440" y="3840480"/>
+            <a:off x="5806440" y="3611880"/>
             <a:ext cx="548640" cy="548640"/>
           </a:xfrm>
           <a:prstGeom prst="rect">
@@ -7337,18 +7337,18 @@
       </p:sp>
       <p:sp>
         <p:nvSpPr>
-          <p:cNvPr id="3" name="agenda card 1"/>
+          <p:cNvPr id="3" name="agenda fila 1"/>
           <p:cNvSpPr/>
           <p:nvPr/>
         </p:nvSpPr>
         <p:spPr>
           <a:xfrm>
-            <a:off x="548640" y="1737360"/>
-            <a:ext cx="2560320" cy="3657600"/>
+            <a:off x="548640" y="1371600"/>
+            <a:ext cx="11064240" cy="1005840"/>
           </a:xfrm>
           <a:prstGeom prst="roundRect">
             <a:avLst>
-              <a:gd name="adj" fmla="val 4286"/>
+              <a:gd name="adj" fmla="val 10909"/>
             </a:avLst>
           </a:prstGeom>
           <a:solidFill>
@@ -7364,14 +7364,53 @@
       </p:sp>
       <p:sp>
         <p:nvSpPr>
-          <p:cNvPr id="4" name="agenda 1 circle"/>
+          <p:cNvPr id="4" name="Text 2"/>
+          <p:cNvSpPr txBox="1"/>
+          <p:nvPr/>
+        </p:nvSpPr>
+        <p:spPr>
+          <a:xfrm>
+            <a:off x="822960" y="1371600"/>
+            <a:ext cx="822960" cy="1005840"/>
+          </a:xfrm>
+          <a:prstGeom prst="rect">
+            <a:avLst/>
+          </a:prstGeom>
+          <a:noFill/>
+          <a:ln/>
+        </p:spPr>
+        <p:txBody>
+          <a:bodyPr wrap="square" lIns="0" tIns="0" rIns="0" bIns="0" rtlCol="0" anchor="ctr"/>
+          <a:lstStyle/>
+          <a:p>
+            <a:pPr indent="0" marL="0">
+              <a:buNone/>
+            </a:pPr>
+            <a:r>
+              <a:rPr lang="en-US" sz="3000" b="1" dirty="0">
+                <a:solidFill>
+                  <a:schemeClr val="accent1"/>
+                </a:solidFill>
+                <a:latin typeface="Cambria" pitchFamily="34" charset="0"/>
+                <a:ea typeface="Cambria" pitchFamily="34" charset="-122"/>
+                <a:cs typeface="Cambria" pitchFamily="34" charset="-120"/>
+              </a:rPr>
+              <a:t>01</a:t>
+            </a:r>
+            <a:endParaRPr lang="en-US" sz="3000" dirty="0"/>
+          </a:p>
+        </p:txBody>
+      </p:sp>
+      <p:sp>
+        <p:nvSpPr>
+          <p:cNvPr id="5" name="agenda 1 circle"/>
           <p:cNvSpPr/>
           <p:nvPr/>
         </p:nvSpPr>
         <p:spPr>
           <a:xfrm>
-            <a:off x="868680" y="2103120"/>
-            <a:ext cx="868680" cy="868680"/>
+            <a:off x="1737360" y="1554480"/>
+            <a:ext cx="640080" cy="640080"/>
           </a:xfrm>
           <a:prstGeom prst="ellipse">
             <a:avLst/>
@@ -7389,7 +7428,7 @@
       </p:sp>
       <p:pic>
         <p:nvPicPr>
-          <p:cNvPr id="5" name="agenda 1 icon" descr="preencoded.png">    </p:cNvPr>
+          <p:cNvPr id="6" name="agenda 1 icon" descr="preencoded.png">    </p:cNvPr>
           <p:cNvPicPr>
             <a:picLocks noChangeAspect="1"/>
           </p:cNvPicPr>
@@ -7403,8 +7442,8 @@
         </p:blipFill>
         <p:spPr>
           <a:xfrm>
-            <a:off x="1059790" y="2294230"/>
-            <a:ext cx="486461" cy="486461"/>
+            <a:off x="1878178" y="1695298"/>
+            <a:ext cx="358445" cy="358445"/>
           </a:xfrm>
           <a:prstGeom prst="rect">
             <a:avLst/>
@@ -7413,14 +7452,14 @@
       </p:pic>
       <p:sp>
         <p:nvSpPr>
-          <p:cNvPr id="6" name="Text 3"/>
+          <p:cNvPr id="7" name="Text 4"/>
           <p:cNvSpPr txBox="1"/>
           <p:nvPr/>
         </p:nvSpPr>
         <p:spPr>
           <a:xfrm>
-            <a:off x="2148840" y="2194560"/>
-            <a:ext cx="731520" cy="548640"/>
+            <a:off x="2651760" y="1371600"/>
+            <a:ext cx="3566160" cy="1005840"/>
           </a:xfrm>
           <a:prstGeom prst="rect">
             <a:avLst/>
@@ -7429,46 +7468,7 @@
           <a:ln/>
         </p:spPr>
         <p:txBody>
-          <a:bodyPr wrap="square" lIns="0" tIns="0" rIns="0" bIns="0" rtlCol="0" anchor="t"/>
-          <a:lstStyle/>
-          <a:p>
-            <a:pPr algn="r" indent="0" marL="0">
-              <a:buNone/>
-            </a:pPr>
-            <a:r>
-              <a:rPr lang="en-US" sz="2800" b="1" dirty="0">
-                <a:solidFill>
-                  <a:schemeClr val="accent5"/>
-                </a:solidFill>
-                <a:latin typeface="Cambria" pitchFamily="34" charset="0"/>
-                <a:ea typeface="Cambria" pitchFamily="34" charset="-122"/>
-                <a:cs typeface="Cambria" pitchFamily="34" charset="-120"/>
-              </a:rPr>
-              <a:t>01</a:t>
-            </a:r>
-            <a:endParaRPr lang="en-US" sz="2800" dirty="0"/>
-          </a:p>
-        </p:txBody>
-      </p:sp>
-      <p:sp>
-        <p:nvSpPr>
-          <p:cNvPr id="7" name="Text 4"/>
-          <p:cNvSpPr txBox="1"/>
-          <p:nvPr/>
-        </p:nvSpPr>
-        <p:spPr>
-          <a:xfrm>
-            <a:off x="868680" y="3246120"/>
-            <a:ext cx="1965960" cy="822960"/>
-          </a:xfrm>
-          <a:prstGeom prst="rect">
-            <a:avLst/>
-          </a:prstGeom>
-          <a:noFill/>
-          <a:ln/>
-        </p:spPr>
-        <p:txBody>
-          <a:bodyPr wrap="square" lIns="0" tIns="0" rIns="0" bIns="0" rtlCol="0" anchor="t"/>
+          <a:bodyPr wrap="square" lIns="0" tIns="0" rIns="0" bIns="0" rtlCol="0" anchor="ctr"/>
           <a:lstStyle/>
           <a:p>
             <a:pPr indent="0" marL="0">
@@ -7497,8 +7497,8 @@
         </p:nvSpPr>
         <p:spPr>
           <a:xfrm>
-            <a:off x="868680" y="4114800"/>
-            <a:ext cx="1965960" cy="1554480"/>
+            <a:off x="6400800" y="1371600"/>
+            <a:ext cx="4937760" cy="1005840"/>
           </a:xfrm>
           <a:prstGeom prst="rect">
             <a:avLst/>
@@ -7507,7 +7507,7 @@
           <a:ln/>
         </p:spPr>
         <p:txBody>
-          <a:bodyPr wrap="square" lIns="0" tIns="0" rIns="0" bIns="0" rtlCol="0" anchor="t"/>
+          <a:bodyPr wrap="square" lIns="0" tIns="0" rIns="0" bIns="0" rtlCol="0" anchor="ctr"/>
           <a:lstStyle/>
           <a:p>
             <a:pPr indent="0" marL="0">
@@ -7527,18 +7527,18 @@
       </p:sp>
       <p:sp>
         <p:nvSpPr>
-          <p:cNvPr id="9" name="agenda card 2"/>
+          <p:cNvPr id="9" name="agenda fila 2"/>
           <p:cNvSpPr/>
           <p:nvPr/>
         </p:nvSpPr>
         <p:spPr>
           <a:xfrm>
-            <a:off x="3383280" y="1737360"/>
-            <a:ext cx="2560320" cy="3657600"/>
+            <a:off x="548640" y="2560320"/>
+            <a:ext cx="11064240" cy="1005840"/>
           </a:xfrm>
           <a:prstGeom prst="roundRect">
             <a:avLst>
-              <a:gd name="adj" fmla="val 4286"/>
+              <a:gd name="adj" fmla="val 10909"/>
             </a:avLst>
           </a:prstGeom>
           <a:solidFill>
@@ -7554,14 +7554,53 @@
       </p:sp>
       <p:sp>
         <p:nvSpPr>
-          <p:cNvPr id="10" name="agenda 2 circle"/>
+          <p:cNvPr id="10" name="Text 7"/>
+          <p:cNvSpPr txBox="1"/>
+          <p:nvPr/>
+        </p:nvSpPr>
+        <p:spPr>
+          <a:xfrm>
+            <a:off x="822960" y="2560320"/>
+            <a:ext cx="822960" cy="1005840"/>
+          </a:xfrm>
+          <a:prstGeom prst="rect">
+            <a:avLst/>
+          </a:prstGeom>
+          <a:noFill/>
+          <a:ln/>
+        </p:spPr>
+        <p:txBody>
+          <a:bodyPr wrap="square" lIns="0" tIns="0" rIns="0" bIns="0" rtlCol="0" anchor="ctr"/>
+          <a:lstStyle/>
+          <a:p>
+            <a:pPr indent="0" marL="0">
+              <a:buNone/>
+            </a:pPr>
+            <a:r>
+              <a:rPr lang="en-US" sz="3000" b="1" dirty="0">
+                <a:solidFill>
+                  <a:schemeClr val="accent1"/>
+                </a:solidFill>
+                <a:latin typeface="Cambria" pitchFamily="34" charset="0"/>
+                <a:ea typeface="Cambria" pitchFamily="34" charset="-122"/>
+                <a:cs typeface="Cambria" pitchFamily="34" charset="-120"/>
+              </a:rPr>
+              <a:t>02</a:t>
+            </a:r>
+            <a:endParaRPr lang="en-US" sz="3000" dirty="0"/>
+          </a:p>
+        </p:txBody>
+      </p:sp>
+      <p:sp>
+        <p:nvSpPr>
+          <p:cNvPr id="11" name="agenda 2 circle"/>
           <p:cNvSpPr/>
           <p:nvPr/>
         </p:nvSpPr>
         <p:spPr>
           <a:xfrm>
-            <a:off x="3703320" y="2103120"/>
-            <a:ext cx="868680" cy="868680"/>
+            <a:off x="1737360" y="2743200"/>
+            <a:ext cx="640080" cy="640080"/>
           </a:xfrm>
           <a:prstGeom prst="ellipse">
             <a:avLst/>
@@ -7579,7 +7618,7 @@
       </p:sp>
       <p:pic>
         <p:nvPicPr>
-          <p:cNvPr id="11" name="agenda 2 icon" descr="preencoded.png">    </p:cNvPr>
+          <p:cNvPr id="12" name="agenda 2 icon" descr="preencoded.png">    </p:cNvPr>
           <p:cNvPicPr>
             <a:picLocks noChangeAspect="1"/>
           </p:cNvPicPr>
@@ -7593,8 +7632,8 @@
         </p:blipFill>
         <p:spPr>
           <a:xfrm>
-            <a:off x="3894430" y="2294230"/>
-            <a:ext cx="486461" cy="486461"/>
+            <a:off x="1878178" y="2884018"/>
+            <a:ext cx="358445" cy="358445"/>
           </a:xfrm>
           <a:prstGeom prst="rect">
             <a:avLst/>
@@ -7603,14 +7642,14 @@
       </p:pic>
       <p:sp>
         <p:nvSpPr>
-          <p:cNvPr id="12" name="Text 8"/>
+          <p:cNvPr id="13" name="Text 9"/>
           <p:cNvSpPr txBox="1"/>
           <p:nvPr/>
         </p:nvSpPr>
         <p:spPr>
           <a:xfrm>
-            <a:off x="4983480" y="2194560"/>
-            <a:ext cx="731520" cy="548640"/>
+            <a:off x="2651760" y="2560320"/>
+            <a:ext cx="3566160" cy="1005840"/>
           </a:xfrm>
           <a:prstGeom prst="rect">
             <a:avLst/>
@@ -7619,46 +7658,7 @@
           <a:ln/>
         </p:spPr>
         <p:txBody>
-          <a:bodyPr wrap="square" lIns="0" tIns="0" rIns="0" bIns="0" rtlCol="0" anchor="t"/>
-          <a:lstStyle/>
-          <a:p>
-            <a:pPr algn="r" indent="0" marL="0">
-              <a:buNone/>
-            </a:pPr>
-            <a:r>
-              <a:rPr lang="en-US" sz="2800" b="1" dirty="0">
-                <a:solidFill>
-                  <a:schemeClr val="accent5"/>
-                </a:solidFill>
-                <a:latin typeface="Cambria" pitchFamily="34" charset="0"/>
-                <a:ea typeface="Cambria" pitchFamily="34" charset="-122"/>
-                <a:cs typeface="Cambria" pitchFamily="34" charset="-120"/>
-              </a:rPr>
-              <a:t>02</a:t>
-            </a:r>
-            <a:endParaRPr lang="en-US" sz="2800" dirty="0"/>
-          </a:p>
-        </p:txBody>
-      </p:sp>
-      <p:sp>
-        <p:nvSpPr>
-          <p:cNvPr id="13" name="Text 9"/>
-          <p:cNvSpPr txBox="1"/>
-          <p:nvPr/>
-        </p:nvSpPr>
-        <p:spPr>
-          <a:xfrm>
-            <a:off x="3703320" y="3246120"/>
-            <a:ext cx="1965960" cy="822960"/>
-          </a:xfrm>
-          <a:prstGeom prst="rect">
-            <a:avLst/>
-          </a:prstGeom>
-          <a:noFill/>
-          <a:ln/>
-        </p:spPr>
-        <p:txBody>
-          <a:bodyPr wrap="square" lIns="0" tIns="0" rIns="0" bIns="0" rtlCol="0" anchor="t"/>
+          <a:bodyPr wrap="square" lIns="0" tIns="0" rIns="0" bIns="0" rtlCol="0" anchor="ctr"/>
           <a:lstStyle/>
           <a:p>
             <a:pPr indent="0" marL="0">
@@ -7687,8 +7687,8 @@
         </p:nvSpPr>
         <p:spPr>
           <a:xfrm>
-            <a:off x="3703320" y="4114800"/>
-            <a:ext cx="1965960" cy="1554480"/>
+            <a:off x="6400800" y="2560320"/>
+            <a:ext cx="4937760" cy="1005840"/>
           </a:xfrm>
           <a:prstGeom prst="rect">
             <a:avLst/>
@@ -7697,7 +7697,7 @@
           <a:ln/>
         </p:spPr>
         <p:txBody>
-          <a:bodyPr wrap="square" lIns="0" tIns="0" rIns="0" bIns="0" rtlCol="0" anchor="t"/>
+          <a:bodyPr wrap="square" lIns="0" tIns="0" rIns="0" bIns="0" rtlCol="0" anchor="ctr"/>
           <a:lstStyle/>
           <a:p>
             <a:pPr indent="0" marL="0">
@@ -7717,18 +7717,18 @@
       </p:sp>
       <p:sp>
         <p:nvSpPr>
-          <p:cNvPr id="15" name="agenda card 3"/>
+          <p:cNvPr id="15" name="agenda fila 3"/>
           <p:cNvSpPr/>
           <p:nvPr/>
         </p:nvSpPr>
         <p:spPr>
           <a:xfrm>
-            <a:off x="6217920" y="1737360"/>
-            <a:ext cx="2560320" cy="3657600"/>
+            <a:off x="548640" y="3749040"/>
+            <a:ext cx="11064240" cy="1005840"/>
           </a:xfrm>
           <a:prstGeom prst="roundRect">
             <a:avLst>
-              <a:gd name="adj" fmla="val 4286"/>
+              <a:gd name="adj" fmla="val 10909"/>
             </a:avLst>
           </a:prstGeom>
           <a:solidFill>
@@ -7744,24 +7744,63 @@
       </p:sp>
       <p:sp>
         <p:nvSpPr>
-          <p:cNvPr id="16" name="agenda 3 circle"/>
+          <p:cNvPr id="16" name="Text 12"/>
+          <p:cNvSpPr txBox="1"/>
+          <p:nvPr/>
+        </p:nvSpPr>
+        <p:spPr>
+          <a:xfrm>
+            <a:off x="822960" y="3749040"/>
+            <a:ext cx="822960" cy="1005840"/>
+          </a:xfrm>
+          <a:prstGeom prst="rect">
+            <a:avLst/>
+          </a:prstGeom>
+          <a:noFill/>
+          <a:ln/>
+        </p:spPr>
+        <p:txBody>
+          <a:bodyPr wrap="square" lIns="0" tIns="0" rIns="0" bIns="0" rtlCol="0" anchor="ctr"/>
+          <a:lstStyle/>
+          <a:p>
+            <a:pPr indent="0" marL="0">
+              <a:buNone/>
+            </a:pPr>
+            <a:r>
+              <a:rPr lang="en-US" sz="3000" b="1" dirty="0">
+                <a:solidFill>
+                  <a:schemeClr val="accent3"/>
+                </a:solidFill>
+                <a:latin typeface="Cambria" pitchFamily="34" charset="0"/>
+                <a:ea typeface="Cambria" pitchFamily="34" charset="-122"/>
+                <a:cs typeface="Cambria" pitchFamily="34" charset="-120"/>
+              </a:rPr>
+              <a:t>03</a:t>
+            </a:r>
+            <a:endParaRPr lang="en-US" sz="3000" dirty="0"/>
+          </a:p>
+        </p:txBody>
+      </p:sp>
+      <p:sp>
+        <p:nvSpPr>
+          <p:cNvPr id="17" name="agenda 3 circle"/>
           <p:cNvSpPr/>
           <p:nvPr/>
         </p:nvSpPr>
         <p:spPr>
           <a:xfrm>
-            <a:off x="6537960" y="2103120"/>
-            <a:ext cx="868680" cy="868680"/>
+            <a:off x="1737360" y="3931920"/>
+            <a:ext cx="640080" cy="640080"/>
           </a:xfrm>
           <a:prstGeom prst="ellipse">
             <a:avLst/>
           </a:prstGeom>
           <a:solidFill>
-            <a:srgbClr val="164A8F"/>
+            <a:srgbClr val="C62828"/>
           </a:solidFill>
           <a:ln w="12700">
             <a:solidFill>
-              <a:srgbClr val="164A8F"/>
+              <a:srgbClr val="C62828"/>
             </a:solidFill>
             <a:prstDash val="solid"/>
           </a:ln>
@@ -7769,7 +7808,7 @@
       </p:sp>
       <p:pic>
         <p:nvPicPr>
-          <p:cNvPr id="17" name="agenda 3 icon" descr="preencoded.png">    </p:cNvPr>
+          <p:cNvPr id="18" name="agenda 3 icon" descr="preencoded.png">    </p:cNvPr>
           <p:cNvPicPr>
             <a:picLocks noChangeAspect="1"/>
           </p:cNvPicPr>
@@ -7783,8 +7822,8 @@
         </p:blipFill>
         <p:spPr>
           <a:xfrm>
-            <a:off x="6729070" y="2294230"/>
-            <a:ext cx="486461" cy="486461"/>
+            <a:off x="1878178" y="4072738"/>
+            <a:ext cx="358445" cy="358445"/>
           </a:xfrm>
           <a:prstGeom prst="rect">
             <a:avLst/>
@@ -7793,14 +7832,14 @@
       </p:pic>
       <p:sp>
         <p:nvSpPr>
-          <p:cNvPr id="18" name="Text 13"/>
+          <p:cNvPr id="19" name="Text 14"/>
           <p:cNvSpPr txBox="1"/>
           <p:nvPr/>
         </p:nvSpPr>
         <p:spPr>
           <a:xfrm>
-            <a:off x="7818120" y="2194560"/>
-            <a:ext cx="731520" cy="548640"/>
+            <a:off x="2651760" y="3749040"/>
+            <a:ext cx="3566160" cy="1005840"/>
           </a:xfrm>
           <a:prstGeom prst="rect">
             <a:avLst/>
@@ -7809,46 +7848,7 @@
           <a:ln/>
         </p:spPr>
         <p:txBody>
-          <a:bodyPr wrap="square" lIns="0" tIns="0" rIns="0" bIns="0" rtlCol="0" anchor="t"/>
-          <a:lstStyle/>
-          <a:p>
-            <a:pPr algn="r" indent="0" marL="0">
-              <a:buNone/>
-            </a:pPr>
-            <a:r>
-              <a:rPr lang="en-US" sz="2800" b="1" dirty="0">
-                <a:solidFill>
-                  <a:schemeClr val="accent5"/>
-                </a:solidFill>
-                <a:latin typeface="Cambria" pitchFamily="34" charset="0"/>
-                <a:ea typeface="Cambria" pitchFamily="34" charset="-122"/>
-                <a:cs typeface="Cambria" pitchFamily="34" charset="-120"/>
-              </a:rPr>
-              <a:t>03</a:t>
-            </a:r>
-            <a:endParaRPr lang="en-US" sz="2800" dirty="0"/>
-          </a:p>
-        </p:txBody>
-      </p:sp>
-      <p:sp>
-        <p:nvSpPr>
-          <p:cNvPr id="19" name="Text 14"/>
-          <p:cNvSpPr txBox="1"/>
-          <p:nvPr/>
-        </p:nvSpPr>
-        <p:spPr>
-          <a:xfrm>
-            <a:off x="6537960" y="3246120"/>
-            <a:ext cx="1965960" cy="822960"/>
-          </a:xfrm>
-          <a:prstGeom prst="rect">
-            <a:avLst/>
-          </a:prstGeom>
-          <a:noFill/>
-          <a:ln/>
-        </p:spPr>
-        <p:txBody>
-          <a:bodyPr wrap="square" lIns="0" tIns="0" rIns="0" bIns="0" rtlCol="0" anchor="t"/>
+          <a:bodyPr wrap="square" lIns="0" tIns="0" rIns="0" bIns="0" rtlCol="0" anchor="ctr"/>
           <a:lstStyle/>
           <a:p>
             <a:pPr indent="0" marL="0">
@@ -7877,8 +7877,8 @@
         </p:nvSpPr>
         <p:spPr>
           <a:xfrm>
-            <a:off x="6537960" y="4114800"/>
-            <a:ext cx="1965960" cy="1554480"/>
+            <a:off x="6400800" y="3749040"/>
+            <a:ext cx="4937760" cy="1005840"/>
           </a:xfrm>
           <a:prstGeom prst="rect">
             <a:avLst/>
@@ -7887,7 +7887,7 @@
           <a:ln/>
         </p:spPr>
         <p:txBody>
-          <a:bodyPr wrap="square" lIns="0" tIns="0" rIns="0" bIns="0" rtlCol="0" anchor="t"/>
+          <a:bodyPr wrap="square" lIns="0" tIns="0" rIns="0" bIns="0" rtlCol="0" anchor="ctr"/>
           <a:lstStyle/>
           <a:p>
             <a:pPr indent="0" marL="0">
@@ -7907,18 +7907,18 @@
       </p:sp>
       <p:sp>
         <p:nvSpPr>
-          <p:cNvPr id="21" name="agenda card 4"/>
+          <p:cNvPr id="21" name="agenda fila 4"/>
           <p:cNvSpPr/>
           <p:nvPr/>
         </p:nvSpPr>
         <p:spPr>
           <a:xfrm>
-            <a:off x="9052560" y="1737360"/>
-            <a:ext cx="2560320" cy="3657600"/>
+            <a:off x="548640" y="4937760"/>
+            <a:ext cx="11064240" cy="1005840"/>
           </a:xfrm>
           <a:prstGeom prst="roundRect">
             <a:avLst>
-              <a:gd name="adj" fmla="val 4286"/>
+              <a:gd name="adj" fmla="val 10909"/>
             </a:avLst>
           </a:prstGeom>
           <a:solidFill>
@@ -7934,14 +7934,53 @@
       </p:sp>
       <p:sp>
         <p:nvSpPr>
-          <p:cNvPr id="22" name="agenda 4 circle"/>
+          <p:cNvPr id="22" name="Text 17"/>
+          <p:cNvSpPr txBox="1"/>
+          <p:nvPr/>
+        </p:nvSpPr>
+        <p:spPr>
+          <a:xfrm>
+            <a:off x="822960" y="4937760"/>
+            <a:ext cx="822960" cy="1005840"/>
+          </a:xfrm>
+          <a:prstGeom prst="rect">
+            <a:avLst/>
+          </a:prstGeom>
+          <a:noFill/>
+          <a:ln/>
+        </p:spPr>
+        <p:txBody>
+          <a:bodyPr wrap="square" lIns="0" tIns="0" rIns="0" bIns="0" rtlCol="0" anchor="ctr"/>
+          <a:lstStyle/>
+          <a:p>
+            <a:pPr indent="0" marL="0">
+              <a:buNone/>
+            </a:pPr>
+            <a:r>
+              <a:rPr lang="en-US" sz="3000" b="1" dirty="0">
+                <a:solidFill>
+                  <a:schemeClr val="accent1"/>
+                </a:solidFill>
+                <a:latin typeface="Cambria" pitchFamily="34" charset="0"/>
+                <a:ea typeface="Cambria" pitchFamily="34" charset="-122"/>
+                <a:cs typeface="Cambria" pitchFamily="34" charset="-120"/>
+              </a:rPr>
+              <a:t>04</a:t>
+            </a:r>
+            <a:endParaRPr lang="en-US" sz="3000" dirty="0"/>
+          </a:p>
+        </p:txBody>
+      </p:sp>
+      <p:sp>
+        <p:nvSpPr>
+          <p:cNvPr id="23" name="agenda 4 circle"/>
           <p:cNvSpPr/>
           <p:nvPr/>
         </p:nvSpPr>
         <p:spPr>
           <a:xfrm>
-            <a:off x="9372600" y="2103120"/>
-            <a:ext cx="868680" cy="868680"/>
+            <a:off x="1737360" y="5120640"/>
+            <a:ext cx="640080" cy="640080"/>
           </a:xfrm>
           <a:prstGeom prst="ellipse">
             <a:avLst/>
@@ -7959,7 +7998,7 @@
       </p:sp>
       <p:pic>
         <p:nvPicPr>
-          <p:cNvPr id="23" name="agenda 4 icon" descr="preencoded.png">    </p:cNvPr>
+          <p:cNvPr id="24" name="agenda 4 icon" descr="preencoded.png">    </p:cNvPr>
           <p:cNvPicPr>
             <a:picLocks noChangeAspect="1"/>
           </p:cNvPicPr>
@@ -7973,8 +8012,8 @@
         </p:blipFill>
         <p:spPr>
           <a:xfrm>
-            <a:off x="9563710" y="2294230"/>
-            <a:ext cx="486461" cy="486461"/>
+            <a:off x="1878178" y="5261458"/>
+            <a:ext cx="358445" cy="358445"/>
           </a:xfrm>
           <a:prstGeom prst="rect">
             <a:avLst/>
@@ -7983,14 +8022,14 @@
       </p:pic>
       <p:sp>
         <p:nvSpPr>
-          <p:cNvPr id="24" name="Text 18"/>
+          <p:cNvPr id="25" name="Text 19"/>
           <p:cNvSpPr txBox="1"/>
           <p:nvPr/>
         </p:nvSpPr>
         <p:spPr>
           <a:xfrm>
-            <a:off x="10652760" y="2194560"/>
-            <a:ext cx="731520" cy="548640"/>
+            <a:off x="2651760" y="4937760"/>
+            <a:ext cx="3566160" cy="1005840"/>
           </a:xfrm>
           <a:prstGeom prst="rect">
             <a:avLst/>
@@ -7999,46 +8038,7 @@
           <a:ln/>
         </p:spPr>
         <p:txBody>
-          <a:bodyPr wrap="square" lIns="0" tIns="0" rIns="0" bIns="0" rtlCol="0" anchor="t"/>
-          <a:lstStyle/>
-          <a:p>
-            <a:pPr algn="r" indent="0" marL="0">
-              <a:buNone/>
-            </a:pPr>
-            <a:r>
-              <a:rPr lang="en-US" sz="2800" b="1" dirty="0">
-                <a:solidFill>
-                  <a:schemeClr val="accent5"/>
-                </a:solidFill>
-                <a:latin typeface="Cambria" pitchFamily="34" charset="0"/>
-                <a:ea typeface="Cambria" pitchFamily="34" charset="-122"/>
-                <a:cs typeface="Cambria" pitchFamily="34" charset="-120"/>
-              </a:rPr>
-              <a:t>04</a:t>
-            </a:r>
-            <a:endParaRPr lang="en-US" sz="2800" dirty="0"/>
-          </a:p>
-        </p:txBody>
-      </p:sp>
-      <p:sp>
-        <p:nvSpPr>
-          <p:cNvPr id="25" name="Text 19"/>
-          <p:cNvSpPr txBox="1"/>
-          <p:nvPr/>
-        </p:nvSpPr>
-        <p:spPr>
-          <a:xfrm>
-            <a:off x="9372600" y="3246120"/>
-            <a:ext cx="1965960" cy="822960"/>
-          </a:xfrm>
-          <a:prstGeom prst="rect">
-            <a:avLst/>
-          </a:prstGeom>
-          <a:noFill/>
-          <a:ln/>
-        </p:spPr>
-        <p:txBody>
-          <a:bodyPr wrap="square" lIns="0" tIns="0" rIns="0" bIns="0" rtlCol="0" anchor="t"/>
+          <a:bodyPr wrap="square" lIns="0" tIns="0" rIns="0" bIns="0" rtlCol="0" anchor="ctr"/>
           <a:lstStyle/>
           <a:p>
             <a:pPr indent="0" marL="0">
@@ -8067,8 +8067,8 @@
         </p:nvSpPr>
         <p:spPr>
           <a:xfrm>
-            <a:off x="9372600" y="4114800"/>
-            <a:ext cx="1965960" cy="1554480"/>
+            <a:off x="6400800" y="4937760"/>
+            <a:ext cx="4937760" cy="1005840"/>
           </a:xfrm>
           <a:prstGeom prst="rect">
             <a:avLst/>
@@ -8077,7 +8077,7 @@
           <a:ln/>
         </p:spPr>
         <p:txBody>
-          <a:bodyPr wrap="square" lIns="0" tIns="0" rIns="0" bIns="0" rtlCol="0" anchor="t"/>
+          <a:bodyPr wrap="square" lIns="0" tIns="0" rIns="0" bIns="0" rtlCol="0" anchor="ctr"/>
           <a:lstStyle/>
           <a:p>
             <a:pPr indent="0" marL="0">
@@ -10161,8 +10161,8 @@
         </p:nvSpPr>
         <p:spPr>
           <a:xfrm>
-            <a:off x="914400" y="2697480"/>
-            <a:ext cx="4617720" cy="2377440"/>
+            <a:off x="914400" y="2651760"/>
+            <a:ext cx="4617720" cy="1920240"/>
           </a:xfrm>
           <a:prstGeom prst="rect">
             <a:avLst/>
@@ -10181,14 +10181,14 @@
               <a:buNone/>
             </a:pPr>
             <a:r>
-              <a:rPr lang="en-US" sz="1500" dirty="0">
+              <a:rPr lang="en-US" sz="1700" dirty="0">
                 <a:solidFill>
                   <a:schemeClr val="tx1"/>
                 </a:solidFill>
               </a:rPr>
               <a:t>Realiza los contratos Hipotecarios y valida información en el Informe de avalúos, para ingresar en el sistema Industrial de Créditos Modulo de garantías la información de Inscripción y presentación de Garantías.</a:t>
             </a:r>
-            <a:endParaRPr lang="en-US" sz="1500" dirty="0"/>
+            <a:endParaRPr lang="en-US" sz="1700" dirty="0"/>
           </a:p>
         </p:txBody>
       </p:sp>
@@ -10200,12 +10200,12 @@
         </p:nvSpPr>
         <p:spPr>
           <a:xfrm>
-            <a:off x="914400" y="5257800"/>
-            <a:ext cx="4617720" cy="548640"/>
+            <a:off x="914400" y="4709160"/>
+            <a:ext cx="4617720" cy="1051560"/>
           </a:xfrm>
           <a:prstGeom prst="roundRect">
             <a:avLst>
-              <a:gd name="adj" fmla="val 16667"/>
+              <a:gd name="adj" fmla="val 8696"/>
             </a:avLst>
           </a:prstGeom>
           <a:solidFill>
@@ -10227,8 +10227,8 @@
         </p:nvSpPr>
         <p:spPr>
           <a:xfrm>
-            <a:off x="1051560" y="5257800"/>
-            <a:ext cx="4389120" cy="548640"/>
+            <a:off x="1143000" y="4709160"/>
+            <a:ext cx="822960" cy="1051560"/>
           </a:xfrm>
           <a:prstGeom prst="rect">
             <a:avLst/>
@@ -10244,20 +10244,59 @@
               <a:buNone/>
             </a:pPr>
             <a:r>
-              <a:rPr lang="en-US" sz="1500" b="1" dirty="0">
+              <a:rPr lang="en-US" sz="4800" b="1" dirty="0">
+                <a:solidFill>
+                  <a:schemeClr val="accent2"/>
+                </a:solidFill>
+                <a:latin typeface="Cambria" pitchFamily="34" charset="0"/>
+                <a:ea typeface="Cambria" pitchFamily="34" charset="-122"/>
+                <a:cs typeface="Cambria" pitchFamily="34" charset="-120"/>
+              </a:rPr>
+              <a:t>2</a:t>
+            </a:r>
+            <a:endParaRPr lang="en-US" sz="4800" dirty="0"/>
+          </a:p>
+        </p:txBody>
+      </p:sp>
+      <p:sp>
+        <p:nvSpPr>
+          <p:cNvPr id="10" name="Text 7"/>
+          <p:cNvSpPr txBox="1"/>
+          <p:nvPr/>
+        </p:nvSpPr>
+        <p:spPr>
+          <a:xfrm>
+            <a:off x="2011680" y="4709160"/>
+            <a:ext cx="3383280" cy="1051560"/>
+          </a:xfrm>
+          <a:prstGeom prst="rect">
+            <a:avLst/>
+          </a:prstGeom>
+          <a:noFill/>
+          <a:ln/>
+        </p:spPr>
+        <p:txBody>
+          <a:bodyPr wrap="square" lIns="0" tIns="0" rIns="0" bIns="0" rtlCol="0" anchor="ctr"/>
+          <a:lstStyle/>
+          <a:p>
+            <a:pPr indent="0" marL="0">
+              <a:buNone/>
+            </a:pPr>
+            <a:r>
+              <a:rPr lang="en-US" sz="1600" b="1" dirty="0">
                 <a:solidFill>
                   <a:schemeClr val="bg1"/>
                 </a:solidFill>
               </a:rPr>
               <a:t>Proceso actual realizado por 2 Personas</a:t>
             </a:r>
-            <a:endParaRPr lang="en-US" sz="1500" dirty="0"/>
-          </a:p>
-        </p:txBody>
-      </p:sp>
-      <p:sp>
-        <p:nvSpPr>
-          <p:cNvPr id="10" name="columna 2"/>
+            <a:endParaRPr lang="en-US" sz="1600" dirty="0"/>
+          </a:p>
+        </p:txBody>
+      </p:sp>
+      <p:sp>
+        <p:nvSpPr>
+          <p:cNvPr id="11" name="columna 2"/>
           <p:cNvSpPr/>
           <p:nvPr/>
         </p:nvSpPr>
@@ -10284,7 +10323,7 @@
       </p:sp>
       <p:sp>
         <p:nvSpPr>
-          <p:cNvPr id="11" name="columna 2 circle"/>
+          <p:cNvPr id="12" name="columna 2 circle"/>
           <p:cNvSpPr/>
           <p:nvPr/>
         </p:nvSpPr>
@@ -10309,7 +10348,7 @@
       </p:sp>
       <p:pic>
         <p:nvPicPr>
-          <p:cNvPr id="12" name="columna 2 icon" descr="preencoded.png">    </p:cNvPr>
+          <p:cNvPr id="13" name="columna 2 icon" descr="preencoded.png">    </p:cNvPr>
           <p:cNvPicPr>
             <a:picLocks noChangeAspect="1"/>
           </p:cNvPicPr>
@@ -10333,7 +10372,7 @@
       </p:pic>
       <p:sp>
         <p:nvSpPr>
-          <p:cNvPr id="13" name="Text 9"/>
+          <p:cNvPr id="14" name="Text 10"/>
           <p:cNvSpPr txBox="1"/>
           <p:nvPr/>
         </p:nvSpPr>
@@ -10372,14 +10411,14 @@
       </p:sp>
       <p:sp>
         <p:nvSpPr>
-          <p:cNvPr id="14" name="Text 10"/>
+          <p:cNvPr id="15" name="Text 11"/>
           <p:cNvSpPr txBox="1"/>
           <p:nvPr/>
         </p:nvSpPr>
         <p:spPr>
           <a:xfrm>
-            <a:off x="6629400" y="2697480"/>
-            <a:ext cx="4617720" cy="2377440"/>
+            <a:off x="6629400" y="2651760"/>
+            <a:ext cx="4617720" cy="1920240"/>
           </a:xfrm>
           <a:prstGeom prst="rect">
             <a:avLst/>
@@ -10398,14 +10437,14 @@
               <a:buNone/>
             </a:pPr>
             <a:r>
-              <a:rPr lang="en-US" sz="1500" dirty="0">
+              <a:rPr lang="en-US" sz="1700" dirty="0">
                 <a:solidFill>
                   <a:schemeClr val="tx1"/>
                 </a:solidFill>
               </a:rPr>
               <a:t>Administración de Cartera: Es la encarga actual de Modificar, Actualizar el Sistema Industrial de Créditos del Módulo de Garantías, (de la Informacion enviada por Créditos y Riesgos)</a:t>
             </a:r>
-            <a:endParaRPr lang="en-US" sz="1500" dirty="0"/>
+            <a:endParaRPr lang="en-US" sz="1700" dirty="0"/>
           </a:p>
           <a:p>
             <a:pPr indent="0" marL="0">
@@ -10415,31 +10454,31 @@
               <a:buNone/>
             </a:pPr>
             <a:r>
-              <a:rPr lang="en-US" sz="1500" dirty="0">
+              <a:rPr lang="en-US" sz="1700" dirty="0">
                 <a:solidFill>
                   <a:schemeClr val="tx1"/>
                 </a:solidFill>
               </a:rPr>
               <a:t>Así mismo ha informado que realiza contrataciones de Peritos para valuaciones especiales de garantías</a:t>
             </a:r>
-            <a:endParaRPr lang="en-US" sz="1500" dirty="0"/>
-          </a:p>
-        </p:txBody>
-      </p:sp>
-      <p:sp>
-        <p:nvSpPr>
-          <p:cNvPr id="15" name="pill 2"/>
+            <a:endParaRPr lang="en-US" sz="1700" dirty="0"/>
+          </a:p>
+        </p:txBody>
+      </p:sp>
+      <p:sp>
+        <p:nvSpPr>
+          <p:cNvPr id="16" name="pill 2"/>
           <p:cNvSpPr/>
           <p:nvPr/>
         </p:nvSpPr>
         <p:spPr>
           <a:xfrm>
-            <a:off x="6629400" y="5257800"/>
-            <a:ext cx="4617720" cy="548640"/>
+            <a:off x="6629400" y="4709160"/>
+            <a:ext cx="4617720" cy="1051560"/>
           </a:xfrm>
           <a:prstGeom prst="roundRect">
             <a:avLst>
-              <a:gd name="adj" fmla="val 16667"/>
+              <a:gd name="adj" fmla="val 8696"/>
             </a:avLst>
           </a:prstGeom>
           <a:solidFill>
@@ -10455,14 +10494,14 @@
       </p:sp>
       <p:sp>
         <p:nvSpPr>
-          <p:cNvPr id="16" name="Text 12"/>
+          <p:cNvPr id="17" name="Text 13"/>
           <p:cNvSpPr txBox="1"/>
           <p:nvPr/>
         </p:nvSpPr>
         <p:spPr>
           <a:xfrm>
-            <a:off x="6766560" y="5257800"/>
-            <a:ext cx="4389120" cy="548640"/>
+            <a:off x="6858000" y="4709160"/>
+            <a:ext cx="822960" cy="1051560"/>
           </a:xfrm>
           <a:prstGeom prst="rect">
             <a:avLst/>
@@ -10478,14 +10517,53 @@
               <a:buNone/>
             </a:pPr>
             <a:r>
-              <a:rPr lang="en-US" sz="1500" b="1" dirty="0">
+              <a:rPr lang="en-US" sz="4800" b="1" dirty="0">
+                <a:solidFill>
+                  <a:schemeClr val="accent2"/>
+                </a:solidFill>
+                <a:latin typeface="Cambria" pitchFamily="34" charset="0"/>
+                <a:ea typeface="Cambria" pitchFamily="34" charset="-122"/>
+                <a:cs typeface="Cambria" pitchFamily="34" charset="-120"/>
+              </a:rPr>
+              <a:t>2</a:t>
+            </a:r>
+            <a:endParaRPr lang="en-US" sz="4800" dirty="0"/>
+          </a:p>
+        </p:txBody>
+      </p:sp>
+      <p:sp>
+        <p:nvSpPr>
+          <p:cNvPr id="18" name="Text 14"/>
+          <p:cNvSpPr txBox="1"/>
+          <p:nvPr/>
+        </p:nvSpPr>
+        <p:spPr>
+          <a:xfrm>
+            <a:off x="7726680" y="4709160"/>
+            <a:ext cx="3383280" cy="1051560"/>
+          </a:xfrm>
+          <a:prstGeom prst="rect">
+            <a:avLst/>
+          </a:prstGeom>
+          <a:noFill/>
+          <a:ln/>
+        </p:spPr>
+        <p:txBody>
+          <a:bodyPr wrap="square" lIns="0" tIns="0" rIns="0" bIns="0" rtlCol="0" anchor="ctr"/>
+          <a:lstStyle/>
+          <a:p>
+            <a:pPr indent="0" marL="0">
+              <a:buNone/>
+            </a:pPr>
+            <a:r>
+              <a:rPr lang="en-US" sz="1600" b="1" dirty="0">
                 <a:solidFill>
                   <a:schemeClr val="bg1"/>
                 </a:solidFill>
               </a:rPr>
               <a:t>Proceso actual realizado por 2 Personas</a:t>
             </a:r>
-            <a:endParaRPr lang="en-US" sz="1500" dirty="0"/>
+            <a:endParaRPr lang="en-US" sz="1600" dirty="0"/>
           </a:p>
         </p:txBody>
       </p:sp>
@@ -15511,7 +15589,7 @@
         <a:srgbClr val="9CC3F0"/>
       </a:accent2>
       <a:accent3>
-        <a:srgbClr val="164A8F"/>
+        <a:srgbClr val="C62828"/>
       </a:accent3>
       <a:accent4>
         <a:srgbClr val="5F7590"/>

</xml_diff>

<commit_message>
Redesign avalúos deck cover with committee tag, presenter and process panel
Co-Authored-By: Claude Opus 5.5 <noreply@anthropic.com>
Claude-Session: https://claude.ai/code/session_01Czk2XnZSpBwy6TjibqLL9A
</commit_message>
<xml_diff>
--- a/administracion-avaluos/Proyecto_Administracion_de_Avaluos.pptx
+++ b/administracion-avaluos/Proyecto_Administracion_de_Avaluos.pptx
@@ -122,17 +122,17 @@
   <p:extLst>
     <p:ext uri="{521415D9-36F7-43E2-AB2F-B90AF26B5E84}">
       <p14:sectionLst xmlns:p14="http://schemas.microsoft.com/office/powerpoint/2010/main">
-        <p14:section name="Portada" id="{c661e664-b82c-c211-0e4a-3a4a54c2c9b7}">
+        <p14:section name="Portada" id="{22d82689-dac6-75e7-c135-93a8c24a2c42}">
           <p14:sldIdLst>
             <p14:sldId id="256"/>
           </p14:sldIdLst>
         </p14:section>
-        <p14:section name="Agenda" id="{3cd19daa-abda-3c52-b4d2-8d60eca5f79a}">
+        <p14:section name="Agenda" id="{7508fe08-8f40-1a38-4575-e9e39b98e0ef}">
           <p14:sldIdLst>
             <p14:sldId id="257"/>
           </p14:sldIdLst>
         </p14:section>
-        <p14:section name="A. Situación actual" id="{080dd570-131c-2337-e7a8-5b5f58a3f19e}">
+        <p14:section name="A. Situación actual" id="{63529c3b-833a-f2c9-68c0-bf28e6cba625}">
           <p14:sldIdLst>
             <p14:sldId id="258"/>
             <p14:sldId id="259"/>
@@ -141,19 +141,19 @@
             <p14:sldId id="262"/>
           </p14:sldIdLst>
         </p14:section>
-        <p14:section name="Datos operativos" id="{46e2077f-4e92-a6bd-d797-b93eac4ca648}">
+        <p14:section name="Datos operativos" id="{eb3d47b3-577d-e5a9-ab33-e22b751e8f89}">
           <p14:sldIdLst>
             <p14:sldId id="263"/>
             <p14:sldId id="264"/>
             <p14:sldId id="265"/>
           </p14:sldIdLst>
         </p14:section>
-        <p14:section name="Riesgo identificado" id="{66fd3ea6-eb99-2181-0d52-b42d91fbfe14}">
+        <p14:section name="Riesgo identificado" id="{0fad8d71-8fb8-6683-149f-3a90880ed91c}">
           <p14:sldIdLst>
             <p14:sldId id="266"/>
           </p14:sldIdLst>
         </p14:section>
-        <p14:section name="B. Propuesta" id="{491ed73d-afbc-2802-7cd9-63c9fdf84546}">
+        <p14:section name="B. Propuesta" id="{ed836c95-da7c-6388-1b34-1557087b48fe}">
           <p14:sldIdLst>
             <p14:sldId id="267"/>
             <p14:sldId id="268"/>
@@ -161,7 +161,7 @@
             <p14:sldId id="270"/>
           </p14:sldIdLst>
         </p14:section>
-        <p14:section name="Solicitud" id="{a37644ab-1a46-45e6-d21a-e7ddbdd7f40a}">
+        <p14:section name="Solicitud" id="{8bdffed7-a00e-ded7-47b9-b4af335f8a61}">
           <p14:sldIdLst>
             <p14:sldId id="271"/>
           </p14:sldIdLst>
@@ -2784,8 +2784,8 @@
         </p:nvSpPr>
         <p:spPr>
           <a:xfrm>
-            <a:off x="731520" y="2011680"/>
-            <a:ext cx="7863840" cy="1737360"/>
+            <a:off x="731520" y="1828800"/>
+            <a:ext cx="6675120" cy="1828800"/>
           </a:xfrm>
           <a:prstGeom prst="rect">
             <a:avLst/>
@@ -2823,8 +2823,8 @@
         </p:nvSpPr>
         <p:spPr>
           <a:xfrm>
-            <a:off x="731520" y="3977640"/>
-            <a:ext cx="7863840" cy="1097280"/>
+            <a:off x="731520" y="3886200"/>
+            <a:ext cx="6675120" cy="914400"/>
           </a:xfrm>
           <a:prstGeom prst="rect">
             <a:avLst/>
@@ -3519,8 +3519,8 @@
         </p:nvSpPr>
         <p:spPr>
           <a:xfrm>
-            <a:off x="731520" y="2011680"/>
-            <a:ext cx="7863840" cy="1737360"/>
+            <a:off x="731520" y="1828800"/>
+            <a:ext cx="6675120" cy="1828800"/>
           </a:xfrm>
           <a:prstGeom prst="rect">
             <a:avLst/>
@@ -3557,8 +3557,8 @@
         </p:nvSpPr>
         <p:spPr>
           <a:xfrm>
-            <a:off x="731520" y="3977640"/>
-            <a:ext cx="7863840" cy="1097280"/>
+            <a:off x="731520" y="3886200"/>
+            <a:ext cx="6675120" cy="914400"/>
           </a:xfrm>
           <a:prstGeom prst="rect">
             <a:avLst/>
@@ -3587,53 +3587,19 @@
       </p:sp>
       <p:sp>
         <p:nvSpPr>
-          <p:cNvPr id="4" name="Text 2"/>
-          <p:cNvSpPr txBox="1"/>
-          <p:nvPr/>
-        </p:nvSpPr>
-        <p:spPr>
-          <a:xfrm>
-            <a:off x="731520" y="5760720"/>
-            <a:ext cx="7315200" cy="365760"/>
-          </a:xfrm>
-          <a:prstGeom prst="rect">
-            <a:avLst/>
-          </a:prstGeom>
-          <a:noFill/>
-          <a:ln/>
-        </p:spPr>
-        <p:txBody>
-          <a:bodyPr wrap="square" lIns="0" tIns="0" rIns="0" bIns="0" rtlCol="0" anchor="t"/>
-          <a:lstStyle/>
-          <a:p>
-            <a:pPr indent="0" marL="0">
-              <a:buNone/>
-            </a:pPr>
-            <a:r>
-              <a:rPr lang="en-US" sz="1400" dirty="0">
-                <a:solidFill>
-                  <a:schemeClr val="bg1"/>
-                </a:solidFill>
-              </a:rPr>
-              <a:t>Departamento de Administración de Riesgos  ·  Octubre 2026</a:t>
-            </a:r>
-            <a:endParaRPr lang="en-US" sz="1400" dirty="0"/>
-          </a:p>
-        </p:txBody>
-      </p:sp>
-      <p:sp>
-        <p:nvSpPr>
-          <p:cNvPr id="5" name="hero circle"/>
+          <p:cNvPr id="4" name="portada etiqueta"/>
           <p:cNvSpPr/>
           <p:nvPr/>
         </p:nvSpPr>
         <p:spPr>
           <a:xfrm>
-            <a:off x="8732520" y="1691640"/>
-            <a:ext cx="2926080" cy="2926080"/>
-          </a:xfrm>
-          <a:prstGeom prst="ellipse">
-            <a:avLst/>
+            <a:off x="731520" y="1051560"/>
+            <a:ext cx="3931920" cy="457200"/>
+          </a:xfrm>
+          <a:prstGeom prst="roundRect">
+            <a:avLst>
+              <a:gd name="adj" fmla="val 50000"/>
+            </a:avLst>
           </a:prstGeom>
           <a:solidFill>
             <a:srgbClr val="1F5FAE"/>
@@ -3646,9 +3612,190 @@
           </a:ln>
         </p:spPr>
       </p:sp>
+      <p:sp>
+        <p:nvSpPr>
+          <p:cNvPr id="5" name="Text 3"/>
+          <p:cNvSpPr txBox="1"/>
+          <p:nvPr/>
+        </p:nvSpPr>
+        <p:spPr>
+          <a:xfrm>
+            <a:off x="731520" y="1051560"/>
+            <a:ext cx="3931920" cy="457200"/>
+          </a:xfrm>
+          <a:prstGeom prst="rect">
+            <a:avLst/>
+          </a:prstGeom>
+          <a:noFill/>
+          <a:ln/>
+        </p:spPr>
+        <p:txBody>
+          <a:bodyPr wrap="square" lIns="0" tIns="0" rIns="0" bIns="0" rtlCol="0" anchor="ctr"/>
+          <a:lstStyle/>
+          <a:p>
+            <a:pPr algn="ctr" indent="0" marL="0">
+              <a:buNone/>
+            </a:pPr>
+            <a:r>
+              <a:rPr lang="en-US" sz="1300" b="1" spc="200" kern="0" dirty="0">
+                <a:solidFill>
+                  <a:schemeClr val="bg1"/>
+                </a:solidFill>
+              </a:rPr>
+              <a:t>COMITÉ DE RIESGO  ·  OCTUBRE 2026</a:t>
+            </a:r>
+            <a:endParaRPr lang="en-US" sz="1300" dirty="0"/>
+          </a:p>
+        </p:txBody>
+      </p:sp>
+      <p:sp>
+        <p:nvSpPr>
+          <p:cNvPr id="6" name="Text 4"/>
+          <p:cNvSpPr txBox="1"/>
+          <p:nvPr/>
+        </p:nvSpPr>
+        <p:spPr>
+          <a:xfrm>
+            <a:off x="731520" y="5257800"/>
+            <a:ext cx="5486400" cy="320040"/>
+          </a:xfrm>
+          <a:prstGeom prst="rect">
+            <a:avLst/>
+          </a:prstGeom>
+          <a:noFill/>
+          <a:ln/>
+        </p:spPr>
+        <p:txBody>
+          <a:bodyPr wrap="square" lIns="0" tIns="0" rIns="0" bIns="0" rtlCol="0" anchor="t"/>
+          <a:lstStyle/>
+          <a:p>
+            <a:pPr indent="0" marL="0">
+              <a:buNone/>
+            </a:pPr>
+            <a:r>
+              <a:rPr lang="en-US" sz="1200" dirty="0">
+                <a:solidFill>
+                  <a:schemeClr val="accent2"/>
+                </a:solidFill>
+              </a:rPr>
+              <a:t>Presentado por</a:t>
+            </a:r>
+            <a:endParaRPr lang="en-US" sz="1200" dirty="0"/>
+          </a:p>
+        </p:txBody>
+      </p:sp>
+      <p:sp>
+        <p:nvSpPr>
+          <p:cNvPr id="7" name="Text 5"/>
+          <p:cNvSpPr txBox="1"/>
+          <p:nvPr/>
+        </p:nvSpPr>
+        <p:spPr>
+          <a:xfrm>
+            <a:off x="731520" y="5577840"/>
+            <a:ext cx="6675120" cy="411480"/>
+          </a:xfrm>
+          <a:prstGeom prst="rect">
+            <a:avLst/>
+          </a:prstGeom>
+          <a:noFill/>
+          <a:ln/>
+        </p:spPr>
+        <p:txBody>
+          <a:bodyPr wrap="square" lIns="0" tIns="0" rIns="0" bIns="0" rtlCol="0" anchor="t"/>
+          <a:lstStyle/>
+          <a:p>
+            <a:pPr indent="0" marL="0">
+              <a:buNone/>
+            </a:pPr>
+            <a:r>
+              <a:rPr lang="en-US" sz="1800" b="1" dirty="0">
+                <a:solidFill>
+                  <a:schemeClr val="bg1"/>
+                </a:solidFill>
+              </a:rPr>
+              <a:t>Departamento de Administración de Riesgos</a:t>
+            </a:r>
+            <a:endParaRPr lang="en-US" sz="1800" dirty="0"/>
+          </a:p>
+        </p:txBody>
+      </p:sp>
+      <p:sp>
+        <p:nvSpPr>
+          <p:cNvPr id="8" name="portada panel"/>
+          <p:cNvSpPr/>
+          <p:nvPr/>
+        </p:nvSpPr>
+        <p:spPr>
+          <a:xfrm>
+            <a:off x="7863840" y="0"/>
+            <a:ext cx="4327855" cy="6858000"/>
+          </a:xfrm>
+          <a:prstGeom prst="rect">
+            <a:avLst/>
+          </a:prstGeom>
+          <a:solidFill>
+            <a:srgbClr val="1F5FAE"/>
+          </a:solidFill>
+          <a:ln w="12700">
+            <a:solidFill>
+              <a:srgbClr val="1F5FAE"/>
+            </a:solidFill>
+            <a:prstDash val="solid"/>
+          </a:ln>
+        </p:spPr>
+      </p:sp>
+      <p:sp>
+        <p:nvSpPr>
+          <p:cNvPr id="9" name="flujo linea 1"/>
+          <p:cNvSpPr/>
+          <p:nvPr/>
+        </p:nvSpPr>
+        <p:spPr>
+          <a:xfrm>
+            <a:off x="8823960" y="1965960"/>
+            <a:ext cx="0" cy="502920"/>
+          </a:xfrm>
+          <a:prstGeom prst="line">
+            <a:avLst/>
+          </a:prstGeom>
+          <a:noFill/>
+          <a:ln w="25400">
+            <a:solidFill>
+              <a:srgbClr val="9CC3F0"/>
+            </a:solidFill>
+            <a:prstDash val="solid"/>
+          </a:ln>
+        </p:spPr>
+      </p:sp>
+      <p:sp>
+        <p:nvSpPr>
+          <p:cNvPr id="10" name="flujo 1 circle"/>
+          <p:cNvSpPr/>
+          <p:nvPr/>
+        </p:nvSpPr>
+        <p:spPr>
+          <a:xfrm>
+            <a:off x="8412480" y="1143000"/>
+            <a:ext cx="822960" cy="822960"/>
+          </a:xfrm>
+          <a:prstGeom prst="ellipse">
+            <a:avLst/>
+          </a:prstGeom>
+          <a:solidFill>
+            <a:srgbClr val="FFFFFF"/>
+          </a:solidFill>
+          <a:ln w="12700">
+            <a:solidFill>
+              <a:srgbClr val="FFFFFF"/>
+            </a:solidFill>
+            <a:prstDash val="solid"/>
+          </a:ln>
+        </p:spPr>
+      </p:sp>
       <p:pic>
         <p:nvPicPr>
-          <p:cNvPr id="6" name="hero icon" descr="preencoded.png">    </p:cNvPr>
+          <p:cNvPr id="11" name="flujo 1 icon" descr="preencoded.png">    </p:cNvPr>
           <p:cNvPicPr>
             <a:picLocks noChangeAspect="1"/>
           </p:cNvPicPr>
@@ -3662,8 +3809,8 @@
         </p:blipFill>
         <p:spPr>
           <a:xfrm>
-            <a:off x="9372600" y="2331720"/>
-            <a:ext cx="1645920" cy="1645920"/>
+            <a:off x="8593531" y="1324051"/>
+            <a:ext cx="460858" cy="460858"/>
           </a:xfrm>
           <a:prstGeom prst="rect">
             <a:avLst/>
@@ -3672,22 +3819,56 @@
       </p:pic>
       <p:sp>
         <p:nvSpPr>
-          <p:cNvPr id="7" name="hero badge"/>
+          <p:cNvPr id="12" name="Text 9"/>
+          <p:cNvSpPr txBox="1"/>
+          <p:nvPr/>
+        </p:nvSpPr>
+        <p:spPr>
+          <a:xfrm>
+            <a:off x="9464040" y="1143000"/>
+            <a:ext cx="2468880" cy="822960"/>
+          </a:xfrm>
+          <a:prstGeom prst="rect">
+            <a:avLst/>
+          </a:prstGeom>
+          <a:noFill/>
+          <a:ln/>
+        </p:spPr>
+        <p:txBody>
+          <a:bodyPr wrap="square" lIns="0" tIns="0" rIns="0" bIns="0" rtlCol="0" anchor="ctr"/>
+          <a:lstStyle/>
+          <a:p>
+            <a:pPr indent="0" marL="0">
+              <a:buNone/>
+            </a:pPr>
+            <a:r>
+              <a:rPr lang="en-US" sz="1700" b="1" dirty="0">
+                <a:solidFill>
+                  <a:schemeClr val="bg1"/>
+                </a:solidFill>
+              </a:rPr>
+              <a:t>Inmueble en garantía</a:t>
+            </a:r>
+            <a:endParaRPr lang="en-US" sz="1700" dirty="0"/>
+          </a:p>
+        </p:txBody>
+      </p:sp>
+      <p:sp>
+        <p:nvSpPr>
+          <p:cNvPr id="13" name="flujo linea 2"/>
           <p:cNvSpPr/>
           <p:nvPr/>
         </p:nvSpPr>
         <p:spPr>
           <a:xfrm>
-            <a:off x="10972800" y="4069080"/>
-            <a:ext cx="822960" cy="822960"/>
-          </a:xfrm>
-          <a:prstGeom prst="ellipse">
-            <a:avLst/>
-          </a:prstGeom>
-          <a:solidFill>
-            <a:srgbClr val="9CC3F0"/>
-          </a:solidFill>
-          <a:ln w="12700">
+            <a:off x="8823960" y="3291840"/>
+            <a:ext cx="0" cy="502920"/>
+          </a:xfrm>
+          <a:prstGeom prst="line">
+            <a:avLst/>
+          </a:prstGeom>
+          <a:noFill/>
+          <a:ln w="25400">
             <a:solidFill>
               <a:srgbClr val="9CC3F0"/>
             </a:solidFill>
@@ -3695,9 +3876,34 @@
           </a:ln>
         </p:spPr>
       </p:sp>
+      <p:sp>
+        <p:nvSpPr>
+          <p:cNvPr id="14" name="flujo 2 circle"/>
+          <p:cNvSpPr/>
+          <p:nvPr/>
+        </p:nvSpPr>
+        <p:spPr>
+          <a:xfrm>
+            <a:off x="8412480" y="2468880"/>
+            <a:ext cx="822960" cy="822960"/>
+          </a:xfrm>
+          <a:prstGeom prst="ellipse">
+            <a:avLst/>
+          </a:prstGeom>
+          <a:solidFill>
+            <a:srgbClr val="FFFFFF"/>
+          </a:solidFill>
+          <a:ln w="12700">
+            <a:solidFill>
+              <a:srgbClr val="FFFFFF"/>
+            </a:solidFill>
+            <a:prstDash val="solid"/>
+          </a:ln>
+        </p:spPr>
+      </p:sp>
       <p:pic>
         <p:nvPicPr>
-          <p:cNvPr id="8" name="hero badge icon" descr="preencoded.png">    </p:cNvPr>
+          <p:cNvPr id="15" name="flujo 2 icon" descr="preencoded.png">    </p:cNvPr>
           <p:cNvPicPr>
             <a:picLocks noChangeAspect="1"/>
           </p:cNvPicPr>
@@ -3711,14 +3917,243 @@
         </p:blipFill>
         <p:spPr>
           <a:xfrm>
-            <a:off x="11137392" y="4233672"/>
-            <a:ext cx="493776" cy="493776"/>
+            <a:off x="8593531" y="2649931"/>
+            <a:ext cx="460858" cy="460858"/>
           </a:xfrm>
           <a:prstGeom prst="rect">
             <a:avLst/>
           </a:prstGeom>
         </p:spPr>
       </p:pic>
+      <p:sp>
+        <p:nvSpPr>
+          <p:cNvPr id="16" name="Text 12"/>
+          <p:cNvSpPr txBox="1"/>
+          <p:nvPr/>
+        </p:nvSpPr>
+        <p:spPr>
+          <a:xfrm>
+            <a:off x="9464040" y="2468880"/>
+            <a:ext cx="2468880" cy="822960"/>
+          </a:xfrm>
+          <a:prstGeom prst="rect">
+            <a:avLst/>
+          </a:prstGeom>
+          <a:noFill/>
+          <a:ln/>
+        </p:spPr>
+        <p:txBody>
+          <a:bodyPr wrap="square" lIns="0" tIns="0" rIns="0" bIns="0" rtlCol="0" anchor="ctr"/>
+          <a:lstStyle/>
+          <a:p>
+            <a:pPr indent="0" marL="0">
+              <a:buNone/>
+            </a:pPr>
+            <a:r>
+              <a:rPr lang="en-US" sz="1700" b="1" dirty="0">
+                <a:solidFill>
+                  <a:schemeClr val="bg1"/>
+                </a:solidFill>
+              </a:rPr>
+              <a:t>Informe de avalúo</a:t>
+            </a:r>
+            <a:endParaRPr lang="en-US" sz="1700" dirty="0"/>
+          </a:p>
+        </p:txBody>
+      </p:sp>
+      <p:sp>
+        <p:nvSpPr>
+          <p:cNvPr id="17" name="flujo linea 3"/>
+          <p:cNvSpPr/>
+          <p:nvPr/>
+        </p:nvSpPr>
+        <p:spPr>
+          <a:xfrm>
+            <a:off x="8823960" y="4617720"/>
+            <a:ext cx="0" cy="502920"/>
+          </a:xfrm>
+          <a:prstGeom prst="line">
+            <a:avLst/>
+          </a:prstGeom>
+          <a:noFill/>
+          <a:ln w="25400">
+            <a:solidFill>
+              <a:srgbClr val="9CC3F0"/>
+            </a:solidFill>
+            <a:prstDash val="solid"/>
+          </a:ln>
+        </p:spPr>
+      </p:sp>
+      <p:sp>
+        <p:nvSpPr>
+          <p:cNvPr id="18" name="flujo 3 circle"/>
+          <p:cNvSpPr/>
+          <p:nvPr/>
+        </p:nvSpPr>
+        <p:spPr>
+          <a:xfrm>
+            <a:off x="8412480" y="3794760"/>
+            <a:ext cx="822960" cy="822960"/>
+          </a:xfrm>
+          <a:prstGeom prst="ellipse">
+            <a:avLst/>
+          </a:prstGeom>
+          <a:solidFill>
+            <a:srgbClr val="FFFFFF"/>
+          </a:solidFill>
+          <a:ln w="12700">
+            <a:solidFill>
+              <a:srgbClr val="FFFFFF"/>
+            </a:solidFill>
+            <a:prstDash val="solid"/>
+          </a:ln>
+        </p:spPr>
+      </p:sp>
+      <p:pic>
+        <p:nvPicPr>
+          <p:cNvPr id="19" name="flujo 3 icon" descr="preencoded.png">    </p:cNvPr>
+          <p:cNvPicPr>
+            <a:picLocks noChangeAspect="1"/>
+          </p:cNvPicPr>
+          <p:nvPr/>
+        </p:nvPicPr>
+        <p:blipFill>
+          <a:blip r:embed="rId3"/>
+          <a:stretch>
+            <a:fillRect/>
+          </a:stretch>
+        </p:blipFill>
+        <p:spPr>
+          <a:xfrm>
+            <a:off x="8593531" y="3975811"/>
+            <a:ext cx="460858" cy="460858"/>
+          </a:xfrm>
+          <a:prstGeom prst="rect">
+            <a:avLst/>
+          </a:prstGeom>
+        </p:spPr>
+      </p:pic>
+      <p:sp>
+        <p:nvSpPr>
+          <p:cNvPr id="20" name="Text 15"/>
+          <p:cNvSpPr txBox="1"/>
+          <p:nvPr/>
+        </p:nvSpPr>
+        <p:spPr>
+          <a:xfrm>
+            <a:off x="9464040" y="3794760"/>
+            <a:ext cx="2468880" cy="822960"/>
+          </a:xfrm>
+          <a:prstGeom prst="rect">
+            <a:avLst/>
+          </a:prstGeom>
+          <a:noFill/>
+          <a:ln/>
+        </p:spPr>
+        <p:txBody>
+          <a:bodyPr wrap="square" lIns="0" tIns="0" rIns="0" bIns="0" rtlCol="0" anchor="ctr"/>
+          <a:lstStyle/>
+          <a:p>
+            <a:pPr indent="0" marL="0">
+              <a:buNone/>
+            </a:pPr>
+            <a:r>
+              <a:rPr lang="en-US" sz="1700" b="1" dirty="0">
+                <a:solidFill>
+                  <a:schemeClr val="bg1"/>
+                </a:solidFill>
+              </a:rPr>
+              <a:t>Revisión (NRP-27)</a:t>
+            </a:r>
+            <a:endParaRPr lang="en-US" sz="1700" dirty="0"/>
+          </a:p>
+        </p:txBody>
+      </p:sp>
+      <p:sp>
+        <p:nvSpPr>
+          <p:cNvPr id="21" name="flujo 4 circle"/>
+          <p:cNvSpPr/>
+          <p:nvPr/>
+        </p:nvSpPr>
+        <p:spPr>
+          <a:xfrm>
+            <a:off x="8412480" y="5120640"/>
+            <a:ext cx="822960" cy="822960"/>
+          </a:xfrm>
+          <a:prstGeom prst="ellipse">
+            <a:avLst/>
+          </a:prstGeom>
+          <a:solidFill>
+            <a:srgbClr val="FFFFFF"/>
+          </a:solidFill>
+          <a:ln w="12700">
+            <a:solidFill>
+              <a:srgbClr val="FFFFFF"/>
+            </a:solidFill>
+            <a:prstDash val="solid"/>
+          </a:ln>
+        </p:spPr>
+      </p:sp>
+      <p:pic>
+        <p:nvPicPr>
+          <p:cNvPr id="22" name="flujo 4 icon" descr="preencoded.png">    </p:cNvPr>
+          <p:cNvPicPr>
+            <a:picLocks noChangeAspect="1"/>
+          </p:cNvPicPr>
+          <p:nvPr/>
+        </p:nvPicPr>
+        <p:blipFill>
+          <a:blip r:embed="rId4"/>
+          <a:stretch>
+            <a:fillRect/>
+          </a:stretch>
+        </p:blipFill>
+        <p:spPr>
+          <a:xfrm>
+            <a:off x="8593531" y="5301691"/>
+            <a:ext cx="460858" cy="460858"/>
+          </a:xfrm>
+          <a:prstGeom prst="rect">
+            <a:avLst/>
+          </a:prstGeom>
+        </p:spPr>
+      </p:pic>
+      <p:sp>
+        <p:nvSpPr>
+          <p:cNvPr id="23" name="Text 17"/>
+          <p:cNvSpPr txBox="1"/>
+          <p:nvPr/>
+        </p:nvSpPr>
+        <p:spPr>
+          <a:xfrm>
+            <a:off x="9464040" y="5120640"/>
+            <a:ext cx="2468880" cy="822960"/>
+          </a:xfrm>
+          <a:prstGeom prst="rect">
+            <a:avLst/>
+          </a:prstGeom>
+          <a:noFill/>
+          <a:ln/>
+        </p:spPr>
+        <p:txBody>
+          <a:bodyPr wrap="square" lIns="0" tIns="0" rIns="0" bIns="0" rtlCol="0" anchor="ctr"/>
+          <a:lstStyle/>
+          <a:p>
+            <a:pPr indent="0" marL="0">
+              <a:buNone/>
+            </a:pPr>
+            <a:r>
+              <a:rPr lang="en-US" sz="1700" b="1" dirty="0">
+                <a:solidFill>
+                  <a:schemeClr val="bg1"/>
+                </a:solidFill>
+              </a:rPr>
+              <a:t>Administración de Riesgos</a:t>
+            </a:r>
+            <a:endParaRPr lang="en-US" sz="1700" dirty="0"/>
+          </a:p>
+        </p:txBody>
+      </p:sp>
     </p:spTree>
   </p:cSld>
   <p:clrMapOvr>

</xml_diff>

<commit_message>
Add current-process slide (weaknesses, 4-step process, policy/procedure response)
Co-Authored-By: Claude Opus 5.5 <noreply@anthropic.com>
Claude-Session: https://claude.ai/code/session_01Czk2XnZSpBwy6TjibqLL9A
</commit_message>
<xml_diff>
--- a/administracion-avaluos/Proyecto_Administracion_de_Avaluos.pptx
+++ b/administracion-avaluos/Proyecto_Administracion_de_Avaluos.pptx
@@ -11,6 +11,7 @@
     <p:sldId id="256" r:id="rId2"/>
     <p:sldId id="257" r:id="rId3"/>
     <p:sldId id="259" r:id="rId5"/>
+    <p:sldId id="274" r:id="rId26"/>
     <p:sldId id="260" r:id="rId6"/>
     <p:sldId id="261" r:id="rId7"/>
     <p:sldId id="262" r:id="rId8"/>
@@ -135,6 +136,7 @@
         <p14:section name="Situación actual" id="{B72421C7-06EF-DB71-5161-B4DC8143E223}">
           <p14:sldIdLst>
             <p14:sldId id="259"/>
+            <p14:sldId id="274"/>
             <p14:sldId id="260"/>
             <p14:sldId id="261"/>
             <p14:sldId id="262"/>
@@ -10134,6 +10136,1377 @@
 </p:sld>
 </file>
 
+<file path=ppt/slides/slide18.xml><?xml version="1.0" encoding="utf-8"?>
+<p:sld xmlns:a="http://schemas.openxmlformats.org/drawingml/2006/main" xmlns:r="http://schemas.openxmlformats.org/officeDocument/2006/relationships" xmlns:p="http://schemas.openxmlformats.org/presentationml/2006/main">
+  <p:cSld name="Slide 4">
+    <p:spTree>
+      <p:nvGrpSpPr>
+        <p:cNvPr id="1" name=""/>
+        <p:cNvGrpSpPr/>
+        <p:nvPr/>
+      </p:nvGrpSpPr>
+      <p:grpSpPr>
+        <a:xfrm>
+          <a:off x="0" y="0"/>
+          <a:ext cx="0" cy="0"/>
+          <a:chOff x="0" y="0"/>
+          <a:chExt cx="0" cy="0"/>
+        </a:xfrm>
+      </p:grpSpPr>
+      <p:sp>
+        <p:nvSpPr>
+          <p:cNvPr id="2" name="Text 1"/>
+          <p:cNvSpPr>
+            <a:spLocks noGrp="1"/>
+          </p:cNvSpPr>
+          <p:nvPr>
+            <p:ph type="title" idx="101" hasCustomPrompt="1"/>
+          </p:nvPr>
+        </p:nvSpPr>
+        <p:spPr>
+          <a:xfrm>
+            <a:off x="777240" y="347472"/>
+            <a:ext cx="9995034" cy="636422"/>
+          </a:xfrm>
+          <a:prstGeom prst="rect">
+            <a:avLst/>
+          </a:prstGeom>
+          <a:noFill/>
+          <a:ln/>
+        </p:spPr>
+        <p:txBody>
+          <a:bodyPr wrap="square" lIns="0" tIns="0" rIns="0" bIns="0" rtlCol="0" anchor="ctr"/>
+          <a:lstStyle/>
+          <a:p>
+            <a:pPr marL="0" indent="0" algn="l">
+              <a:buNone/>
+            </a:pPr>
+            <a:r>
+              <a:rPr lang="es-SV" sz="2400" b="1" noProof="0" dirty="0">
+                <a:solidFill>
+                  <a:schemeClr val="tx2"/>
+                </a:solidFill>
+                <a:latin typeface="Arial" panose="020B0604020202020204" pitchFamily="34" charset="0"/>
+                <a:cs typeface="Arial" panose="020B0604020202020204" pitchFamily="34" charset="0"/>
+              </a:rPr>
+              <a:t>SITUACIÓN ACTUAL DEL PROCESO DE AVALÚOS</a:t>
+            </a:r>
+            <a:endParaRPr lang="es-SV" sz="2400" noProof="0" dirty="0">
+              <a:latin typeface="Arial" panose="020B0604020202020204" pitchFamily="34" charset="0"/>
+              <a:cs typeface="Arial" panose="020B0604020202020204" pitchFamily="34" charset="0"/>
+            </a:endParaRPr>
+          </a:p>
+        </p:txBody>
+      </p:sp>
+      <p:sp>
+        <p:nvSpPr>
+          <p:cNvPr id="101" name="Etiqueta debilidades"/>
+          <p:cNvSpPr txBox="1"/>
+          <p:nvPr/>
+        </p:nvSpPr>
+        <p:spPr>
+          <a:xfrm>
+            <a:off x="548640" y="1188720"/>
+            <a:ext cx="7040880" cy="320040"/>
+          </a:xfrm>
+          <a:prstGeom prst="rect">
+            <a:avLst/>
+          </a:prstGeom>
+          <a:noFill/>
+          <a:ln>
+            <a:noFill/>
+          </a:ln>
+        </p:spPr>
+        <p:txBody>
+          <a:bodyPr wrap="square" lIns="0" tIns="0" rIns="0" bIns="0" rtlCol="0" anchor="ctr">
+            <a:normAutofit/>
+          </a:bodyPr>
+          <a:lstStyle/>
+          <a:p>
+            <a:pPr marL="0" indent="0" algn="l">
+              <a:buNone/>
+            </a:pPr>
+            <a:r>
+              <a:rPr lang="es-SV" sz="1200" b="1" dirty="0">
+                <a:solidFill>
+                  <a:srgbClr val="C62828"/>
+                </a:solidFill>
+                <a:latin typeface="Arial" panose="020B0604020202020204" pitchFamily="34" charset="0"/>
+                <a:cs typeface="Arial" panose="020B0604020202020204" pitchFamily="34" charset="0"/>
+              </a:rPr>
+              <a:t>DEBILIDADES IDENTIFICADAS</a:t>
+            </a:r>
+          </a:p>
+        </p:txBody>
+      </p:sp>
+      <p:sp>
+        <p:nvSpPr>
+          <p:cNvPr id="102" name="Debilidad 1"/>
+          <p:cNvSpPr/>
+          <p:nvPr/>
+        </p:nvSpPr>
+        <p:spPr>
+          <a:xfrm>
+            <a:off x="548640" y="1554480"/>
+            <a:ext cx="3429000" cy="731520"/>
+          </a:xfrm>
+          <a:prstGeom prst="roundRect">
+            <a:avLst>
+              <a:gd name="adj" fmla="val 12000"/>
+            </a:avLst>
+          </a:prstGeom>
+          <a:solidFill>
+            <a:srgbClr val="FBEAEA"/>
+          </a:solidFill>
+          <a:ln w="9525">
+            <a:solidFill>
+              <a:srgbClr val="C62828"/>
+            </a:solidFill>
+          </a:ln>
+        </p:spPr>
+      </p:sp>
+      <p:sp>
+        <p:nvSpPr>
+          <p:cNvPr id="103" name="Debilidad 1 marca"/>
+          <p:cNvSpPr/>
+          <p:nvPr/>
+        </p:nvSpPr>
+        <p:spPr>
+          <a:xfrm>
+            <a:off x="731520" y="1719072"/>
+            <a:ext cx="402336" cy="402336"/>
+          </a:xfrm>
+          <a:prstGeom prst="ellipse">
+            <a:avLst/>
+          </a:prstGeom>
+          <a:solidFill>
+            <a:srgbClr val="C62828"/>
+          </a:solidFill>
+          <a:ln>
+            <a:noFill/>
+          </a:ln>
+        </p:spPr>
+        <p:txBody>
+          <a:bodyPr wrap="square" lIns="0" tIns="0" rIns="0" bIns="0" rtlCol="0" anchor="ctr">
+            <a:normAutofit/>
+          </a:bodyPr>
+          <a:lstStyle/>
+          <a:p>
+            <a:pPr marL="0" indent="0" algn="ctr">
+              <a:buNone/>
+            </a:pPr>
+            <a:r>
+              <a:rPr lang="es-SV" sz="1600" b="1" dirty="0">
+                <a:solidFill>
+                  <a:srgbClr val="FFFFFF"/>
+                </a:solidFill>
+                <a:latin typeface="Arial" panose="020B0604020202020204" pitchFamily="34" charset="0"/>
+                <a:cs typeface="Arial" panose="020B0604020202020204" pitchFamily="34" charset="0"/>
+              </a:rPr>
+              <a:t>!</a:t>
+            </a:r>
+          </a:p>
+        </p:txBody>
+      </p:sp>
+      <p:sp>
+        <p:nvSpPr>
+          <p:cNvPr id="104" name="Debilidad 1 texto"/>
+          <p:cNvSpPr txBox="1"/>
+          <p:nvPr/>
+        </p:nvSpPr>
+        <p:spPr>
+          <a:xfrm>
+            <a:off x="1280160" y="1554480"/>
+            <a:ext cx="2560320" cy="731520"/>
+          </a:xfrm>
+          <a:prstGeom prst="rect">
+            <a:avLst/>
+          </a:prstGeom>
+          <a:noFill/>
+          <a:ln>
+            <a:noFill/>
+          </a:ln>
+        </p:spPr>
+        <p:txBody>
+          <a:bodyPr wrap="square" lIns="0" tIns="0" rIns="0" bIns="0" rtlCol="0" anchor="ctr">
+            <a:normAutofit/>
+          </a:bodyPr>
+          <a:lstStyle/>
+          <a:p>
+            <a:pPr marL="0" indent="0" algn="l">
+              <a:buNone/>
+            </a:pPr>
+            <a:r>
+              <a:rPr lang="es-SV" sz="1300" b="1" dirty="0">
+                <a:solidFill>
+                  <a:srgbClr val="002060"/>
+                </a:solidFill>
+                <a:latin typeface="Arial" panose="020B0604020202020204" pitchFamily="34" charset="0"/>
+                <a:cs typeface="Arial" panose="020B0604020202020204" pitchFamily="34" charset="0"/>
+              </a:rPr>
+              <a:t>Debilidad en el análisis de los Informes de Avalúos</a:t>
+            </a:r>
+          </a:p>
+        </p:txBody>
+      </p:sp>
+      <p:sp>
+        <p:nvSpPr>
+          <p:cNvPr id="105" name="Debilidad 2"/>
+          <p:cNvSpPr/>
+          <p:nvPr/>
+        </p:nvSpPr>
+        <p:spPr>
+          <a:xfrm>
+            <a:off x="4160520" y="1554480"/>
+            <a:ext cx="3429000" cy="731520"/>
+          </a:xfrm>
+          <a:prstGeom prst="roundRect">
+            <a:avLst>
+              <a:gd name="adj" fmla="val 12000"/>
+            </a:avLst>
+          </a:prstGeom>
+          <a:solidFill>
+            <a:srgbClr val="FBEAEA"/>
+          </a:solidFill>
+          <a:ln w="9525">
+            <a:solidFill>
+              <a:srgbClr val="C62828"/>
+            </a:solidFill>
+          </a:ln>
+        </p:spPr>
+      </p:sp>
+      <p:sp>
+        <p:nvSpPr>
+          <p:cNvPr id="106" name="Debilidad 2 marca"/>
+          <p:cNvSpPr/>
+          <p:nvPr/>
+        </p:nvSpPr>
+        <p:spPr>
+          <a:xfrm>
+            <a:off x="4343400" y="1719072"/>
+            <a:ext cx="402336" cy="402336"/>
+          </a:xfrm>
+          <a:prstGeom prst="ellipse">
+            <a:avLst/>
+          </a:prstGeom>
+          <a:solidFill>
+            <a:srgbClr val="C62828"/>
+          </a:solidFill>
+          <a:ln>
+            <a:noFill/>
+          </a:ln>
+        </p:spPr>
+        <p:txBody>
+          <a:bodyPr wrap="square" lIns="0" tIns="0" rIns="0" bIns="0" rtlCol="0" anchor="ctr">
+            <a:normAutofit/>
+          </a:bodyPr>
+          <a:lstStyle/>
+          <a:p>
+            <a:pPr marL="0" indent="0" algn="ctr">
+              <a:buNone/>
+            </a:pPr>
+            <a:r>
+              <a:rPr lang="es-SV" sz="1600" b="1" dirty="0">
+                <a:solidFill>
+                  <a:srgbClr val="FFFFFF"/>
+                </a:solidFill>
+                <a:latin typeface="Arial" panose="020B0604020202020204" pitchFamily="34" charset="0"/>
+                <a:cs typeface="Arial" panose="020B0604020202020204" pitchFamily="34" charset="0"/>
+              </a:rPr>
+              <a:t>!</a:t>
+            </a:r>
+          </a:p>
+        </p:txBody>
+      </p:sp>
+      <p:sp>
+        <p:nvSpPr>
+          <p:cNvPr id="107" name="Debilidad 2 texto"/>
+          <p:cNvSpPr txBox="1"/>
+          <p:nvPr/>
+        </p:nvSpPr>
+        <p:spPr>
+          <a:xfrm>
+            <a:off x="4892040" y="1554480"/>
+            <a:ext cx="2560320" cy="731520"/>
+          </a:xfrm>
+          <a:prstGeom prst="rect">
+            <a:avLst/>
+          </a:prstGeom>
+          <a:noFill/>
+          <a:ln>
+            <a:noFill/>
+          </a:ln>
+        </p:spPr>
+        <p:txBody>
+          <a:bodyPr wrap="square" lIns="0" tIns="0" rIns="0" bIns="0" rtlCol="0" anchor="ctr">
+            <a:normAutofit/>
+          </a:bodyPr>
+          <a:lstStyle/>
+          <a:p>
+            <a:pPr marL="0" indent="0" algn="l">
+              <a:buNone/>
+            </a:pPr>
+            <a:r>
+              <a:rPr lang="es-SV" sz="1300" b="1" dirty="0">
+                <a:solidFill>
+                  <a:srgbClr val="002060"/>
+                </a:solidFill>
+                <a:latin typeface="Arial" panose="020B0604020202020204" pitchFamily="34" charset="0"/>
+                <a:cs typeface="Arial" panose="020B0604020202020204" pitchFamily="34" charset="0"/>
+              </a:rPr>
+              <a:t>Observaciones de la SSF</a:t>
+            </a:r>
+          </a:p>
+        </p:txBody>
+      </p:sp>
+      <p:sp>
+        <p:nvSpPr>
+          <p:cNvPr id="108" name="Etiqueta proceso"/>
+          <p:cNvSpPr txBox="1"/>
+          <p:nvPr/>
+        </p:nvSpPr>
+        <p:spPr>
+          <a:xfrm>
+            <a:off x="548640" y="2514600"/>
+            <a:ext cx="7040880" cy="320040"/>
+          </a:xfrm>
+          <a:prstGeom prst="rect">
+            <a:avLst/>
+          </a:prstGeom>
+          <a:noFill/>
+          <a:ln>
+            <a:noFill/>
+          </a:ln>
+        </p:spPr>
+        <p:txBody>
+          <a:bodyPr wrap="square" lIns="0" tIns="0" rIns="0" bIns="0" rtlCol="0" anchor="ctr">
+            <a:normAutofit/>
+          </a:bodyPr>
+          <a:lstStyle/>
+          <a:p>
+            <a:pPr marL="0" indent="0" algn="l">
+              <a:buNone/>
+            </a:pPr>
+            <a:r>
+              <a:rPr lang="es-SV" sz="1200" b="1" dirty="0">
+                <a:solidFill>
+                  <a:srgbClr val="005C9F"/>
+                </a:solidFill>
+                <a:latin typeface="Arial" panose="020B0604020202020204" pitchFamily="34" charset="0"/>
+                <a:cs typeface="Arial" panose="020B0604020202020204" pitchFamily="34" charset="0"/>
+              </a:rPr>
+              <a:t>PROCESO ACTUAL</a:t>
+            </a:r>
+          </a:p>
+        </p:txBody>
+      </p:sp>
+      <p:sp>
+        <p:nvSpPr>
+          <p:cNvPr id="109" name="Paso 1"/>
+          <p:cNvSpPr/>
+          <p:nvPr/>
+        </p:nvSpPr>
+        <p:spPr>
+          <a:xfrm>
+            <a:off x="548640" y="2880360"/>
+            <a:ext cx="7040880" cy="658368"/>
+          </a:xfrm>
+          <a:prstGeom prst="roundRect">
+            <a:avLst>
+              <a:gd name="adj" fmla="val 12000"/>
+            </a:avLst>
+          </a:prstGeom>
+          <a:solidFill>
+            <a:srgbClr val="EEF3F9"/>
+          </a:solidFill>
+          <a:ln w="9525">
+            <a:solidFill>
+              <a:srgbClr val="D6E2EF"/>
+            </a:solidFill>
+          </a:ln>
+        </p:spPr>
+      </p:sp>
+      <p:sp>
+        <p:nvSpPr>
+          <p:cNvPr id="110" name="Paso 1 numero"/>
+          <p:cNvSpPr/>
+          <p:nvPr/>
+        </p:nvSpPr>
+        <p:spPr>
+          <a:xfrm>
+            <a:off x="731520" y="2990088"/>
+            <a:ext cx="438912" cy="438912"/>
+          </a:xfrm>
+          <a:prstGeom prst="ellipse">
+            <a:avLst/>
+          </a:prstGeom>
+          <a:solidFill>
+            <a:srgbClr val="00376E"/>
+          </a:solidFill>
+          <a:ln>
+            <a:noFill/>
+          </a:ln>
+        </p:spPr>
+        <p:txBody>
+          <a:bodyPr wrap="square" lIns="0" tIns="0" rIns="0" bIns="0" rtlCol="0" anchor="ctr">
+            <a:normAutofit/>
+          </a:bodyPr>
+          <a:lstStyle/>
+          <a:p>
+            <a:pPr marL="0" indent="0" algn="ctr">
+              <a:buNone/>
+            </a:pPr>
+            <a:r>
+              <a:rPr lang="es-SV" sz="1500" b="1" dirty="0">
+                <a:solidFill>
+                  <a:srgbClr val="FFFFFF"/>
+                </a:solidFill>
+                <a:latin typeface="Arial" panose="020B0604020202020204" pitchFamily="34" charset="0"/>
+                <a:cs typeface="Arial" panose="020B0604020202020204" pitchFamily="34" charset="0"/>
+              </a:rPr>
+              <a:t>1</a:t>
+            </a:r>
+          </a:p>
+        </p:txBody>
+      </p:sp>
+      <p:sp>
+        <p:nvSpPr>
+          <p:cNvPr id="111" name="Paso 1 titulo"/>
+          <p:cNvSpPr txBox="1"/>
+          <p:nvPr/>
+        </p:nvSpPr>
+        <p:spPr>
+          <a:xfrm>
+            <a:off x="1325880" y="2880360"/>
+            <a:ext cx="1600200" cy="658368"/>
+          </a:xfrm>
+          <a:prstGeom prst="rect">
+            <a:avLst/>
+          </a:prstGeom>
+          <a:noFill/>
+          <a:ln>
+            <a:noFill/>
+          </a:ln>
+        </p:spPr>
+        <p:txBody>
+          <a:bodyPr wrap="square" lIns="0" tIns="0" rIns="0" bIns="0" rtlCol="0" anchor="ctr">
+            <a:normAutofit/>
+          </a:bodyPr>
+          <a:lstStyle/>
+          <a:p>
+            <a:pPr marL="0" indent="0" algn="l">
+              <a:buNone/>
+            </a:pPr>
+            <a:r>
+              <a:rPr lang="es-SV" sz="1400" b="1" dirty="0">
+                <a:solidFill>
+                  <a:srgbClr val="00376E"/>
+                </a:solidFill>
+                <a:latin typeface="Arial" panose="020B0604020202020204" pitchFamily="34" charset="0"/>
+                <a:cs typeface="Arial" panose="020B0604020202020204" pitchFamily="34" charset="0"/>
+              </a:rPr>
+              <a:t>Contraparte</a:t>
+            </a:r>
+          </a:p>
+        </p:txBody>
+      </p:sp>
+      <p:sp>
+        <p:nvSpPr>
+          <p:cNvPr id="112" name="Paso 1 detalle"/>
+          <p:cNvSpPr txBox="1"/>
+          <p:nvPr/>
+        </p:nvSpPr>
+        <p:spPr>
+          <a:xfrm>
+            <a:off x="2971800" y="2880360"/>
+            <a:ext cx="4480560" cy="658368"/>
+          </a:xfrm>
+          <a:prstGeom prst="rect">
+            <a:avLst/>
+          </a:prstGeom>
+          <a:noFill/>
+          <a:ln>
+            <a:noFill/>
+          </a:ln>
+        </p:spPr>
+        <p:txBody>
+          <a:bodyPr wrap="square" lIns="0" tIns="0" rIns="0" bIns="0" rtlCol="0" anchor="ctr">
+            <a:normAutofit/>
+          </a:bodyPr>
+          <a:lstStyle/>
+          <a:p>
+            <a:pPr marL="0" indent="0" algn="l">
+              <a:buNone/>
+            </a:pPr>
+            <a:r>
+              <a:rPr lang="es-SV" sz="1250" dirty="0">
+                <a:solidFill>
+                  <a:srgbClr val="1E2A3A"/>
+                </a:solidFill>
+                <a:latin typeface="Arial" panose="020B0604020202020204" pitchFamily="34" charset="0"/>
+                <a:cs typeface="Arial" panose="020B0604020202020204" pitchFamily="34" charset="0"/>
+              </a:rPr>
+              <a:t>Centralizado en Riesgo y Negocios</a:t>
+            </a:r>
+          </a:p>
+        </p:txBody>
+      </p:sp>
+      <p:sp>
+        <p:nvSpPr>
+          <p:cNvPr id="113" name="Paso 2"/>
+          <p:cNvSpPr/>
+          <p:nvPr/>
+        </p:nvSpPr>
+        <p:spPr>
+          <a:xfrm>
+            <a:off x="548640" y="3648456"/>
+            <a:ext cx="7040880" cy="658368"/>
+          </a:xfrm>
+          <a:prstGeom prst="roundRect">
+            <a:avLst>
+              <a:gd name="adj" fmla="val 12000"/>
+            </a:avLst>
+          </a:prstGeom>
+          <a:solidFill>
+            <a:srgbClr val="EEF3F9"/>
+          </a:solidFill>
+          <a:ln w="9525">
+            <a:solidFill>
+              <a:srgbClr val="D6E2EF"/>
+            </a:solidFill>
+          </a:ln>
+        </p:spPr>
+      </p:sp>
+      <p:sp>
+        <p:nvSpPr>
+          <p:cNvPr id="114" name="Paso 2 numero"/>
+          <p:cNvSpPr/>
+          <p:nvPr/>
+        </p:nvSpPr>
+        <p:spPr>
+          <a:xfrm>
+            <a:off x="731520" y="3758184"/>
+            <a:ext cx="438912" cy="438912"/>
+          </a:xfrm>
+          <a:prstGeom prst="ellipse">
+            <a:avLst/>
+          </a:prstGeom>
+          <a:solidFill>
+            <a:srgbClr val="00376E"/>
+          </a:solidFill>
+          <a:ln>
+            <a:noFill/>
+          </a:ln>
+        </p:spPr>
+        <p:txBody>
+          <a:bodyPr wrap="square" lIns="0" tIns="0" rIns="0" bIns="0" rtlCol="0" anchor="ctr">
+            <a:normAutofit/>
+          </a:bodyPr>
+          <a:lstStyle/>
+          <a:p>
+            <a:pPr marL="0" indent="0" algn="ctr">
+              <a:buNone/>
+            </a:pPr>
+            <a:r>
+              <a:rPr lang="es-SV" sz="1500" b="1" dirty="0">
+                <a:solidFill>
+                  <a:srgbClr val="FFFFFF"/>
+                </a:solidFill>
+                <a:latin typeface="Arial" panose="020B0604020202020204" pitchFamily="34" charset="0"/>
+                <a:cs typeface="Arial" panose="020B0604020202020204" pitchFamily="34" charset="0"/>
+              </a:rPr>
+              <a:t>2</a:t>
+            </a:r>
+          </a:p>
+        </p:txBody>
+      </p:sp>
+      <p:sp>
+        <p:nvSpPr>
+          <p:cNvPr id="115" name="Paso 2 titulo"/>
+          <p:cNvSpPr txBox="1"/>
+          <p:nvPr/>
+        </p:nvSpPr>
+        <p:spPr>
+          <a:xfrm>
+            <a:off x="1325880" y="3648456"/>
+            <a:ext cx="1600200" cy="658368"/>
+          </a:xfrm>
+          <a:prstGeom prst="rect">
+            <a:avLst/>
+          </a:prstGeom>
+          <a:noFill/>
+          <a:ln>
+            <a:noFill/>
+          </a:ln>
+        </p:spPr>
+        <p:txBody>
+          <a:bodyPr wrap="square" lIns="0" tIns="0" rIns="0" bIns="0" rtlCol="0" anchor="ctr">
+            <a:normAutofit/>
+          </a:bodyPr>
+          <a:lstStyle/>
+          <a:p>
+            <a:pPr marL="0" indent="0" algn="l">
+              <a:buNone/>
+            </a:pPr>
+            <a:r>
+              <a:rPr lang="es-SV" sz="1400" b="1" dirty="0">
+                <a:solidFill>
+                  <a:srgbClr val="00376E"/>
+                </a:solidFill>
+                <a:latin typeface="Arial" panose="020B0604020202020204" pitchFamily="34" charset="0"/>
+                <a:cs typeface="Arial" panose="020B0604020202020204" pitchFamily="34" charset="0"/>
+              </a:rPr>
+              <a:t>Recepción</a:t>
+            </a:r>
+          </a:p>
+        </p:txBody>
+      </p:sp>
+      <p:sp>
+        <p:nvSpPr>
+          <p:cNvPr id="116" name="Paso 2 detalle"/>
+          <p:cNvSpPr txBox="1"/>
+          <p:nvPr/>
+        </p:nvSpPr>
+        <p:spPr>
+          <a:xfrm>
+            <a:off x="2971800" y="3648456"/>
+            <a:ext cx="4480560" cy="658368"/>
+          </a:xfrm>
+          <a:prstGeom prst="rect">
+            <a:avLst/>
+          </a:prstGeom>
+          <a:noFill/>
+          <a:ln>
+            <a:noFill/>
+          </a:ln>
+        </p:spPr>
+        <p:txBody>
+          <a:bodyPr wrap="square" lIns="0" tIns="0" rIns="0" bIns="0" rtlCol="0" anchor="ctr">
+            <a:normAutofit/>
+          </a:bodyPr>
+          <a:lstStyle/>
+          <a:p>
+            <a:pPr marL="0" indent="0" algn="l">
+              <a:buNone/>
+            </a:pPr>
+            <a:r>
+              <a:rPr lang="es-SV" sz="1250" dirty="0">
+                <a:solidFill>
+                  <a:srgbClr val="1E2A3A"/>
+                </a:solidFill>
+                <a:latin typeface="Arial" panose="020B0604020202020204" pitchFamily="34" charset="0"/>
+                <a:cs typeface="Arial" panose="020B0604020202020204" pitchFamily="34" charset="0"/>
+              </a:rPr>
+              <a:t>Recibe información el Ejecutivo, pero no hace la validación y revisión correcta</a:t>
+            </a:r>
+          </a:p>
+        </p:txBody>
+      </p:sp>
+      <p:sp>
+        <p:nvSpPr>
+          <p:cNvPr id="117" name="Paso 3"/>
+          <p:cNvSpPr/>
+          <p:nvPr/>
+        </p:nvSpPr>
+        <p:spPr>
+          <a:xfrm>
+            <a:off x="548640" y="4416552"/>
+            <a:ext cx="7040880" cy="658368"/>
+          </a:xfrm>
+          <a:prstGeom prst="roundRect">
+            <a:avLst>
+              <a:gd name="adj" fmla="val 12000"/>
+            </a:avLst>
+          </a:prstGeom>
+          <a:solidFill>
+            <a:srgbClr val="EEF3F9"/>
+          </a:solidFill>
+          <a:ln w="9525">
+            <a:solidFill>
+              <a:srgbClr val="D6E2EF"/>
+            </a:solidFill>
+          </a:ln>
+        </p:spPr>
+      </p:sp>
+      <p:sp>
+        <p:nvSpPr>
+          <p:cNvPr id="118" name="Paso 3 numero"/>
+          <p:cNvSpPr/>
+          <p:nvPr/>
+        </p:nvSpPr>
+        <p:spPr>
+          <a:xfrm>
+            <a:off x="731520" y="4526280"/>
+            <a:ext cx="438912" cy="438912"/>
+          </a:xfrm>
+          <a:prstGeom prst="ellipse">
+            <a:avLst/>
+          </a:prstGeom>
+          <a:solidFill>
+            <a:srgbClr val="00376E"/>
+          </a:solidFill>
+          <a:ln>
+            <a:noFill/>
+          </a:ln>
+        </p:spPr>
+        <p:txBody>
+          <a:bodyPr wrap="square" lIns="0" tIns="0" rIns="0" bIns="0" rtlCol="0" anchor="ctr">
+            <a:normAutofit/>
+          </a:bodyPr>
+          <a:lstStyle/>
+          <a:p>
+            <a:pPr marL="0" indent="0" algn="ctr">
+              <a:buNone/>
+            </a:pPr>
+            <a:r>
+              <a:rPr lang="es-SV" sz="1500" b="1" dirty="0">
+                <a:solidFill>
+                  <a:srgbClr val="FFFFFF"/>
+                </a:solidFill>
+                <a:latin typeface="Arial" panose="020B0604020202020204" pitchFamily="34" charset="0"/>
+                <a:cs typeface="Arial" panose="020B0604020202020204" pitchFamily="34" charset="0"/>
+              </a:rPr>
+              <a:t>3</a:t>
+            </a:r>
+          </a:p>
+        </p:txBody>
+      </p:sp>
+      <p:sp>
+        <p:nvSpPr>
+          <p:cNvPr id="119" name="Paso 3 titulo"/>
+          <p:cNvSpPr txBox="1"/>
+          <p:nvPr/>
+        </p:nvSpPr>
+        <p:spPr>
+          <a:xfrm>
+            <a:off x="1325880" y="4416552"/>
+            <a:ext cx="1600200" cy="658368"/>
+          </a:xfrm>
+          <a:prstGeom prst="rect">
+            <a:avLst/>
+          </a:prstGeom>
+          <a:noFill/>
+          <a:ln>
+            <a:noFill/>
+          </a:ln>
+        </p:spPr>
+        <p:txBody>
+          <a:bodyPr wrap="square" lIns="0" tIns="0" rIns="0" bIns="0" rtlCol="0" anchor="ctr">
+            <a:normAutofit/>
+          </a:bodyPr>
+          <a:lstStyle/>
+          <a:p>
+            <a:pPr marL="0" indent="0" algn="l">
+              <a:buNone/>
+            </a:pPr>
+            <a:r>
+              <a:rPr lang="es-SV" sz="1400" b="1" dirty="0">
+                <a:solidFill>
+                  <a:srgbClr val="00376E"/>
+                </a:solidFill>
+                <a:latin typeface="Arial" panose="020B0604020202020204" pitchFamily="34" charset="0"/>
+                <a:cs typeface="Arial" panose="020B0604020202020204" pitchFamily="34" charset="0"/>
+              </a:rPr>
+              <a:t>Observaciones</a:t>
+            </a:r>
+          </a:p>
+        </p:txBody>
+      </p:sp>
+      <p:sp>
+        <p:nvSpPr>
+          <p:cNvPr id="120" name="Paso 3 detalle"/>
+          <p:cNvSpPr txBox="1"/>
+          <p:nvPr/>
+        </p:nvSpPr>
+        <p:spPr>
+          <a:xfrm>
+            <a:off x="2971800" y="4416552"/>
+            <a:ext cx="4480560" cy="658368"/>
+          </a:xfrm>
+          <a:prstGeom prst="rect">
+            <a:avLst/>
+          </a:prstGeom>
+          <a:noFill/>
+          <a:ln>
+            <a:noFill/>
+          </a:ln>
+        </p:spPr>
+        <p:txBody>
+          <a:bodyPr wrap="square" lIns="0" tIns="0" rIns="0" bIns="0" rtlCol="0" anchor="ctr">
+            <a:normAutofit/>
+          </a:bodyPr>
+          <a:lstStyle/>
+          <a:p>
+            <a:pPr marL="0" indent="0" algn="l">
+              <a:buNone/>
+            </a:pPr>
+            <a:r>
+              <a:rPr lang="es-SV" sz="1250" dirty="0">
+                <a:solidFill>
+                  <a:srgbClr val="1E2A3A"/>
+                </a:solidFill>
+                <a:latin typeface="Arial" panose="020B0604020202020204" pitchFamily="34" charset="0"/>
+                <a:cs typeface="Arial" panose="020B0604020202020204" pitchFamily="34" charset="0"/>
+              </a:rPr>
+              <a:t>Observaciones de la SSF</a:t>
+            </a:r>
+          </a:p>
+        </p:txBody>
+      </p:sp>
+      <p:sp>
+        <p:nvSpPr>
+          <p:cNvPr id="121" name="Paso 4"/>
+          <p:cNvSpPr/>
+          <p:nvPr/>
+        </p:nvSpPr>
+        <p:spPr>
+          <a:xfrm>
+            <a:off x="548640" y="5184648"/>
+            <a:ext cx="7040880" cy="658368"/>
+          </a:xfrm>
+          <a:prstGeom prst="roundRect">
+            <a:avLst>
+              <a:gd name="adj" fmla="val 12000"/>
+            </a:avLst>
+          </a:prstGeom>
+          <a:solidFill>
+            <a:srgbClr val="EEF3F9"/>
+          </a:solidFill>
+          <a:ln w="9525">
+            <a:solidFill>
+              <a:srgbClr val="D6E2EF"/>
+            </a:solidFill>
+          </a:ln>
+        </p:spPr>
+      </p:sp>
+      <p:sp>
+        <p:nvSpPr>
+          <p:cNvPr id="122" name="Paso 4 numero"/>
+          <p:cNvSpPr/>
+          <p:nvPr/>
+        </p:nvSpPr>
+        <p:spPr>
+          <a:xfrm>
+            <a:off x="731520" y="5294376"/>
+            <a:ext cx="438912" cy="438912"/>
+          </a:xfrm>
+          <a:prstGeom prst="ellipse">
+            <a:avLst/>
+          </a:prstGeom>
+          <a:solidFill>
+            <a:srgbClr val="00376E"/>
+          </a:solidFill>
+          <a:ln>
+            <a:noFill/>
+          </a:ln>
+        </p:spPr>
+        <p:txBody>
+          <a:bodyPr wrap="square" lIns="0" tIns="0" rIns="0" bIns="0" rtlCol="0" anchor="ctr">
+            <a:normAutofit/>
+          </a:bodyPr>
+          <a:lstStyle/>
+          <a:p>
+            <a:pPr marL="0" indent="0" algn="ctr">
+              <a:buNone/>
+            </a:pPr>
+            <a:r>
+              <a:rPr lang="es-SV" sz="1500" b="1" dirty="0">
+                <a:solidFill>
+                  <a:srgbClr val="FFFFFF"/>
+                </a:solidFill>
+                <a:latin typeface="Arial" panose="020B0604020202020204" pitchFamily="34" charset="0"/>
+                <a:cs typeface="Arial" panose="020B0604020202020204" pitchFamily="34" charset="0"/>
+              </a:rPr>
+              <a:t>4</a:t>
+            </a:r>
+          </a:p>
+        </p:txBody>
+      </p:sp>
+      <p:sp>
+        <p:nvSpPr>
+          <p:cNvPr id="123" name="Paso 4 titulo"/>
+          <p:cNvSpPr txBox="1"/>
+          <p:nvPr/>
+        </p:nvSpPr>
+        <p:spPr>
+          <a:xfrm>
+            <a:off x="1325880" y="5184648"/>
+            <a:ext cx="1600200" cy="658368"/>
+          </a:xfrm>
+          <a:prstGeom prst="rect">
+            <a:avLst/>
+          </a:prstGeom>
+          <a:noFill/>
+          <a:ln>
+            <a:noFill/>
+          </a:ln>
+        </p:spPr>
+        <p:txBody>
+          <a:bodyPr wrap="square" lIns="0" tIns="0" rIns="0" bIns="0" rtlCol="0" anchor="ctr">
+            <a:normAutofit/>
+          </a:bodyPr>
+          <a:lstStyle/>
+          <a:p>
+            <a:pPr marL="0" indent="0" algn="l">
+              <a:buNone/>
+            </a:pPr>
+            <a:r>
+              <a:rPr lang="es-SV" sz="1400" b="1" dirty="0">
+                <a:solidFill>
+                  <a:srgbClr val="00376E"/>
+                </a:solidFill>
+                <a:latin typeface="Arial" panose="020B0604020202020204" pitchFamily="34" charset="0"/>
+                <a:cs typeface="Arial" panose="020B0604020202020204" pitchFamily="34" charset="0"/>
+              </a:rPr>
+              <a:t>Seguimiento</a:t>
+            </a:r>
+          </a:p>
+        </p:txBody>
+      </p:sp>
+      <p:sp>
+        <p:nvSpPr>
+          <p:cNvPr id="124" name="Paso 4 detalle"/>
+          <p:cNvSpPr txBox="1"/>
+          <p:nvPr/>
+        </p:nvSpPr>
+        <p:spPr>
+          <a:xfrm>
+            <a:off x="2971800" y="5184648"/>
+            <a:ext cx="4480560" cy="658368"/>
+          </a:xfrm>
+          <a:prstGeom prst="rect">
+            <a:avLst/>
+          </a:prstGeom>
+          <a:noFill/>
+          <a:ln>
+            <a:noFill/>
+          </a:ln>
+        </p:spPr>
+        <p:txBody>
+          <a:bodyPr wrap="square" lIns="0" tIns="0" rIns="0" bIns="0" rtlCol="0" anchor="ctr">
+            <a:normAutofit/>
+          </a:bodyPr>
+          <a:lstStyle/>
+          <a:p>
+            <a:pPr marL="0" indent="0" algn="l">
+              <a:buNone/>
+            </a:pPr>
+            <a:r>
+              <a:rPr lang="es-SV" sz="1250" dirty="0">
+                <a:solidFill>
+                  <a:srgbClr val="1E2A3A"/>
+                </a:solidFill>
+                <a:latin typeface="Arial" panose="020B0604020202020204" pitchFamily="34" charset="0"/>
+                <a:cs typeface="Arial" panose="020B0604020202020204" pitchFamily="34" charset="0"/>
+              </a:rPr>
+              <a:t>Seguimiento de la contraparte – calificación</a:t>
+            </a:r>
+          </a:p>
+        </p:txBody>
+      </p:sp>
+      <p:sp>
+        <p:nvSpPr>
+          <p:cNvPr id="125" name="Flecha"/>
+          <p:cNvSpPr/>
+          <p:nvPr/>
+        </p:nvSpPr>
+        <p:spPr>
+          <a:xfrm>
+            <a:off x="7699248" y="3383280"/>
+            <a:ext cx="365760" cy="548640"/>
+          </a:xfrm>
+          <a:prstGeom prst="rightArrow">
+            <a:avLst/>
+          </a:prstGeom>
+          <a:solidFill>
+            <a:srgbClr val="005C9F"/>
+          </a:solidFill>
+          <a:ln>
+            <a:noFill/>
+          </a:ln>
+        </p:spPr>
+      </p:sp>
+      <p:sp>
+        <p:nvSpPr>
+          <p:cNvPr id="126" name="Panel respuesta"/>
+          <p:cNvSpPr/>
+          <p:nvPr/>
+        </p:nvSpPr>
+        <p:spPr>
+          <a:xfrm>
+            <a:off x="8183880" y="1554480"/>
+            <a:ext cx="3429000" cy="4398264"/>
+          </a:xfrm>
+          <a:prstGeom prst="roundRect">
+            <a:avLst>
+              <a:gd name="adj" fmla="val 6000"/>
+            </a:avLst>
+          </a:prstGeom>
+          <a:solidFill>
+            <a:srgbClr val="00376E"/>
+          </a:solidFill>
+          <a:ln>
+            <a:noFill/>
+          </a:ln>
+        </p:spPr>
+      </p:sp>
+      <p:sp>
+        <p:nvSpPr>
+          <p:cNvPr id="127" name="Respuesta titulo"/>
+          <p:cNvSpPr txBox="1"/>
+          <p:nvPr/>
+        </p:nvSpPr>
+        <p:spPr>
+          <a:xfrm>
+            <a:off x="8458200" y="1783080"/>
+            <a:ext cx="2880360" cy="365760"/>
+          </a:xfrm>
+          <a:prstGeom prst="rect">
+            <a:avLst/>
+          </a:prstGeom>
+          <a:noFill/>
+          <a:ln>
+            <a:noFill/>
+          </a:ln>
+        </p:spPr>
+        <p:txBody>
+          <a:bodyPr wrap="square" lIns="0" tIns="0" rIns="0" bIns="0" rtlCol="0" anchor="ctr">
+            <a:normAutofit/>
+          </a:bodyPr>
+          <a:lstStyle/>
+          <a:p>
+            <a:pPr marL="0" indent="0" algn="l">
+              <a:buNone/>
+            </a:pPr>
+            <a:r>
+              <a:rPr lang="es-SV" sz="1200" b="1" dirty="0">
+                <a:solidFill>
+                  <a:srgbClr val="9CC3F0"/>
+                </a:solidFill>
+                <a:latin typeface="Arial" panose="020B0604020202020204" pitchFamily="34" charset="0"/>
+                <a:cs typeface="Arial" panose="020B0604020202020204" pitchFamily="34" charset="0"/>
+              </a:rPr>
+              <a:t>RESPUESTA</a:t>
+            </a:r>
+          </a:p>
+        </p:txBody>
+      </p:sp>
+      <p:sp>
+        <p:nvSpPr>
+          <p:cNvPr id="128" name="Respuesta 1"/>
+          <p:cNvSpPr/>
+          <p:nvPr/>
+        </p:nvSpPr>
+        <p:spPr>
+          <a:xfrm>
+            <a:off x="8458200" y="2377440"/>
+            <a:ext cx="2880360" cy="1005840"/>
+          </a:xfrm>
+          <a:prstGeom prst="roundRect">
+            <a:avLst>
+              <a:gd name="adj" fmla="val 12000"/>
+            </a:avLst>
+          </a:prstGeom>
+          <a:solidFill>
+            <a:srgbClr val="005C9F"/>
+          </a:solidFill>
+          <a:ln>
+            <a:noFill/>
+          </a:ln>
+        </p:spPr>
+      </p:sp>
+      <p:sp>
+        <p:nvSpPr>
+          <p:cNvPr id="129" name="Respuesta 1 check"/>
+          <p:cNvSpPr/>
+          <p:nvPr/>
+        </p:nvSpPr>
+        <p:spPr>
+          <a:xfrm>
+            <a:off x="8641080" y="2651760"/>
+            <a:ext cx="457200" cy="457200"/>
+          </a:xfrm>
+          <a:prstGeom prst="ellipse">
+            <a:avLst/>
+          </a:prstGeom>
+          <a:solidFill>
+            <a:srgbClr val="FFFFFF"/>
+          </a:solidFill>
+          <a:ln>
+            <a:noFill/>
+          </a:ln>
+        </p:spPr>
+        <p:txBody>
+          <a:bodyPr wrap="square" lIns="0" tIns="0" rIns="0" bIns="0" rtlCol="0" anchor="ctr">
+            <a:normAutofit/>
+          </a:bodyPr>
+          <a:lstStyle/>
+          <a:p>
+            <a:pPr marL="0" indent="0" algn="ctr">
+              <a:buNone/>
+            </a:pPr>
+            <a:r>
+              <a:rPr lang="es-SV" sz="1600" b="1" dirty="0">
+                <a:solidFill>
+                  <a:srgbClr val="00376E"/>
+                </a:solidFill>
+                <a:latin typeface="Arial" panose="020B0604020202020204" pitchFamily="34" charset="0"/>
+                <a:cs typeface="Arial" panose="020B0604020202020204" pitchFamily="34" charset="0"/>
+              </a:rPr>
+              <a:t>✓</a:t>
+            </a:r>
+          </a:p>
+        </p:txBody>
+      </p:sp>
+      <p:sp>
+        <p:nvSpPr>
+          <p:cNvPr id="130" name="Respuesta 1 texto"/>
+          <p:cNvSpPr txBox="1"/>
+          <p:nvPr/>
+        </p:nvSpPr>
+        <p:spPr>
+          <a:xfrm>
+            <a:off x="9281160" y="2377440"/>
+            <a:ext cx="1965960" cy="1005840"/>
+          </a:xfrm>
+          <a:prstGeom prst="rect">
+            <a:avLst/>
+          </a:prstGeom>
+          <a:noFill/>
+          <a:ln>
+            <a:noFill/>
+          </a:ln>
+        </p:spPr>
+        <p:txBody>
+          <a:bodyPr wrap="square" lIns="0" tIns="0" rIns="0" bIns="0" rtlCol="0" anchor="ctr">
+            <a:normAutofit/>
+          </a:bodyPr>
+          <a:lstStyle/>
+          <a:p>
+            <a:pPr marL="0" indent="0" algn="l">
+              <a:buNone/>
+            </a:pPr>
+            <a:r>
+              <a:rPr lang="es-SV" sz="1800" b="1" dirty="0">
+                <a:solidFill>
+                  <a:srgbClr val="FFFFFF"/>
+                </a:solidFill>
+                <a:latin typeface="Arial" panose="020B0604020202020204" pitchFamily="34" charset="0"/>
+                <a:cs typeface="Arial" panose="020B0604020202020204" pitchFamily="34" charset="0"/>
+              </a:rPr>
+              <a:t>Política</a:t>
+            </a:r>
+          </a:p>
+        </p:txBody>
+      </p:sp>
+      <p:sp>
+        <p:nvSpPr>
+          <p:cNvPr id="131" name="Respuesta 2"/>
+          <p:cNvSpPr/>
+          <p:nvPr/>
+        </p:nvSpPr>
+        <p:spPr>
+          <a:xfrm>
+            <a:off x="8458200" y="3611880"/>
+            <a:ext cx="2880360" cy="1005840"/>
+          </a:xfrm>
+          <a:prstGeom prst="roundRect">
+            <a:avLst>
+              <a:gd name="adj" fmla="val 12000"/>
+            </a:avLst>
+          </a:prstGeom>
+          <a:solidFill>
+            <a:srgbClr val="005C9F"/>
+          </a:solidFill>
+          <a:ln>
+            <a:noFill/>
+          </a:ln>
+        </p:spPr>
+      </p:sp>
+      <p:sp>
+        <p:nvSpPr>
+          <p:cNvPr id="132" name="Respuesta 2 check"/>
+          <p:cNvSpPr/>
+          <p:nvPr/>
+        </p:nvSpPr>
+        <p:spPr>
+          <a:xfrm>
+            <a:off x="8641080" y="3886200"/>
+            <a:ext cx="457200" cy="457200"/>
+          </a:xfrm>
+          <a:prstGeom prst="ellipse">
+            <a:avLst/>
+          </a:prstGeom>
+          <a:solidFill>
+            <a:srgbClr val="FFFFFF"/>
+          </a:solidFill>
+          <a:ln>
+            <a:noFill/>
+          </a:ln>
+        </p:spPr>
+        <p:txBody>
+          <a:bodyPr wrap="square" lIns="0" tIns="0" rIns="0" bIns="0" rtlCol="0" anchor="ctr">
+            <a:normAutofit/>
+          </a:bodyPr>
+          <a:lstStyle/>
+          <a:p>
+            <a:pPr marL="0" indent="0" algn="ctr">
+              <a:buNone/>
+            </a:pPr>
+            <a:r>
+              <a:rPr lang="es-SV" sz="1600" b="1" dirty="0">
+                <a:solidFill>
+                  <a:srgbClr val="00376E"/>
+                </a:solidFill>
+                <a:latin typeface="Arial" panose="020B0604020202020204" pitchFamily="34" charset="0"/>
+                <a:cs typeface="Arial" panose="020B0604020202020204" pitchFamily="34" charset="0"/>
+              </a:rPr>
+              <a:t>✓</a:t>
+            </a:r>
+          </a:p>
+        </p:txBody>
+      </p:sp>
+      <p:sp>
+        <p:nvSpPr>
+          <p:cNvPr id="133" name="Respuesta 2 texto"/>
+          <p:cNvSpPr txBox="1"/>
+          <p:nvPr/>
+        </p:nvSpPr>
+        <p:spPr>
+          <a:xfrm>
+            <a:off x="9281160" y="3611880"/>
+            <a:ext cx="1965960" cy="1005840"/>
+          </a:xfrm>
+          <a:prstGeom prst="rect">
+            <a:avLst/>
+          </a:prstGeom>
+          <a:noFill/>
+          <a:ln>
+            <a:noFill/>
+          </a:ln>
+        </p:spPr>
+        <p:txBody>
+          <a:bodyPr wrap="square" lIns="0" tIns="0" rIns="0" bIns="0" rtlCol="0" anchor="ctr">
+            <a:normAutofit/>
+          </a:bodyPr>
+          <a:lstStyle/>
+          <a:p>
+            <a:pPr marL="0" indent="0" algn="l">
+              <a:buNone/>
+            </a:pPr>
+            <a:r>
+              <a:rPr lang="es-SV" sz="1800" b="1" dirty="0">
+                <a:solidFill>
+                  <a:srgbClr val="FFFFFF"/>
+                </a:solidFill>
+                <a:latin typeface="Arial" panose="020B0604020202020204" pitchFamily="34" charset="0"/>
+                <a:cs typeface="Arial" panose="020B0604020202020204" pitchFamily="34" charset="0"/>
+              </a:rPr>
+              <a:t>Procedimiento</a:t>
+            </a:r>
+          </a:p>
+        </p:txBody>
+      </p:sp>
+      <p:sp>
+        <p:nvSpPr>
+          <p:cNvPr id="134" name="Respuesta nota"/>
+          <p:cNvSpPr txBox="1"/>
+          <p:nvPr/>
+        </p:nvSpPr>
+        <p:spPr>
+          <a:xfrm>
+            <a:off x="8458200" y="4937760"/>
+            <a:ext cx="2880360" cy="822960"/>
+          </a:xfrm>
+          <a:prstGeom prst="rect">
+            <a:avLst/>
+          </a:prstGeom>
+          <a:noFill/>
+          <a:ln>
+            <a:noFill/>
+          </a:ln>
+        </p:spPr>
+        <p:txBody>
+          <a:bodyPr wrap="square" lIns="0" tIns="0" rIns="0" bIns="0" rtlCol="0" anchor="t">
+            <a:normAutofit/>
+          </a:bodyPr>
+          <a:lstStyle/>
+          <a:p>
+            <a:pPr marL="0" indent="0" algn="l">
+              <a:buNone/>
+            </a:pPr>
+            <a:r>
+              <a:rPr lang="es-SV" sz="1150" i="1" dirty="0">
+                <a:solidFill>
+                  <a:srgbClr val="C9DBF2"/>
+                </a:solidFill>
+                <a:latin typeface="Arial" panose="020B0604020202020204" pitchFamily="34" charset="0"/>
+                <a:cs typeface="Arial" panose="020B0604020202020204" pitchFamily="34" charset="0"/>
+              </a:rPr>
+              <a:t>Política Administración de Avalúos (ver Propuesta)</a:t>
+            </a:r>
+          </a:p>
+        </p:txBody>
+      </p:sp>
+      <p:sp>
+        <p:nvSpPr>
+          <p:cNvPr id="32" name="Slide Number Placeholder 0"/>
+          <p:cNvSpPr>
+            <a:spLocks noGrp="1"/>
+          </p:cNvSpPr>
+          <p:nvPr>
+            <p:ph type="sldNum" sz="quarter" idx="4294967295"/>
+          </p:nvPr>
+        </p:nvSpPr>
+        <p:spPr>
+          <a:xfrm>
+            <a:off x="548640" y="6400800"/>
+            <a:ext cx="548640" cy="274320"/>
+          </a:xfrm>
+          <a:prstGeom prst="rect">
+            <a:avLst/>
+          </a:prstGeom>
+          <a:extLst>
+            <a:ext uri="{C572A759-6A51-4108-AA02-DFA0A04FC94B}">
+              <ma14:wrappingTextBoxFlag xmlns:ma14="http://schemas.microsoft.com/office/mac/drawingml/2011/main" xmlns="" val="0"/>
+            </a:ext>
+          </a:extLst>
+        </p:spPr>
+        <p:txBody>
+          <a:bodyPr/>
+          <a:lstStyle>
+            <a:lvl1pPr>
+              <a:defRPr sz="1000">
+                <a:solidFill>
+                  <a:schemeClr val="accent4"/>
+                </a:solidFill>
+              </a:defRPr>
+            </a:lvl1pPr>
+          </a:lstStyle>
+          <a:p>
+            <a:pPr algn="l"/>
+            <a:fld id="{F7021451-1387-4CA6-816F-3879F97B5CBC}" type="slidenum">
+              <a:rPr lang="es-SV" b="0" noProof="0" smtClean="0">
+                <a:latin typeface="Arial" panose="020B0604020202020204" pitchFamily="34" charset="0"/>
+                <a:cs typeface="Arial" panose="020B0604020202020204" pitchFamily="34" charset="0"/>
+              </a:rPr>
+              <a:t>4</a:t>
+            </a:fld>
+            <a:endParaRPr lang="es-SV" noProof="0" dirty="0">
+              <a:latin typeface="Arial" panose="020B0604020202020204" pitchFamily="34" charset="0"/>
+              <a:cs typeface="Arial" panose="020B0604020202020204" pitchFamily="34" charset="0"/>
+            </a:endParaRPr>
+          </a:p>
+        </p:txBody>
+      </p:sp>
+    </p:spTree>
+  </p:cSld>
+  <p:clrMapOvr>
+    <a:masterClrMapping/>
+  </p:clrMapOvr>
+</p:sld>
+</file>
+
 <file path=ppt/slides/slide2.xml><?xml version="1.0" encoding="utf-8"?>
 <p:sld xmlns:a="http://schemas.openxmlformats.org/drawingml/2006/main" xmlns:r="http://schemas.openxmlformats.org/officeDocument/2006/relationships" xmlns:p="http://schemas.openxmlformats.org/presentationml/2006/main">
   <p:cSld name="Slide 2">

</xml_diff>

<commit_message>
Add risk diagnosis slides: weaknesses in appraisal report analysis and SSF exposure areas
Co-Authored-By: Claude Opus 5.5 <noreply@anthropic.com>
Claude-Session: https://claude.ai/code/session_01Czk2XnZSpBwy6TjibqLL9A
</commit_message>
<xml_diff>
--- a/administracion-avaluos/Proyecto_Administracion_de_Avaluos.pptx
+++ b/administracion-avaluos/Proyecto_Administracion_de_Avaluos.pptx
@@ -12,6 +12,8 @@
     <p:sldId id="257" r:id="rId3"/>
     <p:sldId id="259" r:id="rId5"/>
     <p:sldId id="274" r:id="rId26"/>
+    <p:sldId id="275" r:id="rId27"/>
+    <p:sldId id="276" r:id="rId28"/>
     <p:sldId id="260" r:id="rId6"/>
     <p:sldId id="261" r:id="rId7"/>
     <p:sldId id="262" r:id="rId8"/>
@@ -137,6 +139,8 @@
           <p14:sldIdLst>
             <p14:sldId id="259"/>
             <p14:sldId id="274"/>
+            <p14:sldId id="275"/>
+            <p14:sldId id="276"/>
             <p14:sldId id="260"/>
             <p14:sldId id="261"/>
             <p14:sldId id="262"/>
@@ -11507,6 +11511,1793 @@
 </p:sld>
 </file>
 
+<file path=ppt/slides/slide19.xml><?xml version="1.0" encoding="utf-8"?>
+<p:sld xmlns:a="http://schemas.openxmlformats.org/drawingml/2006/main" xmlns:r="http://schemas.openxmlformats.org/officeDocument/2006/relationships" xmlns:p="http://schemas.openxmlformats.org/presentationml/2006/main">
+  <p:cSld name="Slide 4">
+    <p:spTree>
+      <p:nvGrpSpPr>
+        <p:cNvPr id="1" name=""/>
+        <p:cNvGrpSpPr/>
+        <p:nvPr/>
+      </p:nvGrpSpPr>
+      <p:grpSpPr>
+        <a:xfrm>
+          <a:off x="0" y="0"/>
+          <a:ext cx="0" cy="0"/>
+          <a:chOff x="0" y="0"/>
+          <a:chExt cx="0" cy="0"/>
+        </a:xfrm>
+      </p:grpSpPr>
+      <p:sp>
+        <p:nvSpPr>
+          <p:cNvPr id="2" name="Text 1"/>
+          <p:cNvSpPr>
+            <a:spLocks noGrp="1"/>
+          </p:cNvSpPr>
+          <p:nvPr>
+            <p:ph type="title" idx="101" hasCustomPrompt="1"/>
+          </p:nvPr>
+        </p:nvSpPr>
+        <p:spPr>
+          <a:xfrm>
+            <a:off x="777240" y="347472"/>
+            <a:ext cx="9995034" cy="636422"/>
+          </a:xfrm>
+          <a:prstGeom prst="rect">
+            <a:avLst/>
+          </a:prstGeom>
+          <a:noFill/>
+          <a:ln/>
+        </p:spPr>
+        <p:txBody>
+          <a:bodyPr wrap="square" lIns="0" tIns="0" rIns="0" bIns="0" rtlCol="0" anchor="ctr"/>
+          <a:lstStyle/>
+          <a:p>
+            <a:pPr marL="0" indent="0" algn="l">
+              <a:buNone/>
+            </a:pPr>
+            <a:r>
+              <a:rPr lang="es-SV" sz="2400" b="1" noProof="0" dirty="0">
+                <a:solidFill>
+                  <a:schemeClr val="tx2"/>
+                </a:solidFill>
+                <a:latin typeface="Arial" panose="020B0604020202020204" pitchFamily="34" charset="0"/>
+                <a:cs typeface="Arial" panose="020B0604020202020204" pitchFamily="34" charset="0"/>
+              </a:rPr>
+              <a:t>DEBILIDADES EN EL ANÁLISIS DE LOS INFORMES DE AVALÚOS</a:t>
+            </a:r>
+            <a:endParaRPr lang="es-SV" sz="2400" noProof="0" dirty="0">
+              <a:latin typeface="Arial" panose="020B0604020202020204" pitchFamily="34" charset="0"/>
+              <a:cs typeface="Arial" panose="020B0604020202020204" pitchFamily="34" charset="0"/>
+            </a:endParaRPr>
+          </a:p>
+        </p:txBody>
+      </p:sp>
+      <p:sp>
+        <p:nvSpPr>
+          <p:cNvPr id="101" name="Subtitulo"/>
+          <p:cNvSpPr txBox="1"/>
+          <p:nvPr/>
+        </p:nvSpPr>
+        <p:spPr>
+          <a:xfrm>
+            <a:off x="777240" y="1005840"/>
+            <a:ext cx="10515600" cy="365760"/>
+          </a:xfrm>
+          <a:prstGeom prst="rect">
+            <a:avLst/>
+          </a:prstGeom>
+          <a:noFill/>
+          <a:ln>
+            <a:noFill/>
+          </a:ln>
+        </p:spPr>
+        <p:txBody>
+          <a:bodyPr wrap="square" lIns="0" tIns="0" rIns="0" bIns="0" rtlCol="0" anchor="ctr">
+            <a:normAutofit/>
+          </a:bodyPr>
+          <a:lstStyle/>
+          <a:p>
+            <a:pPr marL="0" indent="0" algn="l">
+              <a:buNone/>
+            </a:pPr>
+            <a:r>
+              <a:rPr lang="es-SV" sz="1400" dirty="0">
+                <a:solidFill>
+                  <a:srgbClr val="005C9F"/>
+                </a:solidFill>
+                <a:latin typeface="Arial" panose="020B0604020202020204" pitchFamily="34" charset="0"/>
+                <a:cs typeface="Arial" panose="020B0604020202020204" pitchFamily="34" charset="0"/>
+              </a:rPr>
+              <a:t>Diagnóstico de Riesgos sobre el análisis de los informes de avalúos, con base en el proceso actual</a:t>
+            </a:r>
+          </a:p>
+        </p:txBody>
+      </p:sp>
+      <p:sp>
+        <p:nvSpPr>
+          <p:cNvPr id="102" name="Debilidad 1"/>
+          <p:cNvSpPr/>
+          <p:nvPr/>
+        </p:nvSpPr>
+        <p:spPr>
+          <a:xfrm>
+            <a:off x="548640" y="1554480"/>
+            <a:ext cx="5440680" cy="987552"/>
+          </a:xfrm>
+          <a:prstGeom prst="roundRect">
+            <a:avLst>
+              <a:gd name="adj" fmla="val 10000"/>
+            </a:avLst>
+          </a:prstGeom>
+          <a:solidFill>
+            <a:srgbClr val="EEF3F9"/>
+          </a:solidFill>
+          <a:ln w="9525">
+            <a:solidFill>
+              <a:srgbClr val="D6E2EF"/>
+            </a:solidFill>
+          </a:ln>
+        </p:spPr>
+      </p:sp>
+      <p:sp>
+        <p:nvSpPr>
+          <p:cNvPr id="103" name="Debilidad 1 numero"/>
+          <p:cNvSpPr/>
+          <p:nvPr/>
+        </p:nvSpPr>
+        <p:spPr>
+          <a:xfrm>
+            <a:off x="713232" y="1819656"/>
+            <a:ext cx="457200" cy="457200"/>
+          </a:xfrm>
+          <a:prstGeom prst="ellipse">
+            <a:avLst/>
+          </a:prstGeom>
+          <a:solidFill>
+            <a:srgbClr val="00376E"/>
+          </a:solidFill>
+          <a:ln>
+            <a:noFill/>
+          </a:ln>
+        </p:spPr>
+        <p:txBody>
+          <a:bodyPr wrap="square" lIns="0" tIns="0" rIns="0" bIns="0" rtlCol="0" anchor="ctr">
+            <a:normAutofit/>
+          </a:bodyPr>
+          <a:lstStyle/>
+          <a:p>
+            <a:pPr marL="0" indent="0" algn="ctr">
+              <a:buNone/>
+            </a:pPr>
+            <a:r>
+              <a:rPr lang="es-SV" sz="1400" b="1" dirty="0">
+                <a:solidFill>
+                  <a:srgbClr val="FFFFFF"/>
+                </a:solidFill>
+                <a:latin typeface="Arial" panose="020B0604020202020204" pitchFamily="34" charset="0"/>
+                <a:cs typeface="Arial" panose="020B0604020202020204" pitchFamily="34" charset="0"/>
+              </a:rPr>
+              <a:t>1</a:t>
+            </a:r>
+          </a:p>
+        </p:txBody>
+      </p:sp>
+      <p:sp>
+        <p:nvSpPr>
+          <p:cNvPr id="104" name="Debilidad 1 titulo"/>
+          <p:cNvSpPr txBox="1"/>
+          <p:nvPr/>
+        </p:nvSpPr>
+        <p:spPr>
+          <a:xfrm>
+            <a:off x="1325880" y="1645920"/>
+            <a:ext cx="3566160" cy="292608"/>
+          </a:xfrm>
+          <a:prstGeom prst="rect">
+            <a:avLst/>
+          </a:prstGeom>
+          <a:noFill/>
+          <a:ln>
+            <a:noFill/>
+          </a:ln>
+        </p:spPr>
+        <p:txBody>
+          <a:bodyPr wrap="square" lIns="0" tIns="0" rIns="0" bIns="0" rtlCol="0" anchor="ctr">
+            <a:normAutofit/>
+          </a:bodyPr>
+          <a:lstStyle/>
+          <a:p>
+            <a:pPr marL="0" indent="0" algn="l">
+              <a:buNone/>
+            </a:pPr>
+            <a:r>
+              <a:rPr lang="es-SV" sz="1300" b="1" dirty="0">
+                <a:solidFill>
+                  <a:srgbClr val="00376E"/>
+                </a:solidFill>
+                <a:latin typeface="Arial" panose="020B0604020202020204" pitchFamily="34" charset="0"/>
+                <a:cs typeface="Arial" panose="020B0604020202020204" pitchFamily="34" charset="0"/>
+              </a:rPr>
+              <a:t>Sin revisión del contenido mínimo</a:t>
+            </a:r>
+          </a:p>
+        </p:txBody>
+      </p:sp>
+      <p:sp>
+        <p:nvSpPr>
+          <p:cNvPr id="105" name="Debilidad 1 nivel"/>
+          <p:cNvSpPr/>
+          <p:nvPr/>
+        </p:nvSpPr>
+        <p:spPr>
+          <a:xfrm>
+            <a:off x="4983480" y="1664208"/>
+            <a:ext cx="841248" cy="256032"/>
+          </a:xfrm>
+          <a:prstGeom prst="roundRect">
+            <a:avLst>
+              <a:gd name="adj" fmla="val 50000"/>
+            </a:avLst>
+          </a:prstGeom>
+          <a:solidFill>
+            <a:srgbClr val="FBEAEA"/>
+          </a:solidFill>
+          <a:ln w="9525">
+            <a:solidFill>
+              <a:srgbClr val="C62828"/>
+            </a:solidFill>
+          </a:ln>
+        </p:spPr>
+        <p:txBody>
+          <a:bodyPr wrap="square" lIns="0" tIns="0" rIns="0" bIns="0" rtlCol="0" anchor="ctr">
+            <a:normAutofit/>
+          </a:bodyPr>
+          <a:lstStyle/>
+          <a:p>
+            <a:pPr marL="0" indent="0" algn="ctr">
+              <a:buNone/>
+            </a:pPr>
+            <a:r>
+              <a:rPr lang="es-SV" sz="900" b="1" dirty="0">
+                <a:solidFill>
+                  <a:srgbClr val="C62828"/>
+                </a:solidFill>
+                <a:latin typeface="Arial" panose="020B0604020202020204" pitchFamily="34" charset="0"/>
+                <a:cs typeface="Arial" panose="020B0604020202020204" pitchFamily="34" charset="0"/>
+              </a:rPr>
+              <a:t>ALTO</a:t>
+            </a:r>
+          </a:p>
+        </p:txBody>
+      </p:sp>
+      <p:sp>
+        <p:nvSpPr>
+          <p:cNvPr id="106" name="Debilidad 1 detalle"/>
+          <p:cNvSpPr txBox="1"/>
+          <p:nvPr/>
+        </p:nvSpPr>
+        <p:spPr>
+          <a:xfrm>
+            <a:off x="1325880" y="1965960"/>
+            <a:ext cx="4526280" cy="530352"/>
+          </a:xfrm>
+          <a:prstGeom prst="rect">
+            <a:avLst/>
+          </a:prstGeom>
+          <a:noFill/>
+          <a:ln>
+            <a:noFill/>
+          </a:ln>
+        </p:spPr>
+        <p:txBody>
+          <a:bodyPr wrap="square" lIns="0" tIns="0" rIns="0" bIns="0" rtlCol="0" anchor="t">
+            <a:normAutofit/>
+          </a:bodyPr>
+          <a:lstStyle/>
+          <a:p>
+            <a:pPr marL="0" indent="0" algn="l">
+              <a:buNone/>
+            </a:pPr>
+            <a:r>
+              <a:rPr lang="es-SV" sz="1100" dirty="0">
+                <a:solidFill>
+                  <a:srgbClr val="1E2A3A"/>
+                </a:solidFill>
+                <a:latin typeface="Arial" panose="020B0604020202020204" pitchFamily="34" charset="0"/>
+                <a:cs typeface="Arial" panose="020B0604020202020204" pitchFamily="34" charset="0"/>
+              </a:rPr>
+              <a:t>El Ejecutivo recibe el informe, pero no valida ni revisa el contenido mínimo exigido (NRP-27, art. 33).</a:t>
+            </a:r>
+          </a:p>
+        </p:txBody>
+      </p:sp>
+      <p:sp>
+        <p:nvSpPr>
+          <p:cNvPr id="107" name="Debilidad 2"/>
+          <p:cNvSpPr/>
+          <p:nvPr/>
+        </p:nvSpPr>
+        <p:spPr>
+          <a:xfrm>
+            <a:off x="6172200" y="1554480"/>
+            <a:ext cx="5440680" cy="987552"/>
+          </a:xfrm>
+          <a:prstGeom prst="roundRect">
+            <a:avLst>
+              <a:gd name="adj" fmla="val 10000"/>
+            </a:avLst>
+          </a:prstGeom>
+          <a:solidFill>
+            <a:srgbClr val="EEF3F9"/>
+          </a:solidFill>
+          <a:ln w="9525">
+            <a:solidFill>
+              <a:srgbClr val="D6E2EF"/>
+            </a:solidFill>
+          </a:ln>
+        </p:spPr>
+      </p:sp>
+      <p:sp>
+        <p:nvSpPr>
+          <p:cNvPr id="108" name="Debilidad 2 numero"/>
+          <p:cNvSpPr/>
+          <p:nvPr/>
+        </p:nvSpPr>
+        <p:spPr>
+          <a:xfrm>
+            <a:off x="6336792" y="1819656"/>
+            <a:ext cx="457200" cy="457200"/>
+          </a:xfrm>
+          <a:prstGeom prst="ellipse">
+            <a:avLst/>
+          </a:prstGeom>
+          <a:solidFill>
+            <a:srgbClr val="00376E"/>
+          </a:solidFill>
+          <a:ln>
+            <a:noFill/>
+          </a:ln>
+        </p:spPr>
+        <p:txBody>
+          <a:bodyPr wrap="square" lIns="0" tIns="0" rIns="0" bIns="0" rtlCol="0" anchor="ctr">
+            <a:normAutofit/>
+          </a:bodyPr>
+          <a:lstStyle/>
+          <a:p>
+            <a:pPr marL="0" indent="0" algn="ctr">
+              <a:buNone/>
+            </a:pPr>
+            <a:r>
+              <a:rPr lang="es-SV" sz="1400" b="1" dirty="0">
+                <a:solidFill>
+                  <a:srgbClr val="FFFFFF"/>
+                </a:solidFill>
+                <a:latin typeface="Arial" panose="020B0604020202020204" pitchFamily="34" charset="0"/>
+                <a:cs typeface="Arial" panose="020B0604020202020204" pitchFamily="34" charset="0"/>
+              </a:rPr>
+              <a:t>2</a:t>
+            </a:r>
+          </a:p>
+        </p:txBody>
+      </p:sp>
+      <p:sp>
+        <p:nvSpPr>
+          <p:cNvPr id="109" name="Debilidad 2 titulo"/>
+          <p:cNvSpPr txBox="1"/>
+          <p:nvPr/>
+        </p:nvSpPr>
+        <p:spPr>
+          <a:xfrm>
+            <a:off x="6949440" y="1645920"/>
+            <a:ext cx="3566160" cy="292608"/>
+          </a:xfrm>
+          <a:prstGeom prst="rect">
+            <a:avLst/>
+          </a:prstGeom>
+          <a:noFill/>
+          <a:ln>
+            <a:noFill/>
+          </a:ln>
+        </p:spPr>
+        <p:txBody>
+          <a:bodyPr wrap="square" lIns="0" tIns="0" rIns="0" bIns="0" rtlCol="0" anchor="ctr">
+            <a:normAutofit/>
+          </a:bodyPr>
+          <a:lstStyle/>
+          <a:p>
+            <a:pPr marL="0" indent="0" algn="l">
+              <a:buNone/>
+            </a:pPr>
+            <a:r>
+              <a:rPr lang="es-SV" sz="1300" b="1" dirty="0">
+                <a:solidFill>
+                  <a:srgbClr val="00376E"/>
+                </a:solidFill>
+                <a:latin typeface="Arial" panose="020B0604020202020204" pitchFamily="34" charset="0"/>
+                <a:cs typeface="Arial" panose="020B0604020202020204" pitchFamily="34" charset="0"/>
+              </a:rPr>
+              <a:t>Sin Revisor independiente</a:t>
+            </a:r>
+          </a:p>
+        </p:txBody>
+      </p:sp>
+      <p:sp>
+        <p:nvSpPr>
+          <p:cNvPr id="110" name="Debilidad 2 nivel"/>
+          <p:cNvSpPr/>
+          <p:nvPr/>
+        </p:nvSpPr>
+        <p:spPr>
+          <a:xfrm>
+            <a:off x="10607040" y="1664208"/>
+            <a:ext cx="841248" cy="256032"/>
+          </a:xfrm>
+          <a:prstGeom prst="roundRect">
+            <a:avLst>
+              <a:gd name="adj" fmla="val 50000"/>
+            </a:avLst>
+          </a:prstGeom>
+          <a:solidFill>
+            <a:srgbClr val="FBEAEA"/>
+          </a:solidFill>
+          <a:ln w="9525">
+            <a:solidFill>
+              <a:srgbClr val="C62828"/>
+            </a:solidFill>
+          </a:ln>
+        </p:spPr>
+        <p:txBody>
+          <a:bodyPr wrap="square" lIns="0" tIns="0" rIns="0" bIns="0" rtlCol="0" anchor="ctr">
+            <a:normAutofit/>
+          </a:bodyPr>
+          <a:lstStyle/>
+          <a:p>
+            <a:pPr marL="0" indent="0" algn="ctr">
+              <a:buNone/>
+            </a:pPr>
+            <a:r>
+              <a:rPr lang="es-SV" sz="900" b="1" dirty="0">
+                <a:solidFill>
+                  <a:srgbClr val="C62828"/>
+                </a:solidFill>
+                <a:latin typeface="Arial" panose="020B0604020202020204" pitchFamily="34" charset="0"/>
+                <a:cs typeface="Arial" panose="020B0604020202020204" pitchFamily="34" charset="0"/>
+              </a:rPr>
+              <a:t>ALTO</a:t>
+            </a:r>
+          </a:p>
+        </p:txBody>
+      </p:sp>
+      <p:sp>
+        <p:nvSpPr>
+          <p:cNvPr id="111" name="Debilidad 2 detalle"/>
+          <p:cNvSpPr txBox="1"/>
+          <p:nvPr/>
+        </p:nvSpPr>
+        <p:spPr>
+          <a:xfrm>
+            <a:off x="6949440" y="1965960"/>
+            <a:ext cx="4526280" cy="530352"/>
+          </a:xfrm>
+          <a:prstGeom prst="rect">
+            <a:avLst/>
+          </a:prstGeom>
+          <a:noFill/>
+          <a:ln>
+            <a:noFill/>
+          </a:ln>
+        </p:spPr>
+        <p:txBody>
+          <a:bodyPr wrap="square" lIns="0" tIns="0" rIns="0" bIns="0" rtlCol="0" anchor="t">
+            <a:normAutofit/>
+          </a:bodyPr>
+          <a:lstStyle/>
+          <a:p>
+            <a:pPr marL="0" indent="0" algn="l">
+              <a:buNone/>
+            </a:pPr>
+            <a:r>
+              <a:rPr lang="es-SV" sz="1100" dirty="0">
+                <a:solidFill>
+                  <a:srgbClr val="1E2A3A"/>
+                </a:solidFill>
+                <a:latin typeface="Arial" panose="020B0604020202020204" pitchFamily="34" charset="0"/>
+                <a:cs typeface="Arial" panose="020B0604020202020204" pitchFamily="34" charset="0"/>
+              </a:rPr>
+              <a:t>No existe el Revisor que exige la NRP-27, art. 40; el informe lo recibe el área comercial.</a:t>
+            </a:r>
+          </a:p>
+        </p:txBody>
+      </p:sp>
+      <p:sp>
+        <p:nvSpPr>
+          <p:cNvPr id="112" name="Debilidad 3"/>
+          <p:cNvSpPr/>
+          <p:nvPr/>
+        </p:nvSpPr>
+        <p:spPr>
+          <a:xfrm>
+            <a:off x="548640" y="2651760"/>
+            <a:ext cx="5440680" cy="987552"/>
+          </a:xfrm>
+          <a:prstGeom prst="roundRect">
+            <a:avLst>
+              <a:gd name="adj" fmla="val 10000"/>
+            </a:avLst>
+          </a:prstGeom>
+          <a:solidFill>
+            <a:srgbClr val="EEF3F9"/>
+          </a:solidFill>
+          <a:ln w="9525">
+            <a:solidFill>
+              <a:srgbClr val="D6E2EF"/>
+            </a:solidFill>
+          </a:ln>
+        </p:spPr>
+      </p:sp>
+      <p:sp>
+        <p:nvSpPr>
+          <p:cNvPr id="113" name="Debilidad 3 numero"/>
+          <p:cNvSpPr/>
+          <p:nvPr/>
+        </p:nvSpPr>
+        <p:spPr>
+          <a:xfrm>
+            <a:off x="713232" y="2916936"/>
+            <a:ext cx="457200" cy="457200"/>
+          </a:xfrm>
+          <a:prstGeom prst="ellipse">
+            <a:avLst/>
+          </a:prstGeom>
+          <a:solidFill>
+            <a:srgbClr val="00376E"/>
+          </a:solidFill>
+          <a:ln>
+            <a:noFill/>
+          </a:ln>
+        </p:spPr>
+        <p:txBody>
+          <a:bodyPr wrap="square" lIns="0" tIns="0" rIns="0" bIns="0" rtlCol="0" anchor="ctr">
+            <a:normAutofit/>
+          </a:bodyPr>
+          <a:lstStyle/>
+          <a:p>
+            <a:pPr marL="0" indent="0" algn="ctr">
+              <a:buNone/>
+            </a:pPr>
+            <a:r>
+              <a:rPr lang="es-SV" sz="1400" b="1" dirty="0">
+                <a:solidFill>
+                  <a:srgbClr val="FFFFFF"/>
+                </a:solidFill>
+                <a:latin typeface="Arial" panose="020B0604020202020204" pitchFamily="34" charset="0"/>
+                <a:cs typeface="Arial" panose="020B0604020202020204" pitchFamily="34" charset="0"/>
+              </a:rPr>
+              <a:t>3</a:t>
+            </a:r>
+          </a:p>
+        </p:txBody>
+      </p:sp>
+      <p:sp>
+        <p:nvSpPr>
+          <p:cNvPr id="114" name="Debilidad 3 titulo"/>
+          <p:cNvSpPr txBox="1"/>
+          <p:nvPr/>
+        </p:nvSpPr>
+        <p:spPr>
+          <a:xfrm>
+            <a:off x="1325880" y="2743200"/>
+            <a:ext cx="3566160" cy="292608"/>
+          </a:xfrm>
+          <a:prstGeom prst="rect">
+            <a:avLst/>
+          </a:prstGeom>
+          <a:noFill/>
+          <a:ln>
+            <a:noFill/>
+          </a:ln>
+        </p:spPr>
+        <p:txBody>
+          <a:bodyPr wrap="square" lIns="0" tIns="0" rIns="0" bIns="0" rtlCol="0" anchor="ctr">
+            <a:normAutofit/>
+          </a:bodyPr>
+          <a:lstStyle/>
+          <a:p>
+            <a:pPr marL="0" indent="0" algn="l">
+              <a:buNone/>
+            </a:pPr>
+            <a:r>
+              <a:rPr lang="es-SV" sz="1300" b="1" dirty="0">
+                <a:solidFill>
+                  <a:srgbClr val="00376E"/>
+                </a:solidFill>
+                <a:latin typeface="Arial" panose="020B0604020202020204" pitchFamily="34" charset="0"/>
+                <a:cs typeface="Arial" panose="020B0604020202020204" pitchFamily="34" charset="0"/>
+              </a:rPr>
+              <a:t>Independencia del perito</a:t>
+            </a:r>
+          </a:p>
+        </p:txBody>
+      </p:sp>
+      <p:sp>
+        <p:nvSpPr>
+          <p:cNvPr id="115" name="Debilidad 3 nivel"/>
+          <p:cNvSpPr/>
+          <p:nvPr/>
+        </p:nvSpPr>
+        <p:spPr>
+          <a:xfrm>
+            <a:off x="4983480" y="2761488"/>
+            <a:ext cx="841248" cy="256032"/>
+          </a:xfrm>
+          <a:prstGeom prst="roundRect">
+            <a:avLst>
+              <a:gd name="adj" fmla="val 50000"/>
+            </a:avLst>
+          </a:prstGeom>
+          <a:solidFill>
+            <a:srgbClr val="FBEAEA"/>
+          </a:solidFill>
+          <a:ln w="9525">
+            <a:solidFill>
+              <a:srgbClr val="C62828"/>
+            </a:solidFill>
+          </a:ln>
+        </p:spPr>
+        <p:txBody>
+          <a:bodyPr wrap="square" lIns="0" tIns="0" rIns="0" bIns="0" rtlCol="0" anchor="ctr">
+            <a:normAutofit/>
+          </a:bodyPr>
+          <a:lstStyle/>
+          <a:p>
+            <a:pPr marL="0" indent="0" algn="ctr">
+              <a:buNone/>
+            </a:pPr>
+            <a:r>
+              <a:rPr lang="es-SV" sz="900" b="1" dirty="0">
+                <a:solidFill>
+                  <a:srgbClr val="C62828"/>
+                </a:solidFill>
+                <a:latin typeface="Arial" panose="020B0604020202020204" pitchFamily="34" charset="0"/>
+                <a:cs typeface="Arial" panose="020B0604020202020204" pitchFamily="34" charset="0"/>
+              </a:rPr>
+              <a:t>ALTO</a:t>
+            </a:r>
+          </a:p>
+        </p:txBody>
+      </p:sp>
+      <p:sp>
+        <p:nvSpPr>
+          <p:cNvPr id="116" name="Debilidad 3 detalle"/>
+          <p:cNvSpPr txBox="1"/>
+          <p:nvPr/>
+        </p:nvSpPr>
+        <p:spPr>
+          <a:xfrm>
+            <a:off x="1325880" y="3063240"/>
+            <a:ext cx="4526280" cy="530352"/>
+          </a:xfrm>
+          <a:prstGeom prst="rect">
+            <a:avLst/>
+          </a:prstGeom>
+          <a:noFill/>
+          <a:ln>
+            <a:noFill/>
+          </a:ln>
+        </p:spPr>
+        <p:txBody>
+          <a:bodyPr wrap="square" lIns="0" tIns="0" rIns="0" bIns="0" rtlCol="0" anchor="t">
+            <a:normAutofit/>
+          </a:bodyPr>
+          <a:lstStyle/>
+          <a:p>
+            <a:pPr marL="0" indent="0" algn="l">
+              <a:buNone/>
+            </a:pPr>
+            <a:r>
+              <a:rPr lang="es-SV" sz="1100" dirty="0">
+                <a:solidFill>
+                  <a:srgbClr val="1E2A3A"/>
+                </a:solidFill>
+                <a:latin typeface="Arial" panose="020B0604020202020204" pitchFamily="34" charset="0"/>
+                <a:cs typeface="Arial" panose="020B0604020202020204" pitchFamily="34" charset="0"/>
+              </a:rPr>
+              <a:t>Negocio contrata y administra peritos y a la vez origina el crédito: posible conflicto de interés.</a:t>
+            </a:r>
+          </a:p>
+        </p:txBody>
+      </p:sp>
+      <p:sp>
+        <p:nvSpPr>
+          <p:cNvPr id="117" name="Debilidad 4"/>
+          <p:cNvSpPr/>
+          <p:nvPr/>
+        </p:nvSpPr>
+        <p:spPr>
+          <a:xfrm>
+            <a:off x="6172200" y="2651760"/>
+            <a:ext cx="5440680" cy="987552"/>
+          </a:xfrm>
+          <a:prstGeom prst="roundRect">
+            <a:avLst>
+              <a:gd name="adj" fmla="val 10000"/>
+            </a:avLst>
+          </a:prstGeom>
+          <a:solidFill>
+            <a:srgbClr val="EEF3F9"/>
+          </a:solidFill>
+          <a:ln w="9525">
+            <a:solidFill>
+              <a:srgbClr val="D6E2EF"/>
+            </a:solidFill>
+          </a:ln>
+        </p:spPr>
+      </p:sp>
+      <p:sp>
+        <p:nvSpPr>
+          <p:cNvPr id="118" name="Debilidad 4 numero"/>
+          <p:cNvSpPr/>
+          <p:nvPr/>
+        </p:nvSpPr>
+        <p:spPr>
+          <a:xfrm>
+            <a:off x="6336792" y="2916936"/>
+            <a:ext cx="457200" cy="457200"/>
+          </a:xfrm>
+          <a:prstGeom prst="ellipse">
+            <a:avLst/>
+          </a:prstGeom>
+          <a:solidFill>
+            <a:srgbClr val="00376E"/>
+          </a:solidFill>
+          <a:ln>
+            <a:noFill/>
+          </a:ln>
+        </p:spPr>
+        <p:txBody>
+          <a:bodyPr wrap="square" lIns="0" tIns="0" rIns="0" bIns="0" rtlCol="0" anchor="ctr">
+            <a:normAutofit/>
+          </a:bodyPr>
+          <a:lstStyle/>
+          <a:p>
+            <a:pPr marL="0" indent="0" algn="ctr">
+              <a:buNone/>
+            </a:pPr>
+            <a:r>
+              <a:rPr lang="es-SV" sz="1400" b="1" dirty="0">
+                <a:solidFill>
+                  <a:srgbClr val="FFFFFF"/>
+                </a:solidFill>
+                <a:latin typeface="Arial" panose="020B0604020202020204" pitchFamily="34" charset="0"/>
+                <a:cs typeface="Arial" panose="020B0604020202020204" pitchFamily="34" charset="0"/>
+              </a:rPr>
+              <a:t>4</a:t>
+            </a:r>
+          </a:p>
+        </p:txBody>
+      </p:sp>
+      <p:sp>
+        <p:nvSpPr>
+          <p:cNvPr id="119" name="Debilidad 4 titulo"/>
+          <p:cNvSpPr txBox="1"/>
+          <p:nvPr/>
+        </p:nvSpPr>
+        <p:spPr>
+          <a:xfrm>
+            <a:off x="6949440" y="2743200"/>
+            <a:ext cx="3566160" cy="292608"/>
+          </a:xfrm>
+          <a:prstGeom prst="rect">
+            <a:avLst/>
+          </a:prstGeom>
+          <a:noFill/>
+          <a:ln>
+            <a:noFill/>
+          </a:ln>
+        </p:spPr>
+        <p:txBody>
+          <a:bodyPr wrap="square" lIns="0" tIns="0" rIns="0" bIns="0" rtlCol="0" anchor="ctr">
+            <a:normAutofit/>
+          </a:bodyPr>
+          <a:lstStyle/>
+          <a:p>
+            <a:pPr marL="0" indent="0" algn="l">
+              <a:buNone/>
+            </a:pPr>
+            <a:r>
+              <a:rPr lang="es-SV" sz="1300" b="1" dirty="0">
+                <a:solidFill>
+                  <a:srgbClr val="00376E"/>
+                </a:solidFill>
+                <a:latin typeface="Arial" panose="020B0604020202020204" pitchFamily="34" charset="0"/>
+                <a:cs typeface="Arial" panose="020B0604020202020204" pitchFamily="34" charset="0"/>
+              </a:rPr>
+              <a:t>Sin análisis de razonabilidad del valor</a:t>
+            </a:r>
+          </a:p>
+        </p:txBody>
+      </p:sp>
+      <p:sp>
+        <p:nvSpPr>
+          <p:cNvPr id="120" name="Debilidad 4 nivel"/>
+          <p:cNvSpPr/>
+          <p:nvPr/>
+        </p:nvSpPr>
+        <p:spPr>
+          <a:xfrm>
+            <a:off x="10607040" y="2761488"/>
+            <a:ext cx="841248" cy="256032"/>
+          </a:xfrm>
+          <a:prstGeom prst="roundRect">
+            <a:avLst>
+              <a:gd name="adj" fmla="val 50000"/>
+            </a:avLst>
+          </a:prstGeom>
+          <a:solidFill>
+            <a:srgbClr val="FBEAEA"/>
+          </a:solidFill>
+          <a:ln w="9525">
+            <a:solidFill>
+              <a:srgbClr val="C62828"/>
+            </a:solidFill>
+          </a:ln>
+        </p:spPr>
+        <p:txBody>
+          <a:bodyPr wrap="square" lIns="0" tIns="0" rIns="0" bIns="0" rtlCol="0" anchor="ctr">
+            <a:normAutofit/>
+          </a:bodyPr>
+          <a:lstStyle/>
+          <a:p>
+            <a:pPr marL="0" indent="0" algn="ctr">
+              <a:buNone/>
+            </a:pPr>
+            <a:r>
+              <a:rPr lang="es-SV" sz="900" b="1" dirty="0">
+                <a:solidFill>
+                  <a:srgbClr val="C62828"/>
+                </a:solidFill>
+                <a:latin typeface="Arial" panose="020B0604020202020204" pitchFamily="34" charset="0"/>
+                <a:cs typeface="Arial" panose="020B0604020202020204" pitchFamily="34" charset="0"/>
+              </a:rPr>
+              <a:t>ALTO</a:t>
+            </a:r>
+          </a:p>
+        </p:txBody>
+      </p:sp>
+      <p:sp>
+        <p:nvSpPr>
+          <p:cNvPr id="121" name="Debilidad 4 detalle"/>
+          <p:cNvSpPr txBox="1"/>
+          <p:nvPr/>
+        </p:nvSpPr>
+        <p:spPr>
+          <a:xfrm>
+            <a:off x="6949440" y="3063240"/>
+            <a:ext cx="4526280" cy="530352"/>
+          </a:xfrm>
+          <a:prstGeom prst="rect">
+            <a:avLst/>
+          </a:prstGeom>
+          <a:noFill/>
+          <a:ln>
+            <a:noFill/>
+          </a:ln>
+        </p:spPr>
+        <p:txBody>
+          <a:bodyPr wrap="square" lIns="0" tIns="0" rIns="0" bIns="0" rtlCol="0" anchor="t">
+            <a:normAutofit/>
+          </a:bodyPr>
+          <a:lstStyle/>
+          <a:p>
+            <a:pPr marL="0" indent="0" algn="l">
+              <a:buNone/>
+            </a:pPr>
+            <a:r>
+              <a:rPr lang="es-SV" sz="1100" dirty="0">
+                <a:solidFill>
+                  <a:srgbClr val="1E2A3A"/>
+                </a:solidFill>
+                <a:latin typeface="Arial" panose="020B0604020202020204" pitchFamily="34" charset="0"/>
+                <a:cs typeface="Arial" panose="020B0604020202020204" pitchFamily="34" charset="0"/>
+              </a:rPr>
+              <a:t>No se contrasta el valor de mercado y de realización con comparables, avalúos previos ni fotografías.</a:t>
+            </a:r>
+          </a:p>
+        </p:txBody>
+      </p:sp>
+      <p:sp>
+        <p:nvSpPr>
+          <p:cNvPr id="122" name="Debilidad 5"/>
+          <p:cNvSpPr/>
+          <p:nvPr/>
+        </p:nvSpPr>
+        <p:spPr>
+          <a:xfrm>
+            <a:off x="548640" y="3749040"/>
+            <a:ext cx="5440680" cy="987552"/>
+          </a:xfrm>
+          <a:prstGeom prst="roundRect">
+            <a:avLst>
+              <a:gd name="adj" fmla="val 10000"/>
+            </a:avLst>
+          </a:prstGeom>
+          <a:solidFill>
+            <a:srgbClr val="EEF3F9"/>
+          </a:solidFill>
+          <a:ln w="9525">
+            <a:solidFill>
+              <a:srgbClr val="D6E2EF"/>
+            </a:solidFill>
+          </a:ln>
+        </p:spPr>
+      </p:sp>
+      <p:sp>
+        <p:nvSpPr>
+          <p:cNvPr id="123" name="Debilidad 5 numero"/>
+          <p:cNvSpPr/>
+          <p:nvPr/>
+        </p:nvSpPr>
+        <p:spPr>
+          <a:xfrm>
+            <a:off x="713232" y="4014216"/>
+            <a:ext cx="457200" cy="457200"/>
+          </a:xfrm>
+          <a:prstGeom prst="ellipse">
+            <a:avLst/>
+          </a:prstGeom>
+          <a:solidFill>
+            <a:srgbClr val="00376E"/>
+          </a:solidFill>
+          <a:ln>
+            <a:noFill/>
+          </a:ln>
+        </p:spPr>
+        <p:txBody>
+          <a:bodyPr wrap="square" lIns="0" tIns="0" rIns="0" bIns="0" rtlCol="0" anchor="ctr">
+            <a:normAutofit/>
+          </a:bodyPr>
+          <a:lstStyle/>
+          <a:p>
+            <a:pPr marL="0" indent="0" algn="ctr">
+              <a:buNone/>
+            </a:pPr>
+            <a:r>
+              <a:rPr lang="es-SV" sz="1400" b="1" dirty="0">
+                <a:solidFill>
+                  <a:srgbClr val="FFFFFF"/>
+                </a:solidFill>
+                <a:latin typeface="Arial" panose="020B0604020202020204" pitchFamily="34" charset="0"/>
+                <a:cs typeface="Arial" panose="020B0604020202020204" pitchFamily="34" charset="0"/>
+              </a:rPr>
+              <a:t>5</a:t>
+            </a:r>
+          </a:p>
+        </p:txBody>
+      </p:sp>
+      <p:sp>
+        <p:nvSpPr>
+          <p:cNvPr id="124" name="Debilidad 5 titulo"/>
+          <p:cNvSpPr txBox="1"/>
+          <p:nvPr/>
+        </p:nvSpPr>
+        <p:spPr>
+          <a:xfrm>
+            <a:off x="1325880" y="3840480"/>
+            <a:ext cx="3566160" cy="292608"/>
+          </a:xfrm>
+          <a:prstGeom prst="rect">
+            <a:avLst/>
+          </a:prstGeom>
+          <a:noFill/>
+          <a:ln>
+            <a:noFill/>
+          </a:ln>
+        </p:spPr>
+        <p:txBody>
+          <a:bodyPr wrap="square" lIns="0" tIns="0" rIns="0" bIns="0" rtlCol="0" anchor="ctr">
+            <a:normAutofit/>
+          </a:bodyPr>
+          <a:lstStyle/>
+          <a:p>
+            <a:pPr marL="0" indent="0" algn="l">
+              <a:buNone/>
+            </a:pPr>
+            <a:r>
+              <a:rPr lang="es-SV" sz="1300" b="1" dirty="0">
+                <a:solidFill>
+                  <a:srgbClr val="00376E"/>
+                </a:solidFill>
+                <a:latin typeface="Arial" panose="020B0604020202020204" pitchFamily="34" charset="0"/>
+                <a:cs typeface="Arial" panose="020B0604020202020204" pitchFamily="34" charset="0"/>
+              </a:rPr>
+              <a:t>Datos registrales no conciliados</a:t>
+            </a:r>
+          </a:p>
+        </p:txBody>
+      </p:sp>
+      <p:sp>
+        <p:nvSpPr>
+          <p:cNvPr id="125" name="Debilidad 5 nivel"/>
+          <p:cNvSpPr/>
+          <p:nvPr/>
+        </p:nvSpPr>
+        <p:spPr>
+          <a:xfrm>
+            <a:off x="4983480" y="3858768"/>
+            <a:ext cx="841248" cy="256032"/>
+          </a:xfrm>
+          <a:prstGeom prst="roundRect">
+            <a:avLst>
+              <a:gd name="adj" fmla="val 50000"/>
+            </a:avLst>
+          </a:prstGeom>
+          <a:solidFill>
+            <a:srgbClr val="FDF3E3"/>
+          </a:solidFill>
+          <a:ln w="9525">
+            <a:solidFill>
+              <a:srgbClr val="B26A00"/>
+            </a:solidFill>
+          </a:ln>
+        </p:spPr>
+        <p:txBody>
+          <a:bodyPr wrap="square" lIns="0" tIns="0" rIns="0" bIns="0" rtlCol="0" anchor="ctr">
+            <a:normAutofit/>
+          </a:bodyPr>
+          <a:lstStyle/>
+          <a:p>
+            <a:pPr marL="0" indent="0" algn="ctr">
+              <a:buNone/>
+            </a:pPr>
+            <a:r>
+              <a:rPr lang="es-SV" sz="900" b="1" dirty="0">
+                <a:solidFill>
+                  <a:srgbClr val="B26A00"/>
+                </a:solidFill>
+                <a:latin typeface="Arial" panose="020B0604020202020204" pitchFamily="34" charset="0"/>
+                <a:cs typeface="Arial" panose="020B0604020202020204" pitchFamily="34" charset="0"/>
+              </a:rPr>
+              <a:t>MEDIO</a:t>
+            </a:r>
+          </a:p>
+        </p:txBody>
+      </p:sp>
+      <p:sp>
+        <p:nvSpPr>
+          <p:cNvPr id="126" name="Debilidad 5 detalle"/>
+          <p:cNvSpPr txBox="1"/>
+          <p:nvPr/>
+        </p:nvSpPr>
+        <p:spPr>
+          <a:xfrm>
+            <a:off x="1325880" y="4160520"/>
+            <a:ext cx="4526280" cy="530352"/>
+          </a:xfrm>
+          <a:prstGeom prst="rect">
+            <a:avLst/>
+          </a:prstGeom>
+          <a:noFill/>
+          <a:ln>
+            <a:noFill/>
+          </a:ln>
+        </p:spPr>
+        <p:txBody>
+          <a:bodyPr wrap="square" lIns="0" tIns="0" rIns="0" bIns="0" rtlCol="0" anchor="t">
+            <a:normAutofit/>
+          </a:bodyPr>
+          <a:lstStyle/>
+          <a:p>
+            <a:pPr marL="0" indent="0" algn="l">
+              <a:buNone/>
+            </a:pPr>
+            <a:r>
+              <a:rPr lang="es-SV" sz="1100" dirty="0">
+                <a:solidFill>
+                  <a:srgbClr val="1E2A3A"/>
+                </a:solidFill>
+                <a:latin typeface="Arial" panose="020B0604020202020204" pitchFamily="34" charset="0"/>
+                <a:cs typeface="Arial" panose="020B0604020202020204" pitchFamily="34" charset="0"/>
+              </a:rPr>
+              <a:t>Áreas, matrícula, propietario y gravámenes del informe no se concilian de forma sistemática con la inscripción.</a:t>
+            </a:r>
+          </a:p>
+        </p:txBody>
+      </p:sp>
+      <p:sp>
+        <p:nvSpPr>
+          <p:cNvPr id="127" name="Debilidad 6"/>
+          <p:cNvSpPr/>
+          <p:nvPr/>
+        </p:nvSpPr>
+        <p:spPr>
+          <a:xfrm>
+            <a:off x="6172200" y="3749040"/>
+            <a:ext cx="5440680" cy="987552"/>
+          </a:xfrm>
+          <a:prstGeom prst="roundRect">
+            <a:avLst>
+              <a:gd name="adj" fmla="val 10000"/>
+            </a:avLst>
+          </a:prstGeom>
+          <a:solidFill>
+            <a:srgbClr val="EEF3F9"/>
+          </a:solidFill>
+          <a:ln w="9525">
+            <a:solidFill>
+              <a:srgbClr val="D6E2EF"/>
+            </a:solidFill>
+          </a:ln>
+        </p:spPr>
+      </p:sp>
+      <p:sp>
+        <p:nvSpPr>
+          <p:cNvPr id="128" name="Debilidad 6 numero"/>
+          <p:cNvSpPr/>
+          <p:nvPr/>
+        </p:nvSpPr>
+        <p:spPr>
+          <a:xfrm>
+            <a:off x="6336792" y="4014216"/>
+            <a:ext cx="457200" cy="457200"/>
+          </a:xfrm>
+          <a:prstGeom prst="ellipse">
+            <a:avLst/>
+          </a:prstGeom>
+          <a:solidFill>
+            <a:srgbClr val="00376E"/>
+          </a:solidFill>
+          <a:ln>
+            <a:noFill/>
+          </a:ln>
+        </p:spPr>
+        <p:txBody>
+          <a:bodyPr wrap="square" lIns="0" tIns="0" rIns="0" bIns="0" rtlCol="0" anchor="ctr">
+            <a:normAutofit/>
+          </a:bodyPr>
+          <a:lstStyle/>
+          <a:p>
+            <a:pPr marL="0" indent="0" algn="ctr">
+              <a:buNone/>
+            </a:pPr>
+            <a:r>
+              <a:rPr lang="es-SV" sz="1400" b="1" dirty="0">
+                <a:solidFill>
+                  <a:srgbClr val="FFFFFF"/>
+                </a:solidFill>
+                <a:latin typeface="Arial" panose="020B0604020202020204" pitchFamily="34" charset="0"/>
+                <a:cs typeface="Arial" panose="020B0604020202020204" pitchFamily="34" charset="0"/>
+              </a:rPr>
+              <a:t>6</a:t>
+            </a:r>
+          </a:p>
+        </p:txBody>
+      </p:sp>
+      <p:sp>
+        <p:nvSpPr>
+          <p:cNvPr id="129" name="Debilidad 6 titulo"/>
+          <p:cNvSpPr txBox="1"/>
+          <p:nvPr/>
+        </p:nvSpPr>
+        <p:spPr>
+          <a:xfrm>
+            <a:off x="6949440" y="3840480"/>
+            <a:ext cx="3566160" cy="292608"/>
+          </a:xfrm>
+          <a:prstGeom prst="rect">
+            <a:avLst/>
+          </a:prstGeom>
+          <a:noFill/>
+          <a:ln>
+            <a:noFill/>
+          </a:ln>
+        </p:spPr>
+        <p:txBody>
+          <a:bodyPr wrap="square" lIns="0" tIns="0" rIns="0" bIns="0" rtlCol="0" anchor="ctr">
+            <a:normAutofit/>
+          </a:bodyPr>
+          <a:lstStyle/>
+          <a:p>
+            <a:pPr marL="0" indent="0" algn="l">
+              <a:buNone/>
+            </a:pPr>
+            <a:r>
+              <a:rPr lang="es-SV" sz="1300" b="1" dirty="0">
+                <a:solidFill>
+                  <a:srgbClr val="00376E"/>
+                </a:solidFill>
+                <a:latin typeface="Arial" panose="020B0604020202020204" pitchFamily="34" charset="0"/>
+                <a:cs typeface="Arial" panose="020B0604020202020204" pitchFamily="34" charset="0"/>
+              </a:rPr>
+              <a:t>Calidad del dato en el sistema</a:t>
+            </a:r>
+          </a:p>
+        </p:txBody>
+      </p:sp>
+      <p:sp>
+        <p:nvSpPr>
+          <p:cNvPr id="130" name="Debilidad 6 nivel"/>
+          <p:cNvSpPr/>
+          <p:nvPr/>
+        </p:nvSpPr>
+        <p:spPr>
+          <a:xfrm>
+            <a:off x="10607040" y="3858768"/>
+            <a:ext cx="841248" cy="256032"/>
+          </a:xfrm>
+          <a:prstGeom prst="roundRect">
+            <a:avLst>
+              <a:gd name="adj" fmla="val 50000"/>
+            </a:avLst>
+          </a:prstGeom>
+          <a:solidFill>
+            <a:srgbClr val="FBEAEA"/>
+          </a:solidFill>
+          <a:ln w="9525">
+            <a:solidFill>
+              <a:srgbClr val="C62828"/>
+            </a:solidFill>
+          </a:ln>
+        </p:spPr>
+        <p:txBody>
+          <a:bodyPr wrap="square" lIns="0" tIns="0" rIns="0" bIns="0" rtlCol="0" anchor="ctr">
+            <a:normAutofit/>
+          </a:bodyPr>
+          <a:lstStyle/>
+          <a:p>
+            <a:pPr marL="0" indent="0" algn="ctr">
+              <a:buNone/>
+            </a:pPr>
+            <a:r>
+              <a:rPr lang="es-SV" sz="900" b="1" dirty="0">
+                <a:solidFill>
+                  <a:srgbClr val="C62828"/>
+                </a:solidFill>
+                <a:latin typeface="Arial" panose="020B0604020202020204" pitchFamily="34" charset="0"/>
+                <a:cs typeface="Arial" panose="020B0604020202020204" pitchFamily="34" charset="0"/>
+              </a:rPr>
+              <a:t>ALTO</a:t>
+            </a:r>
+          </a:p>
+        </p:txBody>
+      </p:sp>
+      <p:sp>
+        <p:nvSpPr>
+          <p:cNvPr id="131" name="Debilidad 6 detalle"/>
+          <p:cNvSpPr txBox="1"/>
+          <p:nvPr/>
+        </p:nvSpPr>
+        <p:spPr>
+          <a:xfrm>
+            <a:off x="6949440" y="4160520"/>
+            <a:ext cx="4526280" cy="530352"/>
+          </a:xfrm>
+          <a:prstGeom prst="rect">
+            <a:avLst/>
+          </a:prstGeom>
+          <a:noFill/>
+          <a:ln>
+            <a:noFill/>
+          </a:ln>
+        </p:spPr>
+        <p:txBody>
+          <a:bodyPr wrap="square" lIns="0" tIns="0" rIns="0" bIns="0" rtlCol="0" anchor="t">
+            <a:normAutofit/>
+          </a:bodyPr>
+          <a:lstStyle/>
+          <a:p>
+            <a:pPr marL="0" indent="0" algn="l">
+              <a:buNone/>
+            </a:pPr>
+            <a:r>
+              <a:rPr lang="es-SV" sz="1100" dirty="0">
+                <a:solidFill>
+                  <a:srgbClr val="1E2A3A"/>
+                </a:solidFill>
+                <a:latin typeface="Arial" panose="020B0604020202020204" pitchFamily="34" charset="0"/>
+                <a:cs typeface="Arial" panose="020B0604020202020204" pitchFamily="34" charset="0"/>
+              </a:rPr>
+              <a:t>15 Ejecutivos ingresan, Cartera modifica y Riesgos verifica después: riesgo de error en valores y fechas.</a:t>
+            </a:r>
+          </a:p>
+        </p:txBody>
+      </p:sp>
+      <p:sp>
+        <p:nvSpPr>
+          <p:cNvPr id="132" name="Debilidad 7"/>
+          <p:cNvSpPr/>
+          <p:nvPr/>
+        </p:nvSpPr>
+        <p:spPr>
+          <a:xfrm>
+            <a:off x="548640" y="4846320"/>
+            <a:ext cx="5440680" cy="987552"/>
+          </a:xfrm>
+          <a:prstGeom prst="roundRect">
+            <a:avLst>
+              <a:gd name="adj" fmla="val 10000"/>
+            </a:avLst>
+          </a:prstGeom>
+          <a:solidFill>
+            <a:srgbClr val="EEF3F9"/>
+          </a:solidFill>
+          <a:ln w="9525">
+            <a:solidFill>
+              <a:srgbClr val="D6E2EF"/>
+            </a:solidFill>
+          </a:ln>
+        </p:spPr>
+      </p:sp>
+      <p:sp>
+        <p:nvSpPr>
+          <p:cNvPr id="133" name="Debilidad 7 numero"/>
+          <p:cNvSpPr/>
+          <p:nvPr/>
+        </p:nvSpPr>
+        <p:spPr>
+          <a:xfrm>
+            <a:off x="713232" y="5111496"/>
+            <a:ext cx="457200" cy="457200"/>
+          </a:xfrm>
+          <a:prstGeom prst="ellipse">
+            <a:avLst/>
+          </a:prstGeom>
+          <a:solidFill>
+            <a:srgbClr val="00376E"/>
+          </a:solidFill>
+          <a:ln>
+            <a:noFill/>
+          </a:ln>
+        </p:spPr>
+        <p:txBody>
+          <a:bodyPr wrap="square" lIns="0" tIns="0" rIns="0" bIns="0" rtlCol="0" anchor="ctr">
+            <a:normAutofit/>
+          </a:bodyPr>
+          <a:lstStyle/>
+          <a:p>
+            <a:pPr marL="0" indent="0" algn="ctr">
+              <a:buNone/>
+            </a:pPr>
+            <a:r>
+              <a:rPr lang="es-SV" sz="1400" b="1" dirty="0">
+                <a:solidFill>
+                  <a:srgbClr val="FFFFFF"/>
+                </a:solidFill>
+                <a:latin typeface="Arial" panose="020B0604020202020204" pitchFamily="34" charset="0"/>
+                <a:cs typeface="Arial" panose="020B0604020202020204" pitchFamily="34" charset="0"/>
+              </a:rPr>
+              <a:t>7</a:t>
+            </a:r>
+          </a:p>
+        </p:txBody>
+      </p:sp>
+      <p:sp>
+        <p:nvSpPr>
+          <p:cNvPr id="134" name="Debilidad 7 titulo"/>
+          <p:cNvSpPr txBox="1"/>
+          <p:nvPr/>
+        </p:nvSpPr>
+        <p:spPr>
+          <a:xfrm>
+            <a:off x="1325880" y="4937760"/>
+            <a:ext cx="3566160" cy="292608"/>
+          </a:xfrm>
+          <a:prstGeom prst="rect">
+            <a:avLst/>
+          </a:prstGeom>
+          <a:noFill/>
+          <a:ln>
+            <a:noFill/>
+          </a:ln>
+        </p:spPr>
+        <p:txBody>
+          <a:bodyPr wrap="square" lIns="0" tIns="0" rIns="0" bIns="0" rtlCol="0" anchor="ctr">
+            <a:normAutofit/>
+          </a:bodyPr>
+          <a:lstStyle/>
+          <a:p>
+            <a:pPr marL="0" indent="0" algn="l">
+              <a:buNone/>
+            </a:pPr>
+            <a:r>
+              <a:rPr lang="es-SV" sz="1300" b="1" dirty="0">
+                <a:solidFill>
+                  <a:srgbClr val="00376E"/>
+                </a:solidFill>
+                <a:latin typeface="Arial" panose="020B0604020202020204" pitchFamily="34" charset="0"/>
+                <a:cs typeface="Arial" panose="020B0604020202020204" pitchFamily="34" charset="0"/>
+              </a:rPr>
+              <a:t>Vigencia de los avalúos</a:t>
+            </a:r>
+          </a:p>
+        </p:txBody>
+      </p:sp>
+      <p:sp>
+        <p:nvSpPr>
+          <p:cNvPr id="135" name="Debilidad 7 nivel"/>
+          <p:cNvSpPr/>
+          <p:nvPr/>
+        </p:nvSpPr>
+        <p:spPr>
+          <a:xfrm>
+            <a:off x="4983480" y="4956048"/>
+            <a:ext cx="841248" cy="256032"/>
+          </a:xfrm>
+          <a:prstGeom prst="roundRect">
+            <a:avLst>
+              <a:gd name="adj" fmla="val 50000"/>
+            </a:avLst>
+          </a:prstGeom>
+          <a:solidFill>
+            <a:srgbClr val="FBEAEA"/>
+          </a:solidFill>
+          <a:ln w="9525">
+            <a:solidFill>
+              <a:srgbClr val="C62828"/>
+            </a:solidFill>
+          </a:ln>
+        </p:spPr>
+        <p:txBody>
+          <a:bodyPr wrap="square" lIns="0" tIns="0" rIns="0" bIns="0" rtlCol="0" anchor="ctr">
+            <a:normAutofit/>
+          </a:bodyPr>
+          <a:lstStyle/>
+          <a:p>
+            <a:pPr marL="0" indent="0" algn="ctr">
+              <a:buNone/>
+            </a:pPr>
+            <a:r>
+              <a:rPr lang="es-SV" sz="900" b="1" dirty="0">
+                <a:solidFill>
+                  <a:srgbClr val="C62828"/>
+                </a:solidFill>
+                <a:latin typeface="Arial" panose="020B0604020202020204" pitchFamily="34" charset="0"/>
+                <a:cs typeface="Arial" panose="020B0604020202020204" pitchFamily="34" charset="0"/>
+              </a:rPr>
+              <a:t>ALTO</a:t>
+            </a:r>
+          </a:p>
+        </p:txBody>
+      </p:sp>
+      <p:sp>
+        <p:nvSpPr>
+          <p:cNvPr id="136" name="Debilidad 7 detalle"/>
+          <p:cNvSpPr txBox="1"/>
+          <p:nvPr/>
+        </p:nvSpPr>
+        <p:spPr>
+          <a:xfrm>
+            <a:off x="1325880" y="5257800"/>
+            <a:ext cx="4526280" cy="530352"/>
+          </a:xfrm>
+          <a:prstGeom prst="rect">
+            <a:avLst/>
+          </a:prstGeom>
+          <a:noFill/>
+          <a:ln>
+            <a:noFill/>
+          </a:ln>
+        </p:spPr>
+        <p:txBody>
+          <a:bodyPr wrap="square" lIns="0" tIns="0" rIns="0" bIns="0" rtlCol="0" anchor="t">
+            <a:normAutofit/>
+          </a:bodyPr>
+          <a:lstStyle/>
+          <a:p>
+            <a:pPr marL="0" indent="0" algn="l">
+              <a:buNone/>
+            </a:pPr>
+            <a:r>
+              <a:rPr lang="es-SV" sz="1100" dirty="0">
+                <a:solidFill>
+                  <a:srgbClr val="1E2A3A"/>
+                </a:solidFill>
+                <a:latin typeface="Arial" panose="020B0604020202020204" pitchFamily="34" charset="0"/>
+                <a:cs typeface="Arial" panose="020B0604020202020204" pitchFamily="34" charset="0"/>
+              </a:rPr>
+              <a:t>Con 60 actualizaciones al mes, renovar 3,500 garantías toma cerca de 58 meses; impacta reservas (NCB-022).</a:t>
+            </a:r>
+          </a:p>
+        </p:txBody>
+      </p:sp>
+      <p:sp>
+        <p:nvSpPr>
+          <p:cNvPr id="137" name="Debilidad 8"/>
+          <p:cNvSpPr/>
+          <p:nvPr/>
+        </p:nvSpPr>
+        <p:spPr>
+          <a:xfrm>
+            <a:off x="6172200" y="4846320"/>
+            <a:ext cx="5440680" cy="987552"/>
+          </a:xfrm>
+          <a:prstGeom prst="roundRect">
+            <a:avLst>
+              <a:gd name="adj" fmla="val 10000"/>
+            </a:avLst>
+          </a:prstGeom>
+          <a:solidFill>
+            <a:srgbClr val="EEF3F9"/>
+          </a:solidFill>
+          <a:ln w="9525">
+            <a:solidFill>
+              <a:srgbClr val="D6E2EF"/>
+            </a:solidFill>
+          </a:ln>
+        </p:spPr>
+      </p:sp>
+      <p:sp>
+        <p:nvSpPr>
+          <p:cNvPr id="138" name="Debilidad 8 numero"/>
+          <p:cNvSpPr/>
+          <p:nvPr/>
+        </p:nvSpPr>
+        <p:spPr>
+          <a:xfrm>
+            <a:off x="6336792" y="5111496"/>
+            <a:ext cx="457200" cy="457200"/>
+          </a:xfrm>
+          <a:prstGeom prst="ellipse">
+            <a:avLst/>
+          </a:prstGeom>
+          <a:solidFill>
+            <a:srgbClr val="00376E"/>
+          </a:solidFill>
+          <a:ln>
+            <a:noFill/>
+          </a:ln>
+        </p:spPr>
+        <p:txBody>
+          <a:bodyPr wrap="square" lIns="0" tIns="0" rIns="0" bIns="0" rtlCol="0" anchor="ctr">
+            <a:normAutofit/>
+          </a:bodyPr>
+          <a:lstStyle/>
+          <a:p>
+            <a:pPr marL="0" indent="0" algn="ctr">
+              <a:buNone/>
+            </a:pPr>
+            <a:r>
+              <a:rPr lang="es-SV" sz="1400" b="1" dirty="0">
+                <a:solidFill>
+                  <a:srgbClr val="FFFFFF"/>
+                </a:solidFill>
+                <a:latin typeface="Arial" panose="020B0604020202020204" pitchFamily="34" charset="0"/>
+                <a:cs typeface="Arial" panose="020B0604020202020204" pitchFamily="34" charset="0"/>
+              </a:rPr>
+              <a:t>8</a:t>
+            </a:r>
+          </a:p>
+        </p:txBody>
+      </p:sp>
+      <p:sp>
+        <p:nvSpPr>
+          <p:cNvPr id="139" name="Debilidad 8 titulo"/>
+          <p:cNvSpPr txBox="1"/>
+          <p:nvPr/>
+        </p:nvSpPr>
+        <p:spPr>
+          <a:xfrm>
+            <a:off x="6949440" y="4937760"/>
+            <a:ext cx="3566160" cy="292608"/>
+          </a:xfrm>
+          <a:prstGeom prst="rect">
+            <a:avLst/>
+          </a:prstGeom>
+          <a:noFill/>
+          <a:ln>
+            <a:noFill/>
+          </a:ln>
+        </p:spPr>
+        <p:txBody>
+          <a:bodyPr wrap="square" lIns="0" tIns="0" rIns="0" bIns="0" rtlCol="0" anchor="ctr">
+            <a:normAutofit/>
+          </a:bodyPr>
+          <a:lstStyle/>
+          <a:p>
+            <a:pPr marL="0" indent="0" algn="l">
+              <a:buNone/>
+            </a:pPr>
+            <a:r>
+              <a:rPr lang="es-SV" sz="1300" b="1" dirty="0">
+                <a:solidFill>
+                  <a:srgbClr val="00376E"/>
+                </a:solidFill>
+                <a:latin typeface="Arial" panose="020B0604020202020204" pitchFamily="34" charset="0"/>
+                <a:cs typeface="Arial" panose="020B0604020202020204" pitchFamily="34" charset="0"/>
+              </a:rPr>
+              <a:t>Sin trazabilidad ni evaluación de peritos</a:t>
+            </a:r>
+          </a:p>
+        </p:txBody>
+      </p:sp>
+      <p:sp>
+        <p:nvSpPr>
+          <p:cNvPr id="140" name="Debilidad 8 nivel"/>
+          <p:cNvSpPr/>
+          <p:nvPr/>
+        </p:nvSpPr>
+        <p:spPr>
+          <a:xfrm>
+            <a:off x="10607040" y="4956048"/>
+            <a:ext cx="841248" cy="256032"/>
+          </a:xfrm>
+          <a:prstGeom prst="roundRect">
+            <a:avLst>
+              <a:gd name="adj" fmla="val 50000"/>
+            </a:avLst>
+          </a:prstGeom>
+          <a:solidFill>
+            <a:srgbClr val="FDF3E3"/>
+          </a:solidFill>
+          <a:ln w="9525">
+            <a:solidFill>
+              <a:srgbClr val="B26A00"/>
+            </a:solidFill>
+          </a:ln>
+        </p:spPr>
+        <p:txBody>
+          <a:bodyPr wrap="square" lIns="0" tIns="0" rIns="0" bIns="0" rtlCol="0" anchor="ctr">
+            <a:normAutofit/>
+          </a:bodyPr>
+          <a:lstStyle/>
+          <a:p>
+            <a:pPr marL="0" indent="0" algn="ctr">
+              <a:buNone/>
+            </a:pPr>
+            <a:r>
+              <a:rPr lang="es-SV" sz="900" b="1" dirty="0">
+                <a:solidFill>
+                  <a:srgbClr val="B26A00"/>
+                </a:solidFill>
+                <a:latin typeface="Arial" panose="020B0604020202020204" pitchFamily="34" charset="0"/>
+                <a:cs typeface="Arial" panose="020B0604020202020204" pitchFamily="34" charset="0"/>
+              </a:rPr>
+              <a:t>MEDIO</a:t>
+            </a:r>
+          </a:p>
+        </p:txBody>
+      </p:sp>
+      <p:sp>
+        <p:nvSpPr>
+          <p:cNvPr id="141" name="Debilidad 8 detalle"/>
+          <p:cNvSpPr txBox="1"/>
+          <p:nvPr/>
+        </p:nvSpPr>
+        <p:spPr>
+          <a:xfrm>
+            <a:off x="6949440" y="5257800"/>
+            <a:ext cx="4526280" cy="530352"/>
+          </a:xfrm>
+          <a:prstGeom prst="rect">
+            <a:avLst/>
+          </a:prstGeom>
+          <a:noFill/>
+          <a:ln>
+            <a:noFill/>
+          </a:ln>
+        </p:spPr>
+        <p:txBody>
+          <a:bodyPr wrap="square" lIns="0" tIns="0" rIns="0" bIns="0" rtlCol="0" anchor="t">
+            <a:normAutofit/>
+          </a:bodyPr>
+          <a:lstStyle/>
+          <a:p>
+            <a:pPr marL="0" indent="0" algn="l">
+              <a:buNone/>
+            </a:pPr>
+            <a:r>
+              <a:rPr lang="es-SV" sz="1100" dirty="0">
+                <a:solidFill>
+                  <a:srgbClr val="1E2A3A"/>
+                </a:solidFill>
+                <a:latin typeface="Arial" panose="020B0604020202020204" pitchFamily="34" charset="0"/>
+                <a:cs typeface="Arial" panose="020B0604020202020204" pitchFamily="34" charset="0"/>
+              </a:rPr>
+              <a:t>Las observaciones al perito no se documentan ni se califica su desempeño; 5 expedientes al mes sin tramitar.</a:t>
+            </a:r>
+          </a:p>
+        </p:txBody>
+      </p:sp>
+      <p:sp>
+        <p:nvSpPr>
+          <p:cNvPr id="142" name="Nota"/>
+          <p:cNvSpPr txBox="1"/>
+          <p:nvPr/>
+        </p:nvSpPr>
+        <p:spPr>
+          <a:xfrm>
+            <a:off x="548640" y="5961888"/>
+            <a:ext cx="9875520" cy="274320"/>
+          </a:xfrm>
+          <a:prstGeom prst="rect">
+            <a:avLst/>
+          </a:prstGeom>
+          <a:noFill/>
+          <a:ln>
+            <a:noFill/>
+          </a:ln>
+        </p:spPr>
+        <p:txBody>
+          <a:bodyPr wrap="square" lIns="0" tIns="0" rIns="0" bIns="0" rtlCol="0" anchor="ctr">
+            <a:normAutofit/>
+          </a:bodyPr>
+          <a:lstStyle/>
+          <a:p>
+            <a:pPr marL="0" indent="0" algn="l">
+              <a:buNone/>
+            </a:pPr>
+            <a:r>
+              <a:rPr lang="es-SV" sz="950" i="1" dirty="0">
+                <a:solidFill>
+                  <a:srgbClr val="5F7590"/>
+                </a:solidFill>
+                <a:latin typeface="Arial" panose="020B0604020202020204" pitchFamily="34" charset="0"/>
+                <a:cs typeface="Arial" panose="020B0604020202020204" pitchFamily="34" charset="0"/>
+              </a:rPr>
+              <a:t>Nivel de riesgo: criterio del Departamento de Administración de Riesgos. Ciclo de actualización = 3,500 garantías ÷ 60 avalúos al mes.</a:t>
+            </a:r>
+          </a:p>
+        </p:txBody>
+      </p:sp>
+      <p:sp>
+        <p:nvSpPr>
+          <p:cNvPr id="32" name="Slide Number Placeholder 0"/>
+          <p:cNvSpPr>
+            <a:spLocks noGrp="1"/>
+          </p:cNvSpPr>
+          <p:nvPr>
+            <p:ph type="sldNum" sz="quarter" idx="4294967295"/>
+          </p:nvPr>
+        </p:nvSpPr>
+        <p:spPr>
+          <a:xfrm>
+            <a:off x="548640" y="6400800"/>
+            <a:ext cx="548640" cy="274320"/>
+          </a:xfrm>
+          <a:prstGeom prst="rect">
+            <a:avLst/>
+          </a:prstGeom>
+          <a:extLst>
+            <a:ext uri="{C572A759-6A51-4108-AA02-DFA0A04FC94B}">
+              <ma14:wrappingTextBoxFlag xmlns:ma14="http://schemas.microsoft.com/office/mac/drawingml/2011/main" xmlns="" val="0"/>
+            </a:ext>
+          </a:extLst>
+        </p:spPr>
+        <p:txBody>
+          <a:bodyPr/>
+          <a:lstStyle>
+            <a:lvl1pPr>
+              <a:defRPr sz="1000">
+                <a:solidFill>
+                  <a:schemeClr val="accent4"/>
+                </a:solidFill>
+              </a:defRPr>
+            </a:lvl1pPr>
+          </a:lstStyle>
+          <a:p>
+            <a:pPr algn="l"/>
+            <a:fld id="{F7021451-1387-4CA6-816F-3879F97B5CBC}" type="slidenum">
+              <a:rPr lang="es-SV" b="0" noProof="0" smtClean="0">
+                <a:latin typeface="Arial" panose="020B0604020202020204" pitchFamily="34" charset="0"/>
+                <a:cs typeface="Arial" panose="020B0604020202020204" pitchFamily="34" charset="0"/>
+              </a:rPr>
+              <a:t>4</a:t>
+            </a:fld>
+            <a:endParaRPr lang="es-SV" noProof="0" dirty="0">
+              <a:latin typeface="Arial" panose="020B0604020202020204" pitchFamily="34" charset="0"/>
+              <a:cs typeface="Arial" panose="020B0604020202020204" pitchFamily="34" charset="0"/>
+            </a:endParaRPr>
+          </a:p>
+        </p:txBody>
+      </p:sp>
+    </p:spTree>
+  </p:cSld>
+  <p:clrMapOvr>
+    <a:masterClrMapping/>
+  </p:clrMapOvr>
+</p:sld>
+</file>
+
 <file path=ppt/slides/slide2.xml><?xml version="1.0" encoding="utf-8"?>
 <p:sld xmlns:a="http://schemas.openxmlformats.org/drawingml/2006/main" xmlns:r="http://schemas.openxmlformats.org/officeDocument/2006/relationships" xmlns:p="http://schemas.openxmlformats.org/presentationml/2006/main">
   <p:cSld name="Slide 2">
@@ -12541,6 +14332,1508 @@
           </a:prstGeom>
         </p:spPr>
       </p:pic>
+    </p:spTree>
+  </p:cSld>
+  <p:clrMapOvr>
+    <a:masterClrMapping/>
+  </p:clrMapOvr>
+</p:sld>
+</file>
+
+<file path=ppt/slides/slide20.xml><?xml version="1.0" encoding="utf-8"?>
+<p:sld xmlns:a="http://schemas.openxmlformats.org/drawingml/2006/main" xmlns:r="http://schemas.openxmlformats.org/officeDocument/2006/relationships" xmlns:p="http://schemas.openxmlformats.org/presentationml/2006/main">
+  <p:cSld name="Slide 4">
+    <p:spTree>
+      <p:nvGrpSpPr>
+        <p:cNvPr id="1" name=""/>
+        <p:cNvGrpSpPr/>
+        <p:nvPr/>
+      </p:nvGrpSpPr>
+      <p:grpSpPr>
+        <a:xfrm>
+          <a:off x="0" y="0"/>
+          <a:ext cx="0" cy="0"/>
+          <a:chOff x="0" y="0"/>
+          <a:chExt cx="0" cy="0"/>
+        </a:xfrm>
+      </p:grpSpPr>
+      <p:sp>
+        <p:nvSpPr>
+          <p:cNvPr id="2" name="Text 1"/>
+          <p:cNvSpPr>
+            <a:spLocks noGrp="1"/>
+          </p:cNvSpPr>
+          <p:nvPr>
+            <p:ph type="title" idx="101" hasCustomPrompt="1"/>
+          </p:nvPr>
+        </p:nvSpPr>
+        <p:spPr>
+          <a:xfrm>
+            <a:off x="777240" y="347472"/>
+            <a:ext cx="9995034" cy="636422"/>
+          </a:xfrm>
+          <a:prstGeom prst="rect">
+            <a:avLst/>
+          </a:prstGeom>
+          <a:noFill/>
+          <a:ln/>
+        </p:spPr>
+        <p:txBody>
+          <a:bodyPr wrap="square" lIns="0" tIns="0" rIns="0" bIns="0" rtlCol="0" anchor="ctr"/>
+          <a:lstStyle/>
+          <a:p>
+            <a:pPr marL="0" indent="0" algn="l">
+              <a:buNone/>
+            </a:pPr>
+            <a:r>
+              <a:rPr lang="es-SV" sz="2400" b="1" noProof="0" dirty="0">
+                <a:solidFill>
+                  <a:schemeClr val="tx2"/>
+                </a:solidFill>
+                <a:latin typeface="Arial" panose="020B0604020202020204" pitchFamily="34" charset="0"/>
+                <a:cs typeface="Arial" panose="020B0604020202020204" pitchFamily="34" charset="0"/>
+              </a:rPr>
+              <a:t>OBSERVACIONES DE LA SSF: ÁREAS DE MAYOR EXPOSICIÓN</a:t>
+            </a:r>
+            <a:endParaRPr lang="es-SV" sz="2400" noProof="0" dirty="0">
+              <a:latin typeface="Arial" panose="020B0604020202020204" pitchFamily="34" charset="0"/>
+              <a:cs typeface="Arial" panose="020B0604020202020204" pitchFamily="34" charset="0"/>
+            </a:endParaRPr>
+          </a:p>
+        </p:txBody>
+      </p:sp>
+      <p:sp>
+        <p:nvSpPr>
+          <p:cNvPr id="101" name="Subtitulo"/>
+          <p:cNvSpPr txBox="1"/>
+          <p:nvPr/>
+        </p:nvSpPr>
+        <p:spPr>
+          <a:xfrm>
+            <a:off x="777240" y="1005840"/>
+            <a:ext cx="10515600" cy="365760"/>
+          </a:xfrm>
+          <a:prstGeom prst="rect">
+            <a:avLst/>
+          </a:prstGeom>
+          <a:noFill/>
+          <a:ln>
+            <a:noFill/>
+          </a:ln>
+        </p:spPr>
+        <p:txBody>
+          <a:bodyPr wrap="square" lIns="0" tIns="0" rIns="0" bIns="0" rtlCol="0" anchor="ctr">
+            <a:normAutofit/>
+          </a:bodyPr>
+          <a:lstStyle/>
+          <a:p>
+            <a:pPr marL="0" indent="0" algn="l">
+              <a:buNone/>
+            </a:pPr>
+            <a:r>
+              <a:rPr lang="es-SV" sz="1400" dirty="0">
+                <a:solidFill>
+                  <a:srgbClr val="005C9F"/>
+                </a:solidFill>
+                <a:latin typeface="Arial" panose="020B0604020202020204" pitchFamily="34" charset="0"/>
+                <a:cs typeface="Arial" panose="020B0604020202020204" pitchFamily="34" charset="0"/>
+              </a:rPr>
+              <a:t>Áreas en las que la SSF observa con mayor frecuencia la gestión de garantías, y cómo estamos en cada una</a:t>
+            </a:r>
+          </a:p>
+        </p:txBody>
+      </p:sp>
+      <p:sp>
+        <p:nvSpPr>
+          <p:cNvPr id="102" name="Encabezado ÁREA DE OBSERVACIÓN"/>
+          <p:cNvSpPr txBox="1"/>
+          <p:nvPr/>
+        </p:nvSpPr>
+        <p:spPr>
+          <a:xfrm>
+            <a:off x="1234440" y="1508760"/>
+            <a:ext cx="3657600" cy="292608"/>
+          </a:xfrm>
+          <a:prstGeom prst="rect">
+            <a:avLst/>
+          </a:prstGeom>
+          <a:noFill/>
+          <a:ln>
+            <a:noFill/>
+          </a:ln>
+        </p:spPr>
+        <p:txBody>
+          <a:bodyPr wrap="square" lIns="0" tIns="0" rIns="0" bIns="0" rtlCol="0" anchor="ctr">
+            <a:normAutofit/>
+          </a:bodyPr>
+          <a:lstStyle/>
+          <a:p>
+            <a:pPr marL="0" indent="0" algn="l">
+              <a:buNone/>
+            </a:pPr>
+            <a:r>
+              <a:rPr lang="es-SV" sz="1050" b="1" dirty="0">
+                <a:solidFill>
+                  <a:srgbClr val="5F7590"/>
+                </a:solidFill>
+                <a:latin typeface="Arial" panose="020B0604020202020204" pitchFamily="34" charset="0"/>
+                <a:cs typeface="Arial" panose="020B0604020202020204" pitchFamily="34" charset="0"/>
+              </a:rPr>
+              <a:t>ÁREA DE OBSERVACIÓN</a:t>
+            </a:r>
+          </a:p>
+        </p:txBody>
+      </p:sp>
+      <p:sp>
+        <p:nvSpPr>
+          <p:cNvPr id="103" name="Encabezado SITUACIÓN EN LA ENTIDAD"/>
+          <p:cNvSpPr txBox="1"/>
+          <p:nvPr/>
+        </p:nvSpPr>
+        <p:spPr>
+          <a:xfrm>
+            <a:off x="4754880" y="1508760"/>
+            <a:ext cx="3794760" cy="292608"/>
+          </a:xfrm>
+          <a:prstGeom prst="rect">
+            <a:avLst/>
+          </a:prstGeom>
+          <a:noFill/>
+          <a:ln>
+            <a:noFill/>
+          </a:ln>
+        </p:spPr>
+        <p:txBody>
+          <a:bodyPr wrap="square" lIns="0" tIns="0" rIns="0" bIns="0" rtlCol="0" anchor="ctr">
+            <a:normAutofit/>
+          </a:bodyPr>
+          <a:lstStyle/>
+          <a:p>
+            <a:pPr marL="0" indent="0" algn="l">
+              <a:buNone/>
+            </a:pPr>
+            <a:r>
+              <a:rPr lang="es-SV" sz="1050" b="1" dirty="0">
+                <a:solidFill>
+                  <a:srgbClr val="5F7590"/>
+                </a:solidFill>
+                <a:latin typeface="Arial" panose="020B0604020202020204" pitchFamily="34" charset="0"/>
+                <a:cs typeface="Arial" panose="020B0604020202020204" pitchFamily="34" charset="0"/>
+              </a:rPr>
+              <a:t>SITUACIÓN EN LA ENTIDAD</a:t>
+            </a:r>
+          </a:p>
+        </p:txBody>
+      </p:sp>
+      <p:sp>
+        <p:nvSpPr>
+          <p:cNvPr id="104" name="Encabezado SE ATIENDE CON"/>
+          <p:cNvSpPr txBox="1"/>
+          <p:nvPr/>
+        </p:nvSpPr>
+        <p:spPr>
+          <a:xfrm>
+            <a:off x="8961120" y="1508760"/>
+            <a:ext cx="2514600" cy="292608"/>
+          </a:xfrm>
+          <a:prstGeom prst="rect">
+            <a:avLst/>
+          </a:prstGeom>
+          <a:noFill/>
+          <a:ln>
+            <a:noFill/>
+          </a:ln>
+        </p:spPr>
+        <p:txBody>
+          <a:bodyPr wrap="square" lIns="0" tIns="0" rIns="0" bIns="0" rtlCol="0" anchor="ctr">
+            <a:normAutofit/>
+          </a:bodyPr>
+          <a:lstStyle/>
+          <a:p>
+            <a:pPr marL="0" indent="0" algn="l">
+              <a:buNone/>
+            </a:pPr>
+            <a:r>
+              <a:rPr lang="es-SV" sz="1050" b="1" dirty="0">
+                <a:solidFill>
+                  <a:srgbClr val="5F7590"/>
+                </a:solidFill>
+                <a:latin typeface="Arial" panose="020B0604020202020204" pitchFamily="34" charset="0"/>
+                <a:cs typeface="Arial" panose="020B0604020202020204" pitchFamily="34" charset="0"/>
+              </a:rPr>
+              <a:t>SE ATIENDE CON</a:t>
+            </a:r>
+          </a:p>
+        </p:txBody>
+      </p:sp>
+      <p:sp>
+        <p:nvSpPr>
+          <p:cNvPr id="105" name="Fila 1"/>
+          <p:cNvSpPr/>
+          <p:nvPr/>
+        </p:nvSpPr>
+        <p:spPr>
+          <a:xfrm>
+            <a:off x="548640" y="1874520"/>
+            <a:ext cx="11064240" cy="566928"/>
+          </a:xfrm>
+          <a:prstGeom prst="roundRect">
+            <a:avLst>
+              <a:gd name="adj" fmla="val 12000"/>
+            </a:avLst>
+          </a:prstGeom>
+          <a:solidFill>
+            <a:srgbClr val="EEF3F9"/>
+          </a:solidFill>
+          <a:ln w="9525">
+            <a:solidFill>
+              <a:srgbClr val="D6E2EF"/>
+            </a:solidFill>
+          </a:ln>
+        </p:spPr>
+      </p:sp>
+      <p:sp>
+        <p:nvSpPr>
+          <p:cNvPr id="106" name="Fila 1 marca"/>
+          <p:cNvSpPr/>
+          <p:nvPr/>
+        </p:nvSpPr>
+        <p:spPr>
+          <a:xfrm>
+            <a:off x="713232" y="1993392"/>
+            <a:ext cx="329184" cy="329184"/>
+          </a:xfrm>
+          <a:prstGeom prst="ellipse">
+            <a:avLst/>
+          </a:prstGeom>
+          <a:solidFill>
+            <a:srgbClr val="C62828"/>
+          </a:solidFill>
+          <a:ln>
+            <a:noFill/>
+          </a:ln>
+        </p:spPr>
+        <p:txBody>
+          <a:bodyPr wrap="square" lIns="0" tIns="0" rIns="0" bIns="0" rtlCol="0" anchor="ctr">
+            <a:normAutofit/>
+          </a:bodyPr>
+          <a:lstStyle/>
+          <a:p>
+            <a:pPr marL="0" indent="0" algn="ctr">
+              <a:buNone/>
+            </a:pPr>
+            <a:r>
+              <a:rPr lang="es-SV" sz="1200" b="1" dirty="0">
+                <a:solidFill>
+                  <a:srgbClr val="FFFFFF"/>
+                </a:solidFill>
+                <a:latin typeface="Arial" panose="020B0604020202020204" pitchFamily="34" charset="0"/>
+                <a:cs typeface="Arial" panose="020B0604020202020204" pitchFamily="34" charset="0"/>
+              </a:rPr>
+              <a:t>!</a:t>
+            </a:r>
+          </a:p>
+        </p:txBody>
+      </p:sp>
+      <p:sp>
+        <p:nvSpPr>
+          <p:cNvPr id="107" name="Fila 1 area"/>
+          <p:cNvSpPr txBox="1"/>
+          <p:nvPr/>
+        </p:nvSpPr>
+        <p:spPr>
+          <a:xfrm>
+            <a:off x="1188720" y="1874520"/>
+            <a:ext cx="3474720" cy="566928"/>
+          </a:xfrm>
+          <a:prstGeom prst="rect">
+            <a:avLst/>
+          </a:prstGeom>
+          <a:noFill/>
+          <a:ln>
+            <a:noFill/>
+          </a:ln>
+        </p:spPr>
+        <p:txBody>
+          <a:bodyPr wrap="square" lIns="0" tIns="0" rIns="0" bIns="0" rtlCol="0" anchor="ctr">
+            <a:normAutofit/>
+          </a:bodyPr>
+          <a:lstStyle/>
+          <a:p>
+            <a:pPr marL="0" indent="0" algn="l">
+              <a:buNone/>
+            </a:pPr>
+            <a:r>
+              <a:rPr lang="es-SV" sz="1150" b="1" dirty="0">
+                <a:solidFill>
+                  <a:srgbClr val="00376E"/>
+                </a:solidFill>
+                <a:latin typeface="Arial" panose="020B0604020202020204" pitchFamily="34" charset="0"/>
+                <a:cs typeface="Arial" panose="020B0604020202020204" pitchFamily="34" charset="0"/>
+              </a:rPr>
+              <a:t>Contenido mínimo del informe (NRP-27, art. 33)</a:t>
+            </a:r>
+          </a:p>
+        </p:txBody>
+      </p:sp>
+      <p:sp>
+        <p:nvSpPr>
+          <p:cNvPr id="108" name="Fila 1 situacion"/>
+          <p:cNvSpPr txBox="1"/>
+          <p:nvPr/>
+        </p:nvSpPr>
+        <p:spPr>
+          <a:xfrm>
+            <a:off x="4754880" y="1874520"/>
+            <a:ext cx="3886200" cy="566928"/>
+          </a:xfrm>
+          <a:prstGeom prst="rect">
+            <a:avLst/>
+          </a:prstGeom>
+          <a:noFill/>
+          <a:ln>
+            <a:noFill/>
+          </a:ln>
+        </p:spPr>
+        <p:txBody>
+          <a:bodyPr wrap="square" lIns="0" tIns="0" rIns="0" bIns="0" rtlCol="0" anchor="ctr">
+            <a:normAutofit/>
+          </a:bodyPr>
+          <a:lstStyle/>
+          <a:p>
+            <a:pPr marL="0" indent="0" algn="l">
+              <a:buNone/>
+            </a:pPr>
+            <a:r>
+              <a:rPr lang="es-SV" sz="1150" dirty="0">
+                <a:solidFill>
+                  <a:srgbClr val="1E2A3A"/>
+                </a:solidFill>
+                <a:latin typeface="Arial" panose="020B0604020202020204" pitchFamily="34" charset="0"/>
+                <a:cs typeface="Arial" panose="020B0604020202020204" pitchFamily="34" charset="0"/>
+              </a:rPr>
+              <a:t>Sin verificación sistemática al recibir el informe</a:t>
+            </a:r>
+          </a:p>
+        </p:txBody>
+      </p:sp>
+      <p:sp>
+        <p:nvSpPr>
+          <p:cNvPr id="109" name="Fila 1 respuesta"/>
+          <p:cNvSpPr/>
+          <p:nvPr/>
+        </p:nvSpPr>
+        <p:spPr>
+          <a:xfrm>
+            <a:off x="8823960" y="1965960"/>
+            <a:ext cx="2651760" cy="384048"/>
+          </a:xfrm>
+          <a:prstGeom prst="roundRect">
+            <a:avLst>
+              <a:gd name="adj" fmla="val 50000"/>
+            </a:avLst>
+          </a:prstGeom>
+          <a:solidFill>
+            <a:srgbClr val="00376E"/>
+          </a:solidFill>
+          <a:ln>
+            <a:noFill/>
+          </a:ln>
+        </p:spPr>
+        <p:txBody>
+          <a:bodyPr wrap="square" lIns="0" tIns="0" rIns="0" bIns="0" rtlCol="0" anchor="ctr">
+            <a:normAutofit/>
+          </a:bodyPr>
+          <a:lstStyle/>
+          <a:p>
+            <a:pPr marL="0" indent="0" algn="ctr">
+              <a:buNone/>
+            </a:pPr>
+            <a:r>
+              <a:rPr lang="es-SV" sz="1050" b="1" dirty="0">
+                <a:solidFill>
+                  <a:srgbClr val="FFFFFF"/>
+                </a:solidFill>
+                <a:latin typeface="Arial" panose="020B0604020202020204" pitchFamily="34" charset="0"/>
+                <a:cs typeface="Arial" panose="020B0604020202020204" pitchFamily="34" charset="0"/>
+              </a:rPr>
+              <a:t>Propuesta 2: Revisor</a:t>
+            </a:r>
+          </a:p>
+        </p:txBody>
+      </p:sp>
+      <p:sp>
+        <p:nvSpPr>
+          <p:cNvPr id="110" name="Fila 2"/>
+          <p:cNvSpPr/>
+          <p:nvPr/>
+        </p:nvSpPr>
+        <p:spPr>
+          <a:xfrm>
+            <a:off x="548640" y="2532888"/>
+            <a:ext cx="11064240" cy="566928"/>
+          </a:xfrm>
+          <a:prstGeom prst="roundRect">
+            <a:avLst>
+              <a:gd name="adj" fmla="val 12000"/>
+            </a:avLst>
+          </a:prstGeom>
+          <a:solidFill>
+            <a:srgbClr val="EEF3F9"/>
+          </a:solidFill>
+          <a:ln w="9525">
+            <a:solidFill>
+              <a:srgbClr val="D6E2EF"/>
+            </a:solidFill>
+          </a:ln>
+        </p:spPr>
+      </p:sp>
+      <p:sp>
+        <p:nvSpPr>
+          <p:cNvPr id="111" name="Fila 2 marca"/>
+          <p:cNvSpPr/>
+          <p:nvPr/>
+        </p:nvSpPr>
+        <p:spPr>
+          <a:xfrm>
+            <a:off x="713232" y="2651760"/>
+            <a:ext cx="329184" cy="329184"/>
+          </a:xfrm>
+          <a:prstGeom prst="ellipse">
+            <a:avLst/>
+          </a:prstGeom>
+          <a:solidFill>
+            <a:srgbClr val="C62828"/>
+          </a:solidFill>
+          <a:ln>
+            <a:noFill/>
+          </a:ln>
+        </p:spPr>
+        <p:txBody>
+          <a:bodyPr wrap="square" lIns="0" tIns="0" rIns="0" bIns="0" rtlCol="0" anchor="ctr">
+            <a:normAutofit/>
+          </a:bodyPr>
+          <a:lstStyle/>
+          <a:p>
+            <a:pPr marL="0" indent="0" algn="ctr">
+              <a:buNone/>
+            </a:pPr>
+            <a:r>
+              <a:rPr lang="es-SV" sz="1200" b="1" dirty="0">
+                <a:solidFill>
+                  <a:srgbClr val="FFFFFF"/>
+                </a:solidFill>
+                <a:latin typeface="Arial" panose="020B0604020202020204" pitchFamily="34" charset="0"/>
+                <a:cs typeface="Arial" panose="020B0604020202020204" pitchFamily="34" charset="0"/>
+              </a:rPr>
+              <a:t>!</a:t>
+            </a:r>
+          </a:p>
+        </p:txBody>
+      </p:sp>
+      <p:sp>
+        <p:nvSpPr>
+          <p:cNvPr id="112" name="Fila 2 area"/>
+          <p:cNvSpPr txBox="1"/>
+          <p:nvPr/>
+        </p:nvSpPr>
+        <p:spPr>
+          <a:xfrm>
+            <a:off x="1188720" y="2532888"/>
+            <a:ext cx="3474720" cy="566928"/>
+          </a:xfrm>
+          <a:prstGeom prst="rect">
+            <a:avLst/>
+          </a:prstGeom>
+          <a:noFill/>
+          <a:ln>
+            <a:noFill/>
+          </a:ln>
+        </p:spPr>
+        <p:txBody>
+          <a:bodyPr wrap="square" lIns="0" tIns="0" rIns="0" bIns="0" rtlCol="0" anchor="ctr">
+            <a:normAutofit/>
+          </a:bodyPr>
+          <a:lstStyle/>
+          <a:p>
+            <a:pPr marL="0" indent="0" algn="l">
+              <a:buNone/>
+            </a:pPr>
+            <a:r>
+              <a:rPr lang="es-SV" sz="1150" b="1" dirty="0">
+                <a:solidFill>
+                  <a:srgbClr val="00376E"/>
+                </a:solidFill>
+                <a:latin typeface="Arial" panose="020B0604020202020204" pitchFamily="34" charset="0"/>
+                <a:cs typeface="Arial" panose="020B0604020202020204" pitchFamily="34" charset="0"/>
+              </a:rPr>
+              <a:t>Evidencia de revisión y observaciones al perito (art. 40)</a:t>
+            </a:r>
+          </a:p>
+        </p:txBody>
+      </p:sp>
+      <p:sp>
+        <p:nvSpPr>
+          <p:cNvPr id="113" name="Fila 2 situacion"/>
+          <p:cNvSpPr txBox="1"/>
+          <p:nvPr/>
+        </p:nvSpPr>
+        <p:spPr>
+          <a:xfrm>
+            <a:off x="4754880" y="2532888"/>
+            <a:ext cx="3886200" cy="566928"/>
+          </a:xfrm>
+          <a:prstGeom prst="rect">
+            <a:avLst/>
+          </a:prstGeom>
+          <a:noFill/>
+          <a:ln>
+            <a:noFill/>
+          </a:ln>
+        </p:spPr>
+        <p:txBody>
+          <a:bodyPr wrap="square" lIns="0" tIns="0" rIns="0" bIns="0" rtlCol="0" anchor="ctr">
+            <a:normAutofit/>
+          </a:bodyPr>
+          <a:lstStyle/>
+          <a:p>
+            <a:pPr marL="0" indent="0" algn="l">
+              <a:buNone/>
+            </a:pPr>
+            <a:r>
+              <a:rPr lang="es-SV" sz="1150" dirty="0">
+                <a:solidFill>
+                  <a:srgbClr val="1E2A3A"/>
+                </a:solidFill>
+                <a:latin typeface="Arial" panose="020B0604020202020204" pitchFamily="34" charset="0"/>
+                <a:cs typeface="Arial" panose="020B0604020202020204" pitchFamily="34" charset="0"/>
+              </a:rPr>
+              <a:t>No existe Revisor ni registro de observaciones y subsanaciones</a:t>
+            </a:r>
+          </a:p>
+        </p:txBody>
+      </p:sp>
+      <p:sp>
+        <p:nvSpPr>
+          <p:cNvPr id="114" name="Fila 2 respuesta"/>
+          <p:cNvSpPr/>
+          <p:nvPr/>
+        </p:nvSpPr>
+        <p:spPr>
+          <a:xfrm>
+            <a:off x="8823960" y="2624328"/>
+            <a:ext cx="2651760" cy="384048"/>
+          </a:xfrm>
+          <a:prstGeom prst="roundRect">
+            <a:avLst>
+              <a:gd name="adj" fmla="val 50000"/>
+            </a:avLst>
+          </a:prstGeom>
+          <a:solidFill>
+            <a:srgbClr val="00376E"/>
+          </a:solidFill>
+          <a:ln>
+            <a:noFill/>
+          </a:ln>
+        </p:spPr>
+        <p:txBody>
+          <a:bodyPr wrap="square" lIns="0" tIns="0" rIns="0" bIns="0" rtlCol="0" anchor="ctr">
+            <a:normAutofit/>
+          </a:bodyPr>
+          <a:lstStyle/>
+          <a:p>
+            <a:pPr marL="0" indent="0" algn="ctr">
+              <a:buNone/>
+            </a:pPr>
+            <a:r>
+              <a:rPr lang="es-SV" sz="1050" b="1" dirty="0">
+                <a:solidFill>
+                  <a:srgbClr val="FFFFFF"/>
+                </a:solidFill>
+                <a:latin typeface="Arial" panose="020B0604020202020204" pitchFamily="34" charset="0"/>
+                <a:cs typeface="Arial" panose="020B0604020202020204" pitchFamily="34" charset="0"/>
+              </a:rPr>
+              <a:t>Propuesta 2: Revisor</a:t>
+            </a:r>
+          </a:p>
+        </p:txBody>
+      </p:sp>
+      <p:sp>
+        <p:nvSpPr>
+          <p:cNvPr id="115" name="Fila 3"/>
+          <p:cNvSpPr/>
+          <p:nvPr/>
+        </p:nvSpPr>
+        <p:spPr>
+          <a:xfrm>
+            <a:off x="548640" y="3191256"/>
+            <a:ext cx="11064240" cy="566928"/>
+          </a:xfrm>
+          <a:prstGeom prst="roundRect">
+            <a:avLst>
+              <a:gd name="adj" fmla="val 12000"/>
+            </a:avLst>
+          </a:prstGeom>
+          <a:solidFill>
+            <a:srgbClr val="EEF3F9"/>
+          </a:solidFill>
+          <a:ln w="9525">
+            <a:solidFill>
+              <a:srgbClr val="D6E2EF"/>
+            </a:solidFill>
+          </a:ln>
+        </p:spPr>
+      </p:sp>
+      <p:sp>
+        <p:nvSpPr>
+          <p:cNvPr id="116" name="Fila 3 marca"/>
+          <p:cNvSpPr/>
+          <p:nvPr/>
+        </p:nvSpPr>
+        <p:spPr>
+          <a:xfrm>
+            <a:off x="713232" y="3310128"/>
+            <a:ext cx="329184" cy="329184"/>
+          </a:xfrm>
+          <a:prstGeom prst="ellipse">
+            <a:avLst/>
+          </a:prstGeom>
+          <a:solidFill>
+            <a:srgbClr val="C62828"/>
+          </a:solidFill>
+          <a:ln>
+            <a:noFill/>
+          </a:ln>
+        </p:spPr>
+        <p:txBody>
+          <a:bodyPr wrap="square" lIns="0" tIns="0" rIns="0" bIns="0" rtlCol="0" anchor="ctr">
+            <a:normAutofit/>
+          </a:bodyPr>
+          <a:lstStyle/>
+          <a:p>
+            <a:pPr marL="0" indent="0" algn="ctr">
+              <a:buNone/>
+            </a:pPr>
+            <a:r>
+              <a:rPr lang="es-SV" sz="1200" b="1" dirty="0">
+                <a:solidFill>
+                  <a:srgbClr val="FFFFFF"/>
+                </a:solidFill>
+                <a:latin typeface="Arial" panose="020B0604020202020204" pitchFamily="34" charset="0"/>
+                <a:cs typeface="Arial" panose="020B0604020202020204" pitchFamily="34" charset="0"/>
+              </a:rPr>
+              <a:t>!</a:t>
+            </a:r>
+          </a:p>
+        </p:txBody>
+      </p:sp>
+      <p:sp>
+        <p:nvSpPr>
+          <p:cNvPr id="117" name="Fila 3 area"/>
+          <p:cNvSpPr txBox="1"/>
+          <p:nvPr/>
+        </p:nvSpPr>
+        <p:spPr>
+          <a:xfrm>
+            <a:off x="1188720" y="3191256"/>
+            <a:ext cx="3474720" cy="566928"/>
+          </a:xfrm>
+          <a:prstGeom prst="rect">
+            <a:avLst/>
+          </a:prstGeom>
+          <a:noFill/>
+          <a:ln>
+            <a:noFill/>
+          </a:ln>
+        </p:spPr>
+        <p:txBody>
+          <a:bodyPr wrap="square" lIns="0" tIns="0" rIns="0" bIns="0" rtlCol="0" anchor="ctr">
+            <a:normAutofit/>
+          </a:bodyPr>
+          <a:lstStyle/>
+          <a:p>
+            <a:pPr marL="0" indent="0" algn="l">
+              <a:buNone/>
+            </a:pPr>
+            <a:r>
+              <a:rPr lang="es-SV" sz="1150" b="1" dirty="0">
+                <a:solidFill>
+                  <a:srgbClr val="00376E"/>
+                </a:solidFill>
+                <a:latin typeface="Arial" panose="020B0604020202020204" pitchFamily="34" charset="0"/>
+                <a:cs typeface="Arial" panose="020B0604020202020204" pitchFamily="34" charset="0"/>
+              </a:rPr>
+              <a:t>Valor de garantía usado en reservas (NCB-022)</a:t>
+            </a:r>
+          </a:p>
+        </p:txBody>
+      </p:sp>
+      <p:sp>
+        <p:nvSpPr>
+          <p:cNvPr id="118" name="Fila 3 situacion"/>
+          <p:cNvSpPr txBox="1"/>
+          <p:nvPr/>
+        </p:nvSpPr>
+        <p:spPr>
+          <a:xfrm>
+            <a:off x="4754880" y="3191256"/>
+            <a:ext cx="3886200" cy="566928"/>
+          </a:xfrm>
+          <a:prstGeom prst="rect">
+            <a:avLst/>
+          </a:prstGeom>
+          <a:noFill/>
+          <a:ln>
+            <a:noFill/>
+          </a:ln>
+        </p:spPr>
+        <p:txBody>
+          <a:bodyPr wrap="square" lIns="0" tIns="0" rIns="0" bIns="0" rtlCol="0" anchor="ctr">
+            <a:normAutofit/>
+          </a:bodyPr>
+          <a:lstStyle/>
+          <a:p>
+            <a:pPr marL="0" indent="0" algn="l">
+              <a:buNone/>
+            </a:pPr>
+            <a:r>
+              <a:rPr lang="es-SV" sz="1150" dirty="0">
+                <a:solidFill>
+                  <a:srgbClr val="1E2A3A"/>
+                </a:solidFill>
+                <a:latin typeface="Arial" panose="020B0604020202020204" pitchFamily="34" charset="0"/>
+                <a:cs typeface="Arial" panose="020B0604020202020204" pitchFamily="34" charset="0"/>
+              </a:rPr>
+              <a:t>Ciclo de actualización cercano a 5 años para la cartera</a:t>
+            </a:r>
+          </a:p>
+        </p:txBody>
+      </p:sp>
+      <p:sp>
+        <p:nvSpPr>
+          <p:cNvPr id="119" name="Fila 3 respuesta"/>
+          <p:cNvSpPr/>
+          <p:nvPr/>
+        </p:nvSpPr>
+        <p:spPr>
+          <a:xfrm>
+            <a:off x="8823960" y="3282696"/>
+            <a:ext cx="2651760" cy="384048"/>
+          </a:xfrm>
+          <a:prstGeom prst="roundRect">
+            <a:avLst>
+              <a:gd name="adj" fmla="val 50000"/>
+            </a:avLst>
+          </a:prstGeom>
+          <a:solidFill>
+            <a:srgbClr val="00376E"/>
+          </a:solidFill>
+          <a:ln>
+            <a:noFill/>
+          </a:ln>
+        </p:spPr>
+        <p:txBody>
+          <a:bodyPr wrap="square" lIns="0" tIns="0" rIns="0" bIns="0" rtlCol="0" anchor="ctr">
+            <a:normAutofit/>
+          </a:bodyPr>
+          <a:lstStyle/>
+          <a:p>
+            <a:pPr marL="0" indent="0" algn="ctr">
+              <a:buNone/>
+            </a:pPr>
+            <a:r>
+              <a:rPr lang="es-SV" sz="1050" b="1" dirty="0">
+                <a:solidFill>
+                  <a:srgbClr val="FFFFFF"/>
+                </a:solidFill>
+                <a:latin typeface="Arial" panose="020B0604020202020204" pitchFamily="34" charset="0"/>
+                <a:cs typeface="Arial" panose="020B0604020202020204" pitchFamily="34" charset="0"/>
+              </a:rPr>
+              <a:t>Propuesta 1: Política</a:t>
+            </a:r>
+          </a:p>
+        </p:txBody>
+      </p:sp>
+      <p:sp>
+        <p:nvSpPr>
+          <p:cNvPr id="120" name="Fila 4"/>
+          <p:cNvSpPr/>
+          <p:nvPr/>
+        </p:nvSpPr>
+        <p:spPr>
+          <a:xfrm>
+            <a:off x="548640" y="3849624"/>
+            <a:ext cx="11064240" cy="566928"/>
+          </a:xfrm>
+          <a:prstGeom prst="roundRect">
+            <a:avLst>
+              <a:gd name="adj" fmla="val 12000"/>
+            </a:avLst>
+          </a:prstGeom>
+          <a:solidFill>
+            <a:srgbClr val="EEF3F9"/>
+          </a:solidFill>
+          <a:ln w="9525">
+            <a:solidFill>
+              <a:srgbClr val="D6E2EF"/>
+            </a:solidFill>
+          </a:ln>
+        </p:spPr>
+      </p:sp>
+      <p:sp>
+        <p:nvSpPr>
+          <p:cNvPr id="121" name="Fila 4 marca"/>
+          <p:cNvSpPr/>
+          <p:nvPr/>
+        </p:nvSpPr>
+        <p:spPr>
+          <a:xfrm>
+            <a:off x="713232" y="3968496"/>
+            <a:ext cx="329184" cy="329184"/>
+          </a:xfrm>
+          <a:prstGeom prst="ellipse">
+            <a:avLst/>
+          </a:prstGeom>
+          <a:solidFill>
+            <a:srgbClr val="C62828"/>
+          </a:solidFill>
+          <a:ln>
+            <a:noFill/>
+          </a:ln>
+        </p:spPr>
+        <p:txBody>
+          <a:bodyPr wrap="square" lIns="0" tIns="0" rIns="0" bIns="0" rtlCol="0" anchor="ctr">
+            <a:normAutofit/>
+          </a:bodyPr>
+          <a:lstStyle/>
+          <a:p>
+            <a:pPr marL="0" indent="0" algn="ctr">
+              <a:buNone/>
+            </a:pPr>
+            <a:r>
+              <a:rPr lang="es-SV" sz="1200" b="1" dirty="0">
+                <a:solidFill>
+                  <a:srgbClr val="FFFFFF"/>
+                </a:solidFill>
+                <a:latin typeface="Arial" panose="020B0604020202020204" pitchFamily="34" charset="0"/>
+                <a:cs typeface="Arial" panose="020B0604020202020204" pitchFamily="34" charset="0"/>
+              </a:rPr>
+              <a:t>!</a:t>
+            </a:r>
+          </a:p>
+        </p:txBody>
+      </p:sp>
+      <p:sp>
+        <p:nvSpPr>
+          <p:cNvPr id="122" name="Fila 4 area"/>
+          <p:cNvSpPr txBox="1"/>
+          <p:nvPr/>
+        </p:nvSpPr>
+        <p:spPr>
+          <a:xfrm>
+            <a:off x="1188720" y="3849624"/>
+            <a:ext cx="3474720" cy="566928"/>
+          </a:xfrm>
+          <a:prstGeom prst="rect">
+            <a:avLst/>
+          </a:prstGeom>
+          <a:noFill/>
+          <a:ln>
+            <a:noFill/>
+          </a:ln>
+        </p:spPr>
+        <p:txBody>
+          <a:bodyPr wrap="square" lIns="0" tIns="0" rIns="0" bIns="0" rtlCol="0" anchor="ctr">
+            <a:normAutofit/>
+          </a:bodyPr>
+          <a:lstStyle/>
+          <a:p>
+            <a:pPr marL="0" indent="0" algn="l">
+              <a:buNone/>
+            </a:pPr>
+            <a:r>
+              <a:rPr lang="es-SV" sz="1150" b="1" dirty="0">
+                <a:solidFill>
+                  <a:srgbClr val="00376E"/>
+                </a:solidFill>
+                <a:latin typeface="Arial" panose="020B0604020202020204" pitchFamily="34" charset="0"/>
+                <a:cs typeface="Arial" panose="020B0604020202020204" pitchFamily="34" charset="0"/>
+              </a:rPr>
+              <a:t>Integridad del dato en el Módulo de Garantías</a:t>
+            </a:r>
+          </a:p>
+        </p:txBody>
+      </p:sp>
+      <p:sp>
+        <p:nvSpPr>
+          <p:cNvPr id="123" name="Fila 4 situacion"/>
+          <p:cNvSpPr txBox="1"/>
+          <p:nvPr/>
+        </p:nvSpPr>
+        <p:spPr>
+          <a:xfrm>
+            <a:off x="4754880" y="3849624"/>
+            <a:ext cx="3886200" cy="566928"/>
+          </a:xfrm>
+          <a:prstGeom prst="rect">
+            <a:avLst/>
+          </a:prstGeom>
+          <a:noFill/>
+          <a:ln>
+            <a:noFill/>
+          </a:ln>
+        </p:spPr>
+        <p:txBody>
+          <a:bodyPr wrap="square" lIns="0" tIns="0" rIns="0" bIns="0" rtlCol="0" anchor="ctr">
+            <a:normAutofit/>
+          </a:bodyPr>
+          <a:lstStyle/>
+          <a:p>
+            <a:pPr marL="0" indent="0" algn="l">
+              <a:buNone/>
+            </a:pPr>
+            <a:r>
+              <a:rPr lang="es-SV" sz="1150" dirty="0">
+                <a:solidFill>
+                  <a:srgbClr val="1E2A3A"/>
+                </a:solidFill>
+                <a:latin typeface="Arial" panose="020B0604020202020204" pitchFamily="34" charset="0"/>
+                <a:cs typeface="Arial" panose="020B0604020202020204" pitchFamily="34" charset="0"/>
+              </a:rPr>
+              <a:t>Captura y modificación por varias áreas, verificación posterior</a:t>
+            </a:r>
+          </a:p>
+        </p:txBody>
+      </p:sp>
+      <p:sp>
+        <p:nvSpPr>
+          <p:cNvPr id="124" name="Fila 4 respuesta"/>
+          <p:cNvSpPr/>
+          <p:nvPr/>
+        </p:nvSpPr>
+        <p:spPr>
+          <a:xfrm>
+            <a:off x="8823960" y="3941064"/>
+            <a:ext cx="2651760" cy="384048"/>
+          </a:xfrm>
+          <a:prstGeom prst="roundRect">
+            <a:avLst>
+              <a:gd name="adj" fmla="val 50000"/>
+            </a:avLst>
+          </a:prstGeom>
+          <a:solidFill>
+            <a:srgbClr val="00376E"/>
+          </a:solidFill>
+          <a:ln>
+            <a:noFill/>
+          </a:ln>
+        </p:spPr>
+        <p:txBody>
+          <a:bodyPr wrap="square" lIns="0" tIns="0" rIns="0" bIns="0" rtlCol="0" anchor="ctr">
+            <a:normAutofit/>
+          </a:bodyPr>
+          <a:lstStyle/>
+          <a:p>
+            <a:pPr marL="0" indent="0" algn="ctr">
+              <a:buNone/>
+            </a:pPr>
+            <a:r>
+              <a:rPr lang="es-SV" sz="1050" b="1" dirty="0">
+                <a:solidFill>
+                  <a:srgbClr val="FFFFFF"/>
+                </a:solidFill>
+                <a:latin typeface="Arial" panose="020B0604020202020204" pitchFamily="34" charset="0"/>
+                <a:cs typeface="Arial" panose="020B0604020202020204" pitchFamily="34" charset="0"/>
+              </a:rPr>
+              <a:t>Propuesta 3: Depto. de Riesgo</a:t>
+            </a:r>
+          </a:p>
+        </p:txBody>
+      </p:sp>
+      <p:sp>
+        <p:nvSpPr>
+          <p:cNvPr id="125" name="Fila 5"/>
+          <p:cNvSpPr/>
+          <p:nvPr/>
+        </p:nvSpPr>
+        <p:spPr>
+          <a:xfrm>
+            <a:off x="548640" y="4507992"/>
+            <a:ext cx="11064240" cy="566928"/>
+          </a:xfrm>
+          <a:prstGeom prst="roundRect">
+            <a:avLst>
+              <a:gd name="adj" fmla="val 12000"/>
+            </a:avLst>
+          </a:prstGeom>
+          <a:solidFill>
+            <a:srgbClr val="EEF3F9"/>
+          </a:solidFill>
+          <a:ln w="9525">
+            <a:solidFill>
+              <a:srgbClr val="D6E2EF"/>
+            </a:solidFill>
+          </a:ln>
+        </p:spPr>
+      </p:sp>
+      <p:sp>
+        <p:nvSpPr>
+          <p:cNvPr id="126" name="Fila 5 marca"/>
+          <p:cNvSpPr/>
+          <p:nvPr/>
+        </p:nvSpPr>
+        <p:spPr>
+          <a:xfrm>
+            <a:off x="713232" y="4626864"/>
+            <a:ext cx="329184" cy="329184"/>
+          </a:xfrm>
+          <a:prstGeom prst="ellipse">
+            <a:avLst/>
+          </a:prstGeom>
+          <a:solidFill>
+            <a:srgbClr val="C62828"/>
+          </a:solidFill>
+          <a:ln>
+            <a:noFill/>
+          </a:ln>
+        </p:spPr>
+        <p:txBody>
+          <a:bodyPr wrap="square" lIns="0" tIns="0" rIns="0" bIns="0" rtlCol="0" anchor="ctr">
+            <a:normAutofit/>
+          </a:bodyPr>
+          <a:lstStyle/>
+          <a:p>
+            <a:pPr marL="0" indent="0" algn="ctr">
+              <a:buNone/>
+            </a:pPr>
+            <a:r>
+              <a:rPr lang="es-SV" sz="1200" b="1" dirty="0">
+                <a:solidFill>
+                  <a:srgbClr val="FFFFFF"/>
+                </a:solidFill>
+                <a:latin typeface="Arial" panose="020B0604020202020204" pitchFamily="34" charset="0"/>
+                <a:cs typeface="Arial" panose="020B0604020202020204" pitchFamily="34" charset="0"/>
+              </a:rPr>
+              <a:t>!</a:t>
+            </a:r>
+          </a:p>
+        </p:txBody>
+      </p:sp>
+      <p:sp>
+        <p:nvSpPr>
+          <p:cNvPr id="127" name="Fila 5 area"/>
+          <p:cNvSpPr txBox="1"/>
+          <p:nvPr/>
+        </p:nvSpPr>
+        <p:spPr>
+          <a:xfrm>
+            <a:off x="1188720" y="4507992"/>
+            <a:ext cx="3474720" cy="566928"/>
+          </a:xfrm>
+          <a:prstGeom prst="rect">
+            <a:avLst/>
+          </a:prstGeom>
+          <a:noFill/>
+          <a:ln>
+            <a:noFill/>
+          </a:ln>
+        </p:spPr>
+        <p:txBody>
+          <a:bodyPr wrap="square" lIns="0" tIns="0" rIns="0" bIns="0" rtlCol="0" anchor="ctr">
+            <a:normAutofit/>
+          </a:bodyPr>
+          <a:lstStyle/>
+          <a:p>
+            <a:pPr marL="0" indent="0" algn="l">
+              <a:buNone/>
+            </a:pPr>
+            <a:r>
+              <a:rPr lang="es-SV" sz="1150" b="1" dirty="0">
+                <a:solidFill>
+                  <a:srgbClr val="00376E"/>
+                </a:solidFill>
+                <a:latin typeface="Arial" panose="020B0604020202020204" pitchFamily="34" charset="0"/>
+                <a:cs typeface="Arial" panose="020B0604020202020204" pitchFamily="34" charset="0"/>
+              </a:rPr>
+              <a:t>Independencia y gestión de peritos</a:t>
+            </a:r>
+          </a:p>
+        </p:txBody>
+      </p:sp>
+      <p:sp>
+        <p:nvSpPr>
+          <p:cNvPr id="128" name="Fila 5 situacion"/>
+          <p:cNvSpPr txBox="1"/>
+          <p:nvPr/>
+        </p:nvSpPr>
+        <p:spPr>
+          <a:xfrm>
+            <a:off x="4754880" y="4507992"/>
+            <a:ext cx="3886200" cy="566928"/>
+          </a:xfrm>
+          <a:prstGeom prst="rect">
+            <a:avLst/>
+          </a:prstGeom>
+          <a:noFill/>
+          <a:ln>
+            <a:noFill/>
+          </a:ln>
+        </p:spPr>
+        <p:txBody>
+          <a:bodyPr wrap="square" lIns="0" tIns="0" rIns="0" bIns="0" rtlCol="0" anchor="ctr">
+            <a:normAutofit/>
+          </a:bodyPr>
+          <a:lstStyle/>
+          <a:p>
+            <a:pPr marL="0" indent="0" algn="l">
+              <a:buNone/>
+            </a:pPr>
+            <a:r>
+              <a:rPr lang="es-SV" sz="1150" dirty="0">
+                <a:solidFill>
+                  <a:srgbClr val="1E2A3A"/>
+                </a:solidFill>
+                <a:latin typeface="Arial" panose="020B0604020202020204" pitchFamily="34" charset="0"/>
+                <a:cs typeface="Arial" panose="020B0604020202020204" pitchFamily="34" charset="0"/>
+              </a:rPr>
+              <a:t>Contratación dispersa en varias áreas, sin calificación de desempeño</a:t>
+            </a:r>
+          </a:p>
+        </p:txBody>
+      </p:sp>
+      <p:sp>
+        <p:nvSpPr>
+          <p:cNvPr id="129" name="Fila 5 respuesta"/>
+          <p:cNvSpPr/>
+          <p:nvPr/>
+        </p:nvSpPr>
+        <p:spPr>
+          <a:xfrm>
+            <a:off x="8823960" y="4599432"/>
+            <a:ext cx="2651760" cy="384048"/>
+          </a:xfrm>
+          <a:prstGeom prst="roundRect">
+            <a:avLst>
+              <a:gd name="adj" fmla="val 50000"/>
+            </a:avLst>
+          </a:prstGeom>
+          <a:solidFill>
+            <a:srgbClr val="00376E"/>
+          </a:solidFill>
+          <a:ln>
+            <a:noFill/>
+          </a:ln>
+        </p:spPr>
+        <p:txBody>
+          <a:bodyPr wrap="square" lIns="0" tIns="0" rIns="0" bIns="0" rtlCol="0" anchor="ctr">
+            <a:normAutofit/>
+          </a:bodyPr>
+          <a:lstStyle/>
+          <a:p>
+            <a:pPr marL="0" indent="0" algn="ctr">
+              <a:buNone/>
+            </a:pPr>
+            <a:r>
+              <a:rPr lang="es-SV" sz="1050" b="1" dirty="0">
+                <a:solidFill>
+                  <a:srgbClr val="FFFFFF"/>
+                </a:solidFill>
+                <a:latin typeface="Arial" panose="020B0604020202020204" pitchFamily="34" charset="0"/>
+                <a:cs typeface="Arial" panose="020B0604020202020204" pitchFamily="34" charset="0"/>
+              </a:rPr>
+              <a:t>Propuestas 1 y 3</a:t>
+            </a:r>
+          </a:p>
+        </p:txBody>
+      </p:sp>
+      <p:sp>
+        <p:nvSpPr>
+          <p:cNvPr id="130" name="Fila 6"/>
+          <p:cNvSpPr/>
+          <p:nvPr/>
+        </p:nvSpPr>
+        <p:spPr>
+          <a:xfrm>
+            <a:off x="548640" y="5166360"/>
+            <a:ext cx="11064240" cy="566928"/>
+          </a:xfrm>
+          <a:prstGeom prst="roundRect">
+            <a:avLst>
+              <a:gd name="adj" fmla="val 12000"/>
+            </a:avLst>
+          </a:prstGeom>
+          <a:solidFill>
+            <a:srgbClr val="EEF3F9"/>
+          </a:solidFill>
+          <a:ln w="9525">
+            <a:solidFill>
+              <a:srgbClr val="D6E2EF"/>
+            </a:solidFill>
+          </a:ln>
+        </p:spPr>
+      </p:sp>
+      <p:sp>
+        <p:nvSpPr>
+          <p:cNvPr id="131" name="Fila 6 marca"/>
+          <p:cNvSpPr/>
+          <p:nvPr/>
+        </p:nvSpPr>
+        <p:spPr>
+          <a:xfrm>
+            <a:off x="713232" y="5285232"/>
+            <a:ext cx="329184" cy="329184"/>
+          </a:xfrm>
+          <a:prstGeom prst="ellipse">
+            <a:avLst/>
+          </a:prstGeom>
+          <a:solidFill>
+            <a:srgbClr val="C62828"/>
+          </a:solidFill>
+          <a:ln>
+            <a:noFill/>
+          </a:ln>
+        </p:spPr>
+        <p:txBody>
+          <a:bodyPr wrap="square" lIns="0" tIns="0" rIns="0" bIns="0" rtlCol="0" anchor="ctr">
+            <a:normAutofit/>
+          </a:bodyPr>
+          <a:lstStyle/>
+          <a:p>
+            <a:pPr marL="0" indent="0" algn="ctr">
+              <a:buNone/>
+            </a:pPr>
+            <a:r>
+              <a:rPr lang="es-SV" sz="1200" b="1" dirty="0">
+                <a:solidFill>
+                  <a:srgbClr val="FFFFFF"/>
+                </a:solidFill>
+                <a:latin typeface="Arial" panose="020B0604020202020204" pitchFamily="34" charset="0"/>
+                <a:cs typeface="Arial" panose="020B0604020202020204" pitchFamily="34" charset="0"/>
+              </a:rPr>
+              <a:t>!</a:t>
+            </a:r>
+          </a:p>
+        </p:txBody>
+      </p:sp>
+      <p:sp>
+        <p:nvSpPr>
+          <p:cNvPr id="132" name="Fila 6 area"/>
+          <p:cNvSpPr txBox="1"/>
+          <p:nvPr/>
+        </p:nvSpPr>
+        <p:spPr>
+          <a:xfrm>
+            <a:off x="1188720" y="5166360"/>
+            <a:ext cx="3474720" cy="566928"/>
+          </a:xfrm>
+          <a:prstGeom prst="rect">
+            <a:avLst/>
+          </a:prstGeom>
+          <a:noFill/>
+          <a:ln>
+            <a:noFill/>
+          </a:ln>
+        </p:spPr>
+        <p:txBody>
+          <a:bodyPr wrap="square" lIns="0" tIns="0" rIns="0" bIns="0" rtlCol="0" anchor="ctr">
+            <a:normAutofit/>
+          </a:bodyPr>
+          <a:lstStyle/>
+          <a:p>
+            <a:pPr marL="0" indent="0" algn="l">
+              <a:buNone/>
+            </a:pPr>
+            <a:r>
+              <a:rPr lang="es-SV" sz="1150" b="1" dirty="0">
+                <a:solidFill>
+                  <a:srgbClr val="00376E"/>
+                </a:solidFill>
+                <a:latin typeface="Arial" panose="020B0604020202020204" pitchFamily="34" charset="0"/>
+                <a:cs typeface="Arial" panose="020B0604020202020204" pitchFamily="34" charset="0"/>
+              </a:rPr>
+              <a:t>Políticas y procedimientos aprobados</a:t>
+            </a:r>
+          </a:p>
+        </p:txBody>
+      </p:sp>
+      <p:sp>
+        <p:nvSpPr>
+          <p:cNvPr id="133" name="Fila 6 situacion"/>
+          <p:cNvSpPr txBox="1"/>
+          <p:nvPr/>
+        </p:nvSpPr>
+        <p:spPr>
+          <a:xfrm>
+            <a:off x="4754880" y="5166360"/>
+            <a:ext cx="3886200" cy="566928"/>
+          </a:xfrm>
+          <a:prstGeom prst="rect">
+            <a:avLst/>
+          </a:prstGeom>
+          <a:noFill/>
+          <a:ln>
+            <a:noFill/>
+          </a:ln>
+        </p:spPr>
+        <p:txBody>
+          <a:bodyPr wrap="square" lIns="0" tIns="0" rIns="0" bIns="0" rtlCol="0" anchor="ctr">
+            <a:normAutofit/>
+          </a:bodyPr>
+          <a:lstStyle/>
+          <a:p>
+            <a:pPr marL="0" indent="0" algn="l">
+              <a:buNone/>
+            </a:pPr>
+            <a:r>
+              <a:rPr lang="es-SV" sz="1150" dirty="0">
+                <a:solidFill>
+                  <a:srgbClr val="1E2A3A"/>
+                </a:solidFill>
+                <a:latin typeface="Arial" panose="020B0604020202020204" pitchFamily="34" charset="0"/>
+                <a:cs typeface="Arial" panose="020B0604020202020204" pitchFamily="34" charset="0"/>
+              </a:rPr>
+              <a:t>No existen lineamientos internos de cumplimiento</a:t>
+            </a:r>
+          </a:p>
+        </p:txBody>
+      </p:sp>
+      <p:sp>
+        <p:nvSpPr>
+          <p:cNvPr id="134" name="Fila 6 respuesta"/>
+          <p:cNvSpPr/>
+          <p:nvPr/>
+        </p:nvSpPr>
+        <p:spPr>
+          <a:xfrm>
+            <a:off x="8823960" y="5257800"/>
+            <a:ext cx="2651760" cy="384048"/>
+          </a:xfrm>
+          <a:prstGeom prst="roundRect">
+            <a:avLst>
+              <a:gd name="adj" fmla="val 50000"/>
+            </a:avLst>
+          </a:prstGeom>
+          <a:solidFill>
+            <a:srgbClr val="00376E"/>
+          </a:solidFill>
+          <a:ln>
+            <a:noFill/>
+          </a:ln>
+        </p:spPr>
+        <p:txBody>
+          <a:bodyPr wrap="square" lIns="0" tIns="0" rIns="0" bIns="0" rtlCol="0" anchor="ctr">
+            <a:normAutofit/>
+          </a:bodyPr>
+          <a:lstStyle/>
+          <a:p>
+            <a:pPr marL="0" indent="0" algn="ctr">
+              <a:buNone/>
+            </a:pPr>
+            <a:r>
+              <a:rPr lang="es-SV" sz="1050" b="1" dirty="0">
+                <a:solidFill>
+                  <a:srgbClr val="FFFFFF"/>
+                </a:solidFill>
+                <a:latin typeface="Arial" panose="020B0604020202020204" pitchFamily="34" charset="0"/>
+                <a:cs typeface="Arial" panose="020B0604020202020204" pitchFamily="34" charset="0"/>
+              </a:rPr>
+              <a:t>Propuesta 1: Política</a:t>
+            </a:r>
+          </a:p>
+        </p:txBody>
+      </p:sp>
+      <p:sp>
+        <p:nvSpPr>
+          <p:cNvPr id="135" name="Nota"/>
+          <p:cNvSpPr txBox="1"/>
+          <p:nvPr/>
+        </p:nvSpPr>
+        <p:spPr>
+          <a:xfrm>
+            <a:off x="548640" y="5897880"/>
+            <a:ext cx="9875520" cy="365760"/>
+          </a:xfrm>
+          <a:prstGeom prst="rect">
+            <a:avLst/>
+          </a:prstGeom>
+          <a:noFill/>
+          <a:ln>
+            <a:noFill/>
+          </a:ln>
+        </p:spPr>
+        <p:txBody>
+          <a:bodyPr wrap="square" lIns="0" tIns="0" rIns="0" bIns="0" rtlCol="0" anchor="ctr">
+            <a:normAutofit/>
+          </a:bodyPr>
+          <a:lstStyle/>
+          <a:p>
+            <a:pPr marL="0" indent="0" algn="l">
+              <a:buNone/>
+            </a:pPr>
+            <a:r>
+              <a:rPr lang="es-SV" sz="950" i="1" dirty="0">
+                <a:solidFill>
+                  <a:srgbClr val="5F7590"/>
+                </a:solidFill>
+                <a:latin typeface="Arial" panose="020B0604020202020204" pitchFamily="34" charset="0"/>
+                <a:cs typeface="Arial" panose="020B0604020202020204" pitchFamily="34" charset="0"/>
+              </a:rPr>
+              <a:t>Áreas de mayor exposición según la práctica supervisora. Validar y completar con el detalle de las observaciones formales recibidas de la SSF.</a:t>
+            </a:r>
+          </a:p>
+        </p:txBody>
+      </p:sp>
+      <p:sp>
+        <p:nvSpPr>
+          <p:cNvPr id="32" name="Slide Number Placeholder 0"/>
+          <p:cNvSpPr>
+            <a:spLocks noGrp="1"/>
+          </p:cNvSpPr>
+          <p:nvPr>
+            <p:ph type="sldNum" sz="quarter" idx="4294967295"/>
+          </p:nvPr>
+        </p:nvSpPr>
+        <p:spPr>
+          <a:xfrm>
+            <a:off x="548640" y="6400800"/>
+            <a:ext cx="548640" cy="274320"/>
+          </a:xfrm>
+          <a:prstGeom prst="rect">
+            <a:avLst/>
+          </a:prstGeom>
+          <a:extLst>
+            <a:ext uri="{C572A759-6A51-4108-AA02-DFA0A04FC94B}">
+              <ma14:wrappingTextBoxFlag xmlns:ma14="http://schemas.microsoft.com/office/mac/drawingml/2011/main" xmlns="" val="0"/>
+            </a:ext>
+          </a:extLst>
+        </p:spPr>
+        <p:txBody>
+          <a:bodyPr/>
+          <a:lstStyle>
+            <a:lvl1pPr>
+              <a:defRPr sz="1000">
+                <a:solidFill>
+                  <a:schemeClr val="accent4"/>
+                </a:solidFill>
+              </a:defRPr>
+            </a:lvl1pPr>
+          </a:lstStyle>
+          <a:p>
+            <a:pPr algn="l"/>
+            <a:fld id="{F7021451-1387-4CA6-816F-3879F97B5CBC}" type="slidenum">
+              <a:rPr lang="es-SV" b="0" noProof="0" smtClean="0">
+                <a:latin typeface="Arial" panose="020B0604020202020204" pitchFamily="34" charset="0"/>
+                <a:cs typeface="Arial" panose="020B0604020202020204" pitchFamily="34" charset="0"/>
+              </a:rPr>
+              <a:t>4</a:t>
+            </a:fld>
+            <a:endParaRPr lang="es-SV" noProof="0" dirty="0">
+              <a:latin typeface="Arial" panose="020B0604020202020204" pitchFamily="34" charset="0"/>
+              <a:cs typeface="Arial" panose="020B0604020202020204" pitchFamily="34" charset="0"/>
+            </a:endParaRPr>
+          </a:p>
+        </p:txBody>
+      </p:sp>
     </p:spTree>
   </p:cSld>
   <p:clrMapOvr>

</xml_diff>